<commit_message>
Doc Clean + TaskTideService & Repo subsets field on group value
</commit_message>
<xml_diff>
--- a/tasktide/docs/Diagrams/Diagrams.pptx
+++ b/tasktide/docs/Diagrams/Diagrams.pptx
@@ -3082,12 +3082,8 @@
           <a:p>
             <a:pPr algn="ctr"/>
             <a:r>
-              <a:rPr lang="en-IE" sz="3600" b="1" dirty="0" err="1"/>
-              <a:t>TaskTide</a:t>
-            </a:r>
-            <a:r>
               <a:rPr lang="en-IE" sz="3600" b="1" dirty="0"/>
-              <a:t> Client</a:t>
+              <a:t>TaskTide Client</a:t>
             </a:r>
           </a:p>
         </p:txBody>
@@ -3164,7 +3160,7 @@
           <a:p>
             <a:pPr algn="ctr"/>
             <a:r>
-              <a:rPr lang="en-IE" sz="4000" b="1" dirty="0" err="1"/>
+              <a:rPr lang="en-IE" sz="4000" b="1" dirty="0"/>
               <a:t>ManagerClient</a:t>
             </a:r>
             <a:endParaRPr lang="en-IE" sz="3600" b="1" dirty="0"/>
@@ -3243,10 +3239,9 @@
           <a:p>
             <a:pPr algn="ctr"/>
             <a:r>
-              <a:rPr lang="en-IE" sz="4000" b="1" dirty="0" err="1"/>
+              <a:rPr lang="en-IE" sz="4000" b="1" dirty="0"/>
               <a:t>EngineClient</a:t>
             </a:r>
-            <a:endParaRPr lang="en-IE" sz="4000" b="1" dirty="0"/>
           </a:p>
         </p:txBody>
       </p:sp>
@@ -3322,10 +3317,9 @@
           <a:p>
             <a:pPr algn="ctr"/>
             <a:r>
-              <a:rPr lang="en-IE" sz="4000" b="1" dirty="0" err="1"/>
+              <a:rPr lang="en-IE" sz="4000" b="1" dirty="0"/>
               <a:t>TaskTideService</a:t>
             </a:r>
-            <a:endParaRPr lang="en-IE" sz="4000" b="1" dirty="0"/>
           </a:p>
         </p:txBody>
       </p:sp>
@@ -3401,10 +3395,9 @@
           <a:p>
             <a:pPr algn="ctr"/>
             <a:r>
-              <a:rPr lang="en-IE" sz="4000" b="1" dirty="0" err="1"/>
+              <a:rPr lang="en-IE" sz="4000" b="1" dirty="0"/>
               <a:t>TaskTideRepository</a:t>
             </a:r>
-            <a:endParaRPr lang="en-IE" sz="4000" b="1" dirty="0"/>
           </a:p>
         </p:txBody>
       </p:sp>
@@ -3480,7 +3473,7 @@
           <a:p>
             <a:pPr algn="ctr"/>
             <a:r>
-              <a:rPr lang="en-IE" sz="4000" b="1" dirty="0" err="1"/>
+              <a:rPr lang="en-IE" sz="4000" b="1" dirty="0"/>
               <a:t>TemplateRepository</a:t>
             </a:r>
             <a:endParaRPr lang="en-IE" sz="3200" b="1" dirty="0"/>
@@ -3559,10 +3552,9 @@
           <a:p>
             <a:pPr algn="ctr"/>
             <a:r>
-              <a:rPr lang="en-IE" sz="4000" b="1" dirty="0" err="1"/>
+              <a:rPr lang="en-IE" sz="4000" b="1" dirty="0"/>
               <a:t>ItemStoreRepository</a:t>
             </a:r>
-            <a:endParaRPr lang="en-IE" sz="4000" b="1" dirty="0"/>
           </a:p>
         </p:txBody>
       </p:sp>
@@ -4047,10 +4039,9 @@
           <a:p>
             <a:pPr algn="ctr"/>
             <a:r>
-              <a:rPr lang="en-IE" sz="4000" b="1" dirty="0" err="1"/>
+              <a:rPr lang="en-IE" sz="4000" b="1" dirty="0"/>
               <a:t>TaskTideEngine</a:t>
             </a:r>
-            <a:endParaRPr lang="en-IE" sz="4000" b="1" dirty="0"/>
           </a:p>
         </p:txBody>
       </p:sp>
@@ -4162,10 +4153,9 @@
           <a:p>
             <a:pPr algn="ctr"/>
             <a:r>
-              <a:rPr lang="en-IE" sz="4000" b="1" dirty="0" err="1"/>
+              <a:rPr lang="en-IE" sz="4000" b="1" dirty="0"/>
               <a:t>TaskTideModel</a:t>
             </a:r>
-            <a:endParaRPr lang="en-IE" sz="4000" b="1" dirty="0"/>
           </a:p>
         </p:txBody>
       </p:sp>
@@ -4397,10 +4387,9 @@
           <a:p>
             <a:pPr algn="ctr"/>
             <a:r>
-              <a:rPr lang="en-IE" sz="3200" b="1" dirty="0" err="1"/>
+              <a:rPr lang="en-IE" sz="3200" b="1" dirty="0"/>
               <a:t>WorkItem</a:t>
             </a:r>
-            <a:endParaRPr lang="en-IE" sz="3200" b="1" dirty="0"/>
           </a:p>
         </p:txBody>
       </p:sp>
@@ -4959,12 +4948,8 @@
           <a:p>
             <a:pPr algn="ctr"/>
             <a:r>
-              <a:rPr lang="en-IE" sz="3600" b="1" dirty="0" err="1"/>
-              <a:t>TaskTide</a:t>
-            </a:r>
-            <a:r>
               <a:rPr lang="en-IE" sz="3600" b="1" dirty="0"/>
-              <a:t> Client</a:t>
+              <a:t>TaskTide Client</a:t>
             </a:r>
           </a:p>
         </p:txBody>
@@ -5041,7 +5026,7 @@
           <a:p>
             <a:pPr algn="ctr"/>
             <a:r>
-              <a:rPr lang="en-IE" sz="4000" b="1" dirty="0" err="1"/>
+              <a:rPr lang="en-IE" sz="4000" b="1" dirty="0"/>
               <a:t>ManagerClient</a:t>
             </a:r>
             <a:endParaRPr lang="en-IE" sz="3600" b="1" dirty="0"/>
@@ -5120,10 +5105,9 @@
           <a:p>
             <a:pPr algn="ctr"/>
             <a:r>
-              <a:rPr lang="en-IE" sz="4000" b="1" dirty="0" err="1"/>
+              <a:rPr lang="en-IE" sz="4000" b="1" dirty="0"/>
               <a:t>EngineClient</a:t>
             </a:r>
-            <a:endParaRPr lang="en-IE" sz="4000" b="1" dirty="0"/>
           </a:p>
         </p:txBody>
       </p:sp>
@@ -5199,10 +5183,9 @@
           <a:p>
             <a:pPr algn="ctr"/>
             <a:r>
-              <a:rPr lang="en-IE" sz="4000" b="1" dirty="0" err="1"/>
+              <a:rPr lang="en-IE" sz="4000" b="1" dirty="0"/>
               <a:t>TaskTideService</a:t>
             </a:r>
-            <a:endParaRPr lang="en-IE" sz="4000" b="1" dirty="0"/>
           </a:p>
         </p:txBody>
       </p:sp>
@@ -5278,10 +5261,9 @@
           <a:p>
             <a:pPr algn="ctr"/>
             <a:r>
-              <a:rPr lang="en-IE" sz="4000" b="1" dirty="0" err="1"/>
+              <a:rPr lang="en-IE" sz="4000" b="1" dirty="0"/>
               <a:t>TaskTideRepository</a:t>
             </a:r>
-            <a:endParaRPr lang="en-IE" sz="4000" b="1" dirty="0"/>
           </a:p>
         </p:txBody>
       </p:sp>
@@ -5357,7 +5339,7 @@
           <a:p>
             <a:pPr algn="ctr"/>
             <a:r>
-              <a:rPr lang="en-IE" sz="4000" b="1" dirty="0" err="1"/>
+              <a:rPr lang="en-IE" sz="4000" b="1" dirty="0"/>
               <a:t>TemplateRepository</a:t>
             </a:r>
             <a:endParaRPr lang="en-IE" sz="3200" b="1" dirty="0"/>
@@ -5436,10 +5418,9 @@
           <a:p>
             <a:pPr algn="ctr"/>
             <a:r>
-              <a:rPr lang="en-IE" sz="4000" b="1" dirty="0" err="1"/>
+              <a:rPr lang="en-IE" sz="4000" b="1" dirty="0"/>
               <a:t>ItemStoreRepository</a:t>
             </a:r>
-            <a:endParaRPr lang="en-IE" sz="4000" b="1" dirty="0"/>
           </a:p>
         </p:txBody>
       </p:sp>
@@ -5804,10 +5785,9 @@
           <a:p>
             <a:pPr algn="ctr"/>
             <a:r>
-              <a:rPr lang="en-IE" sz="4000" b="1" dirty="0" err="1"/>
+              <a:rPr lang="en-IE" sz="4000" b="1" dirty="0"/>
               <a:t>TaskTideEngine</a:t>
             </a:r>
-            <a:endParaRPr lang="en-IE" sz="4000" b="1" dirty="0"/>
           </a:p>
         </p:txBody>
       </p:sp>
@@ -5919,10 +5899,9 @@
           <a:p>
             <a:pPr algn="ctr"/>
             <a:r>
-              <a:rPr lang="en-IE" sz="4000" b="1" dirty="0" err="1"/>
+              <a:rPr lang="en-IE" sz="4000" b="1" dirty="0"/>
               <a:t>TaskTideModel</a:t>
             </a:r>
-            <a:endParaRPr lang="en-IE" sz="4000" b="1" dirty="0"/>
           </a:p>
         </p:txBody>
       </p:sp>
@@ -6154,10 +6133,9 @@
           <a:p>
             <a:pPr algn="ctr"/>
             <a:r>
-              <a:rPr lang="en-IE" sz="3200" b="1" dirty="0" err="1"/>
+              <a:rPr lang="en-IE" sz="3200" b="1" dirty="0"/>
               <a:t>WorkItem</a:t>
             </a:r>
-            <a:endParaRPr lang="en-IE" sz="3200" b="1" dirty="0"/>
           </a:p>
         </p:txBody>
       </p:sp>

</xml_diff>

<commit_message>
Updated Repo documentation for SQL & JPA Repository updates
</commit_message>
<xml_diff>
--- a/tasktide/docs/Diagrams/Diagrams.pptx
+++ b/tasktide/docs/Diagrams/Diagrams.pptx
@@ -6,7 +6,8 @@
   </p:sldMasterIdLst>
   <p:sldIdLst>
     <p:sldId id="256" r:id="rId2"/>
-    <p:sldId id="257" r:id="rId3"/>
+    <p:sldId id="258" r:id="rId3"/>
+    <p:sldId id="257" r:id="rId4"/>
   </p:sldIdLst>
   <p:sldSz cx="18000663" cy="16200438"/>
   <p:notesSz cx="6858000" cy="9144000"/>
@@ -244,7 +245,7 @@
           <a:p>
             <a:fld id="{79C0705B-4870-4470-A32F-307AEE1697AB}" type="datetimeFigureOut">
               <a:rPr lang="en-IE" smtClean="0"/>
-              <a:t>22/07/2025</a:t>
+              <a:t>25/07/2025</a:t>
             </a:fld>
             <a:endParaRPr lang="en-IE"/>
           </a:p>
@@ -414,7 +415,7 @@
           <a:p>
             <a:fld id="{79C0705B-4870-4470-A32F-307AEE1697AB}" type="datetimeFigureOut">
               <a:rPr lang="en-IE" smtClean="0"/>
-              <a:t>22/07/2025</a:t>
+              <a:t>25/07/2025</a:t>
             </a:fld>
             <a:endParaRPr lang="en-IE"/>
           </a:p>
@@ -594,7 +595,7 @@
           <a:p>
             <a:fld id="{79C0705B-4870-4470-A32F-307AEE1697AB}" type="datetimeFigureOut">
               <a:rPr lang="en-IE" smtClean="0"/>
-              <a:t>22/07/2025</a:t>
+              <a:t>25/07/2025</a:t>
             </a:fld>
             <a:endParaRPr lang="en-IE"/>
           </a:p>
@@ -764,7 +765,7 @@
           <a:p>
             <a:fld id="{79C0705B-4870-4470-A32F-307AEE1697AB}" type="datetimeFigureOut">
               <a:rPr lang="en-IE" smtClean="0"/>
-              <a:t>22/07/2025</a:t>
+              <a:t>25/07/2025</a:t>
             </a:fld>
             <a:endParaRPr lang="en-IE"/>
           </a:p>
@@ -1010,7 +1011,7 @@
           <a:p>
             <a:fld id="{79C0705B-4870-4470-A32F-307AEE1697AB}" type="datetimeFigureOut">
               <a:rPr lang="en-IE" smtClean="0"/>
-              <a:t>22/07/2025</a:t>
+              <a:t>25/07/2025</a:t>
             </a:fld>
             <a:endParaRPr lang="en-IE"/>
           </a:p>
@@ -1242,7 +1243,7 @@
           <a:p>
             <a:fld id="{79C0705B-4870-4470-A32F-307AEE1697AB}" type="datetimeFigureOut">
               <a:rPr lang="en-IE" smtClean="0"/>
-              <a:t>22/07/2025</a:t>
+              <a:t>25/07/2025</a:t>
             </a:fld>
             <a:endParaRPr lang="en-IE"/>
           </a:p>
@@ -1609,7 +1610,7 @@
           <a:p>
             <a:fld id="{79C0705B-4870-4470-A32F-307AEE1697AB}" type="datetimeFigureOut">
               <a:rPr lang="en-IE" smtClean="0"/>
-              <a:t>22/07/2025</a:t>
+              <a:t>25/07/2025</a:t>
             </a:fld>
             <a:endParaRPr lang="en-IE"/>
           </a:p>
@@ -1727,7 +1728,7 @@
           <a:p>
             <a:fld id="{79C0705B-4870-4470-A32F-307AEE1697AB}" type="datetimeFigureOut">
               <a:rPr lang="en-IE" smtClean="0"/>
-              <a:t>22/07/2025</a:t>
+              <a:t>25/07/2025</a:t>
             </a:fld>
             <a:endParaRPr lang="en-IE"/>
           </a:p>
@@ -1822,7 +1823,7 @@
           <a:p>
             <a:fld id="{79C0705B-4870-4470-A32F-307AEE1697AB}" type="datetimeFigureOut">
               <a:rPr lang="en-IE" smtClean="0"/>
-              <a:t>22/07/2025</a:t>
+              <a:t>25/07/2025</a:t>
             </a:fld>
             <a:endParaRPr lang="en-IE"/>
           </a:p>
@@ -2099,7 +2100,7 @@
           <a:p>
             <a:fld id="{79C0705B-4870-4470-A32F-307AEE1697AB}" type="datetimeFigureOut">
               <a:rPr lang="en-IE" smtClean="0"/>
-              <a:t>22/07/2025</a:t>
+              <a:t>25/07/2025</a:t>
             </a:fld>
             <a:endParaRPr lang="en-IE"/>
           </a:p>
@@ -2356,7 +2357,7 @@
           <a:p>
             <a:fld id="{79C0705B-4870-4470-A32F-307AEE1697AB}" type="datetimeFigureOut">
               <a:rPr lang="en-IE" smtClean="0"/>
-              <a:t>22/07/2025</a:t>
+              <a:t>25/07/2025</a:t>
             </a:fld>
             <a:endParaRPr lang="en-IE"/>
           </a:p>
@@ -2569,7 +2570,7 @@
           <a:p>
             <a:fld id="{79C0705B-4870-4470-A32F-307AEE1697AB}" type="datetimeFigureOut">
               <a:rPr lang="en-IE" smtClean="0"/>
-              <a:t>22/07/2025</a:t>
+              <a:t>25/07/2025</a:t>
             </a:fld>
             <a:endParaRPr lang="en-IE"/>
           </a:p>
@@ -3630,10 +3631,9 @@
           <a:p>
             <a:pPr algn="ctr"/>
             <a:r>
-              <a:rPr lang="en-IE" sz="4000" b="1" dirty="0" err="1"/>
-              <a:t>JsonRepository</a:t>
-            </a:r>
-            <a:endParaRPr lang="en-IE" sz="4000" b="1" dirty="0"/>
+              <a:rPr lang="en-IE" sz="4000" b="1" dirty="0"/>
+              <a:t>JpaRepository</a:t>
+            </a:r>
           </a:p>
         </p:txBody>
       </p:sp>
@@ -4804,6 +4804,176 @@
           </a:fontRef>
         </p:style>
       </p:cxnSp>
+      <p:cxnSp>
+        <p:nvCxnSpPr>
+          <p:cNvPr id="2" name="Straight Arrow Connector 1">
+            <a:extLst>
+              <a:ext uri="{FF2B5EF4-FFF2-40B4-BE49-F238E27FC236}">
+                <a16:creationId xmlns:a16="http://schemas.microsoft.com/office/drawing/2014/main" id="{B63FC61A-B064-0C71-D47B-6087923E9AA1}"/>
+              </a:ext>
+            </a:extLst>
+          </p:cNvPr>
+          <p:cNvCxnSpPr>
+            <a:cxnSpLocks/>
+          </p:cNvCxnSpPr>
+          <p:nvPr/>
+        </p:nvCxnSpPr>
+        <p:spPr>
+          <a:xfrm>
+            <a:off x="7446025" y="11818336"/>
+            <a:ext cx="0" cy="912134"/>
+          </a:xfrm>
+          <a:prstGeom prst="straightConnector1">
+            <a:avLst/>
+          </a:prstGeom>
+          <a:ln w="76200">
+            <a:tailEnd type="triangle"/>
+          </a:ln>
+        </p:spPr>
+        <p:style>
+          <a:lnRef idx="3">
+            <a:schemeClr val="accent6"/>
+          </a:lnRef>
+          <a:fillRef idx="0">
+            <a:schemeClr val="accent6"/>
+          </a:fillRef>
+          <a:effectRef idx="2">
+            <a:schemeClr val="accent6"/>
+          </a:effectRef>
+          <a:fontRef idx="minor">
+            <a:schemeClr val="tx1"/>
+          </a:fontRef>
+        </p:style>
+      </p:cxnSp>
+      <p:grpSp>
+        <p:nvGrpSpPr>
+          <p:cNvPr id="20" name="Group 19">
+            <a:extLst>
+              <a:ext uri="{FF2B5EF4-FFF2-40B4-BE49-F238E27FC236}">
+                <a16:creationId xmlns:a16="http://schemas.microsoft.com/office/drawing/2014/main" id="{A1788FC1-D1D9-FCA0-8AA7-E335A3FB44E0}"/>
+              </a:ext>
+            </a:extLst>
+          </p:cNvPr>
+          <p:cNvGrpSpPr/>
+          <p:nvPr/>
+        </p:nvGrpSpPr>
+        <p:grpSpPr>
+          <a:xfrm>
+            <a:off x="5759895" y="12730470"/>
+            <a:ext cx="3317123" cy="2907635"/>
+            <a:chOff x="5722573" y="12674487"/>
+            <a:chExt cx="3317123" cy="2907635"/>
+          </a:xfrm>
+        </p:grpSpPr>
+        <p:pic>
+          <p:nvPicPr>
+            <p:cNvPr id="4" name="Picture 3" descr="A blue circle with white text and a dolphin&#10;&#10;AI-generated content may be incorrect.">
+              <a:extLst>
+                <a:ext uri="{FF2B5EF4-FFF2-40B4-BE49-F238E27FC236}">
+                  <a16:creationId xmlns:a16="http://schemas.microsoft.com/office/drawing/2014/main" id="{4317112C-5E93-13F6-DEEF-8EAA6FDD088F}"/>
+                </a:ext>
+              </a:extLst>
+            </p:cNvPr>
+            <p:cNvPicPr>
+              <a:picLocks noChangeAspect="1"/>
+            </p:cNvPicPr>
+            <p:nvPr/>
+          </p:nvPicPr>
+          <p:blipFill>
+            <a:blip r:embed="rId6">
+              <a:extLst>
+                <a:ext uri="{28A0092B-C50C-407E-A947-70E740481C1C}">
+                  <a14:useLocalDpi xmlns:a14="http://schemas.microsoft.com/office/drawing/2010/main" val="0"/>
+                </a:ext>
+              </a:extLst>
+            </a:blip>
+            <a:stretch>
+              <a:fillRect/>
+            </a:stretch>
+          </p:blipFill>
+          <p:spPr>
+            <a:xfrm>
+              <a:off x="5722573" y="12674487"/>
+              <a:ext cx="1409700" cy="1409700"/>
+            </a:xfrm>
+            <a:prstGeom prst="rect">
+              <a:avLst/>
+            </a:prstGeom>
+          </p:spPr>
+        </p:pic>
+        <p:pic>
+          <p:nvPicPr>
+            <p:cNvPr id="15" name="Picture 14" descr="A logo for a company&#10;&#10;AI-generated content may be incorrect.">
+              <a:extLst>
+                <a:ext uri="{FF2B5EF4-FFF2-40B4-BE49-F238E27FC236}">
+                  <a16:creationId xmlns:a16="http://schemas.microsoft.com/office/drawing/2014/main" id="{B03A0ABC-098B-C812-3DA4-0300D71075D1}"/>
+                </a:ext>
+              </a:extLst>
+            </p:cNvPr>
+            <p:cNvPicPr>
+              <a:picLocks noChangeAspect="1"/>
+            </p:cNvPicPr>
+            <p:nvPr/>
+          </p:nvPicPr>
+          <p:blipFill>
+            <a:blip r:embed="rId7">
+              <a:extLst>
+                <a:ext uri="{28A0092B-C50C-407E-A947-70E740481C1C}">
+                  <a14:useLocalDpi xmlns:a14="http://schemas.microsoft.com/office/drawing/2010/main" val="0"/>
+                </a:ext>
+              </a:extLst>
+            </a:blip>
+            <a:stretch>
+              <a:fillRect/>
+            </a:stretch>
+          </p:blipFill>
+          <p:spPr>
+            <a:xfrm>
+              <a:off x="6647452" y="14381372"/>
+              <a:ext cx="1590182" cy="1200750"/>
+            </a:xfrm>
+            <a:prstGeom prst="rect">
+              <a:avLst/>
+            </a:prstGeom>
+          </p:spPr>
+        </p:pic>
+        <p:pic>
+          <p:nvPicPr>
+            <p:cNvPr id="19" name="Picture 18" descr="A blue elephant logo with white text&#10;&#10;AI-generated content may be incorrect.">
+              <a:extLst>
+                <a:ext uri="{FF2B5EF4-FFF2-40B4-BE49-F238E27FC236}">
+                  <a16:creationId xmlns:a16="http://schemas.microsoft.com/office/drawing/2014/main" id="{33994AF6-0DEF-2EBD-E76A-01617A7F53A2}"/>
+                </a:ext>
+              </a:extLst>
+            </p:cNvPr>
+            <p:cNvPicPr>
+              <a:picLocks noChangeAspect="1"/>
+            </p:cNvPicPr>
+            <p:nvPr/>
+          </p:nvPicPr>
+          <p:blipFill>
+            <a:blip r:embed="rId8">
+              <a:extLst>
+                <a:ext uri="{28A0092B-C50C-407E-A947-70E740481C1C}">
+                  <a14:useLocalDpi xmlns:a14="http://schemas.microsoft.com/office/drawing/2010/main" val="0"/>
+                </a:ext>
+              </a:extLst>
+            </a:blip>
+            <a:stretch>
+              <a:fillRect/>
+            </a:stretch>
+          </p:blipFill>
+          <p:spPr>
+            <a:xfrm>
+              <a:off x="7688502" y="12732993"/>
+              <a:ext cx="1351194" cy="1351194"/>
+            </a:xfrm>
+            <a:prstGeom prst="rect">
+              <a:avLst/>
+            </a:prstGeom>
+          </p:spPr>
+        </p:pic>
+      </p:grpSp>
     </p:spTree>
     <p:extLst>
       <p:ext uri="{BB962C8B-B14F-4D97-AF65-F5344CB8AC3E}">
@@ -4818,6 +4988,1948 @@
 </file>
 
 <file path=ppt/slides/slide2.xml><?xml version="1.0" encoding="utf-8"?>
+<p:sld xmlns:a="http://schemas.openxmlformats.org/drawingml/2006/main" xmlns:r="http://schemas.openxmlformats.org/officeDocument/2006/relationships" xmlns:p="http://schemas.openxmlformats.org/presentationml/2006/main">
+  <p:cSld>
+    <p:spTree>
+      <p:nvGrpSpPr>
+        <p:cNvPr id="1" name="">
+          <a:extLst>
+            <a:ext uri="{FF2B5EF4-FFF2-40B4-BE49-F238E27FC236}">
+              <a16:creationId xmlns:a16="http://schemas.microsoft.com/office/drawing/2014/main" id="{5353CE86-7161-A9BD-45FD-6F22304D5B3A}"/>
+            </a:ext>
+          </a:extLst>
+        </p:cNvPr>
+        <p:cNvGrpSpPr/>
+        <p:nvPr/>
+      </p:nvGrpSpPr>
+      <p:grpSpPr>
+        <a:xfrm>
+          <a:off x="0" y="0"/>
+          <a:ext cx="0" cy="0"/>
+          <a:chOff x="0" y="0"/>
+          <a:chExt cx="0" cy="0"/>
+        </a:xfrm>
+      </p:grpSpPr>
+      <p:pic>
+        <p:nvPicPr>
+          <p:cNvPr id="5" name="Picture 4" descr="A logo with waves and text&#10;&#10;AI-generated content may be incorrect.">
+            <a:extLst>
+              <a:ext uri="{FF2B5EF4-FFF2-40B4-BE49-F238E27FC236}">
+                <a16:creationId xmlns:a16="http://schemas.microsoft.com/office/drawing/2014/main" id="{4D49C95C-FB72-FA1E-BEA8-0066A49008F3}"/>
+              </a:ext>
+            </a:extLst>
+          </p:cNvPr>
+          <p:cNvPicPr>
+            <a:picLocks noChangeAspect="1"/>
+          </p:cNvPicPr>
+          <p:nvPr/>
+        </p:nvPicPr>
+        <p:blipFill>
+          <a:blip r:embed="rId2">
+            <a:extLst>
+              <a:ext uri="{28A0092B-C50C-407E-A947-70E740481C1C}">
+                <a14:useLocalDpi xmlns:a14="http://schemas.microsoft.com/office/drawing/2010/main" val="0"/>
+              </a:ext>
+            </a:extLst>
+          </a:blip>
+          <a:stretch>
+            <a:fillRect/>
+          </a:stretch>
+        </p:blipFill>
+        <p:spPr>
+          <a:xfrm>
+            <a:off x="3710306" y="94762"/>
+            <a:ext cx="5368986" cy="4774210"/>
+          </a:xfrm>
+          <a:prstGeom prst="rect">
+            <a:avLst/>
+          </a:prstGeom>
+        </p:spPr>
+      </p:pic>
+      <p:sp>
+        <p:nvSpPr>
+          <p:cNvPr id="7" name="Flowchart: Alternate Process 6">
+            <a:extLst>
+              <a:ext uri="{FF2B5EF4-FFF2-40B4-BE49-F238E27FC236}">
+                <a16:creationId xmlns:a16="http://schemas.microsoft.com/office/drawing/2014/main" id="{A0D5D681-EC19-52DB-E992-0E57F0AEFD3A}"/>
+              </a:ext>
+            </a:extLst>
+          </p:cNvPr>
+          <p:cNvSpPr/>
+          <p:nvPr/>
+        </p:nvSpPr>
+        <p:spPr>
+          <a:xfrm>
+            <a:off x="3853559" y="4166755"/>
+            <a:ext cx="5147728" cy="846667"/>
+          </a:xfrm>
+          <a:prstGeom prst="flowChartAlternateProcess">
+            <a:avLst/>
+          </a:prstGeom>
+          <a:gradFill flip="none" rotWithShape="1">
+            <a:gsLst>
+              <a:gs pos="0">
+                <a:schemeClr val="accent1">
+                  <a:shade val="30000"/>
+                  <a:satMod val="115000"/>
+                </a:schemeClr>
+              </a:gs>
+              <a:gs pos="50000">
+                <a:schemeClr val="accent1">
+                  <a:shade val="67500"/>
+                  <a:satMod val="115000"/>
+                </a:schemeClr>
+              </a:gs>
+              <a:gs pos="100000">
+                <a:schemeClr val="accent1">
+                  <a:shade val="100000"/>
+                  <a:satMod val="115000"/>
+                </a:schemeClr>
+              </a:gs>
+            </a:gsLst>
+            <a:lin ang="5400000" scaled="1"/>
+            <a:tileRect/>
+          </a:gradFill>
+          <a:ln w="57150">
+            <a:solidFill>
+              <a:schemeClr val="tx1"/>
+            </a:solidFill>
+          </a:ln>
+        </p:spPr>
+        <p:style>
+          <a:lnRef idx="2">
+            <a:schemeClr val="accent1">
+              <a:shade val="15000"/>
+            </a:schemeClr>
+          </a:lnRef>
+          <a:fillRef idx="1">
+            <a:schemeClr val="accent1"/>
+          </a:fillRef>
+          <a:effectRef idx="0">
+            <a:schemeClr val="accent1"/>
+          </a:effectRef>
+          <a:fontRef idx="minor">
+            <a:schemeClr val="lt1"/>
+          </a:fontRef>
+        </p:style>
+        <p:txBody>
+          <a:bodyPr rtlCol="0" anchor="ctr"/>
+          <a:lstStyle/>
+          <a:p>
+            <a:pPr algn="ctr"/>
+            <a:r>
+              <a:rPr lang="en-IE" sz="3600" b="1" dirty="0"/>
+              <a:t>TaskTide Client</a:t>
+            </a:r>
+          </a:p>
+        </p:txBody>
+      </p:sp>
+      <p:sp>
+        <p:nvSpPr>
+          <p:cNvPr id="8" name="Flowchart: Alternate Process 7">
+            <a:extLst>
+              <a:ext uri="{FF2B5EF4-FFF2-40B4-BE49-F238E27FC236}">
+                <a16:creationId xmlns:a16="http://schemas.microsoft.com/office/drawing/2014/main" id="{C9B222C9-BBBA-0888-EF26-AA904B46F6C6}"/>
+              </a:ext>
+            </a:extLst>
+          </p:cNvPr>
+          <p:cNvSpPr/>
+          <p:nvPr/>
+        </p:nvSpPr>
+        <p:spPr>
+          <a:xfrm>
+            <a:off x="1156997" y="5941276"/>
+            <a:ext cx="3806883" cy="1040497"/>
+          </a:xfrm>
+          <a:prstGeom prst="flowChartAlternateProcess">
+            <a:avLst/>
+          </a:prstGeom>
+          <a:gradFill flip="none" rotWithShape="1">
+            <a:gsLst>
+              <a:gs pos="0">
+                <a:schemeClr val="accent1">
+                  <a:shade val="30000"/>
+                  <a:satMod val="115000"/>
+                </a:schemeClr>
+              </a:gs>
+              <a:gs pos="50000">
+                <a:schemeClr val="accent1">
+                  <a:shade val="67500"/>
+                  <a:satMod val="115000"/>
+                </a:schemeClr>
+              </a:gs>
+              <a:gs pos="100000">
+                <a:schemeClr val="accent1">
+                  <a:shade val="100000"/>
+                  <a:satMod val="115000"/>
+                </a:schemeClr>
+              </a:gs>
+            </a:gsLst>
+            <a:lin ang="5400000" scaled="1"/>
+            <a:tileRect/>
+          </a:gradFill>
+          <a:ln w="57150">
+            <a:solidFill>
+              <a:schemeClr val="tx1"/>
+            </a:solidFill>
+          </a:ln>
+        </p:spPr>
+        <p:style>
+          <a:lnRef idx="2">
+            <a:schemeClr val="accent1">
+              <a:shade val="15000"/>
+            </a:schemeClr>
+          </a:lnRef>
+          <a:fillRef idx="1">
+            <a:schemeClr val="accent1"/>
+          </a:fillRef>
+          <a:effectRef idx="0">
+            <a:schemeClr val="accent1"/>
+          </a:effectRef>
+          <a:fontRef idx="minor">
+            <a:schemeClr val="lt1"/>
+          </a:fontRef>
+        </p:style>
+        <p:txBody>
+          <a:bodyPr rtlCol="0" anchor="ctr"/>
+          <a:lstStyle/>
+          <a:p>
+            <a:pPr algn="ctr"/>
+            <a:r>
+              <a:rPr lang="en-IE" sz="4000" b="1" dirty="0"/>
+              <a:t>ManagerClient</a:t>
+            </a:r>
+            <a:endParaRPr lang="en-IE" sz="3600" b="1" dirty="0"/>
+          </a:p>
+        </p:txBody>
+      </p:sp>
+      <p:sp>
+        <p:nvSpPr>
+          <p:cNvPr id="9" name="Flowchart: Alternate Process 8">
+            <a:extLst>
+              <a:ext uri="{FF2B5EF4-FFF2-40B4-BE49-F238E27FC236}">
+                <a16:creationId xmlns:a16="http://schemas.microsoft.com/office/drawing/2014/main" id="{0088A710-20B0-2142-B5AA-A176FCC79125}"/>
+              </a:ext>
+            </a:extLst>
+          </p:cNvPr>
+          <p:cNvSpPr/>
+          <p:nvPr/>
+        </p:nvSpPr>
+        <p:spPr>
+          <a:xfrm>
+            <a:off x="7274333" y="5951364"/>
+            <a:ext cx="3454567" cy="1034688"/>
+          </a:xfrm>
+          <a:prstGeom prst="flowChartAlternateProcess">
+            <a:avLst/>
+          </a:prstGeom>
+          <a:gradFill flip="none" rotWithShape="1">
+            <a:gsLst>
+              <a:gs pos="0">
+                <a:schemeClr val="accent1">
+                  <a:shade val="30000"/>
+                  <a:satMod val="115000"/>
+                </a:schemeClr>
+              </a:gs>
+              <a:gs pos="50000">
+                <a:schemeClr val="accent1">
+                  <a:shade val="67500"/>
+                  <a:satMod val="115000"/>
+                </a:schemeClr>
+              </a:gs>
+              <a:gs pos="100000">
+                <a:schemeClr val="accent1">
+                  <a:shade val="100000"/>
+                  <a:satMod val="115000"/>
+                </a:schemeClr>
+              </a:gs>
+            </a:gsLst>
+            <a:lin ang="5400000" scaled="1"/>
+            <a:tileRect/>
+          </a:gradFill>
+          <a:ln w="57150">
+            <a:solidFill>
+              <a:schemeClr val="tx1"/>
+            </a:solidFill>
+          </a:ln>
+        </p:spPr>
+        <p:style>
+          <a:lnRef idx="2">
+            <a:schemeClr val="accent1">
+              <a:shade val="15000"/>
+            </a:schemeClr>
+          </a:lnRef>
+          <a:fillRef idx="1">
+            <a:schemeClr val="accent1"/>
+          </a:fillRef>
+          <a:effectRef idx="0">
+            <a:schemeClr val="accent1"/>
+          </a:effectRef>
+          <a:fontRef idx="minor">
+            <a:schemeClr val="lt1"/>
+          </a:fontRef>
+        </p:style>
+        <p:txBody>
+          <a:bodyPr rtlCol="0" anchor="ctr"/>
+          <a:lstStyle/>
+          <a:p>
+            <a:pPr algn="ctr"/>
+            <a:r>
+              <a:rPr lang="en-IE" sz="4000" b="1" dirty="0"/>
+              <a:t>EngineClient</a:t>
+            </a:r>
+          </a:p>
+        </p:txBody>
+      </p:sp>
+      <p:sp>
+        <p:nvSpPr>
+          <p:cNvPr id="10" name="Flowchart: Alternate Process 9">
+            <a:extLst>
+              <a:ext uri="{FF2B5EF4-FFF2-40B4-BE49-F238E27FC236}">
+                <a16:creationId xmlns:a16="http://schemas.microsoft.com/office/drawing/2014/main" id="{C175F32A-56DF-9F7C-9A94-1E7802433A90}"/>
+              </a:ext>
+            </a:extLst>
+          </p:cNvPr>
+          <p:cNvSpPr/>
+          <p:nvPr/>
+        </p:nvSpPr>
+        <p:spPr>
+          <a:xfrm>
+            <a:off x="3579676" y="7662740"/>
+            <a:ext cx="5421603" cy="1040497"/>
+          </a:xfrm>
+          <a:prstGeom prst="flowChartAlternateProcess">
+            <a:avLst/>
+          </a:prstGeom>
+          <a:gradFill flip="none" rotWithShape="1">
+            <a:gsLst>
+              <a:gs pos="0">
+                <a:schemeClr val="accent1">
+                  <a:shade val="30000"/>
+                  <a:satMod val="115000"/>
+                </a:schemeClr>
+              </a:gs>
+              <a:gs pos="50000">
+                <a:schemeClr val="accent1">
+                  <a:shade val="67500"/>
+                  <a:satMod val="115000"/>
+                </a:schemeClr>
+              </a:gs>
+              <a:gs pos="100000">
+                <a:schemeClr val="accent1">
+                  <a:shade val="100000"/>
+                  <a:satMod val="115000"/>
+                </a:schemeClr>
+              </a:gs>
+            </a:gsLst>
+            <a:lin ang="5400000" scaled="1"/>
+            <a:tileRect/>
+          </a:gradFill>
+          <a:ln w="57150">
+            <a:solidFill>
+              <a:schemeClr val="tx1"/>
+            </a:solidFill>
+          </a:ln>
+        </p:spPr>
+        <p:style>
+          <a:lnRef idx="2">
+            <a:schemeClr val="accent1">
+              <a:shade val="15000"/>
+            </a:schemeClr>
+          </a:lnRef>
+          <a:fillRef idx="1">
+            <a:schemeClr val="accent1"/>
+          </a:fillRef>
+          <a:effectRef idx="0">
+            <a:schemeClr val="accent1"/>
+          </a:effectRef>
+          <a:fontRef idx="minor">
+            <a:schemeClr val="lt1"/>
+          </a:fontRef>
+        </p:style>
+        <p:txBody>
+          <a:bodyPr rtlCol="0" anchor="ctr"/>
+          <a:lstStyle/>
+          <a:p>
+            <a:pPr algn="ctr"/>
+            <a:r>
+              <a:rPr lang="en-IE" sz="4000" b="1" dirty="0"/>
+              <a:t>TaskTideService</a:t>
+            </a:r>
+          </a:p>
+        </p:txBody>
+      </p:sp>
+      <p:sp>
+        <p:nvSpPr>
+          <p:cNvPr id="11" name="Flowchart: Alternate Process 10">
+            <a:extLst>
+              <a:ext uri="{FF2B5EF4-FFF2-40B4-BE49-F238E27FC236}">
+                <a16:creationId xmlns:a16="http://schemas.microsoft.com/office/drawing/2014/main" id="{BB1892BD-1701-A0BD-82BF-2DE970D0462F}"/>
+              </a:ext>
+            </a:extLst>
+          </p:cNvPr>
+          <p:cNvSpPr/>
+          <p:nvPr/>
+        </p:nvSpPr>
+        <p:spPr>
+          <a:xfrm>
+            <a:off x="3760249" y="9393847"/>
+            <a:ext cx="5147734" cy="846667"/>
+          </a:xfrm>
+          <a:prstGeom prst="flowChartAlternateProcess">
+            <a:avLst/>
+          </a:prstGeom>
+          <a:gradFill flip="none" rotWithShape="1">
+            <a:gsLst>
+              <a:gs pos="0">
+                <a:schemeClr val="accent1">
+                  <a:shade val="30000"/>
+                  <a:satMod val="115000"/>
+                </a:schemeClr>
+              </a:gs>
+              <a:gs pos="50000">
+                <a:schemeClr val="accent1">
+                  <a:shade val="67500"/>
+                  <a:satMod val="115000"/>
+                </a:schemeClr>
+              </a:gs>
+              <a:gs pos="100000">
+                <a:schemeClr val="accent1">
+                  <a:shade val="100000"/>
+                  <a:satMod val="115000"/>
+                </a:schemeClr>
+              </a:gs>
+            </a:gsLst>
+            <a:lin ang="5400000" scaled="1"/>
+            <a:tileRect/>
+          </a:gradFill>
+          <a:ln w="57150">
+            <a:solidFill>
+              <a:schemeClr val="tx1"/>
+            </a:solidFill>
+          </a:ln>
+        </p:spPr>
+        <p:style>
+          <a:lnRef idx="2">
+            <a:schemeClr val="accent1">
+              <a:shade val="15000"/>
+            </a:schemeClr>
+          </a:lnRef>
+          <a:fillRef idx="1">
+            <a:schemeClr val="accent1"/>
+          </a:fillRef>
+          <a:effectRef idx="0">
+            <a:schemeClr val="accent1"/>
+          </a:effectRef>
+          <a:fontRef idx="minor">
+            <a:schemeClr val="lt1"/>
+          </a:fontRef>
+        </p:style>
+        <p:txBody>
+          <a:bodyPr rtlCol="0" anchor="ctr"/>
+          <a:lstStyle/>
+          <a:p>
+            <a:pPr algn="ctr"/>
+            <a:r>
+              <a:rPr lang="en-IE" sz="4000" b="1" dirty="0"/>
+              <a:t>TaskTideRepository</a:t>
+            </a:r>
+          </a:p>
+        </p:txBody>
+      </p:sp>
+      <p:sp>
+        <p:nvSpPr>
+          <p:cNvPr id="12" name="Flowchart: Alternate Process 11">
+            <a:extLst>
+              <a:ext uri="{FF2B5EF4-FFF2-40B4-BE49-F238E27FC236}">
+                <a16:creationId xmlns:a16="http://schemas.microsoft.com/office/drawing/2014/main" id="{96FC22DE-6644-4604-5F43-438B9F4B6E59}"/>
+              </a:ext>
+            </a:extLst>
+          </p:cNvPr>
+          <p:cNvSpPr/>
+          <p:nvPr/>
+        </p:nvSpPr>
+        <p:spPr>
+          <a:xfrm>
+            <a:off x="286029" y="12290092"/>
+            <a:ext cx="4964451" cy="846667"/>
+          </a:xfrm>
+          <a:prstGeom prst="flowChartAlternateProcess">
+            <a:avLst/>
+          </a:prstGeom>
+          <a:gradFill flip="none" rotWithShape="1">
+            <a:gsLst>
+              <a:gs pos="0">
+                <a:schemeClr val="accent1">
+                  <a:shade val="30000"/>
+                  <a:satMod val="115000"/>
+                </a:schemeClr>
+              </a:gs>
+              <a:gs pos="50000">
+                <a:schemeClr val="accent1">
+                  <a:shade val="67500"/>
+                  <a:satMod val="115000"/>
+                </a:schemeClr>
+              </a:gs>
+              <a:gs pos="100000">
+                <a:schemeClr val="accent1">
+                  <a:shade val="100000"/>
+                  <a:satMod val="115000"/>
+                </a:schemeClr>
+              </a:gs>
+            </a:gsLst>
+            <a:lin ang="5400000" scaled="1"/>
+            <a:tileRect/>
+          </a:gradFill>
+          <a:ln w="57150">
+            <a:solidFill>
+              <a:schemeClr val="tx1"/>
+            </a:solidFill>
+          </a:ln>
+        </p:spPr>
+        <p:style>
+          <a:lnRef idx="2">
+            <a:schemeClr val="accent1">
+              <a:shade val="15000"/>
+            </a:schemeClr>
+          </a:lnRef>
+          <a:fillRef idx="1">
+            <a:schemeClr val="accent1"/>
+          </a:fillRef>
+          <a:effectRef idx="0">
+            <a:schemeClr val="accent1"/>
+          </a:effectRef>
+          <a:fontRef idx="minor">
+            <a:schemeClr val="lt1"/>
+          </a:fontRef>
+        </p:style>
+        <p:txBody>
+          <a:bodyPr rtlCol="0" anchor="ctr"/>
+          <a:lstStyle/>
+          <a:p>
+            <a:pPr algn="ctr"/>
+            <a:r>
+              <a:rPr lang="en-IE" sz="4000" b="1" dirty="0"/>
+              <a:t>TemplateRepository</a:t>
+            </a:r>
+            <a:endParaRPr lang="en-IE" sz="3200" b="1" dirty="0"/>
+          </a:p>
+        </p:txBody>
+      </p:sp>
+      <p:sp>
+        <p:nvSpPr>
+          <p:cNvPr id="13" name="Flowchart: Alternate Process 12">
+            <a:extLst>
+              <a:ext uri="{FF2B5EF4-FFF2-40B4-BE49-F238E27FC236}">
+                <a16:creationId xmlns:a16="http://schemas.microsoft.com/office/drawing/2014/main" id="{D8992BE9-744B-1CD2-6A96-DB2DD3646F8C}"/>
+              </a:ext>
+            </a:extLst>
+          </p:cNvPr>
+          <p:cNvSpPr/>
+          <p:nvPr/>
+        </p:nvSpPr>
+        <p:spPr>
+          <a:xfrm>
+            <a:off x="9595925" y="12251154"/>
+            <a:ext cx="5147731" cy="846667"/>
+          </a:xfrm>
+          <a:prstGeom prst="flowChartAlternateProcess">
+            <a:avLst/>
+          </a:prstGeom>
+          <a:gradFill flip="none" rotWithShape="1">
+            <a:gsLst>
+              <a:gs pos="0">
+                <a:schemeClr val="accent1">
+                  <a:shade val="30000"/>
+                  <a:satMod val="115000"/>
+                </a:schemeClr>
+              </a:gs>
+              <a:gs pos="50000">
+                <a:schemeClr val="accent1">
+                  <a:shade val="67500"/>
+                  <a:satMod val="115000"/>
+                </a:schemeClr>
+              </a:gs>
+              <a:gs pos="100000">
+                <a:schemeClr val="accent1">
+                  <a:shade val="100000"/>
+                  <a:satMod val="115000"/>
+                </a:schemeClr>
+              </a:gs>
+            </a:gsLst>
+            <a:lin ang="5400000" scaled="1"/>
+            <a:tileRect/>
+          </a:gradFill>
+          <a:ln w="57150">
+            <a:solidFill>
+              <a:schemeClr val="tx1"/>
+            </a:solidFill>
+          </a:ln>
+        </p:spPr>
+        <p:style>
+          <a:lnRef idx="2">
+            <a:schemeClr val="accent1">
+              <a:shade val="15000"/>
+            </a:schemeClr>
+          </a:lnRef>
+          <a:fillRef idx="1">
+            <a:schemeClr val="accent1"/>
+          </a:fillRef>
+          <a:effectRef idx="0">
+            <a:schemeClr val="accent1"/>
+          </a:effectRef>
+          <a:fontRef idx="minor">
+            <a:schemeClr val="lt1"/>
+          </a:fontRef>
+        </p:style>
+        <p:txBody>
+          <a:bodyPr rtlCol="0" anchor="ctr"/>
+          <a:lstStyle/>
+          <a:p>
+            <a:pPr algn="ctr"/>
+            <a:r>
+              <a:rPr lang="en-IE" sz="4000" b="1" dirty="0"/>
+              <a:t>ItemStoreRepository</a:t>
+            </a:r>
+          </a:p>
+        </p:txBody>
+      </p:sp>
+      <p:sp>
+        <p:nvSpPr>
+          <p:cNvPr id="14" name="Flowchart: Alternate Process 13">
+            <a:extLst>
+              <a:ext uri="{FF2B5EF4-FFF2-40B4-BE49-F238E27FC236}">
+                <a16:creationId xmlns:a16="http://schemas.microsoft.com/office/drawing/2014/main" id="{8CC51A4A-40B6-E63F-1196-E1FC3D71AF33}"/>
+              </a:ext>
+            </a:extLst>
+          </p:cNvPr>
+          <p:cNvSpPr/>
+          <p:nvPr/>
+        </p:nvSpPr>
+        <p:spPr>
+          <a:xfrm>
+            <a:off x="5446220" y="11627080"/>
+            <a:ext cx="4010563" cy="846667"/>
+          </a:xfrm>
+          <a:prstGeom prst="flowChartAlternateProcess">
+            <a:avLst/>
+          </a:prstGeom>
+          <a:gradFill flip="none" rotWithShape="1">
+            <a:gsLst>
+              <a:gs pos="0">
+                <a:schemeClr val="accent1">
+                  <a:shade val="30000"/>
+                  <a:satMod val="115000"/>
+                </a:schemeClr>
+              </a:gs>
+              <a:gs pos="50000">
+                <a:schemeClr val="accent1">
+                  <a:shade val="67500"/>
+                  <a:satMod val="115000"/>
+                </a:schemeClr>
+              </a:gs>
+              <a:gs pos="100000">
+                <a:schemeClr val="accent1">
+                  <a:shade val="100000"/>
+                  <a:satMod val="115000"/>
+                </a:schemeClr>
+              </a:gs>
+            </a:gsLst>
+            <a:lin ang="5400000" scaled="1"/>
+            <a:tileRect/>
+          </a:gradFill>
+          <a:ln w="57150">
+            <a:solidFill>
+              <a:schemeClr val="tx1"/>
+            </a:solidFill>
+          </a:ln>
+        </p:spPr>
+        <p:style>
+          <a:lnRef idx="2">
+            <a:schemeClr val="accent1">
+              <a:shade val="15000"/>
+            </a:schemeClr>
+          </a:lnRef>
+          <a:fillRef idx="1">
+            <a:schemeClr val="accent1"/>
+          </a:fillRef>
+          <a:effectRef idx="0">
+            <a:schemeClr val="accent1"/>
+          </a:effectRef>
+          <a:fontRef idx="minor">
+            <a:schemeClr val="lt1"/>
+          </a:fontRef>
+        </p:style>
+        <p:txBody>
+          <a:bodyPr rtlCol="0" anchor="ctr"/>
+          <a:lstStyle/>
+          <a:p>
+            <a:pPr algn="ctr"/>
+            <a:r>
+              <a:rPr lang="en-IE" sz="4000" b="1" dirty="0"/>
+              <a:t>JpaRepository</a:t>
+            </a:r>
+          </a:p>
+        </p:txBody>
+      </p:sp>
+      <p:pic>
+        <p:nvPicPr>
+          <p:cNvPr id="16" name="Picture 15" descr="A logo of a white tooth with a red ball and bow and arrow&#10;&#10;AI-generated content may be incorrect.">
+            <a:extLst>
+              <a:ext uri="{FF2B5EF4-FFF2-40B4-BE49-F238E27FC236}">
+                <a16:creationId xmlns:a16="http://schemas.microsoft.com/office/drawing/2014/main" id="{E1FE6B74-6CAE-A5DB-C447-6DF730DC7628}"/>
+              </a:ext>
+            </a:extLst>
+          </p:cNvPr>
+          <p:cNvPicPr>
+            <a:picLocks noChangeAspect="1"/>
+          </p:cNvPicPr>
+          <p:nvPr/>
+        </p:nvPicPr>
+        <p:blipFill>
+          <a:blip r:embed="rId3">
+            <a:extLst>
+              <a:ext uri="{28A0092B-C50C-407E-A947-70E740481C1C}">
+                <a14:useLocalDpi xmlns:a14="http://schemas.microsoft.com/office/drawing/2010/main" val="0"/>
+              </a:ext>
+            </a:extLst>
+          </a:blip>
+          <a:stretch>
+            <a:fillRect/>
+          </a:stretch>
+        </p:blipFill>
+        <p:spPr>
+          <a:xfrm>
+            <a:off x="1455575" y="13910704"/>
+            <a:ext cx="2990162" cy="1880368"/>
+          </a:xfrm>
+          <a:prstGeom prst="rect">
+            <a:avLst/>
+          </a:prstGeom>
+        </p:spPr>
+      </p:pic>
+      <p:grpSp>
+        <p:nvGrpSpPr>
+          <p:cNvPr id="42" name="Group 41">
+            <a:extLst>
+              <a:ext uri="{FF2B5EF4-FFF2-40B4-BE49-F238E27FC236}">
+                <a16:creationId xmlns:a16="http://schemas.microsoft.com/office/drawing/2014/main" id="{64A8C982-B01F-7D8D-B23D-07252774B370}"/>
+              </a:ext>
+            </a:extLst>
+          </p:cNvPr>
+          <p:cNvGrpSpPr/>
+          <p:nvPr/>
+        </p:nvGrpSpPr>
+        <p:grpSpPr>
+          <a:xfrm>
+            <a:off x="10419761" y="13755141"/>
+            <a:ext cx="4323877" cy="2162882"/>
+            <a:chOff x="7840081" y="11304872"/>
+            <a:chExt cx="3773478" cy="1545522"/>
+          </a:xfrm>
+        </p:grpSpPr>
+        <p:pic>
+          <p:nvPicPr>
+            <p:cNvPr id="18" name="Picture 17" descr="A logo with a feather&#10;&#10;AI-generated content may be incorrect.">
+              <a:extLst>
+                <a:ext uri="{FF2B5EF4-FFF2-40B4-BE49-F238E27FC236}">
+                  <a16:creationId xmlns:a16="http://schemas.microsoft.com/office/drawing/2014/main" id="{D166C88F-651A-24E5-32CC-193FBA75BD9A}"/>
+                </a:ext>
+              </a:extLst>
+            </p:cNvPr>
+            <p:cNvPicPr>
+              <a:picLocks noChangeAspect="1"/>
+            </p:cNvPicPr>
+            <p:nvPr/>
+          </p:nvPicPr>
+          <p:blipFill>
+            <a:blip r:embed="rId4">
+              <a:extLst>
+                <a:ext uri="{28A0092B-C50C-407E-A947-70E740481C1C}">
+                  <a14:useLocalDpi xmlns:a14="http://schemas.microsoft.com/office/drawing/2010/main" val="0"/>
+                </a:ext>
+              </a:extLst>
+            </a:blip>
+            <a:stretch>
+              <a:fillRect/>
+            </a:stretch>
+          </p:blipFill>
+          <p:spPr>
+            <a:xfrm>
+              <a:off x="7840081" y="11304872"/>
+              <a:ext cx="1552575" cy="733425"/>
+            </a:xfrm>
+            <a:prstGeom prst="rect">
+              <a:avLst/>
+            </a:prstGeom>
+          </p:spPr>
+        </p:pic>
+        <p:pic>
+          <p:nvPicPr>
+            <p:cNvPr id="22" name="Picture 21" descr="A yellow leopard jumping in a folder&#10;&#10;AI-generated content may be incorrect.">
+              <a:extLst>
+                <a:ext uri="{FF2B5EF4-FFF2-40B4-BE49-F238E27FC236}">
+                  <a16:creationId xmlns:a16="http://schemas.microsoft.com/office/drawing/2014/main" id="{51A207A8-6E9F-F4A9-834A-7B02AE0759D8}"/>
+                </a:ext>
+              </a:extLst>
+            </p:cNvPr>
+            <p:cNvPicPr>
+              <a:picLocks noChangeAspect="1"/>
+            </p:cNvPicPr>
+            <p:nvPr/>
+          </p:nvPicPr>
+          <p:blipFill>
+            <a:blip r:embed="rId5">
+              <a:extLst>
+                <a:ext uri="{28A0092B-C50C-407E-A947-70E740481C1C}">
+                  <a14:useLocalDpi xmlns:a14="http://schemas.microsoft.com/office/drawing/2010/main" val="0"/>
+                </a:ext>
+              </a:extLst>
+            </a:blip>
+            <a:stretch>
+              <a:fillRect/>
+            </a:stretch>
+          </p:blipFill>
+          <p:spPr>
+            <a:xfrm>
+              <a:off x="9779476" y="11933352"/>
+              <a:ext cx="1834083" cy="917042"/>
+            </a:xfrm>
+            <a:prstGeom prst="rect">
+              <a:avLst/>
+            </a:prstGeom>
+          </p:spPr>
+        </p:pic>
+        <p:cxnSp>
+          <p:nvCxnSpPr>
+            <p:cNvPr id="24" name="Straight Connector 23">
+              <a:extLst>
+                <a:ext uri="{FF2B5EF4-FFF2-40B4-BE49-F238E27FC236}">
+                  <a16:creationId xmlns:a16="http://schemas.microsoft.com/office/drawing/2014/main" id="{69F910E2-88BD-CE09-B520-B2E23EE50AB1}"/>
+                </a:ext>
+              </a:extLst>
+            </p:cNvPr>
+            <p:cNvCxnSpPr/>
+            <p:nvPr/>
+          </p:nvCxnSpPr>
+          <p:spPr>
+            <a:xfrm flipH="1">
+              <a:off x="8817871" y="11325318"/>
+              <a:ext cx="1765738" cy="1525076"/>
+            </a:xfrm>
+            <a:prstGeom prst="line">
+              <a:avLst/>
+            </a:prstGeom>
+            <a:ln w="38100"/>
+          </p:spPr>
+          <p:style>
+            <a:lnRef idx="2">
+              <a:schemeClr val="dk1"/>
+            </a:lnRef>
+            <a:fillRef idx="0">
+              <a:schemeClr val="dk1"/>
+            </a:fillRef>
+            <a:effectRef idx="1">
+              <a:schemeClr val="dk1"/>
+            </a:effectRef>
+            <a:fontRef idx="minor">
+              <a:schemeClr val="tx1"/>
+            </a:fontRef>
+          </p:style>
+        </p:cxnSp>
+      </p:grpSp>
+      <p:cxnSp>
+        <p:nvCxnSpPr>
+          <p:cNvPr id="26" name="Straight Arrow Connector 25">
+            <a:extLst>
+              <a:ext uri="{FF2B5EF4-FFF2-40B4-BE49-F238E27FC236}">
+                <a16:creationId xmlns:a16="http://schemas.microsoft.com/office/drawing/2014/main" id="{43D0CB47-95C9-9287-B513-23AE7CF501B2}"/>
+              </a:ext>
+            </a:extLst>
+          </p:cNvPr>
+          <p:cNvCxnSpPr>
+            <a:cxnSpLocks/>
+          </p:cNvCxnSpPr>
+          <p:nvPr/>
+        </p:nvCxnSpPr>
+        <p:spPr>
+          <a:xfrm>
+            <a:off x="4277935" y="5024762"/>
+            <a:ext cx="0" cy="909510"/>
+          </a:xfrm>
+          <a:prstGeom prst="straightConnector1">
+            <a:avLst/>
+          </a:prstGeom>
+          <a:ln w="76200">
+            <a:tailEnd type="triangle"/>
+          </a:ln>
+        </p:spPr>
+        <p:style>
+          <a:lnRef idx="3">
+            <a:schemeClr val="accent6"/>
+          </a:lnRef>
+          <a:fillRef idx="0">
+            <a:schemeClr val="accent6"/>
+          </a:fillRef>
+          <a:effectRef idx="2">
+            <a:schemeClr val="accent6"/>
+          </a:effectRef>
+          <a:fontRef idx="minor">
+            <a:schemeClr val="tx1"/>
+          </a:fontRef>
+        </p:style>
+      </p:cxnSp>
+      <p:cxnSp>
+        <p:nvCxnSpPr>
+          <p:cNvPr id="32" name="Straight Arrow Connector 31">
+            <a:extLst>
+              <a:ext uri="{FF2B5EF4-FFF2-40B4-BE49-F238E27FC236}">
+                <a16:creationId xmlns:a16="http://schemas.microsoft.com/office/drawing/2014/main" id="{03503602-132C-5126-AC48-8B5C00F51FA5}"/>
+              </a:ext>
+            </a:extLst>
+          </p:cNvPr>
+          <p:cNvCxnSpPr>
+            <a:cxnSpLocks/>
+          </p:cNvCxnSpPr>
+          <p:nvPr/>
+        </p:nvCxnSpPr>
+        <p:spPr>
+          <a:xfrm>
+            <a:off x="7371381" y="10316491"/>
+            <a:ext cx="0" cy="1310589"/>
+          </a:xfrm>
+          <a:prstGeom prst="straightConnector1">
+            <a:avLst/>
+          </a:prstGeom>
+          <a:ln w="76200">
+            <a:tailEnd type="triangle"/>
+          </a:ln>
+        </p:spPr>
+        <p:style>
+          <a:lnRef idx="3">
+            <a:schemeClr val="accent6"/>
+          </a:lnRef>
+          <a:fillRef idx="0">
+            <a:schemeClr val="accent6"/>
+          </a:fillRef>
+          <a:effectRef idx="2">
+            <a:schemeClr val="accent6"/>
+          </a:effectRef>
+          <a:fontRef idx="minor">
+            <a:schemeClr val="tx1"/>
+          </a:fontRef>
+        </p:style>
+      </p:cxnSp>
+      <p:cxnSp>
+        <p:nvCxnSpPr>
+          <p:cNvPr id="43" name="Straight Arrow Connector 42">
+            <a:extLst>
+              <a:ext uri="{FF2B5EF4-FFF2-40B4-BE49-F238E27FC236}">
+                <a16:creationId xmlns:a16="http://schemas.microsoft.com/office/drawing/2014/main" id="{27D1C97E-F6A7-6691-F346-63827B0E733B}"/>
+              </a:ext>
+            </a:extLst>
+          </p:cNvPr>
+          <p:cNvCxnSpPr>
+            <a:cxnSpLocks/>
+          </p:cNvCxnSpPr>
+          <p:nvPr/>
+        </p:nvCxnSpPr>
+        <p:spPr>
+          <a:xfrm>
+            <a:off x="2891186" y="13207680"/>
+            <a:ext cx="0" cy="550214"/>
+          </a:xfrm>
+          <a:prstGeom prst="straightConnector1">
+            <a:avLst/>
+          </a:prstGeom>
+          <a:ln w="76200">
+            <a:tailEnd type="triangle"/>
+          </a:ln>
+        </p:spPr>
+        <p:style>
+          <a:lnRef idx="3">
+            <a:schemeClr val="accent6"/>
+          </a:lnRef>
+          <a:fillRef idx="0">
+            <a:schemeClr val="accent6"/>
+          </a:fillRef>
+          <a:effectRef idx="2">
+            <a:schemeClr val="accent6"/>
+          </a:effectRef>
+          <a:fontRef idx="minor">
+            <a:schemeClr val="tx1"/>
+          </a:fontRef>
+        </p:style>
+      </p:cxnSp>
+      <p:cxnSp>
+        <p:nvCxnSpPr>
+          <p:cNvPr id="44" name="Straight Arrow Connector 43">
+            <a:extLst>
+              <a:ext uri="{FF2B5EF4-FFF2-40B4-BE49-F238E27FC236}">
+                <a16:creationId xmlns:a16="http://schemas.microsoft.com/office/drawing/2014/main" id="{5027E634-66C4-03B1-4E47-DE591C9A779D}"/>
+              </a:ext>
+            </a:extLst>
+          </p:cNvPr>
+          <p:cNvCxnSpPr>
+            <a:cxnSpLocks/>
+          </p:cNvCxnSpPr>
+          <p:nvPr/>
+        </p:nvCxnSpPr>
+        <p:spPr>
+          <a:xfrm>
+            <a:off x="12097033" y="13136759"/>
+            <a:ext cx="0" cy="550214"/>
+          </a:xfrm>
+          <a:prstGeom prst="straightConnector1">
+            <a:avLst/>
+          </a:prstGeom>
+          <a:ln w="76200">
+            <a:tailEnd type="triangle"/>
+          </a:ln>
+        </p:spPr>
+        <p:style>
+          <a:lnRef idx="3">
+            <a:schemeClr val="accent6"/>
+          </a:lnRef>
+          <a:fillRef idx="0">
+            <a:schemeClr val="accent6"/>
+          </a:fillRef>
+          <a:effectRef idx="2">
+            <a:schemeClr val="accent6"/>
+          </a:effectRef>
+          <a:fontRef idx="minor">
+            <a:schemeClr val="tx1"/>
+          </a:fontRef>
+        </p:style>
+      </p:cxnSp>
+      <p:sp>
+        <p:nvSpPr>
+          <p:cNvPr id="48" name="Flowchart: Alternate Process 47">
+            <a:extLst>
+              <a:ext uri="{FF2B5EF4-FFF2-40B4-BE49-F238E27FC236}">
+                <a16:creationId xmlns:a16="http://schemas.microsoft.com/office/drawing/2014/main" id="{48609721-8B1B-69B1-984D-5BB20FDBBDEE}"/>
+              </a:ext>
+            </a:extLst>
+          </p:cNvPr>
+          <p:cNvSpPr/>
+          <p:nvPr/>
+        </p:nvSpPr>
+        <p:spPr>
+          <a:xfrm>
+            <a:off x="9470064" y="7774941"/>
+            <a:ext cx="3904789" cy="846667"/>
+          </a:xfrm>
+          <a:prstGeom prst="flowChartAlternateProcess">
+            <a:avLst/>
+          </a:prstGeom>
+          <a:gradFill flip="none" rotWithShape="1">
+            <a:gsLst>
+              <a:gs pos="0">
+                <a:schemeClr val="accent1">
+                  <a:shade val="30000"/>
+                  <a:satMod val="115000"/>
+                </a:schemeClr>
+              </a:gs>
+              <a:gs pos="50000">
+                <a:schemeClr val="accent1">
+                  <a:shade val="67500"/>
+                  <a:satMod val="115000"/>
+                </a:schemeClr>
+              </a:gs>
+              <a:gs pos="100000">
+                <a:schemeClr val="accent1">
+                  <a:shade val="100000"/>
+                  <a:satMod val="115000"/>
+                </a:schemeClr>
+              </a:gs>
+            </a:gsLst>
+            <a:lin ang="5400000" scaled="1"/>
+            <a:tileRect/>
+          </a:gradFill>
+          <a:ln w="57150">
+            <a:solidFill>
+              <a:schemeClr val="tx1"/>
+            </a:solidFill>
+          </a:ln>
+        </p:spPr>
+        <p:style>
+          <a:lnRef idx="2">
+            <a:schemeClr val="accent1">
+              <a:shade val="15000"/>
+            </a:schemeClr>
+          </a:lnRef>
+          <a:fillRef idx="1">
+            <a:schemeClr val="accent1"/>
+          </a:fillRef>
+          <a:effectRef idx="0">
+            <a:schemeClr val="accent1"/>
+          </a:effectRef>
+          <a:fontRef idx="minor">
+            <a:schemeClr val="lt1"/>
+          </a:fontRef>
+        </p:style>
+        <p:txBody>
+          <a:bodyPr rtlCol="0" anchor="ctr"/>
+          <a:lstStyle/>
+          <a:p>
+            <a:pPr algn="ctr"/>
+            <a:r>
+              <a:rPr lang="en-IE" sz="4000" b="1" dirty="0"/>
+              <a:t>TaskTideEngine</a:t>
+            </a:r>
+          </a:p>
+        </p:txBody>
+      </p:sp>
+      <p:cxnSp>
+        <p:nvCxnSpPr>
+          <p:cNvPr id="49" name="Straight Arrow Connector 48">
+            <a:extLst>
+              <a:ext uri="{FF2B5EF4-FFF2-40B4-BE49-F238E27FC236}">
+                <a16:creationId xmlns:a16="http://schemas.microsoft.com/office/drawing/2014/main" id="{1291F7EB-C9AA-46EE-6925-A606E5C11666}"/>
+              </a:ext>
+            </a:extLst>
+          </p:cNvPr>
+          <p:cNvCxnSpPr>
+            <a:cxnSpLocks/>
+          </p:cNvCxnSpPr>
+          <p:nvPr/>
+        </p:nvCxnSpPr>
+        <p:spPr>
+          <a:xfrm rot="16200000">
+            <a:off x="9212164" y="9619807"/>
+            <a:ext cx="0" cy="518030"/>
+          </a:xfrm>
+          <a:prstGeom prst="straightConnector1">
+            <a:avLst/>
+          </a:prstGeom>
+          <a:ln w="76200">
+            <a:tailEnd type="triangle"/>
+          </a:ln>
+        </p:spPr>
+        <p:style>
+          <a:lnRef idx="3">
+            <a:schemeClr val="accent6"/>
+          </a:lnRef>
+          <a:fillRef idx="0">
+            <a:schemeClr val="accent6"/>
+          </a:fillRef>
+          <a:effectRef idx="2">
+            <a:schemeClr val="accent6"/>
+          </a:effectRef>
+          <a:fontRef idx="minor">
+            <a:schemeClr val="tx1"/>
+          </a:fontRef>
+        </p:style>
+      </p:cxnSp>
+      <p:sp>
+        <p:nvSpPr>
+          <p:cNvPr id="50" name="Flowchart: Alternate Process 49">
+            <a:extLst>
+              <a:ext uri="{FF2B5EF4-FFF2-40B4-BE49-F238E27FC236}">
+                <a16:creationId xmlns:a16="http://schemas.microsoft.com/office/drawing/2014/main" id="{8B86FAB3-9839-C40F-481E-72C28CB9B5B7}"/>
+              </a:ext>
+            </a:extLst>
+          </p:cNvPr>
+          <p:cNvSpPr/>
+          <p:nvPr/>
+        </p:nvSpPr>
+        <p:spPr>
+          <a:xfrm>
+            <a:off x="9508503" y="9420124"/>
+            <a:ext cx="3904789" cy="860826"/>
+          </a:xfrm>
+          <a:prstGeom prst="flowChartAlternateProcess">
+            <a:avLst/>
+          </a:prstGeom>
+          <a:gradFill flip="none" rotWithShape="1">
+            <a:gsLst>
+              <a:gs pos="0">
+                <a:schemeClr val="accent1">
+                  <a:shade val="30000"/>
+                  <a:satMod val="115000"/>
+                </a:schemeClr>
+              </a:gs>
+              <a:gs pos="50000">
+                <a:schemeClr val="accent1">
+                  <a:shade val="67500"/>
+                  <a:satMod val="115000"/>
+                </a:schemeClr>
+              </a:gs>
+              <a:gs pos="100000">
+                <a:schemeClr val="accent1">
+                  <a:shade val="100000"/>
+                  <a:satMod val="115000"/>
+                </a:schemeClr>
+              </a:gs>
+            </a:gsLst>
+            <a:lin ang="5400000" scaled="1"/>
+            <a:tileRect/>
+          </a:gradFill>
+        </p:spPr>
+        <p:style>
+          <a:lnRef idx="2">
+            <a:schemeClr val="accent1">
+              <a:shade val="15000"/>
+            </a:schemeClr>
+          </a:lnRef>
+          <a:fillRef idx="1">
+            <a:schemeClr val="accent1"/>
+          </a:fillRef>
+          <a:effectRef idx="0">
+            <a:schemeClr val="accent1"/>
+          </a:effectRef>
+          <a:fontRef idx="minor">
+            <a:schemeClr val="lt1"/>
+          </a:fontRef>
+        </p:style>
+        <p:txBody>
+          <a:bodyPr rtlCol="0" anchor="ctr"/>
+          <a:lstStyle/>
+          <a:p>
+            <a:pPr algn="ctr"/>
+            <a:r>
+              <a:rPr lang="en-IE" sz="4000" b="1" dirty="0"/>
+              <a:t>TaskTideModel</a:t>
+            </a:r>
+          </a:p>
+        </p:txBody>
+      </p:sp>
+      <p:sp>
+        <p:nvSpPr>
+          <p:cNvPr id="51" name="Flowchart: Alternate Process 50">
+            <a:extLst>
+              <a:ext uri="{FF2B5EF4-FFF2-40B4-BE49-F238E27FC236}">
+                <a16:creationId xmlns:a16="http://schemas.microsoft.com/office/drawing/2014/main" id="{93C3476F-BECE-5A31-EBB9-99B1E6D1940C}"/>
+              </a:ext>
+            </a:extLst>
+          </p:cNvPr>
+          <p:cNvSpPr/>
+          <p:nvPr/>
+        </p:nvSpPr>
+        <p:spPr>
+          <a:xfrm>
+            <a:off x="14534289" y="8379011"/>
+            <a:ext cx="3121717" cy="846667"/>
+          </a:xfrm>
+          <a:prstGeom prst="flowChartAlternateProcess">
+            <a:avLst/>
+          </a:prstGeom>
+          <a:gradFill flip="none" rotWithShape="1">
+            <a:gsLst>
+              <a:gs pos="0">
+                <a:schemeClr val="accent1">
+                  <a:shade val="30000"/>
+                  <a:satMod val="115000"/>
+                </a:schemeClr>
+              </a:gs>
+              <a:gs pos="50000">
+                <a:schemeClr val="accent1">
+                  <a:shade val="67500"/>
+                  <a:satMod val="115000"/>
+                </a:schemeClr>
+              </a:gs>
+              <a:gs pos="100000">
+                <a:schemeClr val="accent1">
+                  <a:shade val="100000"/>
+                  <a:satMod val="115000"/>
+                </a:schemeClr>
+              </a:gs>
+            </a:gsLst>
+            <a:lin ang="5400000" scaled="1"/>
+            <a:tileRect/>
+          </a:gradFill>
+          <a:ln w="57150">
+            <a:solidFill>
+              <a:schemeClr val="tx1"/>
+            </a:solidFill>
+          </a:ln>
+        </p:spPr>
+        <p:style>
+          <a:lnRef idx="2">
+            <a:schemeClr val="accent1">
+              <a:shade val="15000"/>
+            </a:schemeClr>
+          </a:lnRef>
+          <a:fillRef idx="1">
+            <a:schemeClr val="accent1"/>
+          </a:fillRef>
+          <a:effectRef idx="0">
+            <a:schemeClr val="accent1"/>
+          </a:effectRef>
+          <a:fontRef idx="minor">
+            <a:schemeClr val="lt1"/>
+          </a:fontRef>
+        </p:style>
+        <p:txBody>
+          <a:bodyPr rtlCol="0" anchor="ctr"/>
+          <a:lstStyle/>
+          <a:p>
+            <a:pPr algn="ctr"/>
+            <a:r>
+              <a:rPr lang="en-IE" sz="3200" b="1" dirty="0"/>
+              <a:t>Workflow</a:t>
+            </a:r>
+          </a:p>
+        </p:txBody>
+      </p:sp>
+      <p:sp>
+        <p:nvSpPr>
+          <p:cNvPr id="52" name="Flowchart: Alternate Process 51">
+            <a:extLst>
+              <a:ext uri="{FF2B5EF4-FFF2-40B4-BE49-F238E27FC236}">
+                <a16:creationId xmlns:a16="http://schemas.microsoft.com/office/drawing/2014/main" id="{6D5BD79C-6023-5DD8-A46C-0D202E17ADC3}"/>
+              </a:ext>
+            </a:extLst>
+          </p:cNvPr>
+          <p:cNvSpPr/>
+          <p:nvPr/>
+        </p:nvSpPr>
+        <p:spPr>
+          <a:xfrm>
+            <a:off x="14532171" y="9469824"/>
+            <a:ext cx="3121717" cy="846667"/>
+          </a:xfrm>
+          <a:prstGeom prst="flowChartAlternateProcess">
+            <a:avLst/>
+          </a:prstGeom>
+          <a:gradFill flip="none" rotWithShape="1">
+            <a:gsLst>
+              <a:gs pos="0">
+                <a:schemeClr val="accent1">
+                  <a:shade val="30000"/>
+                  <a:satMod val="115000"/>
+                </a:schemeClr>
+              </a:gs>
+              <a:gs pos="50000">
+                <a:schemeClr val="accent1">
+                  <a:shade val="67500"/>
+                  <a:satMod val="115000"/>
+                </a:schemeClr>
+              </a:gs>
+              <a:gs pos="100000">
+                <a:schemeClr val="accent1">
+                  <a:shade val="100000"/>
+                  <a:satMod val="115000"/>
+                </a:schemeClr>
+              </a:gs>
+            </a:gsLst>
+            <a:lin ang="5400000" scaled="1"/>
+            <a:tileRect/>
+          </a:gradFill>
+          <a:ln w="57150">
+            <a:solidFill>
+              <a:schemeClr val="tx1"/>
+            </a:solidFill>
+          </a:ln>
+        </p:spPr>
+        <p:style>
+          <a:lnRef idx="2">
+            <a:schemeClr val="accent1">
+              <a:shade val="15000"/>
+            </a:schemeClr>
+          </a:lnRef>
+          <a:fillRef idx="1">
+            <a:schemeClr val="accent1"/>
+          </a:fillRef>
+          <a:effectRef idx="0">
+            <a:schemeClr val="accent1"/>
+          </a:effectRef>
+          <a:fontRef idx="minor">
+            <a:schemeClr val="lt1"/>
+          </a:fontRef>
+        </p:style>
+        <p:txBody>
+          <a:bodyPr rtlCol="0" anchor="ctr"/>
+          <a:lstStyle/>
+          <a:p>
+            <a:pPr algn="ctr"/>
+            <a:r>
+              <a:rPr lang="en-IE" sz="3200" b="1" dirty="0"/>
+              <a:t>Step</a:t>
+            </a:r>
+          </a:p>
+        </p:txBody>
+      </p:sp>
+      <p:sp>
+        <p:nvSpPr>
+          <p:cNvPr id="53" name="Flowchart: Alternate Process 52">
+            <a:extLst>
+              <a:ext uri="{FF2B5EF4-FFF2-40B4-BE49-F238E27FC236}">
+                <a16:creationId xmlns:a16="http://schemas.microsoft.com/office/drawing/2014/main" id="{B0AF4BAB-8A23-C95C-6BC3-FB64F87E4C32}"/>
+              </a:ext>
+            </a:extLst>
+          </p:cNvPr>
+          <p:cNvSpPr/>
+          <p:nvPr/>
+        </p:nvSpPr>
+        <p:spPr>
+          <a:xfrm>
+            <a:off x="14519301" y="10539441"/>
+            <a:ext cx="3121717" cy="846667"/>
+          </a:xfrm>
+          <a:prstGeom prst="flowChartAlternateProcess">
+            <a:avLst/>
+          </a:prstGeom>
+          <a:gradFill flip="none" rotWithShape="1">
+            <a:gsLst>
+              <a:gs pos="0">
+                <a:schemeClr val="accent1">
+                  <a:shade val="30000"/>
+                  <a:satMod val="115000"/>
+                </a:schemeClr>
+              </a:gs>
+              <a:gs pos="50000">
+                <a:schemeClr val="accent1">
+                  <a:shade val="67500"/>
+                  <a:satMod val="115000"/>
+                </a:schemeClr>
+              </a:gs>
+              <a:gs pos="100000">
+                <a:schemeClr val="accent1">
+                  <a:shade val="100000"/>
+                  <a:satMod val="115000"/>
+                </a:schemeClr>
+              </a:gs>
+            </a:gsLst>
+            <a:lin ang="5400000" scaled="1"/>
+            <a:tileRect/>
+          </a:gradFill>
+          <a:ln w="57150">
+            <a:solidFill>
+              <a:schemeClr val="tx1"/>
+            </a:solidFill>
+          </a:ln>
+        </p:spPr>
+        <p:style>
+          <a:lnRef idx="2">
+            <a:schemeClr val="accent1">
+              <a:shade val="15000"/>
+            </a:schemeClr>
+          </a:lnRef>
+          <a:fillRef idx="1">
+            <a:schemeClr val="accent1"/>
+          </a:fillRef>
+          <a:effectRef idx="0">
+            <a:schemeClr val="accent1"/>
+          </a:effectRef>
+          <a:fontRef idx="minor">
+            <a:schemeClr val="lt1"/>
+          </a:fontRef>
+        </p:style>
+        <p:txBody>
+          <a:bodyPr rtlCol="0" anchor="ctr"/>
+          <a:lstStyle/>
+          <a:p>
+            <a:pPr algn="ctr"/>
+            <a:r>
+              <a:rPr lang="en-IE" sz="3200" b="1" dirty="0"/>
+              <a:t>WorkItem</a:t>
+            </a:r>
+          </a:p>
+        </p:txBody>
+      </p:sp>
+      <p:cxnSp>
+        <p:nvCxnSpPr>
+          <p:cNvPr id="55" name="Straight Arrow Connector 54">
+            <a:extLst>
+              <a:ext uri="{FF2B5EF4-FFF2-40B4-BE49-F238E27FC236}">
+                <a16:creationId xmlns:a16="http://schemas.microsoft.com/office/drawing/2014/main" id="{64076E49-55B1-A2B0-BEFA-D6A05A2329E8}"/>
+              </a:ext>
+            </a:extLst>
+          </p:cNvPr>
+          <p:cNvCxnSpPr>
+            <a:cxnSpLocks/>
+          </p:cNvCxnSpPr>
+          <p:nvPr/>
+        </p:nvCxnSpPr>
+        <p:spPr>
+          <a:xfrm>
+            <a:off x="8359074" y="5041854"/>
+            <a:ext cx="0" cy="909510"/>
+          </a:xfrm>
+          <a:prstGeom prst="straightConnector1">
+            <a:avLst/>
+          </a:prstGeom>
+          <a:ln w="76200">
+            <a:tailEnd type="triangle"/>
+          </a:ln>
+        </p:spPr>
+        <p:style>
+          <a:lnRef idx="3">
+            <a:schemeClr val="accent6"/>
+          </a:lnRef>
+          <a:fillRef idx="0">
+            <a:schemeClr val="accent6"/>
+          </a:fillRef>
+          <a:effectRef idx="2">
+            <a:schemeClr val="accent6"/>
+          </a:effectRef>
+          <a:fontRef idx="minor">
+            <a:schemeClr val="tx1"/>
+          </a:fontRef>
+        </p:style>
+      </p:cxnSp>
+      <p:cxnSp>
+        <p:nvCxnSpPr>
+          <p:cNvPr id="56" name="Straight Arrow Connector 55">
+            <a:extLst>
+              <a:ext uri="{FF2B5EF4-FFF2-40B4-BE49-F238E27FC236}">
+                <a16:creationId xmlns:a16="http://schemas.microsoft.com/office/drawing/2014/main" id="{9B5D0FB4-8766-54ED-E1E9-22B3DD32B981}"/>
+              </a:ext>
+            </a:extLst>
+          </p:cNvPr>
+          <p:cNvCxnSpPr>
+            <a:cxnSpLocks/>
+          </p:cNvCxnSpPr>
+          <p:nvPr/>
+        </p:nvCxnSpPr>
+        <p:spPr>
+          <a:xfrm>
+            <a:off x="4277935" y="6981843"/>
+            <a:ext cx="0" cy="662236"/>
+          </a:xfrm>
+          <a:prstGeom prst="straightConnector1">
+            <a:avLst/>
+          </a:prstGeom>
+          <a:ln w="76200">
+            <a:tailEnd type="triangle"/>
+          </a:ln>
+        </p:spPr>
+        <p:style>
+          <a:lnRef idx="3">
+            <a:schemeClr val="accent6"/>
+          </a:lnRef>
+          <a:fillRef idx="0">
+            <a:schemeClr val="accent6"/>
+          </a:fillRef>
+          <a:effectRef idx="2">
+            <a:schemeClr val="accent6"/>
+          </a:effectRef>
+          <a:fontRef idx="minor">
+            <a:schemeClr val="tx1"/>
+          </a:fontRef>
+        </p:style>
+      </p:cxnSp>
+      <p:cxnSp>
+        <p:nvCxnSpPr>
+          <p:cNvPr id="58" name="Straight Arrow Connector 57">
+            <a:extLst>
+              <a:ext uri="{FF2B5EF4-FFF2-40B4-BE49-F238E27FC236}">
+                <a16:creationId xmlns:a16="http://schemas.microsoft.com/office/drawing/2014/main" id="{AEBCAA57-D7A6-1D1B-285B-726ADA57EB72}"/>
+              </a:ext>
+            </a:extLst>
+          </p:cNvPr>
+          <p:cNvCxnSpPr>
+            <a:cxnSpLocks/>
+          </p:cNvCxnSpPr>
+          <p:nvPr/>
+        </p:nvCxnSpPr>
+        <p:spPr>
+          <a:xfrm>
+            <a:off x="8405177" y="7022277"/>
+            <a:ext cx="0" cy="662236"/>
+          </a:xfrm>
+          <a:prstGeom prst="straightConnector1">
+            <a:avLst/>
+          </a:prstGeom>
+          <a:ln w="76200">
+            <a:tailEnd type="triangle"/>
+          </a:ln>
+        </p:spPr>
+        <p:style>
+          <a:lnRef idx="3">
+            <a:schemeClr val="accent6"/>
+          </a:lnRef>
+          <a:fillRef idx="0">
+            <a:schemeClr val="accent6"/>
+          </a:fillRef>
+          <a:effectRef idx="2">
+            <a:schemeClr val="accent6"/>
+          </a:effectRef>
+          <a:fontRef idx="minor">
+            <a:schemeClr val="tx1"/>
+          </a:fontRef>
+        </p:style>
+      </p:cxnSp>
+      <p:cxnSp>
+        <p:nvCxnSpPr>
+          <p:cNvPr id="59" name="Straight Arrow Connector 58">
+            <a:extLst>
+              <a:ext uri="{FF2B5EF4-FFF2-40B4-BE49-F238E27FC236}">
+                <a16:creationId xmlns:a16="http://schemas.microsoft.com/office/drawing/2014/main" id="{0F58DA43-F38B-0B4A-C3B4-BB4B0A4E9EE2}"/>
+              </a:ext>
+            </a:extLst>
+          </p:cNvPr>
+          <p:cNvCxnSpPr>
+            <a:cxnSpLocks/>
+          </p:cNvCxnSpPr>
+          <p:nvPr/>
+        </p:nvCxnSpPr>
+        <p:spPr>
+          <a:xfrm>
+            <a:off x="6240474" y="8739227"/>
+            <a:ext cx="0" cy="662236"/>
+          </a:xfrm>
+          <a:prstGeom prst="straightConnector1">
+            <a:avLst/>
+          </a:prstGeom>
+          <a:ln w="76200">
+            <a:tailEnd type="triangle"/>
+          </a:ln>
+        </p:spPr>
+        <p:style>
+          <a:lnRef idx="3">
+            <a:schemeClr val="accent6"/>
+          </a:lnRef>
+          <a:fillRef idx="0">
+            <a:schemeClr val="accent6"/>
+          </a:fillRef>
+          <a:effectRef idx="2">
+            <a:schemeClr val="accent6"/>
+          </a:effectRef>
+          <a:fontRef idx="minor">
+            <a:schemeClr val="tx1"/>
+          </a:fontRef>
+        </p:style>
+      </p:cxnSp>
+      <p:cxnSp>
+        <p:nvCxnSpPr>
+          <p:cNvPr id="60" name="Straight Arrow Connector 59">
+            <a:extLst>
+              <a:ext uri="{FF2B5EF4-FFF2-40B4-BE49-F238E27FC236}">
+                <a16:creationId xmlns:a16="http://schemas.microsoft.com/office/drawing/2014/main" id="{AF4A330A-7534-79EC-F357-B91BEED4D649}"/>
+              </a:ext>
+            </a:extLst>
+          </p:cNvPr>
+          <p:cNvCxnSpPr>
+            <a:cxnSpLocks/>
+          </p:cNvCxnSpPr>
+          <p:nvPr/>
+        </p:nvCxnSpPr>
+        <p:spPr>
+          <a:xfrm rot="16200000">
+            <a:off x="9245002" y="7957089"/>
+            <a:ext cx="0" cy="518030"/>
+          </a:xfrm>
+          <a:prstGeom prst="straightConnector1">
+            <a:avLst/>
+          </a:prstGeom>
+          <a:ln w="76200">
+            <a:tailEnd type="triangle"/>
+          </a:ln>
+        </p:spPr>
+        <p:style>
+          <a:lnRef idx="3">
+            <a:schemeClr val="accent6"/>
+          </a:lnRef>
+          <a:fillRef idx="0">
+            <a:schemeClr val="accent6"/>
+          </a:fillRef>
+          <a:effectRef idx="2">
+            <a:schemeClr val="accent6"/>
+          </a:effectRef>
+          <a:fontRef idx="minor">
+            <a:schemeClr val="tx1"/>
+          </a:fontRef>
+        </p:style>
+      </p:cxnSp>
+      <p:cxnSp>
+        <p:nvCxnSpPr>
+          <p:cNvPr id="61" name="Straight Arrow Connector 60">
+            <a:extLst>
+              <a:ext uri="{FF2B5EF4-FFF2-40B4-BE49-F238E27FC236}">
+                <a16:creationId xmlns:a16="http://schemas.microsoft.com/office/drawing/2014/main" id="{85DEC262-1AE3-204D-EB04-7473F4578BE5}"/>
+              </a:ext>
+            </a:extLst>
+          </p:cNvPr>
+          <p:cNvCxnSpPr>
+            <a:cxnSpLocks/>
+          </p:cNvCxnSpPr>
+          <p:nvPr/>
+        </p:nvCxnSpPr>
+        <p:spPr>
+          <a:xfrm>
+            <a:off x="13492023" y="9897480"/>
+            <a:ext cx="1064600" cy="14338"/>
+          </a:xfrm>
+          <a:prstGeom prst="straightConnector1">
+            <a:avLst/>
+          </a:prstGeom>
+          <a:ln w="76200">
+            <a:tailEnd type="triangle"/>
+          </a:ln>
+        </p:spPr>
+        <p:style>
+          <a:lnRef idx="3">
+            <a:schemeClr val="accent6"/>
+          </a:lnRef>
+          <a:fillRef idx="0">
+            <a:schemeClr val="accent6"/>
+          </a:fillRef>
+          <a:effectRef idx="2">
+            <a:schemeClr val="accent6"/>
+          </a:effectRef>
+          <a:fontRef idx="minor">
+            <a:schemeClr val="tx1"/>
+          </a:fontRef>
+        </p:style>
+      </p:cxnSp>
+      <p:cxnSp>
+        <p:nvCxnSpPr>
+          <p:cNvPr id="63" name="Straight Arrow Connector 62">
+            <a:extLst>
+              <a:ext uri="{FF2B5EF4-FFF2-40B4-BE49-F238E27FC236}">
+                <a16:creationId xmlns:a16="http://schemas.microsoft.com/office/drawing/2014/main" id="{732FD0A3-1DCF-0EEE-3198-2E002B0C1CF2}"/>
+              </a:ext>
+            </a:extLst>
+          </p:cNvPr>
+          <p:cNvCxnSpPr>
+            <a:cxnSpLocks/>
+          </p:cNvCxnSpPr>
+          <p:nvPr/>
+        </p:nvCxnSpPr>
+        <p:spPr>
+          <a:xfrm flipV="1">
+            <a:off x="13412175" y="8938727"/>
+            <a:ext cx="1012951" cy="984185"/>
+          </a:xfrm>
+          <a:prstGeom prst="straightConnector1">
+            <a:avLst/>
+          </a:prstGeom>
+          <a:ln w="76200">
+            <a:tailEnd type="triangle"/>
+          </a:ln>
+        </p:spPr>
+        <p:style>
+          <a:lnRef idx="3">
+            <a:schemeClr val="accent6"/>
+          </a:lnRef>
+          <a:fillRef idx="0">
+            <a:schemeClr val="accent6"/>
+          </a:fillRef>
+          <a:effectRef idx="2">
+            <a:schemeClr val="accent6"/>
+          </a:effectRef>
+          <a:fontRef idx="minor">
+            <a:schemeClr val="tx1"/>
+          </a:fontRef>
+        </p:style>
+      </p:cxnSp>
+      <p:cxnSp>
+        <p:nvCxnSpPr>
+          <p:cNvPr id="65" name="Straight Arrow Connector 64">
+            <a:extLst>
+              <a:ext uri="{FF2B5EF4-FFF2-40B4-BE49-F238E27FC236}">
+                <a16:creationId xmlns:a16="http://schemas.microsoft.com/office/drawing/2014/main" id="{ABBF4229-DE4C-521E-83D4-B150C1247918}"/>
+              </a:ext>
+            </a:extLst>
+          </p:cNvPr>
+          <p:cNvCxnSpPr>
+            <a:cxnSpLocks/>
+          </p:cNvCxnSpPr>
+          <p:nvPr/>
+        </p:nvCxnSpPr>
+        <p:spPr>
+          <a:xfrm rot="5400000" flipV="1">
+            <a:off x="13452609" y="9930881"/>
+            <a:ext cx="1012951" cy="984185"/>
+          </a:xfrm>
+          <a:prstGeom prst="straightConnector1">
+            <a:avLst/>
+          </a:prstGeom>
+          <a:ln w="76200">
+            <a:tailEnd type="triangle"/>
+          </a:ln>
+        </p:spPr>
+        <p:style>
+          <a:lnRef idx="3">
+            <a:schemeClr val="accent6"/>
+          </a:lnRef>
+          <a:fillRef idx="0">
+            <a:schemeClr val="accent6"/>
+          </a:fillRef>
+          <a:effectRef idx="2">
+            <a:schemeClr val="accent6"/>
+          </a:effectRef>
+          <a:fontRef idx="minor">
+            <a:schemeClr val="tx1"/>
+          </a:fontRef>
+        </p:style>
+      </p:cxnSp>
+      <p:cxnSp>
+        <p:nvCxnSpPr>
+          <p:cNvPr id="66" name="Straight Arrow Connector 65">
+            <a:extLst>
+              <a:ext uri="{FF2B5EF4-FFF2-40B4-BE49-F238E27FC236}">
+                <a16:creationId xmlns:a16="http://schemas.microsoft.com/office/drawing/2014/main" id="{AC0456FA-F655-8574-5ED7-E37812288102}"/>
+              </a:ext>
+            </a:extLst>
+          </p:cNvPr>
+          <p:cNvCxnSpPr>
+            <a:cxnSpLocks/>
+          </p:cNvCxnSpPr>
+          <p:nvPr/>
+        </p:nvCxnSpPr>
+        <p:spPr>
+          <a:xfrm flipH="1">
+            <a:off x="4277935" y="10316491"/>
+            <a:ext cx="194" cy="1973601"/>
+          </a:xfrm>
+          <a:prstGeom prst="straightConnector1">
+            <a:avLst/>
+          </a:prstGeom>
+          <a:ln w="76200">
+            <a:tailEnd type="triangle"/>
+          </a:ln>
+        </p:spPr>
+        <p:style>
+          <a:lnRef idx="3">
+            <a:schemeClr val="accent6"/>
+          </a:lnRef>
+          <a:fillRef idx="0">
+            <a:schemeClr val="accent6"/>
+          </a:fillRef>
+          <a:effectRef idx="2">
+            <a:schemeClr val="accent6"/>
+          </a:effectRef>
+          <a:fontRef idx="minor">
+            <a:schemeClr val="tx1"/>
+          </a:fontRef>
+        </p:style>
+      </p:cxnSp>
+      <p:cxnSp>
+        <p:nvCxnSpPr>
+          <p:cNvPr id="68" name="Straight Arrow Connector 67">
+            <a:extLst>
+              <a:ext uri="{FF2B5EF4-FFF2-40B4-BE49-F238E27FC236}">
+                <a16:creationId xmlns:a16="http://schemas.microsoft.com/office/drawing/2014/main" id="{CD1BE198-26FE-5274-F102-FE3EBDC0655C}"/>
+              </a:ext>
+            </a:extLst>
+          </p:cNvPr>
+          <p:cNvCxnSpPr>
+            <a:cxnSpLocks/>
+            <a:endCxn id="13" idx="0"/>
+          </p:cNvCxnSpPr>
+          <p:nvPr/>
+        </p:nvCxnSpPr>
+        <p:spPr>
+          <a:xfrm>
+            <a:off x="8908177" y="10240514"/>
+            <a:ext cx="3261614" cy="2010640"/>
+          </a:xfrm>
+          <a:prstGeom prst="straightConnector1">
+            <a:avLst/>
+          </a:prstGeom>
+          <a:ln w="76200">
+            <a:tailEnd type="triangle"/>
+          </a:ln>
+        </p:spPr>
+        <p:style>
+          <a:lnRef idx="3">
+            <a:schemeClr val="accent6"/>
+          </a:lnRef>
+          <a:fillRef idx="0">
+            <a:schemeClr val="accent6"/>
+          </a:fillRef>
+          <a:effectRef idx="2">
+            <a:schemeClr val="accent6"/>
+          </a:effectRef>
+          <a:fontRef idx="minor">
+            <a:schemeClr val="tx1"/>
+          </a:fontRef>
+        </p:style>
+      </p:cxnSp>
+      <p:cxnSp>
+        <p:nvCxnSpPr>
+          <p:cNvPr id="2" name="Straight Arrow Connector 1">
+            <a:extLst>
+              <a:ext uri="{FF2B5EF4-FFF2-40B4-BE49-F238E27FC236}">
+                <a16:creationId xmlns:a16="http://schemas.microsoft.com/office/drawing/2014/main" id="{DD7FEEE1-2571-A927-F403-D3F4FACDFA4F}"/>
+              </a:ext>
+            </a:extLst>
+          </p:cNvPr>
+          <p:cNvCxnSpPr>
+            <a:cxnSpLocks/>
+          </p:cNvCxnSpPr>
+          <p:nvPr/>
+        </p:nvCxnSpPr>
+        <p:spPr>
+          <a:xfrm>
+            <a:off x="7390042" y="12574705"/>
+            <a:ext cx="0" cy="1093607"/>
+          </a:xfrm>
+          <a:prstGeom prst="straightConnector1">
+            <a:avLst/>
+          </a:prstGeom>
+          <a:ln w="76200">
+            <a:tailEnd type="triangle"/>
+          </a:ln>
+        </p:spPr>
+        <p:style>
+          <a:lnRef idx="3">
+            <a:schemeClr val="accent6"/>
+          </a:lnRef>
+          <a:fillRef idx="0">
+            <a:schemeClr val="accent6"/>
+          </a:fillRef>
+          <a:effectRef idx="2">
+            <a:schemeClr val="accent6"/>
+          </a:effectRef>
+          <a:fontRef idx="minor">
+            <a:schemeClr val="tx1"/>
+          </a:fontRef>
+        </p:style>
+      </p:cxnSp>
+      <p:pic>
+        <p:nvPicPr>
+          <p:cNvPr id="6" name="Picture 5" descr="A close-up of a logo&#10;&#10;AI-generated content may be incorrect.">
+            <a:extLst>
+              <a:ext uri="{FF2B5EF4-FFF2-40B4-BE49-F238E27FC236}">
+                <a16:creationId xmlns:a16="http://schemas.microsoft.com/office/drawing/2014/main" id="{06C3043E-52E1-11EF-906B-59D487C0724F}"/>
+              </a:ext>
+            </a:extLst>
+          </p:cNvPr>
+          <p:cNvPicPr>
+            <a:picLocks noChangeAspect="1"/>
+          </p:cNvPicPr>
+          <p:nvPr/>
+        </p:nvPicPr>
+        <p:blipFill>
+          <a:blip r:embed="rId6">
+            <a:extLst>
+              <a:ext uri="{28A0092B-C50C-407E-A947-70E740481C1C}">
+                <a14:useLocalDpi xmlns:a14="http://schemas.microsoft.com/office/drawing/2010/main" val="0"/>
+              </a:ext>
+            </a:extLst>
+          </a:blip>
+          <a:stretch>
+            <a:fillRect/>
+          </a:stretch>
+        </p:blipFill>
+        <p:spPr>
+          <a:xfrm>
+            <a:off x="6037174" y="13766430"/>
+            <a:ext cx="2876550" cy="1590675"/>
+          </a:xfrm>
+          <a:prstGeom prst="rect">
+            <a:avLst/>
+          </a:prstGeom>
+        </p:spPr>
+      </p:pic>
+    </p:spTree>
+    <p:extLst>
+      <p:ext uri="{BB962C8B-B14F-4D97-AF65-F5344CB8AC3E}">
+        <p14:creationId xmlns:p14="http://schemas.microsoft.com/office/powerpoint/2010/main" val="3965816641"/>
+      </p:ext>
+    </p:extLst>
+  </p:cSld>
+  <p:clrMapOvr>
+    <a:masterClrMapping/>
+  </p:clrMapOvr>
+</p:sld>
+</file>
+
+<file path=ppt/slides/slide3.xml><?xml version="1.0" encoding="utf-8"?>
 <p:sld xmlns:a="http://schemas.openxmlformats.org/drawingml/2006/main" xmlns:r="http://schemas.openxmlformats.org/officeDocument/2006/relationships" xmlns:p="http://schemas.openxmlformats.org/presentationml/2006/main">
   <p:cSld>
     <p:spTree>

</xml_diff>

<commit_message>
Use Cases + Paper Docs
i). Adds RSpark-RAPIDS grayscaling application
ii). Adds R application installation to PS1 installer
iii). Figure adjustments
iv). Renames Julia use case
</commit_message>
<xml_diff>
--- a/tasktide/docs/Diagrams/Diagrams.pptx
+++ b/tasktide/docs/Diagrams/Diagrams.pptx
@@ -6,10 +6,11 @@
   </p:sldMasterIdLst>
   <p:sldIdLst>
     <p:sldId id="259" r:id="rId2"/>
-    <p:sldId id="260" r:id="rId3"/>
-    <p:sldId id="261" r:id="rId4"/>
-    <p:sldId id="258" r:id="rId5"/>
-    <p:sldId id="256" r:id="rId6"/>
+    <p:sldId id="262" r:id="rId3"/>
+    <p:sldId id="260" r:id="rId4"/>
+    <p:sldId id="261" r:id="rId5"/>
+    <p:sldId id="258" r:id="rId6"/>
+    <p:sldId id="256" r:id="rId7"/>
   </p:sldIdLst>
   <p:sldSz cx="18000663" cy="16200438"/>
   <p:notesSz cx="6858000" cy="9144000"/>
@@ -1039,7 +1040,7 @@
 <dgm:dataModel xmlns:dgm="http://schemas.openxmlformats.org/drawingml/2006/diagram" xmlns:a="http://schemas.openxmlformats.org/drawingml/2006/main">
   <dgm:ptLst>
     <dgm:pt modelId="{AD77AFE8-5B80-4FD9-ACBE-C7D752115AD9}" type="doc">
-      <dgm:prSet loTypeId="urn:microsoft.com/office/officeart/2009/layout/CircleArrowProcess" loCatId="cycle" qsTypeId="urn:microsoft.com/office/officeart/2005/8/quickstyle/simple1" qsCatId="simple" csTypeId="urn:microsoft.com/office/officeart/2005/8/colors/colorful1" csCatId="colorful" phldr="1"/>
+      <dgm:prSet loTypeId="urn:microsoft.com/office/officeart/2009/layout/CircleArrowProcess" loCatId="cycle" qsTypeId="urn:microsoft.com/office/officeart/2005/8/quickstyle/3d1" qsCatId="3D" csTypeId="urn:microsoft.com/office/officeart/2005/8/colors/colorful1" csCatId="colorful" phldr="1"/>
       <dgm:spPr/>
       <dgm:t>
         <a:bodyPr/>
@@ -1267,8 +1268,8 @@
       </dsp:nvSpPr>
       <dsp:spPr>
         <a:xfrm>
-          <a:off x="2968998" y="0"/>
-          <a:ext cx="3679265" cy="3679824"/>
+          <a:off x="3312283" y="0"/>
+          <a:ext cx="4444852" cy="4445529"/>
         </a:xfrm>
         <a:prstGeom prst="circularArrow">
           <a:avLst>
@@ -1279,36 +1280,65 @@
             <a:gd name="adj5" fmla="val 12500"/>
           </a:avLst>
         </a:prstGeom>
-        <a:solidFill>
-          <a:schemeClr val="accent2">
-            <a:hueOff val="0"/>
-            <a:satOff val="0"/>
-            <a:lumOff val="0"/>
-            <a:alphaOff val="0"/>
-          </a:schemeClr>
-        </a:solidFill>
-        <a:ln w="19050" cap="flat" cmpd="sng" algn="ctr">
-          <a:solidFill>
-            <a:schemeClr val="lt1">
-              <a:hueOff val="0"/>
-              <a:satOff val="0"/>
-              <a:lumOff val="0"/>
-              <a:alphaOff val="0"/>
-            </a:schemeClr>
-          </a:solidFill>
-          <a:prstDash val="solid"/>
-          <a:miter lim="800000"/>
+        <a:gradFill rotWithShape="0">
+          <a:gsLst>
+            <a:gs pos="0">
+              <a:schemeClr val="accent2">
+                <a:hueOff val="0"/>
+                <a:satOff val="0"/>
+                <a:lumOff val="0"/>
+                <a:alphaOff val="0"/>
+                <a:satMod val="103000"/>
+                <a:lumMod val="102000"/>
+                <a:tint val="94000"/>
+              </a:schemeClr>
+            </a:gs>
+            <a:gs pos="50000">
+              <a:schemeClr val="accent2">
+                <a:hueOff val="0"/>
+                <a:satOff val="0"/>
+                <a:lumOff val="0"/>
+                <a:alphaOff val="0"/>
+                <a:satMod val="110000"/>
+                <a:lumMod val="100000"/>
+                <a:shade val="100000"/>
+              </a:schemeClr>
+            </a:gs>
+            <a:gs pos="100000">
+              <a:schemeClr val="accent2">
+                <a:hueOff val="0"/>
+                <a:satOff val="0"/>
+                <a:lumOff val="0"/>
+                <a:alphaOff val="0"/>
+                <a:lumMod val="99000"/>
+                <a:satMod val="120000"/>
+                <a:shade val="78000"/>
+              </a:schemeClr>
+            </a:gs>
+          </a:gsLst>
+          <a:lin ang="5400000" scaled="0"/>
+        </a:gradFill>
+        <a:ln>
+          <a:noFill/>
         </a:ln>
         <a:effectLst/>
+        <a:scene3d>
+          <a:camera prst="orthographicFront"/>
+          <a:lightRig rig="flat" dir="t"/>
+        </a:scene3d>
+        <a:sp3d prstMaterial="plastic">
+          <a:bevelT w="120900" h="88900"/>
+          <a:bevelB w="88900" h="31750" prst="angle"/>
+        </a:sp3d>
       </dsp:spPr>
       <dsp:style>
-        <a:lnRef idx="2">
+        <a:lnRef idx="0">
           <a:scrgbClr r="0" g="0" b="0"/>
         </a:lnRef>
-        <a:fillRef idx="1">
+        <a:fillRef idx="3">
           <a:scrgbClr r="0" g="0" b="0"/>
         </a:fillRef>
-        <a:effectRef idx="0">
+        <a:effectRef idx="2">
           <a:scrgbClr r="0" g="0" b="0"/>
         </a:effectRef>
         <a:fontRef idx="minor">
@@ -1323,8 +1353,8 @@
       </dsp:nvSpPr>
       <dsp:spPr>
         <a:xfrm>
-          <a:off x="3782237" y="1328528"/>
-          <a:ext cx="2044496" cy="1022003"/>
+          <a:off x="4294742" y="1604970"/>
+          <a:ext cx="2469919" cy="1234664"/>
         </a:xfrm>
         <a:prstGeom prst="rect">
           <a:avLst/>
@@ -1373,8 +1403,8 @@
         </a:p>
       </dsp:txBody>
       <dsp:txXfrm>
-        <a:off x="3782237" y="1328528"/>
-        <a:ext cx="2044496" cy="1022003"/>
+        <a:off x="4294742" y="1604970"/>
+        <a:ext cx="2469919" cy="1234664"/>
       </dsp:txXfrm>
     </dsp:sp>
     <dsp:sp modelId="{668DC389-6720-4236-8011-BFAB07D2AE6E}">
@@ -1384,8 +1414,8 @@
       </dsp:nvSpPr>
       <dsp:spPr>
         <a:xfrm>
-          <a:off x="1947096" y="2114332"/>
-          <a:ext cx="3679265" cy="3679824"/>
+          <a:off x="2077741" y="2554286"/>
+          <a:ext cx="4444852" cy="4445529"/>
         </a:xfrm>
         <a:prstGeom prst="leftCircularArrow">
           <a:avLst>
@@ -1396,36 +1426,65 @@
             <a:gd name="adj5" fmla="val 12500"/>
           </a:avLst>
         </a:prstGeom>
-        <a:solidFill>
-          <a:schemeClr val="accent3">
-            <a:hueOff val="0"/>
-            <a:satOff val="0"/>
-            <a:lumOff val="0"/>
-            <a:alphaOff val="0"/>
-          </a:schemeClr>
-        </a:solidFill>
-        <a:ln w="19050" cap="flat" cmpd="sng" algn="ctr">
-          <a:solidFill>
-            <a:schemeClr val="lt1">
-              <a:hueOff val="0"/>
-              <a:satOff val="0"/>
-              <a:lumOff val="0"/>
-              <a:alphaOff val="0"/>
-            </a:schemeClr>
-          </a:solidFill>
-          <a:prstDash val="solid"/>
-          <a:miter lim="800000"/>
+        <a:gradFill rotWithShape="0">
+          <a:gsLst>
+            <a:gs pos="0">
+              <a:schemeClr val="accent3">
+                <a:hueOff val="0"/>
+                <a:satOff val="0"/>
+                <a:lumOff val="0"/>
+                <a:alphaOff val="0"/>
+                <a:satMod val="103000"/>
+                <a:lumMod val="102000"/>
+                <a:tint val="94000"/>
+              </a:schemeClr>
+            </a:gs>
+            <a:gs pos="50000">
+              <a:schemeClr val="accent3">
+                <a:hueOff val="0"/>
+                <a:satOff val="0"/>
+                <a:lumOff val="0"/>
+                <a:alphaOff val="0"/>
+                <a:satMod val="110000"/>
+                <a:lumMod val="100000"/>
+                <a:shade val="100000"/>
+              </a:schemeClr>
+            </a:gs>
+            <a:gs pos="100000">
+              <a:schemeClr val="accent3">
+                <a:hueOff val="0"/>
+                <a:satOff val="0"/>
+                <a:lumOff val="0"/>
+                <a:alphaOff val="0"/>
+                <a:lumMod val="99000"/>
+                <a:satMod val="120000"/>
+                <a:shade val="78000"/>
+              </a:schemeClr>
+            </a:gs>
+          </a:gsLst>
+          <a:lin ang="5400000" scaled="0"/>
+        </a:gradFill>
+        <a:ln>
+          <a:noFill/>
         </a:ln>
         <a:effectLst/>
+        <a:scene3d>
+          <a:camera prst="orthographicFront"/>
+          <a:lightRig rig="flat" dir="t"/>
+        </a:scene3d>
+        <a:sp3d prstMaterial="plastic">
+          <a:bevelT w="120900" h="88900"/>
+          <a:bevelB w="88900" h="31750" prst="angle"/>
+        </a:sp3d>
       </dsp:spPr>
       <dsp:style>
-        <a:lnRef idx="2">
+        <a:lnRef idx="0">
           <a:scrgbClr r="0" g="0" b="0"/>
         </a:lnRef>
-        <a:fillRef idx="1">
+        <a:fillRef idx="3">
           <a:scrgbClr r="0" g="0" b="0"/>
         </a:fillRef>
-        <a:effectRef idx="0">
+        <a:effectRef idx="2">
           <a:scrgbClr r="0" g="0" b="0"/>
         </a:effectRef>
         <a:fontRef idx="minor">
@@ -1440,8 +1499,8 @@
       </dsp:nvSpPr>
       <dsp:spPr>
         <a:xfrm>
-          <a:off x="2764480" y="3455091"/>
-          <a:ext cx="2044496" cy="1022003"/>
+          <a:off x="3065208" y="4174032"/>
+          <a:ext cx="2469919" cy="1234664"/>
         </a:xfrm>
         <a:prstGeom prst="rect">
           <a:avLst/>
@@ -1489,8 +1548,8 @@
         </a:p>
       </dsp:txBody>
       <dsp:txXfrm>
-        <a:off x="2764480" y="3455091"/>
-        <a:ext cx="2044496" cy="1022003"/>
+        <a:off x="3065208" y="4174032"/>
+        <a:ext cx="2469919" cy="1234664"/>
       </dsp:txXfrm>
     </dsp:sp>
     <dsp:sp modelId="{19D1F821-3860-4F77-A074-BB6401E6326E}">
@@ -1500,8 +1559,8 @@
       </dsp:nvSpPr>
       <dsp:spPr>
         <a:xfrm>
-          <a:off x="3230865" y="4481681"/>
-          <a:ext cx="3161058" cy="3162325"/>
+          <a:off x="3628640" y="5414237"/>
+          <a:ext cx="3818817" cy="3820347"/>
         </a:xfrm>
         <a:prstGeom prst="blockArc">
           <a:avLst>
@@ -1510,36 +1569,65 @@
             <a:gd name="adj3" fmla="val 12740"/>
           </a:avLst>
         </a:prstGeom>
-        <a:solidFill>
-          <a:schemeClr val="accent4">
-            <a:hueOff val="0"/>
-            <a:satOff val="0"/>
-            <a:lumOff val="0"/>
-            <a:alphaOff val="0"/>
-          </a:schemeClr>
-        </a:solidFill>
-        <a:ln w="19050" cap="flat" cmpd="sng" algn="ctr">
-          <a:solidFill>
-            <a:schemeClr val="lt1">
-              <a:hueOff val="0"/>
-              <a:satOff val="0"/>
-              <a:lumOff val="0"/>
-              <a:alphaOff val="0"/>
-            </a:schemeClr>
-          </a:solidFill>
-          <a:prstDash val="solid"/>
-          <a:miter lim="800000"/>
+        <a:gradFill rotWithShape="0">
+          <a:gsLst>
+            <a:gs pos="0">
+              <a:schemeClr val="accent4">
+                <a:hueOff val="0"/>
+                <a:satOff val="0"/>
+                <a:lumOff val="0"/>
+                <a:alphaOff val="0"/>
+                <a:satMod val="103000"/>
+                <a:lumMod val="102000"/>
+                <a:tint val="94000"/>
+              </a:schemeClr>
+            </a:gs>
+            <a:gs pos="50000">
+              <a:schemeClr val="accent4">
+                <a:hueOff val="0"/>
+                <a:satOff val="0"/>
+                <a:lumOff val="0"/>
+                <a:alphaOff val="0"/>
+                <a:satMod val="110000"/>
+                <a:lumMod val="100000"/>
+                <a:shade val="100000"/>
+              </a:schemeClr>
+            </a:gs>
+            <a:gs pos="100000">
+              <a:schemeClr val="accent4">
+                <a:hueOff val="0"/>
+                <a:satOff val="0"/>
+                <a:lumOff val="0"/>
+                <a:alphaOff val="0"/>
+                <a:lumMod val="99000"/>
+                <a:satMod val="120000"/>
+                <a:shade val="78000"/>
+              </a:schemeClr>
+            </a:gs>
+          </a:gsLst>
+          <a:lin ang="5400000" scaled="0"/>
+        </a:gradFill>
+        <a:ln>
+          <a:noFill/>
         </a:ln>
         <a:effectLst/>
+        <a:scene3d>
+          <a:camera prst="orthographicFront"/>
+          <a:lightRig rig="flat" dir="t"/>
+        </a:scene3d>
+        <a:sp3d prstMaterial="plastic">
+          <a:bevelT w="120900" h="88900"/>
+          <a:bevelB w="88900" h="31750" prst="angle"/>
+        </a:sp3d>
       </dsp:spPr>
       <dsp:style>
-        <a:lnRef idx="2">
+        <a:lnRef idx="0">
           <a:scrgbClr r="0" g="0" b="0"/>
         </a:lnRef>
-        <a:fillRef idx="1">
+        <a:fillRef idx="3">
           <a:scrgbClr r="0" g="0" b="0"/>
         </a:fillRef>
-        <a:effectRef idx="0">
+        <a:effectRef idx="2">
           <a:scrgbClr r="0" g="0" b="0"/>
         </a:effectRef>
         <a:fontRef idx="minor">
@@ -1554,8 +1642,8 @@
       </dsp:nvSpPr>
       <dsp:spPr>
         <a:xfrm>
-          <a:off x="3787074" y="5584711"/>
-          <a:ext cx="2044496" cy="1022003"/>
+          <a:off x="4300585" y="6746787"/>
+          <a:ext cx="2469919" cy="1234664"/>
         </a:xfrm>
         <a:prstGeom prst="rect">
           <a:avLst/>
@@ -1603,8 +1691,8 @@
         </a:p>
       </dsp:txBody>
       <dsp:txXfrm>
-        <a:off x="3787074" y="5584711"/>
-        <a:ext cx="2044496" cy="1022003"/>
+        <a:off x="4300585" y="6746787"/>
+        <a:ext cx="2469919" cy="1234664"/>
       </dsp:txXfrm>
     </dsp:sp>
   </dsp:spTree>
@@ -3688,11 +3776,11 @@
 </file>
 
 <file path=ppt/diagrams/quickStyle1.xml><?xml version="1.0" encoding="utf-8"?>
-<dgm:styleDef xmlns:dgm="http://schemas.openxmlformats.org/drawingml/2006/diagram" xmlns:a="http://schemas.openxmlformats.org/drawingml/2006/main" uniqueId="urn:microsoft.com/office/officeart/2005/8/quickstyle/simple1">
+<dgm:styleDef xmlns:dgm="http://schemas.openxmlformats.org/drawingml/2006/diagram" xmlns:a="http://schemas.openxmlformats.org/drawingml/2006/main" uniqueId="urn:microsoft.com/office/officeart/2005/8/quickstyle/3d1">
   <dgm:title val=""/>
   <dgm:desc val=""/>
   <dgm:catLst>
-    <dgm:cat type="simple" pri="10100"/>
+    <dgm:cat type="3D" pri="11100"/>
   </dgm:catLst>
   <dgm:scene3d>
     <a:camera prst="orthographicFront"/>
@@ -3701,18 +3789,21 @@
   <dgm:styleLbl name="node0">
     <dgm:scene3d>
       <a:camera prst="orthographicFront"/>
-      <a:lightRig rig="threePt" dir="t"/>
+      <a:lightRig rig="flat" dir="t"/>
     </dgm:scene3d>
-    <dgm:sp3d/>
+    <dgm:sp3d prstMaterial="plastic">
+      <a:bevelT w="120900" h="88900"/>
+      <a:bevelB w="88900" h="31750" prst="angle"/>
+    </dgm:sp3d>
     <dgm:txPr/>
     <dgm:style>
-      <a:lnRef idx="2">
+      <a:lnRef idx="0">
         <a:scrgbClr r="0" g="0" b="0"/>
       </a:lnRef>
-      <a:fillRef idx="1">
+      <a:fillRef idx="3">
         <a:scrgbClr r="0" g="0" b="0"/>
       </a:fillRef>
-      <a:effectRef idx="0">
+      <a:effectRef idx="2">
         <a:scrgbClr r="0" g="0" b="0"/>
       </a:effectRef>
       <a:fontRef idx="minor">
@@ -3723,18 +3814,21 @@
   <dgm:styleLbl name="lnNode1">
     <dgm:scene3d>
       <a:camera prst="orthographicFront"/>
-      <a:lightRig rig="threePt" dir="t"/>
+      <a:lightRig rig="flat" dir="t"/>
     </dgm:scene3d>
-    <dgm:sp3d/>
+    <dgm:sp3d prstMaterial="plastic">
+      <a:bevelT w="120900" h="88900"/>
+      <a:bevelB w="88900" h="31750" prst="angle"/>
+    </dgm:sp3d>
     <dgm:txPr/>
     <dgm:style>
-      <a:lnRef idx="2">
+      <a:lnRef idx="0">
         <a:scrgbClr r="0" g="0" b="0"/>
       </a:lnRef>
-      <a:fillRef idx="1">
+      <a:fillRef idx="3">
         <a:scrgbClr r="0" g="0" b="0"/>
       </a:fillRef>
-      <a:effectRef idx="0">
+      <a:effectRef idx="1">
         <a:scrgbClr r="0" g="0" b="0"/>
       </a:effectRef>
       <a:fontRef idx="minor">
@@ -3745,18 +3839,21 @@
   <dgm:styleLbl name="vennNode1">
     <dgm:scene3d>
       <a:camera prst="orthographicFront"/>
-      <a:lightRig rig="threePt" dir="t"/>
+      <a:lightRig rig="flat" dir="t"/>
     </dgm:scene3d>
-    <dgm:sp3d/>
+    <dgm:sp3d prstMaterial="plastic">
+      <a:bevelT w="120900" h="88900"/>
+      <a:bevelB w="88900" h="31750" prst="angle"/>
+    </dgm:sp3d>
     <dgm:txPr/>
     <dgm:style>
-      <a:lnRef idx="2">
+      <a:lnRef idx="0">
         <a:scrgbClr r="0" g="0" b="0"/>
       </a:lnRef>
       <a:fillRef idx="1">
         <a:scrgbClr r="0" g="0" b="0"/>
       </a:fillRef>
-      <a:effectRef idx="0">
+      <a:effectRef idx="1">
         <a:scrgbClr r="0" g="0" b="0"/>
       </a:effectRef>
       <a:fontRef idx="minor">
@@ -3767,18 +3864,21 @@
   <dgm:styleLbl name="alignNode1">
     <dgm:scene3d>
       <a:camera prst="orthographicFront"/>
-      <a:lightRig rig="threePt" dir="t"/>
+      <a:lightRig rig="flat" dir="t"/>
     </dgm:scene3d>
-    <dgm:sp3d/>
+    <dgm:sp3d prstMaterial="plastic">
+      <a:bevelT w="120900" h="88900"/>
+      <a:bevelB w="88900" h="31750" prst="angle"/>
+    </dgm:sp3d>
     <dgm:txPr/>
     <dgm:style>
-      <a:lnRef idx="2">
+      <a:lnRef idx="1">
         <a:scrgbClr r="0" g="0" b="0"/>
       </a:lnRef>
-      <a:fillRef idx="1">
+      <a:fillRef idx="3">
         <a:scrgbClr r="0" g="0" b="0"/>
       </a:fillRef>
-      <a:effectRef idx="0">
+      <a:effectRef idx="2">
         <a:scrgbClr r="0" g="0" b="0"/>
       </a:effectRef>
       <a:fontRef idx="minor">
@@ -3789,18 +3889,21 @@
   <dgm:styleLbl name="node1">
     <dgm:scene3d>
       <a:camera prst="orthographicFront"/>
-      <a:lightRig rig="threePt" dir="t"/>
+      <a:lightRig rig="flat" dir="t"/>
     </dgm:scene3d>
-    <dgm:sp3d/>
+    <dgm:sp3d prstMaterial="plastic">
+      <a:bevelT w="120900" h="88900"/>
+      <a:bevelB w="88900" h="31750" prst="angle"/>
+    </dgm:sp3d>
     <dgm:txPr/>
     <dgm:style>
-      <a:lnRef idx="2">
+      <a:lnRef idx="0">
         <a:scrgbClr r="0" g="0" b="0"/>
       </a:lnRef>
-      <a:fillRef idx="1">
+      <a:fillRef idx="3">
         <a:scrgbClr r="0" g="0" b="0"/>
       </a:fillRef>
-      <a:effectRef idx="0">
+      <a:effectRef idx="2">
         <a:scrgbClr r="0" g="0" b="0"/>
       </a:effectRef>
       <a:fontRef idx="minor">
@@ -3811,18 +3914,21 @@
   <dgm:styleLbl name="node2">
     <dgm:scene3d>
       <a:camera prst="orthographicFront"/>
-      <a:lightRig rig="threePt" dir="t"/>
+      <a:lightRig rig="flat" dir="t"/>
     </dgm:scene3d>
-    <dgm:sp3d/>
+    <dgm:sp3d prstMaterial="plastic">
+      <a:bevelT w="120900" h="88900"/>
+      <a:bevelB w="88900" h="31750" prst="angle"/>
+    </dgm:sp3d>
     <dgm:txPr/>
     <dgm:style>
-      <a:lnRef idx="2">
+      <a:lnRef idx="0">
         <a:scrgbClr r="0" g="0" b="0"/>
       </a:lnRef>
-      <a:fillRef idx="1">
+      <a:fillRef idx="3">
         <a:scrgbClr r="0" g="0" b="0"/>
       </a:fillRef>
-      <a:effectRef idx="0">
+      <a:effectRef idx="1">
         <a:scrgbClr r="0" g="0" b="0"/>
       </a:effectRef>
       <a:fontRef idx="minor">
@@ -3833,18 +3939,21 @@
   <dgm:styleLbl name="node3">
     <dgm:scene3d>
       <a:camera prst="orthographicFront"/>
-      <a:lightRig rig="threePt" dir="t"/>
+      <a:lightRig rig="flat" dir="t"/>
     </dgm:scene3d>
-    <dgm:sp3d/>
+    <dgm:sp3d prstMaterial="plastic">
+      <a:bevelT w="120900" h="88900"/>
+      <a:bevelB w="88900" h="31750" prst="angle"/>
+    </dgm:sp3d>
     <dgm:txPr/>
     <dgm:style>
-      <a:lnRef idx="2">
+      <a:lnRef idx="0">
         <a:scrgbClr r="0" g="0" b="0"/>
       </a:lnRef>
-      <a:fillRef idx="1">
+      <a:fillRef idx="3">
         <a:scrgbClr r="0" g="0" b="0"/>
       </a:fillRef>
-      <a:effectRef idx="0">
+      <a:effectRef idx="1">
         <a:scrgbClr r="0" g="0" b="0"/>
       </a:effectRef>
       <a:fontRef idx="minor">
@@ -3855,18 +3964,21 @@
   <dgm:styleLbl name="node4">
     <dgm:scene3d>
       <a:camera prst="orthographicFront"/>
-      <a:lightRig rig="threePt" dir="t"/>
+      <a:lightRig rig="flat" dir="t"/>
     </dgm:scene3d>
-    <dgm:sp3d/>
+    <dgm:sp3d prstMaterial="plastic">
+      <a:bevelT w="120900" h="88900"/>
+      <a:bevelB w="88900" h="31750" prst="angle"/>
+    </dgm:sp3d>
     <dgm:txPr/>
     <dgm:style>
-      <a:lnRef idx="2">
+      <a:lnRef idx="0">
         <a:scrgbClr r="0" g="0" b="0"/>
       </a:lnRef>
-      <a:fillRef idx="1">
+      <a:fillRef idx="3">
         <a:scrgbClr r="0" g="0" b="0"/>
       </a:fillRef>
-      <a:effectRef idx="0">
+      <a:effectRef idx="1">
         <a:scrgbClr r="0" g="0" b="0"/>
       </a:effectRef>
       <a:fontRef idx="minor">
@@ -3877,18 +3989,21 @@
   <dgm:styleLbl name="fgImgPlace1">
     <dgm:scene3d>
       <a:camera prst="orthographicFront"/>
-      <a:lightRig rig="threePt" dir="t"/>
+      <a:lightRig rig="flat" dir="t"/>
     </dgm:scene3d>
-    <dgm:sp3d/>
+    <dgm:sp3d z="127000" prstMaterial="plastic">
+      <a:bevelT w="88900" h="88900"/>
+      <a:bevelB w="88900" h="31750" prst="angle"/>
+    </dgm:sp3d>
     <dgm:txPr/>
     <dgm:style>
-      <a:lnRef idx="2">
+      <a:lnRef idx="0">
         <a:scrgbClr r="0" g="0" b="0"/>
       </a:lnRef>
-      <a:fillRef idx="1">
+      <a:fillRef idx="3">
         <a:scrgbClr r="0" g="0" b="0"/>
       </a:fillRef>
-      <a:effectRef idx="0">
+      <a:effectRef idx="2">
         <a:scrgbClr r="0" g="0" b="0"/>
       </a:effectRef>
       <a:fontRef idx="minor"/>
@@ -3897,18 +4012,21 @@
   <dgm:styleLbl name="alignImgPlace1">
     <dgm:scene3d>
       <a:camera prst="orthographicFront"/>
-      <a:lightRig rig="threePt" dir="t"/>
+      <a:lightRig rig="flat" dir="t"/>
     </dgm:scene3d>
-    <dgm:sp3d/>
+    <dgm:sp3d prstMaterial="plastic">
+      <a:bevelT w="88900" h="88900"/>
+      <a:bevelB w="88900" h="31750" prst="angle"/>
+    </dgm:sp3d>
     <dgm:txPr/>
     <dgm:style>
-      <a:lnRef idx="2">
+      <a:lnRef idx="0">
         <a:scrgbClr r="0" g="0" b="0"/>
       </a:lnRef>
-      <a:fillRef idx="1">
+      <a:fillRef idx="3">
         <a:scrgbClr r="0" g="0" b="0"/>
       </a:fillRef>
-      <a:effectRef idx="0">
+      <a:effectRef idx="2">
         <a:scrgbClr r="0" g="0" b="0"/>
       </a:effectRef>
       <a:fontRef idx="minor"/>
@@ -3917,18 +4035,21 @@
   <dgm:styleLbl name="bgImgPlace1">
     <dgm:scene3d>
       <a:camera prst="orthographicFront"/>
-      <a:lightRig rig="threePt" dir="t"/>
+      <a:lightRig rig="flat" dir="t"/>
     </dgm:scene3d>
-    <dgm:sp3d/>
+    <dgm:sp3d z="-190500" prstMaterial="plastic">
+      <a:bevelT w="88900" h="88900"/>
+      <a:bevelB w="88900" h="31750" prst="angle"/>
+    </dgm:sp3d>
     <dgm:txPr/>
     <dgm:style>
-      <a:lnRef idx="2">
+      <a:lnRef idx="0">
         <a:scrgbClr r="0" g="0" b="0"/>
       </a:lnRef>
-      <a:fillRef idx="1">
+      <a:fillRef idx="3">
         <a:scrgbClr r="0" g="0" b="0"/>
       </a:fillRef>
-      <a:effectRef idx="0">
+      <a:effectRef idx="2">
         <a:scrgbClr r="0" g="0" b="0"/>
       </a:effectRef>
       <a:fontRef idx="minor"/>
@@ -3937,18 +4058,21 @@
   <dgm:styleLbl name="sibTrans2D1">
     <dgm:scene3d>
       <a:camera prst="orthographicFront"/>
-      <a:lightRig rig="threePt" dir="t"/>
+      <a:lightRig rig="flat" dir="t"/>
     </dgm:scene3d>
-    <dgm:sp3d/>
+    <dgm:sp3d z="-80000" prstMaterial="plastic">
+      <a:bevelT w="50800" h="50800"/>
+      <a:bevelB w="25400" h="25400" prst="angle"/>
+    </dgm:sp3d>
     <dgm:txPr/>
     <dgm:style>
       <a:lnRef idx="0">
         <a:scrgbClr r="0" g="0" b="0"/>
       </a:lnRef>
-      <a:fillRef idx="1">
+      <a:fillRef idx="3">
         <a:scrgbClr r="0" g="0" b="0"/>
       </a:fillRef>
-      <a:effectRef idx="0">
+      <a:effectRef idx="2">
         <a:scrgbClr r="0" g="0" b="0"/>
       </a:effectRef>
       <a:fontRef idx="minor">
@@ -3959,18 +4083,21 @@
   <dgm:styleLbl name="fgSibTrans2D1">
     <dgm:scene3d>
       <a:camera prst="orthographicFront"/>
-      <a:lightRig rig="threePt" dir="t"/>
+      <a:lightRig rig="flat" dir="t"/>
     </dgm:scene3d>
-    <dgm:sp3d/>
+    <dgm:sp3d z="127000" prstMaterial="plastic">
+      <a:bevelT w="50800" h="50800"/>
+      <a:bevelB w="25400" h="25400" prst="angle"/>
+    </dgm:sp3d>
     <dgm:txPr/>
     <dgm:style>
       <a:lnRef idx="0">
         <a:scrgbClr r="0" g="0" b="0"/>
       </a:lnRef>
-      <a:fillRef idx="1">
+      <a:fillRef idx="3">
         <a:scrgbClr r="0" g="0" b="0"/>
       </a:fillRef>
-      <a:effectRef idx="0">
+      <a:effectRef idx="2">
         <a:scrgbClr r="0" g="0" b="0"/>
       </a:effectRef>
       <a:fontRef idx="minor">
@@ -3981,18 +4108,21 @@
   <dgm:styleLbl name="bgSibTrans2D1">
     <dgm:scene3d>
       <a:camera prst="orthographicFront"/>
-      <a:lightRig rig="threePt" dir="t"/>
+      <a:lightRig rig="flat" dir="t"/>
     </dgm:scene3d>
-    <dgm:sp3d/>
+    <dgm:sp3d z="-190500" prstMaterial="plastic">
+      <a:bevelT w="50800" h="50800"/>
+      <a:bevelB w="25400" h="25400" prst="angle"/>
+    </dgm:sp3d>
     <dgm:txPr/>
     <dgm:style>
       <a:lnRef idx="0">
         <a:scrgbClr r="0" g="0" b="0"/>
       </a:lnRef>
-      <a:fillRef idx="1">
+      <a:fillRef idx="3">
         <a:scrgbClr r="0" g="0" b="0"/>
       </a:fillRef>
-      <a:effectRef idx="0">
+      <a:effectRef idx="2">
         <a:scrgbClr r="0" g="0" b="0"/>
       </a:effectRef>
       <a:fontRef idx="minor">
@@ -4003,9 +4133,9 @@
   <dgm:styleLbl name="sibTrans1D1">
     <dgm:scene3d>
       <a:camera prst="orthographicFront"/>
-      <a:lightRig rig="threePt" dir="t"/>
+      <a:lightRig rig="flat" dir="t"/>
     </dgm:scene3d>
-    <dgm:sp3d/>
+    <dgm:sp3d z="-40000" prstMaterial="matte"/>
     <dgm:txPr/>
     <dgm:style>
       <a:lnRef idx="1">
@@ -4025,7 +4155,7 @@
       <a:camera prst="orthographicFront"/>
       <a:lightRig rig="threePt" dir="t"/>
     </dgm:scene3d>
-    <dgm:sp3d/>
+    <dgm:sp3d z="127000" prstMaterial="matte"/>
     <dgm:txPr/>
     <dgm:style>
       <a:lnRef idx="2">
@@ -4043,18 +4173,21 @@
   <dgm:styleLbl name="asst0">
     <dgm:scene3d>
       <a:camera prst="orthographicFront"/>
-      <a:lightRig rig="threePt" dir="t"/>
+      <a:lightRig rig="flat" dir="t"/>
     </dgm:scene3d>
-    <dgm:sp3d/>
+    <dgm:sp3d prstMaterial="plastic">
+      <a:bevelT w="120900" h="88900"/>
+      <a:bevelB w="88900" h="31750" prst="angle"/>
+    </dgm:sp3d>
     <dgm:txPr/>
     <dgm:style>
-      <a:lnRef idx="2">
+      <a:lnRef idx="0">
         <a:scrgbClr r="0" g="0" b="0"/>
       </a:lnRef>
-      <a:fillRef idx="1">
+      <a:fillRef idx="3">
         <a:scrgbClr r="0" g="0" b="0"/>
       </a:fillRef>
-      <a:effectRef idx="0">
+      <a:effectRef idx="1">
         <a:scrgbClr r="0" g="0" b="0"/>
       </a:effectRef>
       <a:fontRef idx="minor">
@@ -4065,18 +4198,21 @@
   <dgm:styleLbl name="asst1">
     <dgm:scene3d>
       <a:camera prst="orthographicFront"/>
-      <a:lightRig rig="threePt" dir="t"/>
+      <a:lightRig rig="flat" dir="t"/>
     </dgm:scene3d>
-    <dgm:sp3d/>
+    <dgm:sp3d prstMaterial="plastic">
+      <a:bevelT w="120900" h="88900"/>
+      <a:bevelB w="88900" h="31750" prst="angle"/>
+    </dgm:sp3d>
     <dgm:txPr/>
     <dgm:style>
-      <a:lnRef idx="2">
+      <a:lnRef idx="0">
         <a:scrgbClr r="0" g="0" b="0"/>
       </a:lnRef>
-      <a:fillRef idx="1">
+      <a:fillRef idx="3">
         <a:scrgbClr r="0" g="0" b="0"/>
       </a:fillRef>
-      <a:effectRef idx="0">
+      <a:effectRef idx="1">
         <a:scrgbClr r="0" g="0" b="0"/>
       </a:effectRef>
       <a:fontRef idx="minor">
@@ -4087,18 +4223,21 @@
   <dgm:styleLbl name="asst2">
     <dgm:scene3d>
       <a:camera prst="orthographicFront"/>
-      <a:lightRig rig="threePt" dir="t"/>
+      <a:lightRig rig="flat" dir="t"/>
     </dgm:scene3d>
-    <dgm:sp3d/>
+    <dgm:sp3d prstMaterial="plastic">
+      <a:bevelT w="120900" h="88900"/>
+      <a:bevelB w="88900" h="31750" prst="angle"/>
+    </dgm:sp3d>
     <dgm:txPr/>
     <dgm:style>
-      <a:lnRef idx="2">
+      <a:lnRef idx="0">
         <a:scrgbClr r="0" g="0" b="0"/>
       </a:lnRef>
-      <a:fillRef idx="1">
+      <a:fillRef idx="3">
         <a:scrgbClr r="0" g="0" b="0"/>
       </a:fillRef>
-      <a:effectRef idx="0">
+      <a:effectRef idx="1">
         <a:scrgbClr r="0" g="0" b="0"/>
       </a:effectRef>
       <a:fontRef idx="minor">
@@ -4109,40 +4248,21 @@
   <dgm:styleLbl name="asst3">
     <dgm:scene3d>
       <a:camera prst="orthographicFront"/>
-      <a:lightRig rig="threePt" dir="t"/>
+      <a:lightRig rig="flat" dir="t"/>
     </dgm:scene3d>
-    <dgm:sp3d/>
+    <dgm:sp3d prstMaterial="plastic">
+      <a:bevelT w="120900" h="88900"/>
+      <a:bevelB w="88900" h="31750" prst="angle"/>
+    </dgm:sp3d>
     <dgm:txPr/>
     <dgm:style>
-      <a:lnRef idx="2">
+      <a:lnRef idx="0">
         <a:scrgbClr r="0" g="0" b="0"/>
       </a:lnRef>
-      <a:fillRef idx="1">
+      <a:fillRef idx="3">
         <a:scrgbClr r="0" g="0" b="0"/>
       </a:fillRef>
-      <a:effectRef idx="0">
-        <a:scrgbClr r="0" g="0" b="0"/>
-      </a:effectRef>
-      <a:fontRef idx="minor">
-        <a:schemeClr val="lt1"/>
-      </a:fontRef>
-    </dgm:style>
-  </dgm:styleLbl>
-  <dgm:styleLbl name="asst4">
-    <dgm:scene3d>
-      <a:camera prst="orthographicFront"/>
-      <a:lightRig rig="threePt" dir="t"/>
-    </dgm:scene3d>
-    <dgm:sp3d/>
-    <dgm:txPr/>
-    <dgm:style>
-      <a:lnRef idx="2">
-        <a:scrgbClr r="0" g="0" b="0"/>
-      </a:lnRef>
-      <a:fillRef idx="1">
-        <a:scrgbClr r="0" g="0" b="0"/>
-      </a:fillRef>
-      <a:effectRef idx="0">
+      <a:effectRef idx="1">
         <a:scrgbClr r="0" g="0" b="0"/>
       </a:effectRef>
       <a:fontRef idx="minor">
@@ -4153,18 +4273,21 @@
   <dgm:styleLbl name="parChTrans2D1">
     <dgm:scene3d>
       <a:camera prst="orthographicFront"/>
-      <a:lightRig rig="threePt" dir="t"/>
+      <a:lightRig rig="flat" dir="t"/>
     </dgm:scene3d>
-    <dgm:sp3d/>
+    <dgm:sp3d z="-100000" prstMaterial="plastic">
+      <a:bevelT w="120900" h="88900"/>
+      <a:bevelB w="88900" h="31750" prst="angle"/>
+    </dgm:sp3d>
     <dgm:txPr/>
     <dgm:style>
-      <a:lnRef idx="2">
+      <a:lnRef idx="0">
         <a:scrgbClr r="0" g="0" b="0"/>
       </a:lnRef>
-      <a:fillRef idx="1">
+      <a:fillRef idx="3">
         <a:scrgbClr r="0" g="0" b="0"/>
       </a:fillRef>
-      <a:effectRef idx="0">
+      <a:effectRef idx="1">
         <a:scrgbClr r="0" g="0" b="0"/>
       </a:effectRef>
       <a:fontRef idx="minor">
@@ -4175,18 +4298,21 @@
   <dgm:styleLbl name="parChTrans2D2">
     <dgm:scene3d>
       <a:camera prst="orthographicFront"/>
-      <a:lightRig rig="threePt" dir="t"/>
+      <a:lightRig rig="flat" dir="t"/>
     </dgm:scene3d>
-    <dgm:sp3d/>
+    <dgm:sp3d z="-60000" prstMaterial="plastic">
+      <a:bevelT w="120900" h="88900"/>
+      <a:bevelB w="88900" h="31750" prst="angle"/>
+    </dgm:sp3d>
     <dgm:txPr/>
     <dgm:style>
-      <a:lnRef idx="2">
+      <a:lnRef idx="0">
         <a:scrgbClr r="0" g="0" b="0"/>
       </a:lnRef>
-      <a:fillRef idx="1">
+      <a:fillRef idx="3">
         <a:scrgbClr r="0" g="0" b="0"/>
       </a:fillRef>
-      <a:effectRef idx="0">
+      <a:effectRef idx="1">
         <a:scrgbClr r="0" g="0" b="0"/>
       </a:effectRef>
       <a:fontRef idx="minor">
@@ -4197,18 +4323,21 @@
   <dgm:styleLbl name="parChTrans2D3">
     <dgm:scene3d>
       <a:camera prst="orthographicFront"/>
-      <a:lightRig rig="threePt" dir="t"/>
+      <a:lightRig rig="flat" dir="t"/>
     </dgm:scene3d>
-    <dgm:sp3d/>
+    <dgm:sp3d z="-60000" prstMaterial="plastic">
+      <a:bevelT w="120900" h="88900"/>
+      <a:bevelB w="88900" h="31750" prst="angle"/>
+    </dgm:sp3d>
     <dgm:txPr/>
     <dgm:style>
-      <a:lnRef idx="2">
+      <a:lnRef idx="0">
         <a:scrgbClr r="0" g="0" b="0"/>
       </a:lnRef>
-      <a:fillRef idx="1">
+      <a:fillRef idx="3">
         <a:scrgbClr r="0" g="0" b="0"/>
       </a:fillRef>
-      <a:effectRef idx="0">
+      <a:effectRef idx="1">
         <a:scrgbClr r="0" g="0" b="0"/>
       </a:effectRef>
       <a:fontRef idx="minor">
@@ -4219,18 +4348,21 @@
   <dgm:styleLbl name="parChTrans2D4">
     <dgm:scene3d>
       <a:camera prst="orthographicFront"/>
-      <a:lightRig rig="threePt" dir="t"/>
+      <a:lightRig rig="flat" dir="t"/>
     </dgm:scene3d>
-    <dgm:sp3d/>
+    <dgm:sp3d z="-60000" prstMaterial="plastic">
+      <a:bevelT w="120900" h="88900"/>
+      <a:bevelB w="88900" h="31750" prst="angle"/>
+    </dgm:sp3d>
     <dgm:txPr/>
     <dgm:style>
-      <a:lnRef idx="2">
+      <a:lnRef idx="0">
         <a:scrgbClr r="0" g="0" b="0"/>
       </a:lnRef>
-      <a:fillRef idx="1">
+      <a:fillRef idx="3">
         <a:scrgbClr r="0" g="0" b="0"/>
       </a:fillRef>
-      <a:effectRef idx="0">
+      <a:effectRef idx="1">
         <a:scrgbClr r="0" g="0" b="0"/>
       </a:effectRef>
       <a:fontRef idx="minor">
@@ -4241,9 +4373,9 @@
   <dgm:styleLbl name="parChTrans1D1">
     <dgm:scene3d>
       <a:camera prst="orthographicFront"/>
-      <a:lightRig rig="threePt" dir="t"/>
+      <a:lightRig rig="flat" dir="t"/>
     </dgm:scene3d>
-    <dgm:sp3d/>
+    <dgm:sp3d prstMaterial="matte"/>
     <dgm:txPr/>
     <dgm:style>
       <a:lnRef idx="2">
@@ -4261,9 +4393,9 @@
   <dgm:styleLbl name="parChTrans1D2">
     <dgm:scene3d>
       <a:camera prst="orthographicFront"/>
-      <a:lightRig rig="threePt" dir="t"/>
+      <a:lightRig rig="flat" dir="t"/>
     </dgm:scene3d>
-    <dgm:sp3d/>
+    <dgm:sp3d prstMaterial="matte"/>
     <dgm:txPr/>
     <dgm:style>
       <a:lnRef idx="2">
@@ -4281,9 +4413,9 @@
   <dgm:styleLbl name="parChTrans1D3">
     <dgm:scene3d>
       <a:camera prst="orthographicFront"/>
-      <a:lightRig rig="threePt" dir="t"/>
+      <a:lightRig rig="flat" dir="t"/>
     </dgm:scene3d>
-    <dgm:sp3d/>
+    <dgm:sp3d prstMaterial="matte"/>
     <dgm:txPr/>
     <dgm:style>
       <a:lnRef idx="2">
@@ -4301,9 +4433,9 @@
   <dgm:styleLbl name="parChTrans1D4">
     <dgm:scene3d>
       <a:camera prst="orthographicFront"/>
-      <a:lightRig rig="threePt" dir="t"/>
+      <a:lightRig rig="flat" dir="t"/>
     </dgm:scene3d>
-    <dgm:sp3d/>
+    <dgm:sp3d prstMaterial="matte"/>
     <dgm:txPr/>
     <dgm:style>
       <a:lnRef idx="2">
@@ -4321,18 +4453,20 @@
   <dgm:styleLbl name="fgAcc1">
     <dgm:scene3d>
       <a:camera prst="orthographicFront"/>
-      <a:lightRig rig="threePt" dir="t"/>
+      <a:lightRig rig="flat" dir="t"/>
     </dgm:scene3d>
-    <dgm:sp3d/>
+    <dgm:sp3d z="190500" extrusionH="12700" prstMaterial="plastic">
+      <a:bevelT w="50800" h="50800"/>
+    </dgm:sp3d>
     <dgm:txPr/>
     <dgm:style>
-      <a:lnRef idx="2">
+      <a:lnRef idx="1">
         <a:scrgbClr r="0" g="0" b="0"/>
       </a:lnRef>
       <a:fillRef idx="1">
         <a:scrgbClr r="0" g="0" b="0"/>
       </a:fillRef>
-      <a:effectRef idx="0">
+      <a:effectRef idx="2">
         <a:scrgbClr r="0" g="0" b="0"/>
       </a:effectRef>
       <a:fontRef idx="minor"/>
@@ -4341,18 +4475,20 @@
   <dgm:styleLbl name="conFgAcc1">
     <dgm:scene3d>
       <a:camera prst="orthographicFront"/>
-      <a:lightRig rig="threePt" dir="t"/>
+      <a:lightRig rig="flat" dir="t"/>
     </dgm:scene3d>
-    <dgm:sp3d/>
+    <dgm:sp3d z="190500" extrusionH="12700" prstMaterial="plastic">
+      <a:bevelT w="50800" h="50800"/>
+    </dgm:sp3d>
     <dgm:txPr/>
     <dgm:style>
-      <a:lnRef idx="2">
+      <a:lnRef idx="1">
         <a:scrgbClr r="0" g="0" b="0"/>
       </a:lnRef>
       <a:fillRef idx="1">
         <a:scrgbClr r="0" g="0" b="0"/>
       </a:fillRef>
-      <a:effectRef idx="0">
+      <a:effectRef idx="2">
         <a:scrgbClr r="0" g="0" b="0"/>
       </a:effectRef>
       <a:fontRef idx="minor"/>
@@ -4361,18 +4497,20 @@
   <dgm:styleLbl name="alignAcc1">
     <dgm:scene3d>
       <a:camera prst="orthographicFront"/>
-      <a:lightRig rig="threePt" dir="t"/>
+      <a:lightRig rig="flat" dir="t"/>
     </dgm:scene3d>
-    <dgm:sp3d/>
+    <dgm:sp3d extrusionH="12700" prstMaterial="plastic">
+      <a:bevelT w="50800" h="50800"/>
+    </dgm:sp3d>
     <dgm:txPr/>
     <dgm:style>
-      <a:lnRef idx="2">
+      <a:lnRef idx="1">
         <a:scrgbClr r="0" g="0" b="0"/>
       </a:lnRef>
       <a:fillRef idx="1">
         <a:scrgbClr r="0" g="0" b="0"/>
       </a:fillRef>
-      <a:effectRef idx="0">
+      <a:effectRef idx="2">
         <a:scrgbClr r="0" g="0" b="0"/>
       </a:effectRef>
       <a:fontRef idx="minor"/>
@@ -4381,9 +4519,11 @@
   <dgm:styleLbl name="trAlignAcc1">
     <dgm:scene3d>
       <a:camera prst="orthographicFront"/>
-      <a:lightRig rig="threePt" dir="t"/>
+      <a:lightRig rig="flat" dir="t"/>
     </dgm:scene3d>
-    <dgm:sp3d/>
+    <dgm:sp3d extrusionH="12700" prstMaterial="plastic">
+      <a:bevelT w="50800" h="50800"/>
+    </dgm:sp3d>
     <dgm:txPr/>
     <dgm:style>
       <a:lnRef idx="1">
@@ -4392,7 +4532,7 @@
       <a:fillRef idx="1">
         <a:scrgbClr r="0" g="0" b="0"/>
       </a:fillRef>
-      <a:effectRef idx="0">
+      <a:effectRef idx="2">
         <a:scrgbClr r="0" g="0" b="0"/>
       </a:effectRef>
       <a:fontRef idx="minor"/>
@@ -4401,18 +4541,20 @@
   <dgm:styleLbl name="bgAcc1">
     <dgm:scene3d>
       <a:camera prst="orthographicFront"/>
-      <a:lightRig rig="threePt" dir="t"/>
+      <a:lightRig rig="flat" dir="t"/>
     </dgm:scene3d>
-    <dgm:sp3d/>
+    <dgm:sp3d z="-190500" extrusionH="12700" prstMaterial="plastic">
+      <a:bevelT w="50800" h="50800"/>
+    </dgm:sp3d>
     <dgm:txPr/>
     <dgm:style>
-      <a:lnRef idx="2">
+      <a:lnRef idx="1">
         <a:scrgbClr r="0" g="0" b="0"/>
       </a:lnRef>
       <a:fillRef idx="1">
         <a:scrgbClr r="0" g="0" b="0"/>
       </a:fillRef>
-      <a:effectRef idx="0">
+      <a:effectRef idx="2">
         <a:scrgbClr r="0" g="0" b="0"/>
       </a:effectRef>
       <a:fontRef idx="minor"/>
@@ -4421,18 +4563,20 @@
   <dgm:styleLbl name="solidFgAcc1">
     <dgm:scene3d>
       <a:camera prst="orthographicFront"/>
-      <a:lightRig rig="threePt" dir="t"/>
+      <a:lightRig rig="flat" dir="t"/>
     </dgm:scene3d>
-    <dgm:sp3d/>
+    <dgm:sp3d z="190500" extrusionH="12700" prstMaterial="plastic">
+      <a:bevelT w="50800" h="50800"/>
+    </dgm:sp3d>
     <dgm:txPr/>
     <dgm:style>
-      <a:lnRef idx="2">
+      <a:lnRef idx="1">
         <a:scrgbClr r="0" g="0" b="0"/>
       </a:lnRef>
       <a:fillRef idx="1">
         <a:scrgbClr r="0" g="0" b="0"/>
       </a:fillRef>
-      <a:effectRef idx="0">
+      <a:effectRef idx="2">
         <a:scrgbClr r="0" g="0" b="0"/>
       </a:effectRef>
       <a:fontRef idx="minor"/>
@@ -4441,18 +4585,20 @@
   <dgm:styleLbl name="solidAlignAcc1">
     <dgm:scene3d>
       <a:camera prst="orthographicFront"/>
-      <a:lightRig rig="threePt" dir="t"/>
+      <a:lightRig rig="flat" dir="t"/>
     </dgm:scene3d>
-    <dgm:sp3d/>
+    <dgm:sp3d extrusionH="12700" prstMaterial="plastic">
+      <a:bevelT w="50800" h="50800"/>
+    </dgm:sp3d>
     <dgm:txPr/>
     <dgm:style>
-      <a:lnRef idx="2">
+      <a:lnRef idx="1">
         <a:scrgbClr r="0" g="0" b="0"/>
       </a:lnRef>
       <a:fillRef idx="1">
         <a:scrgbClr r="0" g="0" b="0"/>
       </a:fillRef>
-      <a:effectRef idx="0">
+      <a:effectRef idx="2">
         <a:scrgbClr r="0" g="0" b="0"/>
       </a:effectRef>
       <a:fontRef idx="minor"/>
@@ -4461,18 +4607,20 @@
   <dgm:styleLbl name="solidBgAcc1">
     <dgm:scene3d>
       <a:camera prst="orthographicFront"/>
-      <a:lightRig rig="threePt" dir="t"/>
+      <a:lightRig rig="flat" dir="t"/>
     </dgm:scene3d>
-    <dgm:sp3d/>
+    <dgm:sp3d z="-190500" extrusionH="12700" prstMaterial="plastic">
+      <a:bevelT w="50800" h="50800"/>
+    </dgm:sp3d>
     <dgm:txPr/>
     <dgm:style>
-      <a:lnRef idx="2">
+      <a:lnRef idx="1">
         <a:scrgbClr r="0" g="0" b="0"/>
       </a:lnRef>
       <a:fillRef idx="1">
         <a:scrgbClr r="0" g="0" b="0"/>
       </a:fillRef>
-      <a:effectRef idx="0">
+      <a:effectRef idx="2">
         <a:scrgbClr r="0" g="0" b="0"/>
       </a:effectRef>
       <a:fontRef idx="minor"/>
@@ -4481,18 +4629,20 @@
   <dgm:styleLbl name="fgAccFollowNode1">
     <dgm:scene3d>
       <a:camera prst="orthographicFront"/>
-      <a:lightRig rig="threePt" dir="t"/>
+      <a:lightRig rig="flat" dir="t"/>
     </dgm:scene3d>
-    <dgm:sp3d/>
+    <dgm:sp3d z="190500" extrusionH="12700" prstMaterial="plastic">
+      <a:bevelT w="50800" h="50800"/>
+    </dgm:sp3d>
     <dgm:txPr/>
     <dgm:style>
-      <a:lnRef idx="2">
+      <a:lnRef idx="1">
         <a:scrgbClr r="0" g="0" b="0"/>
       </a:lnRef>
       <a:fillRef idx="1">
         <a:scrgbClr r="0" g="0" b="0"/>
       </a:fillRef>
-      <a:effectRef idx="0">
+      <a:effectRef idx="2">
         <a:scrgbClr r="0" g="0" b="0"/>
       </a:effectRef>
       <a:fontRef idx="minor"/>
@@ -4501,18 +4651,20 @@
   <dgm:styleLbl name="alignAccFollowNode1">
     <dgm:scene3d>
       <a:camera prst="orthographicFront"/>
-      <a:lightRig rig="threePt" dir="t"/>
+      <a:lightRig rig="flat" dir="t"/>
     </dgm:scene3d>
-    <dgm:sp3d/>
+    <dgm:sp3d extrusionH="12700" prstMaterial="plastic">
+      <a:bevelT w="50800" h="50800"/>
+    </dgm:sp3d>
     <dgm:txPr/>
     <dgm:style>
-      <a:lnRef idx="2">
+      <a:lnRef idx="1">
         <a:scrgbClr r="0" g="0" b="0"/>
       </a:lnRef>
       <a:fillRef idx="1">
         <a:scrgbClr r="0" g="0" b="0"/>
       </a:fillRef>
-      <a:effectRef idx="0">
+      <a:effectRef idx="2">
         <a:scrgbClr r="0" g="0" b="0"/>
       </a:effectRef>
       <a:fontRef idx="minor"/>
@@ -4521,18 +4673,20 @@
   <dgm:styleLbl name="bgAccFollowNode1">
     <dgm:scene3d>
       <a:camera prst="orthographicFront"/>
-      <a:lightRig rig="threePt" dir="t"/>
+      <a:lightRig rig="flat" dir="t"/>
     </dgm:scene3d>
-    <dgm:sp3d/>
+    <dgm:sp3d z="-190500" extrusionH="12700" prstMaterial="plastic">
+      <a:bevelT w="50800" h="50800"/>
+    </dgm:sp3d>
     <dgm:txPr/>
     <dgm:style>
-      <a:lnRef idx="2">
+      <a:lnRef idx="1">
         <a:scrgbClr r="0" g="0" b="0"/>
       </a:lnRef>
       <a:fillRef idx="1">
         <a:scrgbClr r="0" g="0" b="0"/>
       </a:fillRef>
-      <a:effectRef idx="0">
+      <a:effectRef idx="2">
         <a:scrgbClr r="0" g="0" b="0"/>
       </a:effectRef>
       <a:fontRef idx="minor"/>
@@ -4541,18 +4695,20 @@
   <dgm:styleLbl name="fgAcc0">
     <dgm:scene3d>
       <a:camera prst="orthographicFront"/>
-      <a:lightRig rig="threePt" dir="t"/>
+      <a:lightRig rig="flat" dir="t"/>
     </dgm:scene3d>
-    <dgm:sp3d/>
+    <dgm:sp3d z="190500" extrusionH="12700" prstMaterial="plastic">
+      <a:bevelT w="50800" h="50800"/>
+    </dgm:sp3d>
     <dgm:txPr/>
     <dgm:style>
-      <a:lnRef idx="2">
+      <a:lnRef idx="1">
         <a:scrgbClr r="0" g="0" b="0"/>
       </a:lnRef>
       <a:fillRef idx="1">
         <a:scrgbClr r="0" g="0" b="0"/>
       </a:fillRef>
-      <a:effectRef idx="0">
+      <a:effectRef idx="2">
         <a:scrgbClr r="0" g="0" b="0"/>
       </a:effectRef>
       <a:fontRef idx="minor"/>
@@ -4561,18 +4717,20 @@
   <dgm:styleLbl name="fgAcc2">
     <dgm:scene3d>
       <a:camera prst="orthographicFront"/>
-      <a:lightRig rig="threePt" dir="t"/>
+      <a:lightRig rig="flat" dir="t"/>
     </dgm:scene3d>
-    <dgm:sp3d/>
+    <dgm:sp3d z="190500" extrusionH="12700" prstMaterial="plastic">
+      <a:bevelT w="50800" h="50800"/>
+    </dgm:sp3d>
     <dgm:txPr/>
     <dgm:style>
-      <a:lnRef idx="2">
+      <a:lnRef idx="1">
         <a:scrgbClr r="0" g="0" b="0"/>
       </a:lnRef>
       <a:fillRef idx="1">
         <a:scrgbClr r="0" g="0" b="0"/>
       </a:fillRef>
-      <a:effectRef idx="0">
+      <a:effectRef idx="2">
         <a:scrgbClr r="0" g="0" b="0"/>
       </a:effectRef>
       <a:fontRef idx="minor"/>
@@ -4581,18 +4739,20 @@
   <dgm:styleLbl name="fgAcc3">
     <dgm:scene3d>
       <a:camera prst="orthographicFront"/>
-      <a:lightRig rig="threePt" dir="t"/>
+      <a:lightRig rig="flat" dir="t"/>
     </dgm:scene3d>
-    <dgm:sp3d/>
+    <dgm:sp3d z="190500" extrusionH="12700" prstMaterial="plastic">
+      <a:bevelT w="50800" h="50800"/>
+    </dgm:sp3d>
     <dgm:txPr/>
     <dgm:style>
-      <a:lnRef idx="2">
+      <a:lnRef idx="1">
         <a:scrgbClr r="0" g="0" b="0"/>
       </a:lnRef>
       <a:fillRef idx="1">
         <a:scrgbClr r="0" g="0" b="0"/>
       </a:fillRef>
-      <a:effectRef idx="0">
+      <a:effectRef idx="2">
         <a:scrgbClr r="0" g="0" b="0"/>
       </a:effectRef>
       <a:fontRef idx="minor"/>
@@ -4601,18 +4761,20 @@
   <dgm:styleLbl name="fgAcc4">
     <dgm:scene3d>
       <a:camera prst="orthographicFront"/>
-      <a:lightRig rig="threePt" dir="t"/>
+      <a:lightRig rig="flat" dir="t"/>
     </dgm:scene3d>
-    <dgm:sp3d/>
+    <dgm:sp3d z="190500" extrusionH="12700" prstMaterial="plastic">
+      <a:bevelT w="50800" h="50800"/>
+    </dgm:sp3d>
     <dgm:txPr/>
     <dgm:style>
-      <a:lnRef idx="2">
+      <a:lnRef idx="1">
         <a:scrgbClr r="0" g="0" b="0"/>
       </a:lnRef>
       <a:fillRef idx="1">
         <a:scrgbClr r="0" g="0" b="0"/>
       </a:fillRef>
-      <a:effectRef idx="0">
+      <a:effectRef idx="2">
         <a:scrgbClr r="0" g="0" b="0"/>
       </a:effectRef>
       <a:fontRef idx="minor"/>
@@ -4621,15 +4783,17 @@
   <dgm:styleLbl name="bgShp">
     <dgm:scene3d>
       <a:camera prst="orthographicFront"/>
-      <a:lightRig rig="threePt" dir="t"/>
+      <a:lightRig rig="flat" dir="t"/>
     </dgm:scene3d>
-    <dgm:sp3d/>
+    <dgm:sp3d z="-190500" extrusionH="12700" prstMaterial="plastic">
+      <a:bevelT w="50800" h="50800"/>
+    </dgm:sp3d>
     <dgm:txPr/>
     <dgm:style>
       <a:lnRef idx="0">
         <a:scrgbClr r="0" g="0" b="0"/>
       </a:lnRef>
-      <a:fillRef idx="1">
+      <a:fillRef idx="3">
         <a:scrgbClr r="0" g="0" b="0"/>
       </a:fillRef>
       <a:effectRef idx="0">
@@ -4641,15 +4805,17 @@
   <dgm:styleLbl name="dkBgShp">
     <dgm:scene3d>
       <a:camera prst="orthographicFront"/>
-      <a:lightRig rig="threePt" dir="t"/>
+      <a:lightRig rig="flat" dir="t"/>
     </dgm:scene3d>
-    <dgm:sp3d/>
+    <dgm:sp3d z="-190500" extrusionH="12700" prstMaterial="plastic">
+      <a:bevelT w="50800" h="50800"/>
+    </dgm:sp3d>
     <dgm:txPr/>
     <dgm:style>
       <a:lnRef idx="0">
         <a:scrgbClr r="0" g="0" b="0"/>
       </a:lnRef>
-      <a:fillRef idx="1">
+      <a:fillRef idx="2">
         <a:scrgbClr r="0" g="0" b="0"/>
       </a:fillRef>
       <a:effectRef idx="0">
@@ -4661,9 +4827,9 @@
   <dgm:styleLbl name="trBgShp">
     <dgm:scene3d>
       <a:camera prst="orthographicFront"/>
-      <a:lightRig rig="threePt" dir="t"/>
+      <a:lightRig rig="flat" dir="t"/>
     </dgm:scene3d>
-    <dgm:sp3d/>
+    <dgm:sp3d z="-190500" extrusionH="12700" prstMaterial="matte"/>
     <dgm:txPr/>
     <dgm:style>
       <a:lnRef idx="0">
@@ -4681,21 +4847,26 @@
   <dgm:styleLbl name="fgShp">
     <dgm:scene3d>
       <a:camera prst="orthographicFront"/>
-      <a:lightRig rig="threePt" dir="t"/>
+      <a:lightRig rig="flat" dir="t"/>
     </dgm:scene3d>
-    <dgm:sp3d/>
+    <dgm:sp3d z="190500" prstMaterial="plastic">
+      <a:bevelT w="120900" h="88900"/>
+      <a:bevelB w="88900" h="31750" prst="angle"/>
+    </dgm:sp3d>
     <dgm:txPr/>
     <dgm:style>
-      <a:lnRef idx="2">
+      <a:lnRef idx="0">
         <a:scrgbClr r="0" g="0" b="0"/>
       </a:lnRef>
       <a:fillRef idx="1">
         <a:scrgbClr r="0" g="0" b="0"/>
       </a:fillRef>
-      <a:effectRef idx="0">
+      <a:effectRef idx="3">
         <a:scrgbClr r="0" g="0" b="0"/>
       </a:effectRef>
-      <a:fontRef idx="minor"/>
+      <a:fontRef idx="minor">
+        <a:schemeClr val="lt1"/>
+      </a:fontRef>
     </dgm:style>
   </dgm:styleLbl>
   <dgm:styleLbl name="revTx">
@@ -7696,20 +7867,12 @@
           <a:p>
             <a:pPr algn="ctr"/>
             <a:r>
-              <a:rPr lang="en-IE" sz="3200" b="1" i="1" dirty="0" err="1">
-                <a:solidFill>
-                  <a:schemeClr val="bg1"/>
-                </a:solidFill>
-              </a:rPr>
-              <a:t>TaskTide</a:t>
-            </a:r>
-            <a:r>
               <a:rPr lang="en-IE" sz="3200" b="1" i="1" dirty="0">
                 <a:solidFill>
                   <a:schemeClr val="bg1"/>
                 </a:solidFill>
               </a:rPr>
-              <a:t> DB Coordinated Clients</a:t>
+              <a:t>TaskTide DB Coordinated Clients</a:t>
             </a:r>
           </a:p>
           <a:p>
@@ -7984,6 +8147,764 @@
           <a:chExt cx="0" cy="0"/>
         </a:xfrm>
       </p:grpSpPr>
+      <p:pic>
+        <p:nvPicPr>
+          <p:cNvPr id="5" name="Picture 4" descr="A logo of a white tooth with a red ball and bow and arrow&#10;&#10;AI-generated content may be incorrect.">
+            <a:extLst>
+              <a:ext uri="{FF2B5EF4-FFF2-40B4-BE49-F238E27FC236}">
+                <a16:creationId xmlns:a16="http://schemas.microsoft.com/office/drawing/2014/main" id="{73E130C7-F43E-218E-CFA0-2E472A9883D9}"/>
+              </a:ext>
+            </a:extLst>
+          </p:cNvPr>
+          <p:cNvPicPr>
+            <a:picLocks noChangeAspect="1"/>
+          </p:cNvPicPr>
+          <p:nvPr/>
+        </p:nvPicPr>
+        <p:blipFill>
+          <a:blip r:embed="rId2">
+            <a:extLst>
+              <a:ext uri="{28A0092B-C50C-407E-A947-70E740481C1C}">
+                <a14:useLocalDpi xmlns:a14="http://schemas.microsoft.com/office/drawing/2010/main" val="0"/>
+              </a:ext>
+            </a:extLst>
+          </a:blip>
+          <a:stretch>
+            <a:fillRect/>
+          </a:stretch>
+        </p:blipFill>
+        <p:spPr>
+          <a:xfrm>
+            <a:off x="13210843" y="5771452"/>
+            <a:ext cx="3585819" cy="2254948"/>
+          </a:xfrm>
+          <a:prstGeom prst="rect">
+            <a:avLst/>
+          </a:prstGeom>
+        </p:spPr>
+      </p:pic>
+      <p:pic>
+        <p:nvPicPr>
+          <p:cNvPr id="6" name="Picture 5" descr="A close-up of a logo&#10;&#10;AI-generated content may be incorrect.">
+            <a:extLst>
+              <a:ext uri="{FF2B5EF4-FFF2-40B4-BE49-F238E27FC236}">
+                <a16:creationId xmlns:a16="http://schemas.microsoft.com/office/drawing/2014/main" id="{3B2EDDBA-81FB-2174-1909-4135281C0833}"/>
+              </a:ext>
+            </a:extLst>
+          </p:cNvPr>
+          <p:cNvPicPr>
+            <a:picLocks noChangeAspect="1"/>
+          </p:cNvPicPr>
+          <p:nvPr/>
+        </p:nvPicPr>
+        <p:blipFill>
+          <a:blip r:embed="rId3">
+            <a:extLst>
+              <a:ext uri="{28A0092B-C50C-407E-A947-70E740481C1C}">
+                <a14:useLocalDpi xmlns:a14="http://schemas.microsoft.com/office/drawing/2010/main" val="0"/>
+              </a:ext>
+            </a:extLst>
+          </a:blip>
+          <a:stretch>
+            <a:fillRect/>
+          </a:stretch>
+        </p:blipFill>
+        <p:spPr>
+          <a:xfrm>
+            <a:off x="3007139" y="6145315"/>
+            <a:ext cx="3585454" cy="1982685"/>
+          </a:xfrm>
+          <a:prstGeom prst="rect">
+            <a:avLst/>
+          </a:prstGeom>
+        </p:spPr>
+      </p:pic>
+      <p:pic>
+        <p:nvPicPr>
+          <p:cNvPr id="1026" name="Picture 2">
+            <a:extLst>
+              <a:ext uri="{FF2B5EF4-FFF2-40B4-BE49-F238E27FC236}">
+                <a16:creationId xmlns:a16="http://schemas.microsoft.com/office/drawing/2014/main" id="{CCDAD23B-55A5-E907-1F02-B4E40AB999A3}"/>
+              </a:ext>
+            </a:extLst>
+          </p:cNvPr>
+          <p:cNvPicPr>
+            <a:picLocks noChangeAspect="1" noChangeArrowheads="1"/>
+          </p:cNvPicPr>
+          <p:nvPr/>
+        </p:nvPicPr>
+        <p:blipFill>
+          <a:blip r:embed="rId4">
+            <a:extLst>
+              <a:ext uri="{28A0092B-C50C-407E-A947-70E740481C1C}">
+                <a14:useLocalDpi xmlns:a14="http://schemas.microsoft.com/office/drawing/2010/main" val="0"/>
+              </a:ext>
+            </a:extLst>
+          </a:blip>
+          <a:srcRect/>
+          <a:stretch>
+            <a:fillRect/>
+          </a:stretch>
+        </p:blipFill>
+        <p:spPr bwMode="auto">
+          <a:xfrm>
+            <a:off x="7844101" y="2325720"/>
+            <a:ext cx="4115234" cy="2139922"/>
+          </a:xfrm>
+          <a:prstGeom prst="rect">
+            <a:avLst/>
+          </a:prstGeom>
+          <a:noFill/>
+          <a:extLst>
+            <a:ext uri="{909E8E84-426E-40DD-AFC4-6F175D3DCCD1}">
+              <a14:hiddenFill xmlns:a14="http://schemas.microsoft.com/office/drawing/2010/main">
+                <a:solidFill>
+                  <a:srgbClr val="FFFFFF"/>
+                </a:solidFill>
+              </a14:hiddenFill>
+            </a:ext>
+          </a:extLst>
+        </p:spPr>
+      </p:pic>
+      <p:pic>
+        <p:nvPicPr>
+          <p:cNvPr id="1028" name="Picture 4">
+            <a:extLst>
+              <a:ext uri="{FF2B5EF4-FFF2-40B4-BE49-F238E27FC236}">
+                <a16:creationId xmlns:a16="http://schemas.microsoft.com/office/drawing/2014/main" id="{F536A531-ACB6-9D4D-412A-8B43D77767FF}"/>
+              </a:ext>
+            </a:extLst>
+          </p:cNvPr>
+          <p:cNvPicPr>
+            <a:picLocks noChangeAspect="1" noChangeArrowheads="1"/>
+          </p:cNvPicPr>
+          <p:nvPr/>
+        </p:nvPicPr>
+        <p:blipFill>
+          <a:blip r:embed="rId5">
+            <a:extLst>
+              <a:ext uri="{28A0092B-C50C-407E-A947-70E740481C1C}">
+                <a14:useLocalDpi xmlns:a14="http://schemas.microsoft.com/office/drawing/2010/main" val="0"/>
+              </a:ext>
+            </a:extLst>
+          </a:blip>
+          <a:srcRect/>
+          <a:stretch>
+            <a:fillRect/>
+          </a:stretch>
+        </p:blipFill>
+        <p:spPr bwMode="auto">
+          <a:xfrm>
+            <a:off x="8331200" y="542940"/>
+            <a:ext cx="2435749" cy="1567352"/>
+          </a:xfrm>
+          <a:prstGeom prst="rect">
+            <a:avLst/>
+          </a:prstGeom>
+          <a:noFill/>
+          <a:extLst>
+            <a:ext uri="{909E8E84-426E-40DD-AFC4-6F175D3DCCD1}">
+              <a14:hiddenFill xmlns:a14="http://schemas.microsoft.com/office/drawing/2010/main">
+                <a:solidFill>
+                  <a:srgbClr val="FFFFFF"/>
+                </a:solidFill>
+              </a14:hiddenFill>
+            </a:ext>
+          </a:extLst>
+        </p:spPr>
+      </p:pic>
+      <p:pic>
+        <p:nvPicPr>
+          <p:cNvPr id="1034" name="Picture 10" descr="Slurm Workload Manager - Wikipedia">
+            <a:extLst>
+              <a:ext uri="{FF2B5EF4-FFF2-40B4-BE49-F238E27FC236}">
+                <a16:creationId xmlns:a16="http://schemas.microsoft.com/office/drawing/2014/main" id="{B310FE77-77EC-EC3C-705C-C79EAD29B838}"/>
+              </a:ext>
+            </a:extLst>
+          </p:cNvPr>
+          <p:cNvPicPr>
+            <a:picLocks noChangeAspect="1" noChangeArrowheads="1"/>
+          </p:cNvPicPr>
+          <p:nvPr/>
+        </p:nvPicPr>
+        <p:blipFill>
+          <a:blip r:embed="rId6">
+            <a:extLst>
+              <a:ext uri="{28A0092B-C50C-407E-A947-70E740481C1C}">
+                <a14:useLocalDpi xmlns:a14="http://schemas.microsoft.com/office/drawing/2010/main" val="0"/>
+              </a:ext>
+            </a:extLst>
+          </a:blip>
+          <a:srcRect/>
+          <a:stretch>
+            <a:fillRect/>
+          </a:stretch>
+        </p:blipFill>
+        <p:spPr bwMode="auto">
+          <a:xfrm>
+            <a:off x="2734852" y="11067701"/>
+            <a:ext cx="3908804" cy="3579813"/>
+          </a:xfrm>
+          <a:prstGeom prst="rect">
+            <a:avLst/>
+          </a:prstGeom>
+          <a:noFill/>
+          <a:extLst>
+            <a:ext uri="{909E8E84-426E-40DD-AFC4-6F175D3DCCD1}">
+              <a14:hiddenFill xmlns:a14="http://schemas.microsoft.com/office/drawing/2010/main">
+                <a:solidFill>
+                  <a:srgbClr val="FFFFFF"/>
+                </a:solidFill>
+              </a14:hiddenFill>
+            </a:ext>
+          </a:extLst>
+        </p:spPr>
+      </p:pic>
+      <p:pic>
+        <p:nvPicPr>
+          <p:cNvPr id="1036" name="Picture 12" descr="Hadoop Consulting and Support Services 🐘">
+            <a:extLst>
+              <a:ext uri="{FF2B5EF4-FFF2-40B4-BE49-F238E27FC236}">
+                <a16:creationId xmlns:a16="http://schemas.microsoft.com/office/drawing/2014/main" id="{CF53062D-BC41-1A84-6CCE-94958EE1D6EE}"/>
+              </a:ext>
+            </a:extLst>
+          </p:cNvPr>
+          <p:cNvPicPr>
+            <a:picLocks noChangeAspect="1" noChangeArrowheads="1"/>
+          </p:cNvPicPr>
+          <p:nvPr/>
+        </p:nvPicPr>
+        <p:blipFill>
+          <a:blip r:embed="rId7">
+            <a:extLst>
+              <a:ext uri="{28A0092B-C50C-407E-A947-70E740481C1C}">
+                <a14:useLocalDpi xmlns:a14="http://schemas.microsoft.com/office/drawing/2010/main" val="0"/>
+              </a:ext>
+            </a:extLst>
+          </a:blip>
+          <a:srcRect/>
+          <a:stretch>
+            <a:fillRect/>
+          </a:stretch>
+        </p:blipFill>
+        <p:spPr bwMode="auto">
+          <a:xfrm>
+            <a:off x="7966021" y="12792478"/>
+            <a:ext cx="4872885" cy="2789194"/>
+          </a:xfrm>
+          <a:prstGeom prst="rect">
+            <a:avLst/>
+          </a:prstGeom>
+          <a:noFill/>
+          <a:extLst>
+            <a:ext uri="{909E8E84-426E-40DD-AFC4-6F175D3DCCD1}">
+              <a14:hiddenFill xmlns:a14="http://schemas.microsoft.com/office/drawing/2010/main">
+                <a:solidFill>
+                  <a:srgbClr val="FFFFFF"/>
+                </a:solidFill>
+              </a14:hiddenFill>
+            </a:ext>
+          </a:extLst>
+        </p:spPr>
+      </p:pic>
+      <p:pic>
+        <p:nvPicPr>
+          <p:cNvPr id="1038" name="Picture 14" descr="Kubernetes Logo and Wordmark Sticker ...">
+            <a:extLst>
+              <a:ext uri="{FF2B5EF4-FFF2-40B4-BE49-F238E27FC236}">
+                <a16:creationId xmlns:a16="http://schemas.microsoft.com/office/drawing/2014/main" id="{15AB4257-9B6F-5A87-7CEA-CC7E2C01453E}"/>
+              </a:ext>
+            </a:extLst>
+          </p:cNvPr>
+          <p:cNvPicPr>
+            <a:picLocks noChangeAspect="1" noChangeArrowheads="1"/>
+          </p:cNvPicPr>
+          <p:nvPr/>
+        </p:nvPicPr>
+        <p:blipFill>
+          <a:blip r:embed="rId8">
+            <a:extLst>
+              <a:ext uri="{28A0092B-C50C-407E-A947-70E740481C1C}">
+                <a14:useLocalDpi xmlns:a14="http://schemas.microsoft.com/office/drawing/2010/main" val="0"/>
+              </a:ext>
+            </a:extLst>
+          </a:blip>
+          <a:srcRect/>
+          <a:stretch>
+            <a:fillRect/>
+          </a:stretch>
+        </p:blipFill>
+        <p:spPr bwMode="auto">
+          <a:xfrm>
+            <a:off x="13871688" y="11093020"/>
+            <a:ext cx="3371614" cy="3371614"/>
+          </a:xfrm>
+          <a:prstGeom prst="rect">
+            <a:avLst/>
+          </a:prstGeom>
+          <a:noFill/>
+          <a:extLst>
+            <a:ext uri="{909E8E84-426E-40DD-AFC4-6F175D3DCCD1}">
+              <a14:hiddenFill xmlns:a14="http://schemas.microsoft.com/office/drawing/2010/main">
+                <a:solidFill>
+                  <a:srgbClr val="FFFFFF"/>
+                </a:solidFill>
+              </a14:hiddenFill>
+            </a:ext>
+          </a:extLst>
+        </p:spPr>
+      </p:pic>
+      <p:pic>
+        <p:nvPicPr>
+          <p:cNvPr id="1042" name="Picture 18" descr="Python Logo PNG Vector (SVG) Free Download">
+            <a:extLst>
+              <a:ext uri="{FF2B5EF4-FFF2-40B4-BE49-F238E27FC236}">
+                <a16:creationId xmlns:a16="http://schemas.microsoft.com/office/drawing/2014/main" id="{62B89B67-4639-4806-8F38-BF34A527733A}"/>
+              </a:ext>
+            </a:extLst>
+          </p:cNvPr>
+          <p:cNvPicPr>
+            <a:picLocks noChangeAspect="1" noChangeArrowheads="1"/>
+          </p:cNvPicPr>
+          <p:nvPr/>
+        </p:nvPicPr>
+        <p:blipFill>
+          <a:blip r:embed="rId9">
+            <a:extLst>
+              <a:ext uri="{28A0092B-C50C-407E-A947-70E740481C1C}">
+                <a14:useLocalDpi xmlns:a14="http://schemas.microsoft.com/office/drawing/2010/main" val="0"/>
+              </a:ext>
+            </a:extLst>
+          </a:blip>
+          <a:srcRect/>
+          <a:stretch>
+            <a:fillRect/>
+          </a:stretch>
+        </p:blipFill>
+        <p:spPr bwMode="auto">
+          <a:xfrm>
+            <a:off x="3109214" y="825415"/>
+            <a:ext cx="3227499" cy="3227499"/>
+          </a:xfrm>
+          <a:prstGeom prst="rect">
+            <a:avLst/>
+          </a:prstGeom>
+          <a:noFill/>
+          <a:extLst>
+            <a:ext uri="{909E8E84-426E-40DD-AFC4-6F175D3DCCD1}">
+              <a14:hiddenFill xmlns:a14="http://schemas.microsoft.com/office/drawing/2010/main">
+                <a:solidFill>
+                  <a:srgbClr val="FFFFFF"/>
+                </a:solidFill>
+              </a14:hiddenFill>
+            </a:ext>
+          </a:extLst>
+        </p:spPr>
+      </p:pic>
+      <p:sp>
+        <p:nvSpPr>
+          <p:cNvPr id="10" name="Rectangle: Rounded Corners 9">
+            <a:extLst>
+              <a:ext uri="{FF2B5EF4-FFF2-40B4-BE49-F238E27FC236}">
+                <a16:creationId xmlns:a16="http://schemas.microsoft.com/office/drawing/2014/main" id="{5A815DD6-CF85-CA76-C8C9-BE2CB88C0BC0}"/>
+              </a:ext>
+            </a:extLst>
+          </p:cNvPr>
+          <p:cNvSpPr/>
+          <p:nvPr/>
+        </p:nvSpPr>
+        <p:spPr>
+          <a:xfrm>
+            <a:off x="2052320" y="243840"/>
+            <a:ext cx="15544800" cy="4470400"/>
+          </a:xfrm>
+          <a:prstGeom prst="roundRect">
+            <a:avLst/>
+          </a:prstGeom>
+          <a:noFill/>
+          <a:ln w="76200">
+            <a:solidFill>
+              <a:srgbClr val="2A2A72"/>
+            </a:solidFill>
+          </a:ln>
+          <a:effectLst>
+            <a:outerShdw blurRad="50800" dist="38100" dir="2700000" algn="tl" rotWithShape="0">
+              <a:prstClr val="black">
+                <a:alpha val="40000"/>
+              </a:prstClr>
+            </a:outerShdw>
+          </a:effectLst>
+        </p:spPr>
+        <p:style>
+          <a:lnRef idx="2">
+            <a:schemeClr val="accent1">
+              <a:shade val="15000"/>
+            </a:schemeClr>
+          </a:lnRef>
+          <a:fillRef idx="1">
+            <a:schemeClr val="accent1"/>
+          </a:fillRef>
+          <a:effectRef idx="0">
+            <a:schemeClr val="accent1"/>
+          </a:effectRef>
+          <a:fontRef idx="minor">
+            <a:schemeClr val="lt1"/>
+          </a:fontRef>
+        </p:style>
+        <p:txBody>
+          <a:bodyPr rtlCol="0" anchor="ctr"/>
+          <a:lstStyle/>
+          <a:p>
+            <a:pPr algn="ctr"/>
+            <a:endParaRPr lang="en-IE"/>
+          </a:p>
+        </p:txBody>
+      </p:sp>
+      <p:sp>
+        <p:nvSpPr>
+          <p:cNvPr id="11" name="Rectangle: Rounded Corners 10">
+            <a:extLst>
+              <a:ext uri="{FF2B5EF4-FFF2-40B4-BE49-F238E27FC236}">
+                <a16:creationId xmlns:a16="http://schemas.microsoft.com/office/drawing/2014/main" id="{93361AE9-7B9B-9BA8-B967-A09704AB0BCC}"/>
+              </a:ext>
+            </a:extLst>
+          </p:cNvPr>
+          <p:cNvSpPr/>
+          <p:nvPr/>
+        </p:nvSpPr>
+        <p:spPr>
+          <a:xfrm>
+            <a:off x="2082800" y="5207856"/>
+            <a:ext cx="15544800" cy="4909804"/>
+          </a:xfrm>
+          <a:prstGeom prst="roundRect">
+            <a:avLst/>
+          </a:prstGeom>
+          <a:noFill/>
+          <a:ln w="76200">
+            <a:solidFill>
+              <a:srgbClr val="800020"/>
+            </a:solidFill>
+          </a:ln>
+          <a:effectLst>
+            <a:outerShdw blurRad="50800" dist="38100" dir="2700000" algn="tl" rotWithShape="0">
+              <a:prstClr val="black">
+                <a:alpha val="40000"/>
+              </a:prstClr>
+            </a:outerShdw>
+          </a:effectLst>
+        </p:spPr>
+        <p:style>
+          <a:lnRef idx="2">
+            <a:schemeClr val="accent1">
+              <a:shade val="15000"/>
+            </a:schemeClr>
+          </a:lnRef>
+          <a:fillRef idx="1">
+            <a:schemeClr val="accent1"/>
+          </a:fillRef>
+          <a:effectRef idx="0">
+            <a:schemeClr val="accent1"/>
+          </a:effectRef>
+          <a:fontRef idx="minor">
+            <a:schemeClr val="lt1"/>
+          </a:fontRef>
+        </p:style>
+        <p:txBody>
+          <a:bodyPr rtlCol="0" anchor="ctr"/>
+          <a:lstStyle/>
+          <a:p>
+            <a:pPr algn="ctr"/>
+            <a:endParaRPr lang="en-IE"/>
+          </a:p>
+        </p:txBody>
+      </p:sp>
+      <p:sp>
+        <p:nvSpPr>
+          <p:cNvPr id="12" name="Rectangle: Rounded Corners 11">
+            <a:extLst>
+              <a:ext uri="{FF2B5EF4-FFF2-40B4-BE49-F238E27FC236}">
+                <a16:creationId xmlns:a16="http://schemas.microsoft.com/office/drawing/2014/main" id="{1E4D2371-C54A-9C5B-B216-E076192FB328}"/>
+              </a:ext>
+            </a:extLst>
+          </p:cNvPr>
+          <p:cNvSpPr/>
+          <p:nvPr/>
+        </p:nvSpPr>
+        <p:spPr>
+          <a:xfrm>
+            <a:off x="2113280" y="10586720"/>
+            <a:ext cx="15544800" cy="5332300"/>
+          </a:xfrm>
+          <a:prstGeom prst="roundRect">
+            <a:avLst/>
+          </a:prstGeom>
+          <a:noFill/>
+          <a:ln w="76200">
+            <a:solidFill>
+              <a:srgbClr val="3B3B98"/>
+            </a:solidFill>
+          </a:ln>
+          <a:effectLst>
+            <a:outerShdw blurRad="50800" dist="38100" dir="2700000" algn="tl" rotWithShape="0">
+              <a:prstClr val="black">
+                <a:alpha val="40000"/>
+              </a:prstClr>
+            </a:outerShdw>
+          </a:effectLst>
+        </p:spPr>
+        <p:style>
+          <a:lnRef idx="2">
+            <a:schemeClr val="accent1">
+              <a:shade val="15000"/>
+            </a:schemeClr>
+          </a:lnRef>
+          <a:fillRef idx="1">
+            <a:schemeClr val="accent1"/>
+          </a:fillRef>
+          <a:effectRef idx="0">
+            <a:schemeClr val="accent1"/>
+          </a:effectRef>
+          <a:fontRef idx="minor">
+            <a:schemeClr val="lt1"/>
+          </a:fontRef>
+        </p:style>
+        <p:txBody>
+          <a:bodyPr rtlCol="0" anchor="ctr"/>
+          <a:lstStyle/>
+          <a:p>
+            <a:pPr algn="ctr"/>
+            <a:endParaRPr lang="en-IE"/>
+          </a:p>
+        </p:txBody>
+      </p:sp>
+      <p:pic>
+        <p:nvPicPr>
+          <p:cNvPr id="1046" name="Picture 22" descr="R Meets Hardware | R-bloggers">
+            <a:extLst>
+              <a:ext uri="{FF2B5EF4-FFF2-40B4-BE49-F238E27FC236}">
+                <a16:creationId xmlns:a16="http://schemas.microsoft.com/office/drawing/2014/main" id="{A71FA59A-7421-FA14-8B69-A08ECC946178}"/>
+              </a:ext>
+            </a:extLst>
+          </p:cNvPr>
+          <p:cNvPicPr>
+            <a:picLocks noChangeAspect="1" noChangeArrowheads="1"/>
+          </p:cNvPicPr>
+          <p:nvPr/>
+        </p:nvPicPr>
+        <p:blipFill>
+          <a:blip r:embed="rId10">
+            <a:extLst>
+              <a:ext uri="{28A0092B-C50C-407E-A947-70E740481C1C}">
+                <a14:useLocalDpi xmlns:a14="http://schemas.microsoft.com/office/drawing/2010/main" val="0"/>
+              </a:ext>
+            </a:extLst>
+          </a:blip>
+          <a:srcRect/>
+          <a:stretch>
+            <a:fillRect/>
+          </a:stretch>
+        </p:blipFill>
+        <p:spPr bwMode="auto">
+          <a:xfrm>
+            <a:off x="13318408" y="679142"/>
+            <a:ext cx="3478254" cy="3478254"/>
+          </a:xfrm>
+          <a:prstGeom prst="rect">
+            <a:avLst/>
+          </a:prstGeom>
+          <a:noFill/>
+          <a:extLst>
+            <a:ext uri="{909E8E84-426E-40DD-AFC4-6F175D3DCCD1}">
+              <a14:hiddenFill xmlns:a14="http://schemas.microsoft.com/office/drawing/2010/main">
+                <a:solidFill>
+                  <a:srgbClr val="FFFFFF"/>
+                </a:solidFill>
+              </a14:hiddenFill>
+            </a:ext>
+          </a:extLst>
+        </p:spPr>
+      </p:pic>
+      <p:sp>
+        <p:nvSpPr>
+          <p:cNvPr id="13" name="TextBox 12">
+            <a:extLst>
+              <a:ext uri="{FF2B5EF4-FFF2-40B4-BE49-F238E27FC236}">
+                <a16:creationId xmlns:a16="http://schemas.microsoft.com/office/drawing/2014/main" id="{982E426D-90DF-9E70-8E8B-8220C5D9CE9B}"/>
+              </a:ext>
+            </a:extLst>
+          </p:cNvPr>
+          <p:cNvSpPr txBox="1"/>
+          <p:nvPr/>
+        </p:nvSpPr>
+        <p:spPr>
+          <a:xfrm rot="16200000">
+            <a:off x="-732238" y="1689187"/>
+            <a:ext cx="4035097" cy="1077218"/>
+          </a:xfrm>
+          <a:prstGeom prst="rect">
+            <a:avLst/>
+          </a:prstGeom>
+          <a:noFill/>
+        </p:spPr>
+        <p:txBody>
+          <a:bodyPr wrap="square" rtlCol="0">
+            <a:spAutoFit/>
+          </a:bodyPr>
+          <a:lstStyle/>
+          <a:p>
+            <a:pPr algn="ctr"/>
+            <a:r>
+              <a:rPr lang="en-IE" sz="3200" b="1" i="1" dirty="0">
+                <a:solidFill>
+                  <a:srgbClr val="2A2A72"/>
+                </a:solidFill>
+              </a:rPr>
+              <a:t>Data Application Layer</a:t>
+            </a:r>
+          </a:p>
+        </p:txBody>
+      </p:sp>
+      <p:sp>
+        <p:nvSpPr>
+          <p:cNvPr id="14" name="TextBox 13">
+            <a:extLst>
+              <a:ext uri="{FF2B5EF4-FFF2-40B4-BE49-F238E27FC236}">
+                <a16:creationId xmlns:a16="http://schemas.microsoft.com/office/drawing/2014/main" id="{7A1024C1-7776-2129-C309-C8FF5AE68EEE}"/>
+              </a:ext>
+            </a:extLst>
+          </p:cNvPr>
+          <p:cNvSpPr txBox="1"/>
+          <p:nvPr/>
+        </p:nvSpPr>
+        <p:spPr>
+          <a:xfrm rot="16200000">
+            <a:off x="-722078" y="6962227"/>
+            <a:ext cx="4035097" cy="1077218"/>
+          </a:xfrm>
+          <a:prstGeom prst="rect">
+            <a:avLst/>
+          </a:prstGeom>
+          <a:noFill/>
+        </p:spPr>
+        <p:txBody>
+          <a:bodyPr wrap="square" rtlCol="0">
+            <a:spAutoFit/>
+          </a:bodyPr>
+          <a:lstStyle/>
+          <a:p>
+            <a:pPr algn="ctr"/>
+            <a:r>
+              <a:rPr lang="en-IE" sz="3200" b="1" i="1" dirty="0">
+                <a:solidFill>
+                  <a:srgbClr val="800020"/>
+                </a:solidFill>
+              </a:rPr>
+              <a:t>Orchestration    Layer</a:t>
+            </a:r>
+          </a:p>
+        </p:txBody>
+      </p:sp>
+      <p:sp>
+        <p:nvSpPr>
+          <p:cNvPr id="15" name="TextBox 14">
+            <a:extLst>
+              <a:ext uri="{FF2B5EF4-FFF2-40B4-BE49-F238E27FC236}">
+                <a16:creationId xmlns:a16="http://schemas.microsoft.com/office/drawing/2014/main" id="{8B442966-5C09-8D5B-777A-DC9B15E129F1}"/>
+              </a:ext>
+            </a:extLst>
+          </p:cNvPr>
+          <p:cNvSpPr txBox="1"/>
+          <p:nvPr/>
+        </p:nvSpPr>
+        <p:spPr>
+          <a:xfrm rot="16200000">
+            <a:off x="-610318" y="12621347"/>
+            <a:ext cx="4035097" cy="1077218"/>
+          </a:xfrm>
+          <a:prstGeom prst="rect">
+            <a:avLst/>
+          </a:prstGeom>
+          <a:noFill/>
+        </p:spPr>
+        <p:txBody>
+          <a:bodyPr wrap="square" rtlCol="0">
+            <a:spAutoFit/>
+          </a:bodyPr>
+          <a:lstStyle/>
+          <a:p>
+            <a:pPr algn="ctr"/>
+            <a:r>
+              <a:rPr lang="en-IE" sz="3200" b="1" i="1" dirty="0">
+                <a:solidFill>
+                  <a:srgbClr val="3B3B98"/>
+                </a:solidFill>
+              </a:rPr>
+              <a:t>Infrastructure    Layer</a:t>
+            </a:r>
+          </a:p>
+        </p:txBody>
+      </p:sp>
+      <p:pic>
+        <p:nvPicPr>
+          <p:cNvPr id="17" name="Picture 16">
+            <a:extLst>
+              <a:ext uri="{FF2B5EF4-FFF2-40B4-BE49-F238E27FC236}">
+                <a16:creationId xmlns:a16="http://schemas.microsoft.com/office/drawing/2014/main" id="{30CB8691-6939-E709-3301-C6197E8637E5}"/>
+              </a:ext>
+            </a:extLst>
+          </p:cNvPr>
+          <p:cNvPicPr>
+            <a:picLocks noChangeAspect="1"/>
+          </p:cNvPicPr>
+          <p:nvPr/>
+        </p:nvPicPr>
+        <p:blipFill>
+          <a:blip r:embed="rId11"/>
+          <a:stretch>
+            <a:fillRect/>
+          </a:stretch>
+        </p:blipFill>
+        <p:spPr>
+          <a:xfrm>
+            <a:off x="7463180" y="5501394"/>
+            <a:ext cx="4877076" cy="4359810"/>
+          </a:xfrm>
+          <a:prstGeom prst="rect">
+            <a:avLst/>
+          </a:prstGeom>
+        </p:spPr>
+      </p:pic>
+    </p:spTree>
+    <p:extLst>
+      <p:ext uri="{BB962C8B-B14F-4D97-AF65-F5344CB8AC3E}">
+        <p14:creationId xmlns:p14="http://schemas.microsoft.com/office/powerpoint/2010/main" val="2635011521"/>
+      </p:ext>
+    </p:extLst>
+  </p:cSld>
+  <p:clrMapOvr>
+    <a:masterClrMapping/>
+  </p:clrMapOvr>
+</p:sld>
+</file>
+
+<file path=ppt/slides/slide3.xml><?xml version="1.0" encoding="utf-8"?>
+<p:sld xmlns:a="http://schemas.openxmlformats.org/drawingml/2006/main" xmlns:r="http://schemas.openxmlformats.org/officeDocument/2006/relationships" xmlns:p="http://schemas.openxmlformats.org/presentationml/2006/main">
+  <p:cSld>
+    <p:spTree>
+      <p:nvGrpSpPr>
+        <p:cNvPr id="1" name=""/>
+        <p:cNvGrpSpPr/>
+        <p:nvPr/>
+      </p:nvGrpSpPr>
+      <p:grpSpPr>
+        <a:xfrm>
+          <a:off x="0" y="0"/>
+          <a:ext cx="0" cy="0"/>
+          <a:chOff x="0" y="0"/>
+          <a:chExt cx="0" cy="0"/>
+        </a:xfrm>
+      </p:grpSpPr>
       <p:sp>
         <p:nvSpPr>
           <p:cNvPr id="4" name="Title 1">
@@ -8015,15 +8936,7 @@
             <a:pPr algn="ctr"/>
             <a:r>
               <a:rPr lang="en-IE" b="1" dirty="0"/>
-              <a:t>Mapping of </a:t>
-            </a:r>
-            <a:r>
-              <a:rPr lang="en-IE" b="1" dirty="0" err="1"/>
-              <a:t>TaskTide</a:t>
-            </a:r>
-            <a:r>
-              <a:rPr lang="en-IE" b="1" dirty="0"/>
-              <a:t> Components to Pilot Job Model</a:t>
+              <a:t>Mapping of TaskTide Components to Pilot Job Model</a:t>
             </a:r>
           </a:p>
         </p:txBody>
@@ -8335,12 +9248,8 @@
           <a:p>
             <a:pPr algn="ctr"/>
             <a:r>
-              <a:rPr lang="en-IE" sz="4000" b="1" i="1" dirty="0" err="1"/>
-              <a:t>TaskTide</a:t>
-            </a:r>
-            <a:r>
               <a:rPr lang="en-IE" sz="4000" b="1" i="1" dirty="0"/>
-              <a:t> Manager</a:t>
+              <a:t>TaskTide Manager</a:t>
             </a:r>
           </a:p>
           <a:p>
@@ -8353,12 +9262,8 @@
           <a:p>
             <a:pPr algn="ctr"/>
             <a:r>
-              <a:rPr lang="en-IE" sz="4000" b="1" i="1" dirty="0" err="1"/>
-              <a:t>TaskTide</a:t>
-            </a:r>
-            <a:r>
               <a:rPr lang="en-IE" sz="4000" b="1" i="1" dirty="0"/>
-              <a:t> Repository</a:t>
+              <a:t>TaskTide Repository</a:t>
             </a:r>
             <a:endParaRPr lang="en-IE" sz="3600" b="1" i="1" dirty="0"/>
           </a:p>
@@ -8511,12 +9416,8 @@
           <a:p>
             <a:pPr algn="ctr"/>
             <a:r>
-              <a:rPr lang="en-IE" sz="4000" b="1" i="1" dirty="0" err="1"/>
-              <a:t>TaskTide</a:t>
-            </a:r>
-            <a:r>
               <a:rPr lang="en-IE" sz="4000" b="1" i="1" dirty="0"/>
-              <a:t> Client</a:t>
+              <a:t>TaskTide Client</a:t>
             </a:r>
           </a:p>
           <a:p>
@@ -8529,12 +9430,8 @@
           <a:p>
             <a:pPr algn="ctr"/>
             <a:r>
-              <a:rPr lang="en-IE" sz="4000" b="1" i="1" dirty="0" err="1"/>
-              <a:t>TaskTide</a:t>
-            </a:r>
-            <a:r>
               <a:rPr lang="en-IE" sz="4000" b="1" i="1" dirty="0"/>
-              <a:t> Engine</a:t>
+              <a:t>TaskTide Engine</a:t>
             </a:r>
             <a:endParaRPr lang="en-IE" sz="3600" b="1" i="1" dirty="0"/>
           </a:p>
@@ -8554,7 +9451,7 @@
         </p:nvSpPr>
         <p:spPr>
           <a:xfrm>
-            <a:off x="2275840" y="7924801"/>
+            <a:off x="2275840" y="7904481"/>
             <a:ext cx="1178560" cy="3891280"/>
           </a:xfrm>
           <a:prstGeom prst="downArrow">
@@ -8568,6 +9465,13 @@
               <a:schemeClr val="tx1"/>
             </a:solidFill>
           </a:ln>
+          <a:scene3d>
+            <a:camera prst="orthographicFront"/>
+            <a:lightRig rig="threePt" dir="t"/>
+          </a:scene3d>
+          <a:sp3d>
+            <a:bevelT w="152400" h="50800" prst="softRound"/>
+          </a:sp3d>
         </p:spPr>
         <p:style>
           <a:lnRef idx="2">
@@ -8608,7 +9512,7 @@
         </p:nvSpPr>
         <p:spPr>
           <a:xfrm>
-            <a:off x="8300720" y="7914640"/>
+            <a:off x="8300720" y="7894320"/>
             <a:ext cx="1178560" cy="3901440"/>
           </a:xfrm>
           <a:prstGeom prst="downArrow">
@@ -8622,6 +9526,13 @@
               <a:schemeClr val="tx1"/>
             </a:solidFill>
           </a:ln>
+          <a:scene3d>
+            <a:camera prst="orthographicFront"/>
+            <a:lightRig rig="threePt" dir="t"/>
+          </a:scene3d>
+          <a:sp3d>
+            <a:bevelT w="152400" h="50800" prst="softRound"/>
+          </a:sp3d>
         </p:spPr>
         <p:style>
           <a:lnRef idx="2">
@@ -8662,7 +9573,7 @@
         </p:nvSpPr>
         <p:spPr>
           <a:xfrm>
-            <a:off x="14406880" y="7945120"/>
+            <a:off x="14406880" y="7904480"/>
             <a:ext cx="1178560" cy="3901440"/>
           </a:xfrm>
           <a:prstGeom prst="downArrow">
@@ -8676,6 +9587,13 @@
               <a:schemeClr val="tx1"/>
             </a:solidFill>
           </a:ln>
+          <a:scene3d>
+            <a:camera prst="orthographicFront"/>
+            <a:lightRig rig="threePt" dir="t"/>
+          </a:scene3d>
+          <a:sp3d>
+            <a:bevelT w="152400" h="50800" prst="softRound"/>
+          </a:sp3d>
         </p:spPr>
         <p:style>
           <a:lnRef idx="2">
@@ -8715,7 +9633,7 @@
 </p:sld>
 </file>
 
-<file path=ppt/slides/slide3.xml><?xml version="1.0" encoding="utf-8"?>
+<file path=ppt/slides/slide4.xml><?xml version="1.0" encoding="utf-8"?>
 <p:sld xmlns:a="http://schemas.openxmlformats.org/drawingml/2006/main" xmlns:r="http://schemas.openxmlformats.org/officeDocument/2006/relationships" xmlns:p="http://schemas.openxmlformats.org/presentationml/2006/main">
   <p:cSld>
     <p:spTree>
@@ -8742,11 +9660,17 @@
             </a:extLst>
           </p:cNvPr>
           <p:cNvGraphicFramePr/>
-          <p:nvPr/>
+          <p:nvPr>
+            <p:extLst>
+              <p:ext uri="{D42A27DB-BD31-4B8C-83A1-F6EECF244321}">
+                <p14:modId xmlns:p14="http://schemas.microsoft.com/office/powerpoint/2010/main" val="3174936920"/>
+              </p:ext>
+            </p:extLst>
+          </p:nvPr>
         </p:nvGraphicFramePr>
         <p:xfrm>
-          <a:off x="-1320800" y="4278215"/>
-          <a:ext cx="8595360" cy="7644007"/>
+          <a:off x="-2113278" y="3993735"/>
+          <a:ext cx="9834878" cy="9234585"/>
         </p:xfrm>
         <a:graphic>
           <a:graphicData uri="http://schemas.openxmlformats.org/drawingml/2006/diagram">
@@ -8768,7 +9692,7 @@
         </p:nvCxnSpPr>
         <p:spPr>
           <a:xfrm>
-            <a:off x="5831840" y="3169920"/>
+            <a:off x="5831840" y="2743200"/>
             <a:ext cx="0" cy="11988800"/>
           </a:xfrm>
           <a:prstGeom prst="line">
@@ -8812,7 +9736,7 @@
         </p:nvSpPr>
         <p:spPr>
           <a:xfrm>
-            <a:off x="10911847" y="2540001"/>
+            <a:off x="10789927" y="2113281"/>
             <a:ext cx="2153905" cy="2022695"/>
           </a:xfrm>
           <a:prstGeom prst="can">
@@ -8823,6 +9747,13 @@
               <a:schemeClr val="tx1"/>
             </a:solidFill>
           </a:ln>
+          <a:effectLst>
+            <a:outerShdw blurRad="50800" dist="38100" algn="l" rotWithShape="0">
+              <a:prstClr val="black">
+                <a:alpha val="40000"/>
+              </a:prstClr>
+            </a:outerShdw>
+          </a:effectLst>
         </p:spPr>
         <p:style>
           <a:lnRef idx="2">
@@ -8846,10 +9777,9 @@
           <a:p>
             <a:pPr algn="ctr"/>
             <a:r>
-              <a:rPr lang="en-IE" sz="2800" b="1" dirty="0" err="1"/>
+              <a:rPr lang="en-IE" sz="2800" b="1" dirty="0"/>
               <a:t>TaskTide</a:t>
             </a:r>
-            <a:endParaRPr lang="en-IE" sz="2800" b="1" dirty="0"/>
           </a:p>
           <a:p>
             <a:pPr algn="ctr"/>
@@ -8874,7 +9804,7 @@
         </p:nvSpPr>
         <p:spPr>
           <a:xfrm>
-            <a:off x="6583687" y="5852161"/>
+            <a:off x="6461767" y="5425441"/>
             <a:ext cx="11155674" cy="9384150"/>
           </a:xfrm>
           <a:prstGeom prst="roundRect">
@@ -8932,9 +9862,9 @@
           <p:nvPr/>
         </p:nvCxnSpPr>
         <p:spPr>
-          <a:xfrm flipH="1">
-            <a:off x="9078905" y="4772895"/>
-            <a:ext cx="2413040" cy="1648226"/>
+          <a:xfrm>
+            <a:off x="11532585" y="4346175"/>
+            <a:ext cx="0" cy="968362"/>
           </a:xfrm>
           <a:prstGeom prst="straightConnector1">
             <a:avLst/>
@@ -8977,8 +9907,8 @@
         </p:nvCxnSpPr>
         <p:spPr>
           <a:xfrm flipH="1" flipV="1">
-            <a:off x="12039600" y="4673600"/>
-            <a:ext cx="2619852" cy="3426619"/>
+            <a:off x="11998960" y="4287520"/>
+            <a:ext cx="1" cy="954107"/>
           </a:xfrm>
           <a:prstGeom prst="straightConnector1">
             <a:avLst/>
@@ -9019,7 +9949,7 @@
         </p:nvSpPr>
         <p:spPr>
           <a:xfrm>
-            <a:off x="10952480" y="7100986"/>
+            <a:off x="10830560" y="6674266"/>
             <a:ext cx="1767841" cy="6797894"/>
           </a:xfrm>
           <a:prstGeom prst="rightBrace">
@@ -9068,7 +9998,7 @@
         </p:nvCxnSpPr>
         <p:spPr>
           <a:xfrm>
-            <a:off x="8991600" y="8517637"/>
+            <a:off x="8869680" y="8090917"/>
             <a:ext cx="0" cy="1036320"/>
           </a:xfrm>
           <a:prstGeom prst="straightConnector1">
@@ -9110,7 +10040,7 @@
         </p:nvCxnSpPr>
         <p:spPr>
           <a:xfrm>
-            <a:off x="9013346" y="11700606"/>
+            <a:off x="8891426" y="11273886"/>
             <a:ext cx="0" cy="1036320"/>
           </a:xfrm>
           <a:prstGeom prst="straightConnector1">
@@ -9154,7 +10084,7 @@
         </p:nvCxnSpPr>
         <p:spPr>
           <a:xfrm flipH="1">
-            <a:off x="13414054" y="10271270"/>
+            <a:off x="13292134" y="9844550"/>
             <a:ext cx="1284683" cy="904731"/>
           </a:xfrm>
           <a:prstGeom prst="straightConnector1">
@@ -9198,7 +10128,7 @@
         </p:nvCxnSpPr>
         <p:spPr>
           <a:xfrm>
-            <a:off x="13358654" y="12717426"/>
+            <a:off x="13236734" y="12290706"/>
             <a:ext cx="1340082" cy="1026324"/>
           </a:xfrm>
           <a:prstGeom prst="straightConnector1">
@@ -9242,7 +10172,7 @@
         </p:nvCxnSpPr>
         <p:spPr>
           <a:xfrm flipV="1">
-            <a:off x="15039647" y="12731753"/>
+            <a:off x="14917727" y="12305033"/>
             <a:ext cx="1282078" cy="978690"/>
           </a:xfrm>
           <a:prstGeom prst="straightConnector1">
@@ -9284,17 +10214,33 @@
         </p:nvSpPr>
         <p:spPr>
           <a:xfrm>
-            <a:off x="7492516" y="6543040"/>
+            <a:off x="7370596" y="6116320"/>
             <a:ext cx="3152458" cy="1852676"/>
           </a:xfrm>
           <a:prstGeom prst="roundRect">
             <a:avLst/>
           </a:prstGeom>
           <a:ln w="38100">
-            <a:solidFill>
-              <a:schemeClr val="tx1"/>
-            </a:solidFill>
+            <a:noFill/>
           </a:ln>
+          <a:effectLst>
+            <a:outerShdw blurRad="190500" dist="228600" dir="2700000" algn="ctr">
+              <a:srgbClr val="000000">
+                <a:alpha val="30000"/>
+              </a:srgbClr>
+            </a:outerShdw>
+          </a:effectLst>
+          <a:scene3d>
+            <a:camera prst="orthographicFront">
+              <a:rot lat="0" lon="0" rev="0"/>
+            </a:camera>
+            <a:lightRig rig="glow" dir="t">
+              <a:rot lat="0" lon="0" rev="4800000"/>
+            </a:lightRig>
+          </a:scene3d>
+          <a:sp3d prstMaterial="matte">
+            <a:bevelT w="127000" h="63500"/>
+          </a:sp3d>
         </p:spPr>
         <p:style>
           <a:lnRef idx="2">
@@ -9319,7 +10265,7 @@
             <a:pPr algn="ctr"/>
             <a:r>
               <a:rPr lang="en-IE" sz="2800" b="1" dirty="0"/>
-              <a:t>Tasks Fetched</a:t>
+              <a:t>Fetch Tasks</a:t>
             </a:r>
           </a:p>
         </p:txBody>
@@ -9338,17 +10284,33 @@
         </p:nvSpPr>
         <p:spPr>
           <a:xfrm>
-            <a:off x="7502677" y="9662160"/>
+            <a:off x="7380757" y="9235440"/>
             <a:ext cx="3152458" cy="1852676"/>
           </a:xfrm>
           <a:prstGeom prst="roundRect">
             <a:avLst/>
           </a:prstGeom>
           <a:ln w="38100">
-            <a:solidFill>
-              <a:schemeClr val="tx1"/>
-            </a:solidFill>
+            <a:noFill/>
           </a:ln>
+          <a:effectLst>
+            <a:outerShdw blurRad="190500" dist="228600" dir="2700000" algn="ctr">
+              <a:srgbClr val="000000">
+                <a:alpha val="30000"/>
+              </a:srgbClr>
+            </a:outerShdw>
+          </a:effectLst>
+          <a:scene3d>
+            <a:camera prst="orthographicFront">
+              <a:rot lat="0" lon="0" rev="0"/>
+            </a:camera>
+            <a:lightRig rig="glow" dir="t">
+              <a:rot lat="0" lon="0" rev="4800000"/>
+            </a:lightRig>
+          </a:scene3d>
+          <a:sp3d prstMaterial="matte">
+            <a:bevelT w="127000" h="63500"/>
+          </a:sp3d>
         </p:spPr>
         <p:style>
           <a:lnRef idx="2">
@@ -9392,17 +10354,33 @@
         </p:nvSpPr>
         <p:spPr>
           <a:xfrm>
-            <a:off x="7502677" y="12872720"/>
+            <a:off x="7380757" y="12446000"/>
             <a:ext cx="3152458" cy="1852676"/>
           </a:xfrm>
           <a:prstGeom prst="roundRect">
             <a:avLst/>
           </a:prstGeom>
           <a:ln w="38100">
-            <a:solidFill>
-              <a:schemeClr val="tx1"/>
-            </a:solidFill>
+            <a:noFill/>
           </a:ln>
+          <a:effectLst>
+            <a:outerShdw blurRad="190500" dist="228600" dir="2700000" algn="ctr">
+              <a:srgbClr val="000000">
+                <a:alpha val="30000"/>
+              </a:srgbClr>
+            </a:outerShdw>
+          </a:effectLst>
+          <a:scene3d>
+            <a:camera prst="orthographicFront">
+              <a:rot lat="0" lon="0" rev="0"/>
+            </a:camera>
+            <a:lightRig rig="glow" dir="t">
+              <a:rot lat="0" lon="0" rev="4800000"/>
+            </a:lightRig>
+          </a:scene3d>
+          <a:sp3d prstMaterial="matte">
+            <a:bevelT w="127000" h="63500"/>
+          </a:sp3d>
         </p:spPr>
         <p:style>
           <a:lnRef idx="2">
@@ -9446,17 +10424,33 @@
         </p:nvSpPr>
         <p:spPr>
           <a:xfrm>
-            <a:off x="13159348" y="8274065"/>
+            <a:off x="13037428" y="7847345"/>
             <a:ext cx="3152458" cy="1852676"/>
           </a:xfrm>
           <a:prstGeom prst="roundRect">
             <a:avLst/>
           </a:prstGeom>
           <a:ln w="38100">
-            <a:solidFill>
-              <a:schemeClr val="tx1"/>
-            </a:solidFill>
+            <a:noFill/>
           </a:ln>
+          <a:effectLst>
+            <a:outerShdw blurRad="190500" dist="228600" dir="2700000" algn="ctr">
+              <a:srgbClr val="000000">
+                <a:alpha val="30000"/>
+              </a:srgbClr>
+            </a:outerShdw>
+          </a:effectLst>
+          <a:scene3d>
+            <a:camera prst="orthographicFront">
+              <a:rot lat="0" lon="0" rev="0"/>
+            </a:camera>
+            <a:lightRig rig="glow" dir="t">
+              <a:rot lat="0" lon="0" rev="4800000"/>
+            </a:lightRig>
+          </a:scene3d>
+          <a:sp3d prstMaterial="matte">
+            <a:bevelT w="127000" h="63500"/>
+          </a:sp3d>
         </p:spPr>
         <p:style>
           <a:lnRef idx="2">
@@ -9500,17 +10494,33 @@
         </p:nvSpPr>
         <p:spPr>
           <a:xfrm>
-            <a:off x="12248432" y="11343102"/>
+            <a:off x="12126512" y="10916382"/>
             <a:ext cx="2220444" cy="1158240"/>
           </a:xfrm>
           <a:prstGeom prst="roundRect">
             <a:avLst/>
           </a:prstGeom>
           <a:ln w="38100">
-            <a:solidFill>
-              <a:schemeClr val="tx1"/>
-            </a:solidFill>
+            <a:noFill/>
           </a:ln>
+          <a:effectLst>
+            <a:outerShdw blurRad="190500" dist="228600" dir="2700000" algn="ctr">
+              <a:srgbClr val="000000">
+                <a:alpha val="30000"/>
+              </a:srgbClr>
+            </a:outerShdw>
+          </a:effectLst>
+          <a:scene3d>
+            <a:camera prst="orthographicFront">
+              <a:rot lat="0" lon="0" rev="0"/>
+            </a:camera>
+            <a:lightRig rig="glow" dir="t">
+              <a:rot lat="0" lon="0" rev="4800000"/>
+            </a:lightRig>
+          </a:scene3d>
+          <a:sp3d prstMaterial="matte">
+            <a:bevelT w="127000" h="63500"/>
+          </a:sp3d>
         </p:spPr>
         <p:style>
           <a:lnRef idx="2">
@@ -9558,17 +10568,33 @@
         </p:nvSpPr>
         <p:spPr>
           <a:xfrm>
-            <a:off x="13414053" y="13872088"/>
+            <a:off x="13292133" y="13445368"/>
             <a:ext cx="2897752" cy="1158240"/>
           </a:xfrm>
           <a:prstGeom prst="roundRect">
             <a:avLst/>
           </a:prstGeom>
           <a:ln w="38100">
-            <a:solidFill>
-              <a:schemeClr val="tx1"/>
-            </a:solidFill>
+            <a:noFill/>
           </a:ln>
+          <a:effectLst>
+            <a:outerShdw blurRad="190500" dist="228600" dir="2700000" algn="ctr">
+              <a:srgbClr val="000000">
+                <a:alpha val="30000"/>
+              </a:srgbClr>
+            </a:outerShdw>
+          </a:effectLst>
+          <a:scene3d>
+            <a:camera prst="orthographicFront">
+              <a:rot lat="0" lon="0" rev="0"/>
+            </a:camera>
+            <a:lightRig rig="glow" dir="t">
+              <a:rot lat="0" lon="0" rev="4800000"/>
+            </a:lightRig>
+          </a:scene3d>
+          <a:sp3d prstMaterial="matte">
+            <a:bevelT w="127000" h="63500"/>
+          </a:sp3d>
         </p:spPr>
         <p:style>
           <a:lnRef idx="2">
@@ -9616,17 +10642,33 @@
         </p:nvSpPr>
         <p:spPr>
           <a:xfrm>
-            <a:off x="15201583" y="11344147"/>
+            <a:off x="15079663" y="10917427"/>
             <a:ext cx="2220444" cy="1158240"/>
           </a:xfrm>
           <a:prstGeom prst="roundRect">
             <a:avLst/>
           </a:prstGeom>
           <a:ln w="38100">
-            <a:solidFill>
-              <a:schemeClr val="tx1"/>
-            </a:solidFill>
+            <a:noFill/>
           </a:ln>
+          <a:effectLst>
+            <a:outerShdw blurRad="190500" dist="228600" dir="2700000" algn="ctr">
+              <a:srgbClr val="000000">
+                <a:alpha val="30000"/>
+              </a:srgbClr>
+            </a:outerShdw>
+          </a:effectLst>
+          <a:scene3d>
+            <a:camera prst="orthographicFront">
+              <a:rot lat="0" lon="0" rev="0"/>
+            </a:camera>
+            <a:lightRig rig="glow" dir="t">
+              <a:rot lat="0" lon="0" rev="4800000"/>
+            </a:lightRig>
+          </a:scene3d>
+          <a:sp3d prstMaterial="matte">
+            <a:bevelT w="127000" h="63500"/>
+          </a:sp3d>
         </p:spPr>
         <p:style>
           <a:lnRef idx="2">
@@ -9709,7 +10751,7 @@
         </p:nvSpPr>
         <p:spPr>
           <a:xfrm>
-            <a:off x="13701784" y="5368177"/>
+            <a:off x="7604971" y="4942861"/>
             <a:ext cx="2960616" cy="523220"/>
           </a:xfrm>
           <a:prstGeom prst="rect">
@@ -9724,12 +10766,8 @@
           <a:lstStyle/>
           <a:p>
             <a:r>
-              <a:rPr lang="en-IE" sz="2800" b="1" dirty="0" err="1"/>
-              <a:t>TaskTide</a:t>
-            </a:r>
-            <a:r>
               <a:rPr lang="en-IE" sz="2800" b="1" dirty="0"/>
-              <a:t> Engine</a:t>
+              <a:t>TaskTide Engine</a:t>
             </a:r>
           </a:p>
         </p:txBody>
@@ -9748,7 +10786,7 @@
         </p:nvSpPr>
         <p:spPr>
           <a:xfrm>
-            <a:off x="13929706" y="6741324"/>
+            <a:off x="13807786" y="6314604"/>
             <a:ext cx="2960616" cy="954107"/>
           </a:xfrm>
           <a:prstGeom prst="rect">
@@ -9766,6 +10804,41 @@
             <a:r>
               <a:rPr lang="en-IE" sz="2800" b="1" dirty="0"/>
               <a:t>Commits task updates</a:t>
+            </a:r>
+          </a:p>
+        </p:txBody>
+      </p:sp>
+      <p:sp>
+        <p:nvSpPr>
+          <p:cNvPr id="8" name="TextBox 7">
+            <a:extLst>
+              <a:ext uri="{FF2B5EF4-FFF2-40B4-BE49-F238E27FC236}">
+                <a16:creationId xmlns:a16="http://schemas.microsoft.com/office/drawing/2014/main" id="{4A83F73D-D09F-B45C-DA3C-EF859F32AFF6}"/>
+              </a:ext>
+            </a:extLst>
+          </p:cNvPr>
+          <p:cNvSpPr txBox="1"/>
+          <p:nvPr/>
+        </p:nvSpPr>
+        <p:spPr>
+          <a:xfrm>
+            <a:off x="12296651" y="4630079"/>
+            <a:ext cx="2546293" cy="523220"/>
+          </a:xfrm>
+          <a:prstGeom prst="rect">
+            <a:avLst/>
+          </a:prstGeom>
+          <a:noFill/>
+        </p:spPr>
+        <p:txBody>
+          <a:bodyPr wrap="square" rtlCol="0">
+            <a:spAutoFit/>
+          </a:bodyPr>
+          <a:lstStyle/>
+          <a:p>
+            <a:r>
+              <a:rPr lang="en-IE" sz="2800" b="1" dirty="0"/>
+              <a:t>Task Updates</a:t>
             </a:r>
           </a:p>
         </p:txBody>
@@ -9783,7 +10856,7 @@
 </p:sld>
 </file>
 
-<file path=ppt/slides/slide4.xml><?xml version="1.0" encoding="utf-8"?>
+<file path=ppt/slides/slide5.xml><?xml version="1.0" encoding="utf-8"?>
 <p:sld xmlns:a="http://schemas.openxmlformats.org/drawingml/2006/main" xmlns:r="http://schemas.openxmlformats.org/officeDocument/2006/relationships" xmlns:p="http://schemas.openxmlformats.org/presentationml/2006/main">
   <p:cSld>
     <p:spTree>
@@ -11725,7 +12798,7 @@
 </p:sld>
 </file>
 
-<file path=ppt/slides/slide5.xml><?xml version="1.0" encoding="utf-8"?>
+<file path=ppt/slides/slide6.xml><?xml version="1.0" encoding="utf-8"?>
 <p:sld xmlns:a="http://schemas.openxmlformats.org/drawingml/2006/main" xmlns:r="http://schemas.openxmlformats.org/officeDocument/2006/relationships" xmlns:p="http://schemas.openxmlformats.org/presentationml/2006/main">
   <p:cSld>
     <p:spTree>

</xml_diff>

<commit_message>
Annotations opened on Repository + TaskTideServiceManager is now map
</commit_message>
<xml_diff>
--- a/tasktide/docs/Diagrams/Diagrams.pptx
+++ b/tasktide/docs/Diagrams/Diagrams.pptx
@@ -9,8 +9,9 @@
     <p:sldId id="262" r:id="rId3"/>
     <p:sldId id="260" r:id="rId4"/>
     <p:sldId id="261" r:id="rId5"/>
-    <p:sldId id="258" r:id="rId6"/>
-    <p:sldId id="256" r:id="rId7"/>
+    <p:sldId id="263" r:id="rId6"/>
+    <p:sldId id="258" r:id="rId7"/>
+    <p:sldId id="256" r:id="rId8"/>
   </p:sldIdLst>
   <p:sldSz cx="18000663" cy="16200438"/>
   <p:notesSz cx="6858000" cy="9144000"/>
@@ -1003,6 +1004,753 @@
     <dgm:fillClrLst meth="repeat">
       <a:schemeClr val="accent2">
         <a:tint val="40000"/>
+      </a:schemeClr>
+    </dgm:fillClrLst>
+    <dgm:linClrLst meth="repeat">
+      <a:schemeClr val="lt1"/>
+    </dgm:linClrLst>
+    <dgm:effectClrLst/>
+    <dgm:txLinClrLst/>
+    <dgm:txFillClrLst meth="repeat">
+      <a:schemeClr val="dk1"/>
+    </dgm:txFillClrLst>
+    <dgm:txEffectClrLst/>
+  </dgm:styleLbl>
+  <dgm:styleLbl name="revTx">
+    <dgm:fillClrLst meth="repeat">
+      <a:schemeClr val="lt1">
+        <a:alpha val="0"/>
+      </a:schemeClr>
+    </dgm:fillClrLst>
+    <dgm:linClrLst meth="repeat">
+      <a:schemeClr val="dk1">
+        <a:alpha val="0"/>
+      </a:schemeClr>
+    </dgm:linClrLst>
+    <dgm:effectClrLst/>
+    <dgm:txLinClrLst/>
+    <dgm:txFillClrLst meth="repeat">
+      <a:schemeClr val="tx1"/>
+    </dgm:txFillClrLst>
+    <dgm:txEffectClrLst/>
+  </dgm:styleLbl>
+</dgm:colorsDef>
+</file>
+
+<file path=ppt/diagrams/colors2.xml><?xml version="1.0" encoding="utf-8"?>
+<dgm:colorsDef xmlns:dgm="http://schemas.openxmlformats.org/drawingml/2006/diagram" xmlns:a="http://schemas.openxmlformats.org/drawingml/2006/main" uniqueId="urn:microsoft.com/office/officeart/2005/8/colors/accent1_2">
+  <dgm:title val=""/>
+  <dgm:desc val=""/>
+  <dgm:catLst>
+    <dgm:cat type="accent1" pri="11200"/>
+  </dgm:catLst>
+  <dgm:styleLbl name="node0">
+    <dgm:fillClrLst meth="repeat">
+      <a:schemeClr val="accent1"/>
+    </dgm:fillClrLst>
+    <dgm:linClrLst meth="repeat">
+      <a:schemeClr val="lt1"/>
+    </dgm:linClrLst>
+    <dgm:effectClrLst/>
+    <dgm:txLinClrLst/>
+    <dgm:txFillClrLst/>
+    <dgm:txEffectClrLst/>
+  </dgm:styleLbl>
+  <dgm:styleLbl name="alignNode1">
+    <dgm:fillClrLst meth="repeat">
+      <a:schemeClr val="accent1"/>
+    </dgm:fillClrLst>
+    <dgm:linClrLst meth="repeat">
+      <a:schemeClr val="accent1"/>
+    </dgm:linClrLst>
+    <dgm:effectClrLst/>
+    <dgm:txLinClrLst/>
+    <dgm:txFillClrLst/>
+    <dgm:txEffectClrLst/>
+  </dgm:styleLbl>
+  <dgm:styleLbl name="node1">
+    <dgm:fillClrLst meth="repeat">
+      <a:schemeClr val="accent1"/>
+    </dgm:fillClrLst>
+    <dgm:linClrLst meth="repeat">
+      <a:schemeClr val="lt1"/>
+    </dgm:linClrLst>
+    <dgm:effectClrLst/>
+    <dgm:txLinClrLst/>
+    <dgm:txFillClrLst/>
+    <dgm:txEffectClrLst/>
+  </dgm:styleLbl>
+  <dgm:styleLbl name="lnNode1">
+    <dgm:fillClrLst meth="repeat">
+      <a:schemeClr val="accent1"/>
+    </dgm:fillClrLst>
+    <dgm:linClrLst meth="repeat">
+      <a:schemeClr val="lt1"/>
+    </dgm:linClrLst>
+    <dgm:effectClrLst/>
+    <dgm:txLinClrLst/>
+    <dgm:txFillClrLst/>
+    <dgm:txEffectClrLst/>
+  </dgm:styleLbl>
+  <dgm:styleLbl name="vennNode1">
+    <dgm:fillClrLst meth="repeat">
+      <a:schemeClr val="accent1">
+        <a:alpha val="50000"/>
+      </a:schemeClr>
+    </dgm:fillClrLst>
+    <dgm:linClrLst meth="repeat">
+      <a:schemeClr val="lt1"/>
+    </dgm:linClrLst>
+    <dgm:effectClrLst/>
+    <dgm:txLinClrLst/>
+    <dgm:txFillClrLst/>
+    <dgm:txEffectClrLst/>
+  </dgm:styleLbl>
+  <dgm:styleLbl name="node2">
+    <dgm:fillClrLst meth="repeat">
+      <a:schemeClr val="accent1"/>
+    </dgm:fillClrLst>
+    <dgm:linClrLst meth="repeat">
+      <a:schemeClr val="lt1"/>
+    </dgm:linClrLst>
+    <dgm:effectClrLst/>
+    <dgm:txLinClrLst/>
+    <dgm:txFillClrLst/>
+    <dgm:txEffectClrLst/>
+  </dgm:styleLbl>
+  <dgm:styleLbl name="node3">
+    <dgm:fillClrLst meth="repeat">
+      <a:schemeClr val="accent1"/>
+    </dgm:fillClrLst>
+    <dgm:linClrLst meth="repeat">
+      <a:schemeClr val="lt1"/>
+    </dgm:linClrLst>
+    <dgm:effectClrLst/>
+    <dgm:txLinClrLst/>
+    <dgm:txFillClrLst/>
+    <dgm:txEffectClrLst/>
+  </dgm:styleLbl>
+  <dgm:styleLbl name="node4">
+    <dgm:fillClrLst meth="repeat">
+      <a:schemeClr val="accent1"/>
+    </dgm:fillClrLst>
+    <dgm:linClrLst meth="repeat">
+      <a:schemeClr val="lt1"/>
+    </dgm:linClrLst>
+    <dgm:effectClrLst/>
+    <dgm:txLinClrLst/>
+    <dgm:txFillClrLst/>
+    <dgm:txEffectClrLst/>
+  </dgm:styleLbl>
+  <dgm:styleLbl name="fgImgPlace1">
+    <dgm:fillClrLst meth="repeat">
+      <a:schemeClr val="accent1">
+        <a:tint val="50000"/>
+      </a:schemeClr>
+    </dgm:fillClrLst>
+    <dgm:linClrLst meth="repeat">
+      <a:schemeClr val="lt1"/>
+    </dgm:linClrLst>
+    <dgm:effectClrLst/>
+    <dgm:txLinClrLst/>
+    <dgm:txFillClrLst meth="repeat">
+      <a:schemeClr val="lt1"/>
+    </dgm:txFillClrLst>
+    <dgm:txEffectClrLst/>
+  </dgm:styleLbl>
+  <dgm:styleLbl name="alignImgPlace1">
+    <dgm:fillClrLst meth="repeat">
+      <a:schemeClr val="accent1">
+        <a:tint val="50000"/>
+      </a:schemeClr>
+    </dgm:fillClrLst>
+    <dgm:linClrLst meth="repeat">
+      <a:schemeClr val="lt1"/>
+    </dgm:linClrLst>
+    <dgm:effectClrLst/>
+    <dgm:txLinClrLst/>
+    <dgm:txFillClrLst meth="repeat">
+      <a:schemeClr val="lt1"/>
+    </dgm:txFillClrLst>
+    <dgm:txEffectClrLst/>
+  </dgm:styleLbl>
+  <dgm:styleLbl name="bgImgPlace1">
+    <dgm:fillClrLst meth="repeat">
+      <a:schemeClr val="accent1">
+        <a:tint val="50000"/>
+      </a:schemeClr>
+    </dgm:fillClrLst>
+    <dgm:linClrLst meth="repeat">
+      <a:schemeClr val="lt1"/>
+    </dgm:linClrLst>
+    <dgm:effectClrLst/>
+    <dgm:txLinClrLst/>
+    <dgm:txFillClrLst meth="repeat">
+      <a:schemeClr val="lt1"/>
+    </dgm:txFillClrLst>
+    <dgm:txEffectClrLst/>
+  </dgm:styleLbl>
+  <dgm:styleLbl name="sibTrans2D1">
+    <dgm:fillClrLst meth="repeat">
+      <a:schemeClr val="accent1">
+        <a:tint val="60000"/>
+      </a:schemeClr>
+    </dgm:fillClrLst>
+    <dgm:linClrLst meth="repeat">
+      <a:schemeClr val="accent1">
+        <a:tint val="60000"/>
+      </a:schemeClr>
+    </dgm:linClrLst>
+    <dgm:effectClrLst/>
+    <dgm:txLinClrLst/>
+    <dgm:txFillClrLst/>
+    <dgm:txEffectClrLst/>
+  </dgm:styleLbl>
+  <dgm:styleLbl name="fgSibTrans2D1">
+    <dgm:fillClrLst meth="repeat">
+      <a:schemeClr val="accent1">
+        <a:tint val="60000"/>
+      </a:schemeClr>
+    </dgm:fillClrLst>
+    <dgm:linClrLst meth="repeat">
+      <a:schemeClr val="accent1">
+        <a:tint val="60000"/>
+      </a:schemeClr>
+    </dgm:linClrLst>
+    <dgm:effectClrLst/>
+    <dgm:txLinClrLst/>
+    <dgm:txFillClrLst/>
+    <dgm:txEffectClrLst/>
+  </dgm:styleLbl>
+  <dgm:styleLbl name="bgSibTrans2D1">
+    <dgm:fillClrLst meth="repeat">
+      <a:schemeClr val="accent1">
+        <a:tint val="60000"/>
+      </a:schemeClr>
+    </dgm:fillClrLst>
+    <dgm:linClrLst meth="repeat">
+      <a:schemeClr val="accent1">
+        <a:tint val="60000"/>
+      </a:schemeClr>
+    </dgm:linClrLst>
+    <dgm:effectClrLst/>
+    <dgm:txLinClrLst/>
+    <dgm:txFillClrLst/>
+    <dgm:txEffectClrLst/>
+  </dgm:styleLbl>
+  <dgm:styleLbl name="sibTrans1D1">
+    <dgm:fillClrLst meth="repeat">
+      <a:schemeClr val="accent1"/>
+    </dgm:fillClrLst>
+    <dgm:linClrLst meth="repeat">
+      <a:schemeClr val="accent1"/>
+    </dgm:linClrLst>
+    <dgm:effectClrLst/>
+    <dgm:txLinClrLst/>
+    <dgm:txFillClrLst meth="repeat">
+      <a:schemeClr val="tx1"/>
+    </dgm:txFillClrLst>
+    <dgm:txEffectClrLst/>
+  </dgm:styleLbl>
+  <dgm:styleLbl name="callout">
+    <dgm:fillClrLst meth="repeat">
+      <a:schemeClr val="accent1"/>
+    </dgm:fillClrLst>
+    <dgm:linClrLst meth="repeat">
+      <a:schemeClr val="accent1">
+        <a:tint val="50000"/>
+      </a:schemeClr>
+    </dgm:linClrLst>
+    <dgm:effectClrLst/>
+    <dgm:txLinClrLst/>
+    <dgm:txFillClrLst meth="repeat">
+      <a:schemeClr val="tx1"/>
+    </dgm:txFillClrLst>
+    <dgm:txEffectClrLst/>
+  </dgm:styleLbl>
+  <dgm:styleLbl name="asst0">
+    <dgm:fillClrLst meth="repeat">
+      <a:schemeClr val="accent1"/>
+    </dgm:fillClrLst>
+    <dgm:linClrLst meth="repeat">
+      <a:schemeClr val="lt1"/>
+    </dgm:linClrLst>
+    <dgm:effectClrLst/>
+    <dgm:txLinClrLst/>
+    <dgm:txFillClrLst/>
+    <dgm:txEffectClrLst/>
+  </dgm:styleLbl>
+  <dgm:styleLbl name="asst1">
+    <dgm:fillClrLst meth="repeat">
+      <a:schemeClr val="accent1"/>
+    </dgm:fillClrLst>
+    <dgm:linClrLst meth="repeat">
+      <a:schemeClr val="lt1"/>
+    </dgm:linClrLst>
+    <dgm:effectClrLst/>
+    <dgm:txLinClrLst/>
+    <dgm:txFillClrLst/>
+    <dgm:txEffectClrLst/>
+  </dgm:styleLbl>
+  <dgm:styleLbl name="asst2">
+    <dgm:fillClrLst meth="repeat">
+      <a:schemeClr val="accent1"/>
+    </dgm:fillClrLst>
+    <dgm:linClrLst meth="repeat">
+      <a:schemeClr val="lt1"/>
+    </dgm:linClrLst>
+    <dgm:effectClrLst/>
+    <dgm:txLinClrLst/>
+    <dgm:txFillClrLst/>
+    <dgm:txEffectClrLst/>
+  </dgm:styleLbl>
+  <dgm:styleLbl name="asst3">
+    <dgm:fillClrLst meth="repeat">
+      <a:schemeClr val="accent1"/>
+    </dgm:fillClrLst>
+    <dgm:linClrLst meth="repeat">
+      <a:schemeClr val="lt1"/>
+    </dgm:linClrLst>
+    <dgm:effectClrLst/>
+    <dgm:txLinClrLst/>
+    <dgm:txFillClrLst/>
+    <dgm:txEffectClrLst/>
+  </dgm:styleLbl>
+  <dgm:styleLbl name="asst4">
+    <dgm:fillClrLst meth="repeat">
+      <a:schemeClr val="accent1"/>
+    </dgm:fillClrLst>
+    <dgm:linClrLst meth="repeat">
+      <a:schemeClr val="lt1"/>
+    </dgm:linClrLst>
+    <dgm:effectClrLst/>
+    <dgm:txLinClrLst/>
+    <dgm:txFillClrLst/>
+    <dgm:txEffectClrLst/>
+  </dgm:styleLbl>
+  <dgm:styleLbl name="parChTrans2D1">
+    <dgm:fillClrLst meth="repeat">
+      <a:schemeClr val="accent1">
+        <a:tint val="60000"/>
+      </a:schemeClr>
+    </dgm:fillClrLst>
+    <dgm:linClrLst meth="repeat">
+      <a:schemeClr val="accent1">
+        <a:tint val="60000"/>
+      </a:schemeClr>
+    </dgm:linClrLst>
+    <dgm:effectClrLst/>
+    <dgm:txLinClrLst/>
+    <dgm:txFillClrLst meth="repeat">
+      <a:schemeClr val="lt1"/>
+    </dgm:txFillClrLst>
+    <dgm:txEffectClrLst/>
+  </dgm:styleLbl>
+  <dgm:styleLbl name="parChTrans2D2">
+    <dgm:fillClrLst meth="repeat">
+      <a:schemeClr val="accent1"/>
+    </dgm:fillClrLst>
+    <dgm:linClrLst meth="repeat">
+      <a:schemeClr val="accent1"/>
+    </dgm:linClrLst>
+    <dgm:effectClrLst/>
+    <dgm:txLinClrLst/>
+    <dgm:txFillClrLst meth="repeat">
+      <a:schemeClr val="lt1"/>
+    </dgm:txFillClrLst>
+    <dgm:txEffectClrLst/>
+  </dgm:styleLbl>
+  <dgm:styleLbl name="parChTrans2D3">
+    <dgm:fillClrLst meth="repeat">
+      <a:schemeClr val="accent1"/>
+    </dgm:fillClrLst>
+    <dgm:linClrLst meth="repeat">
+      <a:schemeClr val="accent1"/>
+    </dgm:linClrLst>
+    <dgm:effectClrLst/>
+    <dgm:txLinClrLst/>
+    <dgm:txFillClrLst meth="repeat">
+      <a:schemeClr val="lt1"/>
+    </dgm:txFillClrLst>
+    <dgm:txEffectClrLst/>
+  </dgm:styleLbl>
+  <dgm:styleLbl name="parChTrans2D4">
+    <dgm:fillClrLst meth="repeat">
+      <a:schemeClr val="accent1"/>
+    </dgm:fillClrLst>
+    <dgm:linClrLst meth="repeat">
+      <a:schemeClr val="accent1"/>
+    </dgm:linClrLst>
+    <dgm:effectClrLst/>
+    <dgm:txLinClrLst/>
+    <dgm:txFillClrLst meth="repeat">
+      <a:schemeClr val="lt1"/>
+    </dgm:txFillClrLst>
+    <dgm:txEffectClrLst/>
+  </dgm:styleLbl>
+  <dgm:styleLbl name="parChTrans1D1">
+    <dgm:fillClrLst meth="repeat">
+      <a:schemeClr val="accent1"/>
+    </dgm:fillClrLst>
+    <dgm:linClrLst meth="repeat">
+      <a:schemeClr val="accent1">
+        <a:shade val="60000"/>
+      </a:schemeClr>
+    </dgm:linClrLst>
+    <dgm:effectClrLst/>
+    <dgm:txLinClrLst/>
+    <dgm:txFillClrLst meth="repeat">
+      <a:schemeClr val="tx1"/>
+    </dgm:txFillClrLst>
+    <dgm:txEffectClrLst/>
+  </dgm:styleLbl>
+  <dgm:styleLbl name="parChTrans1D2">
+    <dgm:fillClrLst meth="repeat">
+      <a:schemeClr val="accent1"/>
+    </dgm:fillClrLst>
+    <dgm:linClrLst meth="repeat">
+      <a:schemeClr val="accent1">
+        <a:shade val="60000"/>
+      </a:schemeClr>
+    </dgm:linClrLst>
+    <dgm:effectClrLst/>
+    <dgm:txLinClrLst/>
+    <dgm:txFillClrLst meth="repeat">
+      <a:schemeClr val="tx1"/>
+    </dgm:txFillClrLst>
+    <dgm:txEffectClrLst/>
+  </dgm:styleLbl>
+  <dgm:styleLbl name="parChTrans1D3">
+    <dgm:fillClrLst meth="repeat">
+      <a:schemeClr val="accent1"/>
+    </dgm:fillClrLst>
+    <dgm:linClrLst meth="repeat">
+      <a:schemeClr val="accent1">
+        <a:shade val="80000"/>
+      </a:schemeClr>
+    </dgm:linClrLst>
+    <dgm:effectClrLst/>
+    <dgm:txLinClrLst/>
+    <dgm:txFillClrLst meth="repeat">
+      <a:schemeClr val="tx1"/>
+    </dgm:txFillClrLst>
+    <dgm:txEffectClrLst/>
+  </dgm:styleLbl>
+  <dgm:styleLbl name="parChTrans1D4">
+    <dgm:fillClrLst meth="repeat">
+      <a:schemeClr val="accent1"/>
+    </dgm:fillClrLst>
+    <dgm:linClrLst meth="repeat">
+      <a:schemeClr val="accent1">
+        <a:shade val="80000"/>
+      </a:schemeClr>
+    </dgm:linClrLst>
+    <dgm:effectClrLst/>
+    <dgm:txLinClrLst/>
+    <dgm:txFillClrLst meth="repeat">
+      <a:schemeClr val="tx1"/>
+    </dgm:txFillClrLst>
+    <dgm:txEffectClrLst/>
+  </dgm:styleLbl>
+  <dgm:styleLbl name="fgAcc1">
+    <dgm:fillClrLst meth="repeat">
+      <a:schemeClr val="lt1">
+        <a:alpha val="90000"/>
+      </a:schemeClr>
+    </dgm:fillClrLst>
+    <dgm:linClrLst meth="repeat">
+      <a:schemeClr val="accent1"/>
+    </dgm:linClrLst>
+    <dgm:effectClrLst/>
+    <dgm:txLinClrLst/>
+    <dgm:txFillClrLst meth="repeat">
+      <a:schemeClr val="dk1"/>
+    </dgm:txFillClrLst>
+    <dgm:txEffectClrLst/>
+  </dgm:styleLbl>
+  <dgm:styleLbl name="conFgAcc1">
+    <dgm:fillClrLst meth="repeat">
+      <a:schemeClr val="lt1">
+        <a:alpha val="90000"/>
+      </a:schemeClr>
+    </dgm:fillClrLst>
+    <dgm:linClrLst meth="repeat">
+      <a:schemeClr val="accent1"/>
+    </dgm:linClrLst>
+    <dgm:effectClrLst/>
+    <dgm:txLinClrLst/>
+    <dgm:txFillClrLst meth="repeat">
+      <a:schemeClr val="dk1"/>
+    </dgm:txFillClrLst>
+    <dgm:txEffectClrLst/>
+  </dgm:styleLbl>
+  <dgm:styleLbl name="alignAcc1">
+    <dgm:fillClrLst meth="repeat">
+      <a:schemeClr val="lt1">
+        <a:alpha val="90000"/>
+      </a:schemeClr>
+    </dgm:fillClrLst>
+    <dgm:linClrLst meth="repeat">
+      <a:schemeClr val="accent1"/>
+    </dgm:linClrLst>
+    <dgm:effectClrLst/>
+    <dgm:txLinClrLst/>
+    <dgm:txFillClrLst meth="repeat">
+      <a:schemeClr val="dk1"/>
+    </dgm:txFillClrLst>
+    <dgm:txEffectClrLst/>
+  </dgm:styleLbl>
+  <dgm:styleLbl name="trAlignAcc1">
+    <dgm:fillClrLst meth="repeat">
+      <a:schemeClr val="lt1">
+        <a:alpha val="40000"/>
+      </a:schemeClr>
+    </dgm:fillClrLst>
+    <dgm:linClrLst meth="repeat">
+      <a:schemeClr val="accent1"/>
+    </dgm:linClrLst>
+    <dgm:effectClrLst/>
+    <dgm:txLinClrLst/>
+    <dgm:txFillClrLst meth="repeat">
+      <a:schemeClr val="dk1"/>
+    </dgm:txFillClrLst>
+    <dgm:txEffectClrLst/>
+  </dgm:styleLbl>
+  <dgm:styleLbl name="bgAcc1">
+    <dgm:fillClrLst meth="repeat">
+      <a:schemeClr val="lt1">
+        <a:alpha val="90000"/>
+      </a:schemeClr>
+    </dgm:fillClrLst>
+    <dgm:linClrLst meth="repeat">
+      <a:schemeClr val="accent1"/>
+    </dgm:linClrLst>
+    <dgm:effectClrLst/>
+    <dgm:txLinClrLst/>
+    <dgm:txFillClrLst meth="repeat">
+      <a:schemeClr val="dk1"/>
+    </dgm:txFillClrLst>
+    <dgm:txEffectClrLst/>
+  </dgm:styleLbl>
+  <dgm:styleLbl name="solidFgAcc1">
+    <dgm:fillClrLst meth="repeat">
+      <a:schemeClr val="lt1"/>
+    </dgm:fillClrLst>
+    <dgm:linClrLst meth="repeat">
+      <a:schemeClr val="accent1"/>
+    </dgm:linClrLst>
+    <dgm:effectClrLst/>
+    <dgm:txLinClrLst/>
+    <dgm:txFillClrLst meth="repeat">
+      <a:schemeClr val="dk1"/>
+    </dgm:txFillClrLst>
+    <dgm:txEffectClrLst/>
+  </dgm:styleLbl>
+  <dgm:styleLbl name="solidAlignAcc1">
+    <dgm:fillClrLst meth="repeat">
+      <a:schemeClr val="lt1"/>
+    </dgm:fillClrLst>
+    <dgm:linClrLst meth="repeat">
+      <a:schemeClr val="accent1"/>
+    </dgm:linClrLst>
+    <dgm:effectClrLst/>
+    <dgm:txLinClrLst/>
+    <dgm:txFillClrLst meth="repeat">
+      <a:schemeClr val="dk1"/>
+    </dgm:txFillClrLst>
+    <dgm:txEffectClrLst/>
+  </dgm:styleLbl>
+  <dgm:styleLbl name="solidBgAcc1">
+    <dgm:fillClrLst meth="repeat">
+      <a:schemeClr val="lt1"/>
+    </dgm:fillClrLst>
+    <dgm:linClrLst meth="repeat">
+      <a:schemeClr val="accent1"/>
+    </dgm:linClrLst>
+    <dgm:effectClrLst/>
+    <dgm:txLinClrLst/>
+    <dgm:txFillClrLst meth="repeat">
+      <a:schemeClr val="dk1"/>
+    </dgm:txFillClrLst>
+    <dgm:txEffectClrLst/>
+  </dgm:styleLbl>
+  <dgm:styleLbl name="fgAccFollowNode1">
+    <dgm:fillClrLst meth="repeat">
+      <a:schemeClr val="accent1">
+        <a:alpha val="90000"/>
+        <a:tint val="40000"/>
+      </a:schemeClr>
+    </dgm:fillClrLst>
+    <dgm:linClrLst meth="repeat">
+      <a:schemeClr val="accent1">
+        <a:alpha val="90000"/>
+        <a:tint val="40000"/>
+      </a:schemeClr>
+    </dgm:linClrLst>
+    <dgm:effectClrLst/>
+    <dgm:txLinClrLst/>
+    <dgm:txFillClrLst meth="repeat">
+      <a:schemeClr val="dk1"/>
+    </dgm:txFillClrLst>
+    <dgm:txEffectClrLst/>
+  </dgm:styleLbl>
+  <dgm:styleLbl name="alignAccFollowNode1">
+    <dgm:fillClrLst meth="repeat">
+      <a:schemeClr val="accent1">
+        <a:alpha val="90000"/>
+        <a:tint val="40000"/>
+      </a:schemeClr>
+    </dgm:fillClrLst>
+    <dgm:linClrLst meth="repeat">
+      <a:schemeClr val="accent1">
+        <a:alpha val="90000"/>
+        <a:tint val="40000"/>
+      </a:schemeClr>
+    </dgm:linClrLst>
+    <dgm:effectClrLst/>
+    <dgm:txLinClrLst/>
+    <dgm:txFillClrLst meth="repeat">
+      <a:schemeClr val="dk1"/>
+    </dgm:txFillClrLst>
+    <dgm:txEffectClrLst/>
+  </dgm:styleLbl>
+  <dgm:styleLbl name="bgAccFollowNode1">
+    <dgm:fillClrLst meth="repeat">
+      <a:schemeClr val="accent1">
+        <a:alpha val="90000"/>
+        <a:tint val="40000"/>
+      </a:schemeClr>
+    </dgm:fillClrLst>
+    <dgm:linClrLst meth="repeat">
+      <a:schemeClr val="accent1">
+        <a:alpha val="90000"/>
+        <a:tint val="40000"/>
+      </a:schemeClr>
+    </dgm:linClrLst>
+    <dgm:effectClrLst/>
+    <dgm:txLinClrLst/>
+    <dgm:txFillClrLst meth="repeat">
+      <a:schemeClr val="dk1"/>
+    </dgm:txFillClrLst>
+    <dgm:txEffectClrLst/>
+  </dgm:styleLbl>
+  <dgm:styleLbl name="fgAcc0">
+    <dgm:fillClrLst meth="repeat">
+      <a:schemeClr val="lt1">
+        <a:alpha val="90000"/>
+      </a:schemeClr>
+    </dgm:fillClrLst>
+    <dgm:linClrLst meth="repeat">
+      <a:schemeClr val="accent1"/>
+    </dgm:linClrLst>
+    <dgm:effectClrLst/>
+    <dgm:txLinClrLst/>
+    <dgm:txFillClrLst meth="repeat">
+      <a:schemeClr val="dk1"/>
+    </dgm:txFillClrLst>
+    <dgm:txEffectClrLst/>
+  </dgm:styleLbl>
+  <dgm:styleLbl name="fgAcc2">
+    <dgm:fillClrLst meth="repeat">
+      <a:schemeClr val="lt1">
+        <a:alpha val="90000"/>
+      </a:schemeClr>
+    </dgm:fillClrLst>
+    <dgm:linClrLst meth="repeat">
+      <a:schemeClr val="accent1"/>
+    </dgm:linClrLst>
+    <dgm:effectClrLst/>
+    <dgm:txLinClrLst/>
+    <dgm:txFillClrLst meth="repeat">
+      <a:schemeClr val="dk1"/>
+    </dgm:txFillClrLst>
+    <dgm:txEffectClrLst/>
+  </dgm:styleLbl>
+  <dgm:styleLbl name="fgAcc3">
+    <dgm:fillClrLst meth="repeat">
+      <a:schemeClr val="lt1">
+        <a:alpha val="90000"/>
+      </a:schemeClr>
+    </dgm:fillClrLst>
+    <dgm:linClrLst meth="repeat">
+      <a:schemeClr val="accent1"/>
+    </dgm:linClrLst>
+    <dgm:effectClrLst/>
+    <dgm:txLinClrLst/>
+    <dgm:txFillClrLst meth="repeat">
+      <a:schemeClr val="dk1"/>
+    </dgm:txFillClrLst>
+    <dgm:txEffectClrLst/>
+  </dgm:styleLbl>
+  <dgm:styleLbl name="fgAcc4">
+    <dgm:fillClrLst meth="repeat">
+      <a:schemeClr val="lt1">
+        <a:alpha val="90000"/>
+      </a:schemeClr>
+    </dgm:fillClrLst>
+    <dgm:linClrLst meth="repeat">
+      <a:schemeClr val="accent1"/>
+    </dgm:linClrLst>
+    <dgm:effectClrLst/>
+    <dgm:txLinClrLst/>
+    <dgm:txFillClrLst meth="repeat">
+      <a:schemeClr val="dk1"/>
+    </dgm:txFillClrLst>
+    <dgm:txEffectClrLst/>
+  </dgm:styleLbl>
+  <dgm:styleLbl name="bgShp">
+    <dgm:fillClrLst meth="repeat">
+      <a:schemeClr val="accent1">
+        <a:tint val="40000"/>
+      </a:schemeClr>
+    </dgm:fillClrLst>
+    <dgm:linClrLst meth="repeat">
+      <a:schemeClr val="accent1"/>
+    </dgm:linClrLst>
+    <dgm:effectClrLst/>
+    <dgm:txLinClrLst/>
+    <dgm:txFillClrLst meth="repeat">
+      <a:schemeClr val="dk1"/>
+    </dgm:txFillClrLst>
+    <dgm:txEffectClrLst/>
+  </dgm:styleLbl>
+  <dgm:styleLbl name="dkBgShp">
+    <dgm:fillClrLst meth="repeat">
+      <a:schemeClr val="accent1">
+        <a:shade val="80000"/>
+      </a:schemeClr>
+    </dgm:fillClrLst>
+    <dgm:linClrLst meth="repeat">
+      <a:schemeClr val="accent1"/>
+    </dgm:linClrLst>
+    <dgm:effectClrLst/>
+    <dgm:txLinClrLst/>
+    <dgm:txFillClrLst meth="repeat">
+      <a:schemeClr val="lt1"/>
+    </dgm:txFillClrLst>
+    <dgm:txEffectClrLst/>
+  </dgm:styleLbl>
+  <dgm:styleLbl name="trBgShp">
+    <dgm:fillClrLst meth="repeat">
+      <a:schemeClr val="accent1">
+        <a:tint val="50000"/>
+        <a:alpha val="40000"/>
+      </a:schemeClr>
+    </dgm:fillClrLst>
+    <dgm:linClrLst meth="repeat">
+      <a:schemeClr val="accent1"/>
+    </dgm:linClrLst>
+    <dgm:effectClrLst/>
+    <dgm:txLinClrLst/>
+    <dgm:txFillClrLst meth="repeat">
+      <a:schemeClr val="lt1"/>
+    </dgm:txFillClrLst>
+    <dgm:txEffectClrLst/>
+  </dgm:styleLbl>
+  <dgm:styleLbl name="fgShp">
+    <dgm:fillClrLst meth="repeat">
+      <a:schemeClr val="accent1">
+        <a:tint val="60000"/>
       </a:schemeClr>
     </dgm:fillClrLst>
     <dgm:linClrLst meth="repeat">
@@ -1176,7 +1924,13 @@
     </dgm:pt>
     <dgm:pt modelId="{30AB2770-B492-48AD-84C5-695BDA28E134}" type="pres">
       <dgm:prSet presAssocID="{4725363A-B69F-4FF0-AC74-23D7A1D4A150}" presName="Accent" presStyleLbl="node1" presStyleIdx="0" presStyleCnt="3"/>
-      <dgm:spPr/>
+      <dgm:spPr>
+        <a:ln>
+          <a:solidFill>
+            <a:schemeClr val="tx1"/>
+          </a:solidFill>
+        </a:ln>
+      </dgm:spPr>
     </dgm:pt>
     <dgm:pt modelId="{37706D51-2842-4F8A-80D2-54D86E34456B}" type="pres">
       <dgm:prSet presAssocID="{4725363A-B69F-4FF0-AC74-23D7A1D4A150}" presName="Parent1" presStyleLbl="revTx" presStyleIdx="0" presStyleCnt="3">
@@ -1194,7 +1948,13 @@
     </dgm:pt>
     <dgm:pt modelId="{668DC389-6720-4236-8011-BFAB07D2AE6E}" type="pres">
       <dgm:prSet presAssocID="{DFC53582-58F9-4F3D-B75A-A00A5F4DA501}" presName="Accent" presStyleLbl="node1" presStyleIdx="1" presStyleCnt="3"/>
-      <dgm:spPr/>
+      <dgm:spPr>
+        <a:ln>
+          <a:solidFill>
+            <a:schemeClr val="tx1"/>
+          </a:solidFill>
+        </a:ln>
+      </dgm:spPr>
     </dgm:pt>
     <dgm:pt modelId="{1EF67315-41CD-4E1F-B065-C474DA2F6D76}" type="pres">
       <dgm:prSet presAssocID="{DFC53582-58F9-4F3D-B75A-A00A5F4DA501}" presName="Parent2" presStyleLbl="revTx" presStyleIdx="1" presStyleCnt="3">
@@ -1212,7 +1972,13 @@
     </dgm:pt>
     <dgm:pt modelId="{19D1F821-3860-4F77-A074-BB6401E6326E}" type="pres">
       <dgm:prSet presAssocID="{82B2E3DA-6C6C-4017-BB49-39C721A45AC6}" presName="Accent" presStyleLbl="node1" presStyleIdx="2" presStyleCnt="3"/>
-      <dgm:spPr/>
+      <dgm:spPr>
+        <a:ln>
+          <a:solidFill>
+            <a:schemeClr val="tx1"/>
+          </a:solidFill>
+        </a:ln>
+      </dgm:spPr>
     </dgm:pt>
     <dgm:pt modelId="{FA32A094-D9B4-4A76-8D4C-335142121065}" type="pres">
       <dgm:prSet presAssocID="{82B2E3DA-6C6C-4017-BB49-39C721A45AC6}" presName="Parent3" presStyleLbl="revTx" presStyleIdx="2" presStyleCnt="3">
@@ -1245,6 +2011,725 @@
   </dgm:cxnLst>
   <dgm:bg/>
   <dgm:whole/>
+  <dgm:extLst>
+    <a:ext uri="http://schemas.microsoft.com/office/drawing/2008/diagram">
+      <dsp:dataModelExt xmlns:dsp="http://schemas.microsoft.com/office/drawing/2008/diagram" relId="rId6" minVer="http://schemas.openxmlformats.org/drawingml/2006/diagram"/>
+    </a:ext>
+  </dgm:extLst>
+</dgm:dataModel>
+</file>
+
+<file path=ppt/diagrams/data2.xml><?xml version="1.0" encoding="utf-8"?>
+<dgm:dataModel xmlns:dgm="http://schemas.openxmlformats.org/drawingml/2006/diagram" xmlns:a="http://schemas.openxmlformats.org/drawingml/2006/main">
+  <dgm:ptLst>
+    <dgm:pt modelId="{7536D2AB-18D2-4540-86EF-97DAA68F47BD}" type="doc">
+      <dgm:prSet loTypeId="urn:microsoft.com/office/officeart/2005/8/layout/process4" loCatId="process" qsTypeId="urn:microsoft.com/office/officeart/2005/8/quickstyle/3d1" qsCatId="3D" csTypeId="urn:microsoft.com/office/officeart/2005/8/colors/accent1_2" csCatId="accent1" phldr="1"/>
+      <dgm:spPr/>
+      <dgm:t>
+        <a:bodyPr/>
+        <a:lstStyle/>
+        <a:p>
+          <a:endParaRPr lang="en-IE"/>
+        </a:p>
+      </dgm:t>
+    </dgm:pt>
+    <dgm:pt modelId="{A147FCF5-872C-402E-8FFA-7F62F8AEC165}">
+      <dgm:prSet phldrT="[Text]" custT="1"/>
+      <dgm:spPr/>
+      <dgm:t>
+        <a:bodyPr/>
+        <a:lstStyle/>
+        <a:p>
+          <a:r>
+            <a:rPr lang="en-IE" sz="4800" b="1" dirty="0"/>
+            <a:t>Workflow Orchestration</a:t>
+          </a:r>
+        </a:p>
+      </dgm:t>
+    </dgm:pt>
+    <dgm:pt modelId="{023FA848-FBA0-4C53-878C-D0304385935A}" type="parTrans" cxnId="{8B432C63-7580-4035-9DEC-014222462859}">
+      <dgm:prSet/>
+      <dgm:spPr/>
+      <dgm:t>
+        <a:bodyPr/>
+        <a:lstStyle/>
+        <a:p>
+          <a:endParaRPr lang="en-IE"/>
+        </a:p>
+      </dgm:t>
+    </dgm:pt>
+    <dgm:pt modelId="{A9E9F8DD-5CCA-40F8-A82E-6599C0DAC405}" type="sibTrans" cxnId="{8B432C63-7580-4035-9DEC-014222462859}">
+      <dgm:prSet/>
+      <dgm:spPr/>
+      <dgm:t>
+        <a:bodyPr/>
+        <a:lstStyle/>
+        <a:p>
+          <a:endParaRPr lang="en-IE"/>
+        </a:p>
+      </dgm:t>
+    </dgm:pt>
+    <dgm:pt modelId="{C9D27329-5219-4575-8C28-F198FA7C7E21}">
+      <dgm:prSet phldrT="[Text]" custT="1"/>
+      <dgm:spPr>
+        <a:ln>
+          <a:solidFill>
+            <a:schemeClr val="tx1"/>
+          </a:solidFill>
+        </a:ln>
+      </dgm:spPr>
+      <dgm:t>
+        <a:bodyPr/>
+        <a:lstStyle/>
+        <a:p>
+          <a:r>
+            <a:rPr lang="en-IE" sz="2800" dirty="0"/>
+            <a:t>Bioinformatic workflow</a:t>
+          </a:r>
+        </a:p>
+      </dgm:t>
+    </dgm:pt>
+    <dgm:pt modelId="{4DC991F5-7EAA-42B5-9763-B81A6440FC1D}" type="parTrans" cxnId="{93CA0631-D0E1-4549-B58F-5AEAAB69B0A6}">
+      <dgm:prSet/>
+      <dgm:spPr/>
+      <dgm:t>
+        <a:bodyPr/>
+        <a:lstStyle/>
+        <a:p>
+          <a:endParaRPr lang="en-IE"/>
+        </a:p>
+      </dgm:t>
+    </dgm:pt>
+    <dgm:pt modelId="{11CC70F2-8FA3-4E4E-83A1-23C4FE696FBD}" type="sibTrans" cxnId="{93CA0631-D0E1-4549-B58F-5AEAAB69B0A6}">
+      <dgm:prSet/>
+      <dgm:spPr/>
+      <dgm:t>
+        <a:bodyPr/>
+        <a:lstStyle/>
+        <a:p>
+          <a:endParaRPr lang="en-IE"/>
+        </a:p>
+      </dgm:t>
+    </dgm:pt>
+    <dgm:pt modelId="{0E7A854B-37EA-407C-A97F-3A739191418A}">
+      <dgm:prSet phldrT="[Text]" custT="1"/>
+      <dgm:spPr>
+        <a:ln>
+          <a:solidFill>
+            <a:schemeClr val="tx1"/>
+          </a:solidFill>
+        </a:ln>
+      </dgm:spPr>
+      <dgm:t>
+        <a:bodyPr/>
+        <a:lstStyle/>
+        <a:p>
+          <a:r>
+            <a:rPr lang="en-IE" sz="2800" dirty="0"/>
+            <a:t>Validates workflow orchestration across generic pilots</a:t>
+          </a:r>
+        </a:p>
+      </dgm:t>
+    </dgm:pt>
+    <dgm:pt modelId="{AF30101B-D9D7-4112-A369-FBA7968528B2}" type="parTrans" cxnId="{BCDBDB62-C3B5-49C6-97FA-E967A4F76A6C}">
+      <dgm:prSet/>
+      <dgm:spPr/>
+      <dgm:t>
+        <a:bodyPr/>
+        <a:lstStyle/>
+        <a:p>
+          <a:endParaRPr lang="en-IE"/>
+        </a:p>
+      </dgm:t>
+    </dgm:pt>
+    <dgm:pt modelId="{711A1785-5017-41F7-B6D5-1B80308B8FF2}" type="sibTrans" cxnId="{BCDBDB62-C3B5-49C6-97FA-E967A4F76A6C}">
+      <dgm:prSet/>
+      <dgm:spPr/>
+      <dgm:t>
+        <a:bodyPr/>
+        <a:lstStyle/>
+        <a:p>
+          <a:endParaRPr lang="en-IE"/>
+        </a:p>
+      </dgm:t>
+    </dgm:pt>
+    <dgm:pt modelId="{4D999CEA-99A2-40B3-ACFE-2DDA830830D4}">
+      <dgm:prSet phldrT="[Text]" custT="1"/>
+      <dgm:spPr>
+        <a:ln>
+          <a:solidFill>
+            <a:schemeClr val="tx1"/>
+          </a:solidFill>
+        </a:ln>
+      </dgm:spPr>
+      <dgm:t>
+        <a:bodyPr/>
+        <a:lstStyle/>
+        <a:p>
+          <a:r>
+            <a:rPr lang="en-IE" sz="4800" b="1" dirty="0"/>
+            <a:t>Task Binding</a:t>
+          </a:r>
+        </a:p>
+      </dgm:t>
+    </dgm:pt>
+    <dgm:pt modelId="{63D0C301-A3D8-4900-A21C-4D4CA4636897}" type="parTrans" cxnId="{666E48F8-172A-4B9D-8257-4FB3F5D02377}">
+      <dgm:prSet/>
+      <dgm:spPr/>
+      <dgm:t>
+        <a:bodyPr/>
+        <a:lstStyle/>
+        <a:p>
+          <a:endParaRPr lang="en-IE"/>
+        </a:p>
+      </dgm:t>
+    </dgm:pt>
+    <dgm:pt modelId="{F78658CE-FCEA-4831-A7C9-BF133CDED4D9}" type="sibTrans" cxnId="{666E48F8-172A-4B9D-8257-4FB3F5D02377}">
+      <dgm:prSet/>
+      <dgm:spPr/>
+      <dgm:t>
+        <a:bodyPr/>
+        <a:lstStyle/>
+        <a:p>
+          <a:endParaRPr lang="en-IE"/>
+        </a:p>
+      </dgm:t>
+    </dgm:pt>
+    <dgm:pt modelId="{475C2055-1A5C-4F93-BCF0-4362192FEDE2}">
+      <dgm:prSet phldrT="[Text]" custT="1"/>
+      <dgm:spPr>
+        <a:ln>
+          <a:solidFill>
+            <a:schemeClr val="tx1"/>
+          </a:solidFill>
+        </a:ln>
+      </dgm:spPr>
+      <dgm:t>
+        <a:bodyPr/>
+        <a:lstStyle/>
+        <a:p>
+          <a:r>
+            <a:rPr lang="en-IE" sz="2800" dirty="0"/>
+            <a:t>Serialized function runner</a:t>
+          </a:r>
+        </a:p>
+      </dgm:t>
+    </dgm:pt>
+    <dgm:pt modelId="{57C885D4-B9D5-44AF-BA3E-95F85B0C4C85}" type="parTrans" cxnId="{B95C229C-BFA4-4E7F-809D-E96E94AB46B1}">
+      <dgm:prSet/>
+      <dgm:spPr/>
+      <dgm:t>
+        <a:bodyPr/>
+        <a:lstStyle/>
+        <a:p>
+          <a:endParaRPr lang="en-IE"/>
+        </a:p>
+      </dgm:t>
+    </dgm:pt>
+    <dgm:pt modelId="{B58CF49D-66C4-492C-A689-EEBD464FF5AB}" type="sibTrans" cxnId="{B95C229C-BFA4-4E7F-809D-E96E94AB46B1}">
+      <dgm:prSet/>
+      <dgm:spPr/>
+      <dgm:t>
+        <a:bodyPr/>
+        <a:lstStyle/>
+        <a:p>
+          <a:endParaRPr lang="en-IE"/>
+        </a:p>
+      </dgm:t>
+    </dgm:pt>
+    <dgm:pt modelId="{4F50E452-5834-4018-8DFF-B75D124C036A}">
+      <dgm:prSet phldrT="[Text]" custT="1"/>
+      <dgm:spPr>
+        <a:ln>
+          <a:solidFill>
+            <a:schemeClr val="tx1"/>
+          </a:solidFill>
+        </a:ln>
+      </dgm:spPr>
+      <dgm:t>
+        <a:bodyPr/>
+        <a:lstStyle/>
+        <a:p>
+          <a:r>
+            <a:rPr lang="en-IE" sz="2800" dirty="0"/>
+            <a:t>Validates explicit binding semantics (early vs late)</a:t>
+          </a:r>
+        </a:p>
+      </dgm:t>
+    </dgm:pt>
+    <dgm:pt modelId="{DB41BBB4-9AA8-49FB-AEE9-BDB37221A1CC}" type="parTrans" cxnId="{660948F6-410D-460D-81D5-714AFD1D381D}">
+      <dgm:prSet/>
+      <dgm:spPr/>
+      <dgm:t>
+        <a:bodyPr/>
+        <a:lstStyle/>
+        <a:p>
+          <a:endParaRPr lang="en-IE"/>
+        </a:p>
+      </dgm:t>
+    </dgm:pt>
+    <dgm:pt modelId="{2B9FE0FB-368C-4C11-8492-76D40C878944}" type="sibTrans" cxnId="{660948F6-410D-460D-81D5-714AFD1D381D}">
+      <dgm:prSet/>
+      <dgm:spPr/>
+      <dgm:t>
+        <a:bodyPr/>
+        <a:lstStyle/>
+        <a:p>
+          <a:endParaRPr lang="en-IE"/>
+        </a:p>
+      </dgm:t>
+    </dgm:pt>
+    <dgm:pt modelId="{A50E33B6-DC31-4625-B7FA-95FFDF7345DB}">
+      <dgm:prSet phldrT="[Text]" custT="1"/>
+      <dgm:spPr>
+        <a:ln>
+          <a:solidFill>
+            <a:schemeClr val="tx1"/>
+          </a:solidFill>
+        </a:ln>
+      </dgm:spPr>
+      <dgm:t>
+        <a:bodyPr/>
+        <a:lstStyle/>
+        <a:p>
+          <a:r>
+            <a:rPr lang="en-IE" sz="4800" b="1" dirty="0"/>
+            <a:t>Deployment</a:t>
+          </a:r>
+          <a:endParaRPr lang="en-IE" sz="4000" b="1" dirty="0"/>
+        </a:p>
+      </dgm:t>
+    </dgm:pt>
+    <dgm:pt modelId="{A7AB8128-93C5-4A74-8036-EF7B01CFFEE9}" type="parTrans" cxnId="{959C6A08-27DF-47D6-9B66-DA641F7D940E}">
+      <dgm:prSet/>
+      <dgm:spPr/>
+      <dgm:t>
+        <a:bodyPr/>
+        <a:lstStyle/>
+        <a:p>
+          <a:endParaRPr lang="en-IE"/>
+        </a:p>
+      </dgm:t>
+    </dgm:pt>
+    <dgm:pt modelId="{736A49DB-336A-4637-ACEC-4A4F70A87822}" type="sibTrans" cxnId="{959C6A08-27DF-47D6-9B66-DA641F7D940E}">
+      <dgm:prSet/>
+      <dgm:spPr/>
+      <dgm:t>
+        <a:bodyPr/>
+        <a:lstStyle/>
+        <a:p>
+          <a:endParaRPr lang="en-IE"/>
+        </a:p>
+      </dgm:t>
+    </dgm:pt>
+    <dgm:pt modelId="{1550EBB1-3E8A-4444-A1CB-728671E739D9}">
+      <dgm:prSet phldrT="[Text]" custT="1"/>
+      <dgm:spPr>
+        <a:ln>
+          <a:solidFill>
+            <a:schemeClr val="tx1"/>
+          </a:solidFill>
+        </a:ln>
+      </dgm:spPr>
+      <dgm:t>
+        <a:bodyPr/>
+        <a:lstStyle/>
+        <a:p>
+          <a:r>
+            <a:rPr lang="en-IE" sz="2800" dirty="0"/>
+            <a:t>AI play time optimizer</a:t>
+          </a:r>
+        </a:p>
+      </dgm:t>
+    </dgm:pt>
+    <dgm:pt modelId="{32899119-31C1-4B31-8ECF-4586BABA58D4}" type="parTrans" cxnId="{ED435997-8F2D-4DBD-ABF8-B74B739979B0}">
+      <dgm:prSet/>
+      <dgm:spPr/>
+      <dgm:t>
+        <a:bodyPr/>
+        <a:lstStyle/>
+        <a:p>
+          <a:endParaRPr lang="en-IE"/>
+        </a:p>
+      </dgm:t>
+    </dgm:pt>
+    <dgm:pt modelId="{9B5E1A06-E163-4B01-A622-E03D5AFA8104}" type="sibTrans" cxnId="{ED435997-8F2D-4DBD-ABF8-B74B739979B0}">
+      <dgm:prSet/>
+      <dgm:spPr/>
+      <dgm:t>
+        <a:bodyPr/>
+        <a:lstStyle/>
+        <a:p>
+          <a:endParaRPr lang="en-IE"/>
+        </a:p>
+      </dgm:t>
+    </dgm:pt>
+    <dgm:pt modelId="{F87B134D-0DC2-4772-90D6-BABD7BD5BC76}">
+      <dgm:prSet phldrT="[Text]" custT="1"/>
+      <dgm:spPr>
+        <a:ln>
+          <a:solidFill>
+            <a:schemeClr val="tx1"/>
+          </a:solidFill>
+        </a:ln>
+      </dgm:spPr>
+      <dgm:t>
+        <a:bodyPr/>
+        <a:lstStyle/>
+        <a:p>
+          <a:r>
+            <a:rPr lang="en-IE" sz="2800" dirty="0"/>
+            <a:t>Validate containerized workloads</a:t>
+          </a:r>
+        </a:p>
+      </dgm:t>
+    </dgm:pt>
+    <dgm:pt modelId="{2E6F75F3-F662-4A68-9323-758B5EFFF8B7}" type="parTrans" cxnId="{C12C3EC6-91DA-4D90-BA1A-0D2BDB5392CD}">
+      <dgm:prSet/>
+      <dgm:spPr/>
+      <dgm:t>
+        <a:bodyPr/>
+        <a:lstStyle/>
+        <a:p>
+          <a:endParaRPr lang="en-IE"/>
+        </a:p>
+      </dgm:t>
+    </dgm:pt>
+    <dgm:pt modelId="{0A75DA54-DE29-44C8-8B8A-7569270B07DC}" type="sibTrans" cxnId="{C12C3EC6-91DA-4D90-BA1A-0D2BDB5392CD}">
+      <dgm:prSet/>
+      <dgm:spPr/>
+      <dgm:t>
+        <a:bodyPr/>
+        <a:lstStyle/>
+        <a:p>
+          <a:endParaRPr lang="en-IE"/>
+        </a:p>
+      </dgm:t>
+    </dgm:pt>
+    <dgm:pt modelId="{28E7254B-914D-454C-9420-190BF7BC8B3F}">
+      <dgm:prSet phldrT="[Text]" custT="1"/>
+      <dgm:spPr>
+        <a:ln>
+          <a:solidFill>
+            <a:schemeClr val="tx1"/>
+          </a:solidFill>
+        </a:ln>
+      </dgm:spPr>
+      <dgm:t>
+        <a:bodyPr/>
+        <a:lstStyle/>
+        <a:p>
+          <a:r>
+            <a:rPr lang="en-IE" sz="2800" dirty="0"/>
+            <a:t>Job environment attached             to tasks</a:t>
+          </a:r>
+        </a:p>
+      </dgm:t>
+    </dgm:pt>
+    <dgm:pt modelId="{8F0A91F8-582C-4A33-8B33-F4735279C0A7}" type="parTrans" cxnId="{39BC804A-82BB-4A5F-A919-C53DC23D8C15}">
+      <dgm:prSet/>
+      <dgm:spPr/>
+      <dgm:t>
+        <a:bodyPr/>
+        <a:lstStyle/>
+        <a:p>
+          <a:endParaRPr lang="en-IE"/>
+        </a:p>
+      </dgm:t>
+    </dgm:pt>
+    <dgm:pt modelId="{8D5BCE3D-5A36-461F-ABB5-D2E303C418C4}" type="sibTrans" cxnId="{39BC804A-82BB-4A5F-A919-C53DC23D8C15}">
+      <dgm:prSet/>
+      <dgm:spPr/>
+      <dgm:t>
+        <a:bodyPr/>
+        <a:lstStyle/>
+        <a:p>
+          <a:endParaRPr lang="en-IE"/>
+        </a:p>
+      </dgm:t>
+    </dgm:pt>
+    <dgm:pt modelId="{A68E66D0-FC3E-4696-AEE9-FA917CE8B43F}">
+      <dgm:prSet phldrT="[Text]" custT="1"/>
+      <dgm:spPr>
+        <a:ln>
+          <a:solidFill>
+            <a:schemeClr val="tx1"/>
+          </a:solidFill>
+        </a:ln>
+      </dgm:spPr>
+      <dgm:t>
+        <a:bodyPr/>
+        <a:lstStyle/>
+        <a:p>
+          <a:r>
+            <a:rPr lang="en-IE" sz="2800" dirty="0"/>
+            <a:t>Node label constraints</a:t>
+          </a:r>
+        </a:p>
+      </dgm:t>
+    </dgm:pt>
+    <dgm:pt modelId="{0BC1C561-C6CF-4EE1-9459-E0E77208A87F}" type="parTrans" cxnId="{F50111F6-A6EB-47CE-8260-B7A1AB99D369}">
+      <dgm:prSet/>
+      <dgm:spPr/>
+      <dgm:t>
+        <a:bodyPr/>
+        <a:lstStyle/>
+        <a:p>
+          <a:endParaRPr lang="en-IE"/>
+        </a:p>
+      </dgm:t>
+    </dgm:pt>
+    <dgm:pt modelId="{979997D5-F373-4E06-9823-A469297F2E86}" type="sibTrans" cxnId="{F50111F6-A6EB-47CE-8260-B7A1AB99D369}">
+      <dgm:prSet/>
+      <dgm:spPr/>
+      <dgm:t>
+        <a:bodyPr/>
+        <a:lstStyle/>
+        <a:p>
+          <a:endParaRPr lang="en-IE"/>
+        </a:p>
+      </dgm:t>
+    </dgm:pt>
+    <dgm:pt modelId="{51E22944-1523-458B-8828-B060A21B0734}">
+      <dgm:prSet phldrT="[Text]" custT="1"/>
+      <dgm:spPr>
+        <a:ln>
+          <a:solidFill>
+            <a:schemeClr val="tx1"/>
+          </a:solidFill>
+        </a:ln>
+      </dgm:spPr>
+      <dgm:t>
+        <a:bodyPr/>
+        <a:lstStyle/>
+        <a:p>
+          <a:r>
+            <a:rPr lang="en-IE" sz="2800" dirty="0"/>
+            <a:t>Operational across relational        &amp; non-relational databases</a:t>
+          </a:r>
+        </a:p>
+      </dgm:t>
+    </dgm:pt>
+    <dgm:pt modelId="{3DF91E0F-97D3-4C63-8906-8F506DA31CAE}" type="parTrans" cxnId="{313B8469-A1FD-4F09-887E-E3142279E0D5}">
+      <dgm:prSet/>
+      <dgm:spPr/>
+      <dgm:t>
+        <a:bodyPr/>
+        <a:lstStyle/>
+        <a:p>
+          <a:endParaRPr lang="en-IE"/>
+        </a:p>
+      </dgm:t>
+    </dgm:pt>
+    <dgm:pt modelId="{56CDA8DD-B1A5-4AB8-AF97-E4AD7080C76E}" type="sibTrans" cxnId="{313B8469-A1FD-4F09-887E-E3142279E0D5}">
+      <dgm:prSet/>
+      <dgm:spPr/>
+      <dgm:t>
+        <a:bodyPr/>
+        <a:lstStyle/>
+        <a:p>
+          <a:endParaRPr lang="en-IE"/>
+        </a:p>
+      </dgm:t>
+    </dgm:pt>
+    <dgm:pt modelId="{A6E38CAE-DC8A-4A4F-BC73-1AEC372FC167}" type="pres">
+      <dgm:prSet presAssocID="{7536D2AB-18D2-4540-86EF-97DAA68F47BD}" presName="Name0" presStyleCnt="0">
+        <dgm:presLayoutVars>
+          <dgm:dir/>
+          <dgm:animLvl val="lvl"/>
+          <dgm:resizeHandles val="exact"/>
+        </dgm:presLayoutVars>
+      </dgm:prSet>
+      <dgm:spPr/>
+    </dgm:pt>
+    <dgm:pt modelId="{555A3F28-1E25-47B1-AA96-93AB9EB21F31}" type="pres">
+      <dgm:prSet presAssocID="{A50E33B6-DC31-4625-B7FA-95FFDF7345DB}" presName="boxAndChildren" presStyleCnt="0"/>
+      <dgm:spPr/>
+    </dgm:pt>
+    <dgm:pt modelId="{C38CF6F9-DC53-4200-9C30-5EC6A4B6A3DD}" type="pres">
+      <dgm:prSet presAssocID="{A50E33B6-DC31-4625-B7FA-95FFDF7345DB}" presName="parentTextBox" presStyleLbl="node1" presStyleIdx="0" presStyleCnt="3"/>
+      <dgm:spPr/>
+    </dgm:pt>
+    <dgm:pt modelId="{32DFF38E-0B8C-4811-8E25-D1D460553EEF}" type="pres">
+      <dgm:prSet presAssocID="{A50E33B6-DC31-4625-B7FA-95FFDF7345DB}" presName="entireBox" presStyleLbl="node1" presStyleIdx="0" presStyleCnt="3"/>
+      <dgm:spPr/>
+    </dgm:pt>
+    <dgm:pt modelId="{2D9853DB-9952-41DA-9459-C0F92D4048FC}" type="pres">
+      <dgm:prSet presAssocID="{A50E33B6-DC31-4625-B7FA-95FFDF7345DB}" presName="descendantBox" presStyleCnt="0"/>
+      <dgm:spPr/>
+    </dgm:pt>
+    <dgm:pt modelId="{2147C4C3-E4ED-44EA-8A74-5AB07B9224C6}" type="pres">
+      <dgm:prSet presAssocID="{1550EBB1-3E8A-4444-A1CB-728671E739D9}" presName="childTextBox" presStyleLbl="fgAccFollowNode1" presStyleIdx="0" presStyleCnt="9" custLinFactNeighborX="-364" custLinFactNeighborY="4503">
+        <dgm:presLayoutVars>
+          <dgm:bulletEnabled val="1"/>
+        </dgm:presLayoutVars>
+      </dgm:prSet>
+      <dgm:spPr/>
+    </dgm:pt>
+    <dgm:pt modelId="{EF0D8E2E-611F-48CE-B1FC-FF5FEBAA646D}" type="pres">
+      <dgm:prSet presAssocID="{F87B134D-0DC2-4772-90D6-BABD7BD5BC76}" presName="childTextBox" presStyleLbl="fgAccFollowNode1" presStyleIdx="1" presStyleCnt="9" custLinFactNeighborX="-364" custLinFactNeighborY="4503">
+        <dgm:presLayoutVars>
+          <dgm:bulletEnabled val="1"/>
+        </dgm:presLayoutVars>
+      </dgm:prSet>
+      <dgm:spPr/>
+    </dgm:pt>
+    <dgm:pt modelId="{A26E17A3-6ADC-4207-BAA9-6F37A7025026}" type="pres">
+      <dgm:prSet presAssocID="{A68E66D0-FC3E-4696-AEE9-FA917CE8B43F}" presName="childTextBox" presStyleLbl="fgAccFollowNode1" presStyleIdx="2" presStyleCnt="9" custLinFactNeighborX="0" custLinFactNeighborY="4503">
+        <dgm:presLayoutVars>
+          <dgm:bulletEnabled val="1"/>
+        </dgm:presLayoutVars>
+      </dgm:prSet>
+      <dgm:spPr/>
+    </dgm:pt>
+    <dgm:pt modelId="{1316DF51-73D5-42A2-A129-8BE6AE24E91D}" type="pres">
+      <dgm:prSet presAssocID="{F78658CE-FCEA-4831-A7C9-BF133CDED4D9}" presName="sp" presStyleCnt="0"/>
+      <dgm:spPr/>
+    </dgm:pt>
+    <dgm:pt modelId="{B8F9DB49-CD09-45A9-B2C9-CE22CE971DE6}" type="pres">
+      <dgm:prSet presAssocID="{4D999CEA-99A2-40B3-ACFE-2DDA830830D4}" presName="arrowAndChildren" presStyleCnt="0"/>
+      <dgm:spPr/>
+    </dgm:pt>
+    <dgm:pt modelId="{EC217E12-E4E2-4324-9106-BE0B637A87F8}" type="pres">
+      <dgm:prSet presAssocID="{4D999CEA-99A2-40B3-ACFE-2DDA830830D4}" presName="parentTextArrow" presStyleLbl="node1" presStyleIdx="0" presStyleCnt="3"/>
+      <dgm:spPr/>
+    </dgm:pt>
+    <dgm:pt modelId="{B5901160-2EED-4BC1-9CD9-CBC7C725C48E}" type="pres">
+      <dgm:prSet presAssocID="{4D999CEA-99A2-40B3-ACFE-2DDA830830D4}" presName="arrow" presStyleLbl="node1" presStyleIdx="1" presStyleCnt="3"/>
+      <dgm:spPr/>
+    </dgm:pt>
+    <dgm:pt modelId="{E6E30F24-75D5-41DC-BD30-BCEEDAB3EDA1}" type="pres">
+      <dgm:prSet presAssocID="{4D999CEA-99A2-40B3-ACFE-2DDA830830D4}" presName="descendantArrow" presStyleCnt="0"/>
+      <dgm:spPr/>
+    </dgm:pt>
+    <dgm:pt modelId="{9CE9A027-D096-4DBA-9F41-ACB337DEDCA0}" type="pres">
+      <dgm:prSet presAssocID="{475C2055-1A5C-4F93-BCF0-4362192FEDE2}" presName="childTextArrow" presStyleLbl="fgAccFollowNode1" presStyleIdx="3" presStyleCnt="9">
+        <dgm:presLayoutVars>
+          <dgm:bulletEnabled val="1"/>
+        </dgm:presLayoutVars>
+      </dgm:prSet>
+      <dgm:spPr/>
+    </dgm:pt>
+    <dgm:pt modelId="{87C3872B-7E02-4085-B647-9CD9B06A0313}" type="pres">
+      <dgm:prSet presAssocID="{4F50E452-5834-4018-8DFF-B75D124C036A}" presName="childTextArrow" presStyleLbl="fgAccFollowNode1" presStyleIdx="4" presStyleCnt="9">
+        <dgm:presLayoutVars>
+          <dgm:bulletEnabled val="1"/>
+        </dgm:presLayoutVars>
+      </dgm:prSet>
+      <dgm:spPr/>
+    </dgm:pt>
+    <dgm:pt modelId="{6A9F14BE-80C0-4B02-B21C-6C233AACAF51}" type="pres">
+      <dgm:prSet presAssocID="{28E7254B-914D-454C-9420-190BF7BC8B3F}" presName="childTextArrow" presStyleLbl="fgAccFollowNode1" presStyleIdx="5" presStyleCnt="9">
+        <dgm:presLayoutVars>
+          <dgm:bulletEnabled val="1"/>
+        </dgm:presLayoutVars>
+      </dgm:prSet>
+      <dgm:spPr/>
+    </dgm:pt>
+    <dgm:pt modelId="{9CE618A8-6BAD-4BC3-A55A-3B35D7AC190A}" type="pres">
+      <dgm:prSet presAssocID="{A9E9F8DD-5CCA-40F8-A82E-6599C0DAC405}" presName="sp" presStyleCnt="0"/>
+      <dgm:spPr/>
+    </dgm:pt>
+    <dgm:pt modelId="{84BC15C4-57C2-4215-B051-1FC12DE4D56A}" type="pres">
+      <dgm:prSet presAssocID="{A147FCF5-872C-402E-8FFA-7F62F8AEC165}" presName="arrowAndChildren" presStyleCnt="0"/>
+      <dgm:spPr/>
+    </dgm:pt>
+    <dgm:pt modelId="{821BB53C-F789-4FDF-A619-F676C9DAFA47}" type="pres">
+      <dgm:prSet presAssocID="{A147FCF5-872C-402E-8FFA-7F62F8AEC165}" presName="parentTextArrow" presStyleLbl="node1" presStyleIdx="1" presStyleCnt="3"/>
+      <dgm:spPr/>
+    </dgm:pt>
+    <dgm:pt modelId="{452ACE0D-CF1A-4DE8-8E3E-A45C514F1149}" type="pres">
+      <dgm:prSet presAssocID="{A147FCF5-872C-402E-8FFA-7F62F8AEC165}" presName="arrow" presStyleLbl="node1" presStyleIdx="2" presStyleCnt="3" custLinFactNeighborY="-504"/>
+      <dgm:spPr/>
+    </dgm:pt>
+    <dgm:pt modelId="{1A7D03B3-E5DC-4BF8-BC0E-673BE8094F20}" type="pres">
+      <dgm:prSet presAssocID="{A147FCF5-872C-402E-8FFA-7F62F8AEC165}" presName="descendantArrow" presStyleCnt="0"/>
+      <dgm:spPr/>
+    </dgm:pt>
+    <dgm:pt modelId="{07763EBB-4274-4F86-A670-BA07EE7CCAD5}" type="pres">
+      <dgm:prSet presAssocID="{C9D27329-5219-4575-8C28-F198FA7C7E21}" presName="childTextArrow" presStyleLbl="fgAccFollowNode1" presStyleIdx="6" presStyleCnt="9" custLinFactNeighborX="364">
+        <dgm:presLayoutVars>
+          <dgm:bulletEnabled val="1"/>
+        </dgm:presLayoutVars>
+      </dgm:prSet>
+      <dgm:spPr/>
+    </dgm:pt>
+    <dgm:pt modelId="{A5384461-3C55-409F-A76C-DC6C5CADCFE8}" type="pres">
+      <dgm:prSet presAssocID="{0E7A854B-37EA-407C-A97F-3A739191418A}" presName="childTextArrow" presStyleLbl="fgAccFollowNode1" presStyleIdx="7" presStyleCnt="9">
+        <dgm:presLayoutVars>
+          <dgm:bulletEnabled val="1"/>
+        </dgm:presLayoutVars>
+      </dgm:prSet>
+      <dgm:spPr/>
+    </dgm:pt>
+    <dgm:pt modelId="{1CEB22B1-9A7E-4A91-AF0C-26B893E69FA6}" type="pres">
+      <dgm:prSet presAssocID="{51E22944-1523-458B-8828-B060A21B0734}" presName="childTextArrow" presStyleLbl="fgAccFollowNode1" presStyleIdx="8" presStyleCnt="9">
+        <dgm:presLayoutVars>
+          <dgm:bulletEnabled val="1"/>
+        </dgm:presLayoutVars>
+      </dgm:prSet>
+      <dgm:spPr/>
+    </dgm:pt>
+  </dgm:ptLst>
+  <dgm:cxnLst>
+    <dgm:cxn modelId="{959C6A08-27DF-47D6-9B66-DA641F7D940E}" srcId="{7536D2AB-18D2-4540-86EF-97DAA68F47BD}" destId="{A50E33B6-DC31-4625-B7FA-95FFDF7345DB}" srcOrd="2" destOrd="0" parTransId="{A7AB8128-93C5-4A74-8036-EF7B01CFFEE9}" sibTransId="{736A49DB-336A-4637-ACEC-4A4F70A87822}"/>
+    <dgm:cxn modelId="{12163709-F225-4219-8EF0-7EA41899A9C2}" type="presOf" srcId="{475C2055-1A5C-4F93-BCF0-4362192FEDE2}" destId="{9CE9A027-D096-4DBA-9F41-ACB337DEDCA0}" srcOrd="0" destOrd="0" presId="urn:microsoft.com/office/officeart/2005/8/layout/process4"/>
+    <dgm:cxn modelId="{E30C4A24-E267-4C49-B2EA-BD4355E628F6}" type="presOf" srcId="{51E22944-1523-458B-8828-B060A21B0734}" destId="{1CEB22B1-9A7E-4A91-AF0C-26B893E69FA6}" srcOrd="0" destOrd="0" presId="urn:microsoft.com/office/officeart/2005/8/layout/process4"/>
+    <dgm:cxn modelId="{93CA0631-D0E1-4549-B58F-5AEAAB69B0A6}" srcId="{A147FCF5-872C-402E-8FFA-7F62F8AEC165}" destId="{C9D27329-5219-4575-8C28-F198FA7C7E21}" srcOrd="0" destOrd="0" parTransId="{4DC991F5-7EAA-42B5-9763-B81A6440FC1D}" sibTransId="{11CC70F2-8FA3-4E4E-83A1-23C4FE696FBD}"/>
+    <dgm:cxn modelId="{16669A5B-C315-4A49-AD9C-FC4AE7CA3AC5}" type="presOf" srcId="{4D999CEA-99A2-40B3-ACFE-2DDA830830D4}" destId="{B5901160-2EED-4BC1-9CD9-CBC7C725C48E}" srcOrd="1" destOrd="0" presId="urn:microsoft.com/office/officeart/2005/8/layout/process4"/>
+    <dgm:cxn modelId="{BCDBDB62-C3B5-49C6-97FA-E967A4F76A6C}" srcId="{A147FCF5-872C-402E-8FFA-7F62F8AEC165}" destId="{0E7A854B-37EA-407C-A97F-3A739191418A}" srcOrd="1" destOrd="0" parTransId="{AF30101B-D9D7-4112-A369-FBA7968528B2}" sibTransId="{711A1785-5017-41F7-B6D5-1B80308B8FF2}"/>
+    <dgm:cxn modelId="{8B432C63-7580-4035-9DEC-014222462859}" srcId="{7536D2AB-18D2-4540-86EF-97DAA68F47BD}" destId="{A147FCF5-872C-402E-8FFA-7F62F8AEC165}" srcOrd="0" destOrd="0" parTransId="{023FA848-FBA0-4C53-878C-D0304385935A}" sibTransId="{A9E9F8DD-5CCA-40F8-A82E-6599C0DAC405}"/>
+    <dgm:cxn modelId="{41D48A64-64D5-4DB1-98B7-64FE88C60DA6}" type="presOf" srcId="{7536D2AB-18D2-4540-86EF-97DAA68F47BD}" destId="{A6E38CAE-DC8A-4A4F-BC73-1AEC372FC167}" srcOrd="0" destOrd="0" presId="urn:microsoft.com/office/officeart/2005/8/layout/process4"/>
+    <dgm:cxn modelId="{313B8469-A1FD-4F09-887E-E3142279E0D5}" srcId="{A147FCF5-872C-402E-8FFA-7F62F8AEC165}" destId="{51E22944-1523-458B-8828-B060A21B0734}" srcOrd="2" destOrd="0" parTransId="{3DF91E0F-97D3-4C63-8906-8F506DA31CAE}" sibTransId="{56CDA8DD-B1A5-4AB8-AF97-E4AD7080C76E}"/>
+    <dgm:cxn modelId="{39BC804A-82BB-4A5F-A919-C53DC23D8C15}" srcId="{4D999CEA-99A2-40B3-ACFE-2DDA830830D4}" destId="{28E7254B-914D-454C-9420-190BF7BC8B3F}" srcOrd="2" destOrd="0" parTransId="{8F0A91F8-582C-4A33-8B33-F4735279C0A7}" sibTransId="{8D5BCE3D-5A36-461F-ABB5-D2E303C418C4}"/>
+    <dgm:cxn modelId="{2BE09C6B-550C-492B-8123-E3285DA6B775}" type="presOf" srcId="{A147FCF5-872C-402E-8FFA-7F62F8AEC165}" destId="{452ACE0D-CF1A-4DE8-8E3E-A45C514F1149}" srcOrd="1" destOrd="0" presId="urn:microsoft.com/office/officeart/2005/8/layout/process4"/>
+    <dgm:cxn modelId="{2D83546D-26B6-42FC-B911-10B6CB990C14}" type="presOf" srcId="{C9D27329-5219-4575-8C28-F198FA7C7E21}" destId="{07763EBB-4274-4F86-A670-BA07EE7CCAD5}" srcOrd="0" destOrd="0" presId="urn:microsoft.com/office/officeart/2005/8/layout/process4"/>
+    <dgm:cxn modelId="{F8E64681-1CD5-4238-A571-0145A84B3E4B}" type="presOf" srcId="{A68E66D0-FC3E-4696-AEE9-FA917CE8B43F}" destId="{A26E17A3-6ADC-4207-BAA9-6F37A7025026}" srcOrd="0" destOrd="0" presId="urn:microsoft.com/office/officeart/2005/8/layout/process4"/>
+    <dgm:cxn modelId="{6039E883-BBA3-4D37-ADEA-76FE6305AADF}" type="presOf" srcId="{1550EBB1-3E8A-4444-A1CB-728671E739D9}" destId="{2147C4C3-E4ED-44EA-8A74-5AB07B9224C6}" srcOrd="0" destOrd="0" presId="urn:microsoft.com/office/officeart/2005/8/layout/process4"/>
+    <dgm:cxn modelId="{14DE1086-4CC0-4962-9121-4BC99060A682}" type="presOf" srcId="{28E7254B-914D-454C-9420-190BF7BC8B3F}" destId="{6A9F14BE-80C0-4B02-B21C-6C233AACAF51}" srcOrd="0" destOrd="0" presId="urn:microsoft.com/office/officeart/2005/8/layout/process4"/>
+    <dgm:cxn modelId="{CA60A795-0B56-4B32-B4B8-258A44CDB63B}" type="presOf" srcId="{A50E33B6-DC31-4625-B7FA-95FFDF7345DB}" destId="{C38CF6F9-DC53-4200-9C30-5EC6A4B6A3DD}" srcOrd="0" destOrd="0" presId="urn:microsoft.com/office/officeart/2005/8/layout/process4"/>
+    <dgm:cxn modelId="{ED435997-8F2D-4DBD-ABF8-B74B739979B0}" srcId="{A50E33B6-DC31-4625-B7FA-95FFDF7345DB}" destId="{1550EBB1-3E8A-4444-A1CB-728671E739D9}" srcOrd="0" destOrd="0" parTransId="{32899119-31C1-4B31-8ECF-4586BABA58D4}" sibTransId="{9B5E1A06-E163-4B01-A622-E03D5AFA8104}"/>
+    <dgm:cxn modelId="{720C1299-B139-4C79-A3E3-1C02E6A91DA5}" type="presOf" srcId="{F87B134D-0DC2-4772-90D6-BABD7BD5BC76}" destId="{EF0D8E2E-611F-48CE-B1FC-FF5FEBAA646D}" srcOrd="0" destOrd="0" presId="urn:microsoft.com/office/officeart/2005/8/layout/process4"/>
+    <dgm:cxn modelId="{A5CA2F99-6DF3-4AD4-A7D6-6EFAB4350F10}" type="presOf" srcId="{4D999CEA-99A2-40B3-ACFE-2DDA830830D4}" destId="{EC217E12-E4E2-4324-9106-BE0B637A87F8}" srcOrd="0" destOrd="0" presId="urn:microsoft.com/office/officeart/2005/8/layout/process4"/>
+    <dgm:cxn modelId="{B95C229C-BFA4-4E7F-809D-E96E94AB46B1}" srcId="{4D999CEA-99A2-40B3-ACFE-2DDA830830D4}" destId="{475C2055-1A5C-4F93-BCF0-4362192FEDE2}" srcOrd="0" destOrd="0" parTransId="{57C885D4-B9D5-44AF-BA3E-95F85B0C4C85}" sibTransId="{B58CF49D-66C4-492C-A689-EEBD464FF5AB}"/>
+    <dgm:cxn modelId="{A71FA0A9-9EA9-4D0E-81E7-802814729BD8}" type="presOf" srcId="{A50E33B6-DC31-4625-B7FA-95FFDF7345DB}" destId="{32DFF38E-0B8C-4811-8E25-D1D460553EEF}" srcOrd="1" destOrd="0" presId="urn:microsoft.com/office/officeart/2005/8/layout/process4"/>
+    <dgm:cxn modelId="{0189B1B2-08AA-492D-A891-BCF750032056}" type="presOf" srcId="{4F50E452-5834-4018-8DFF-B75D124C036A}" destId="{87C3872B-7E02-4085-B647-9CD9B06A0313}" srcOrd="0" destOrd="0" presId="urn:microsoft.com/office/officeart/2005/8/layout/process4"/>
+    <dgm:cxn modelId="{C12C3EC6-91DA-4D90-BA1A-0D2BDB5392CD}" srcId="{A50E33B6-DC31-4625-B7FA-95FFDF7345DB}" destId="{F87B134D-0DC2-4772-90D6-BABD7BD5BC76}" srcOrd="1" destOrd="0" parTransId="{2E6F75F3-F662-4A68-9323-758B5EFFF8B7}" sibTransId="{0A75DA54-DE29-44C8-8B8A-7569270B07DC}"/>
+    <dgm:cxn modelId="{F67826D6-125C-4FAA-89F2-D7906452C10C}" type="presOf" srcId="{0E7A854B-37EA-407C-A97F-3A739191418A}" destId="{A5384461-3C55-409F-A76C-DC6C5CADCFE8}" srcOrd="0" destOrd="0" presId="urn:microsoft.com/office/officeart/2005/8/layout/process4"/>
+    <dgm:cxn modelId="{F50111F6-A6EB-47CE-8260-B7A1AB99D369}" srcId="{A50E33B6-DC31-4625-B7FA-95FFDF7345DB}" destId="{A68E66D0-FC3E-4696-AEE9-FA917CE8B43F}" srcOrd="2" destOrd="0" parTransId="{0BC1C561-C6CF-4EE1-9459-E0E77208A87F}" sibTransId="{979997D5-F373-4E06-9823-A469297F2E86}"/>
+    <dgm:cxn modelId="{660948F6-410D-460D-81D5-714AFD1D381D}" srcId="{4D999CEA-99A2-40B3-ACFE-2DDA830830D4}" destId="{4F50E452-5834-4018-8DFF-B75D124C036A}" srcOrd="1" destOrd="0" parTransId="{DB41BBB4-9AA8-49FB-AEE9-BDB37221A1CC}" sibTransId="{2B9FE0FB-368C-4C11-8492-76D40C878944}"/>
+    <dgm:cxn modelId="{666E48F8-172A-4B9D-8257-4FB3F5D02377}" srcId="{7536D2AB-18D2-4540-86EF-97DAA68F47BD}" destId="{4D999CEA-99A2-40B3-ACFE-2DDA830830D4}" srcOrd="1" destOrd="0" parTransId="{63D0C301-A3D8-4900-A21C-4D4CA4636897}" sibTransId="{F78658CE-FCEA-4831-A7C9-BF133CDED4D9}"/>
+    <dgm:cxn modelId="{77511BFA-3A7A-4DD5-9466-9D66AAFC594F}" type="presOf" srcId="{A147FCF5-872C-402E-8FFA-7F62F8AEC165}" destId="{821BB53C-F789-4FDF-A619-F676C9DAFA47}" srcOrd="0" destOrd="0" presId="urn:microsoft.com/office/officeart/2005/8/layout/process4"/>
+    <dgm:cxn modelId="{D3DB6E62-DFBD-4849-ACB6-0DA7456D2DB4}" type="presParOf" srcId="{A6E38CAE-DC8A-4A4F-BC73-1AEC372FC167}" destId="{555A3F28-1E25-47B1-AA96-93AB9EB21F31}" srcOrd="0" destOrd="0" presId="urn:microsoft.com/office/officeart/2005/8/layout/process4"/>
+    <dgm:cxn modelId="{3F8B5A89-03C3-4D81-8F2C-FBBBF27CF382}" type="presParOf" srcId="{555A3F28-1E25-47B1-AA96-93AB9EB21F31}" destId="{C38CF6F9-DC53-4200-9C30-5EC6A4B6A3DD}" srcOrd="0" destOrd="0" presId="urn:microsoft.com/office/officeart/2005/8/layout/process4"/>
+    <dgm:cxn modelId="{4A483FA8-E5CF-490F-BC91-DBCA94C56442}" type="presParOf" srcId="{555A3F28-1E25-47B1-AA96-93AB9EB21F31}" destId="{32DFF38E-0B8C-4811-8E25-D1D460553EEF}" srcOrd="1" destOrd="0" presId="urn:microsoft.com/office/officeart/2005/8/layout/process4"/>
+    <dgm:cxn modelId="{8D63AA43-4DC4-4374-87B6-4906CA589DA2}" type="presParOf" srcId="{555A3F28-1E25-47B1-AA96-93AB9EB21F31}" destId="{2D9853DB-9952-41DA-9459-C0F92D4048FC}" srcOrd="2" destOrd="0" presId="urn:microsoft.com/office/officeart/2005/8/layout/process4"/>
+    <dgm:cxn modelId="{CA24DF2C-D47C-46FB-B9D8-0ABA8186D3B4}" type="presParOf" srcId="{2D9853DB-9952-41DA-9459-C0F92D4048FC}" destId="{2147C4C3-E4ED-44EA-8A74-5AB07B9224C6}" srcOrd="0" destOrd="0" presId="urn:microsoft.com/office/officeart/2005/8/layout/process4"/>
+    <dgm:cxn modelId="{0AE411B4-978E-47BE-B187-3D95F8996E49}" type="presParOf" srcId="{2D9853DB-9952-41DA-9459-C0F92D4048FC}" destId="{EF0D8E2E-611F-48CE-B1FC-FF5FEBAA646D}" srcOrd="1" destOrd="0" presId="urn:microsoft.com/office/officeart/2005/8/layout/process4"/>
+    <dgm:cxn modelId="{96B76070-C592-4228-9154-2864F64B9493}" type="presParOf" srcId="{2D9853DB-9952-41DA-9459-C0F92D4048FC}" destId="{A26E17A3-6ADC-4207-BAA9-6F37A7025026}" srcOrd="2" destOrd="0" presId="urn:microsoft.com/office/officeart/2005/8/layout/process4"/>
+    <dgm:cxn modelId="{DB157B07-9425-49BA-A7C8-AE225FE1570E}" type="presParOf" srcId="{A6E38CAE-DC8A-4A4F-BC73-1AEC372FC167}" destId="{1316DF51-73D5-42A2-A129-8BE6AE24E91D}" srcOrd="1" destOrd="0" presId="urn:microsoft.com/office/officeart/2005/8/layout/process4"/>
+    <dgm:cxn modelId="{CA4A4CFA-A831-4296-AC4D-3DDF660E58E9}" type="presParOf" srcId="{A6E38CAE-DC8A-4A4F-BC73-1AEC372FC167}" destId="{B8F9DB49-CD09-45A9-B2C9-CE22CE971DE6}" srcOrd="2" destOrd="0" presId="urn:microsoft.com/office/officeart/2005/8/layout/process4"/>
+    <dgm:cxn modelId="{F51A94F5-CE02-4611-9497-6D87BAFAB1A4}" type="presParOf" srcId="{B8F9DB49-CD09-45A9-B2C9-CE22CE971DE6}" destId="{EC217E12-E4E2-4324-9106-BE0B637A87F8}" srcOrd="0" destOrd="0" presId="urn:microsoft.com/office/officeart/2005/8/layout/process4"/>
+    <dgm:cxn modelId="{4369B197-F0E5-4BAC-8E93-B51E319C50E7}" type="presParOf" srcId="{B8F9DB49-CD09-45A9-B2C9-CE22CE971DE6}" destId="{B5901160-2EED-4BC1-9CD9-CBC7C725C48E}" srcOrd="1" destOrd="0" presId="urn:microsoft.com/office/officeart/2005/8/layout/process4"/>
+    <dgm:cxn modelId="{7790F057-101D-4FEE-B4BB-416F03A87FB7}" type="presParOf" srcId="{B8F9DB49-CD09-45A9-B2C9-CE22CE971DE6}" destId="{E6E30F24-75D5-41DC-BD30-BCEEDAB3EDA1}" srcOrd="2" destOrd="0" presId="urn:microsoft.com/office/officeart/2005/8/layout/process4"/>
+    <dgm:cxn modelId="{993589D6-6D1B-4049-8C42-FA528C4C35A8}" type="presParOf" srcId="{E6E30F24-75D5-41DC-BD30-BCEEDAB3EDA1}" destId="{9CE9A027-D096-4DBA-9F41-ACB337DEDCA0}" srcOrd="0" destOrd="0" presId="urn:microsoft.com/office/officeart/2005/8/layout/process4"/>
+    <dgm:cxn modelId="{39F09CA2-B8E7-4E42-897E-90CF66D3532C}" type="presParOf" srcId="{E6E30F24-75D5-41DC-BD30-BCEEDAB3EDA1}" destId="{87C3872B-7E02-4085-B647-9CD9B06A0313}" srcOrd="1" destOrd="0" presId="urn:microsoft.com/office/officeart/2005/8/layout/process4"/>
+    <dgm:cxn modelId="{71AA1812-61D8-4BF1-A8D2-E9050EAD9FE1}" type="presParOf" srcId="{E6E30F24-75D5-41DC-BD30-BCEEDAB3EDA1}" destId="{6A9F14BE-80C0-4B02-B21C-6C233AACAF51}" srcOrd="2" destOrd="0" presId="urn:microsoft.com/office/officeart/2005/8/layout/process4"/>
+    <dgm:cxn modelId="{7EFA4A68-72FA-4B77-BFB8-C53D4BE233E4}" type="presParOf" srcId="{A6E38CAE-DC8A-4A4F-BC73-1AEC372FC167}" destId="{9CE618A8-6BAD-4BC3-A55A-3B35D7AC190A}" srcOrd="3" destOrd="0" presId="urn:microsoft.com/office/officeart/2005/8/layout/process4"/>
+    <dgm:cxn modelId="{1C48AD57-6CD6-4967-8CFA-6FFCC9231B70}" type="presParOf" srcId="{A6E38CAE-DC8A-4A4F-BC73-1AEC372FC167}" destId="{84BC15C4-57C2-4215-B051-1FC12DE4D56A}" srcOrd="4" destOrd="0" presId="urn:microsoft.com/office/officeart/2005/8/layout/process4"/>
+    <dgm:cxn modelId="{0DA12771-6498-4822-8CC7-337E76EFAFF9}" type="presParOf" srcId="{84BC15C4-57C2-4215-B051-1FC12DE4D56A}" destId="{821BB53C-F789-4FDF-A619-F676C9DAFA47}" srcOrd="0" destOrd="0" presId="urn:microsoft.com/office/officeart/2005/8/layout/process4"/>
+    <dgm:cxn modelId="{81944EEE-575C-49F5-87B3-304C559B6FD7}" type="presParOf" srcId="{84BC15C4-57C2-4215-B051-1FC12DE4D56A}" destId="{452ACE0D-CF1A-4DE8-8E3E-A45C514F1149}" srcOrd="1" destOrd="0" presId="urn:microsoft.com/office/officeart/2005/8/layout/process4"/>
+    <dgm:cxn modelId="{00BF2E83-C8E4-4AFC-9414-CFBEE0587C81}" type="presParOf" srcId="{84BC15C4-57C2-4215-B051-1FC12DE4D56A}" destId="{1A7D03B3-E5DC-4BF8-BC0E-673BE8094F20}" srcOrd="2" destOrd="0" presId="urn:microsoft.com/office/officeart/2005/8/layout/process4"/>
+    <dgm:cxn modelId="{5A10022A-D741-429A-8603-EA0CFA5A5EFC}" type="presParOf" srcId="{1A7D03B3-E5DC-4BF8-BC0E-673BE8094F20}" destId="{07763EBB-4274-4F86-A670-BA07EE7CCAD5}" srcOrd="0" destOrd="0" presId="urn:microsoft.com/office/officeart/2005/8/layout/process4"/>
+    <dgm:cxn modelId="{47EC8A92-A198-4820-84FC-7D7E7CC646FB}" type="presParOf" srcId="{1A7D03B3-E5DC-4BF8-BC0E-673BE8094F20}" destId="{A5384461-3C55-409F-A76C-DC6C5CADCFE8}" srcOrd="1" destOrd="0" presId="urn:microsoft.com/office/officeart/2005/8/layout/process4"/>
+    <dgm:cxn modelId="{F7544B4B-402A-4829-A5D4-71EFE4283CE2}" type="presParOf" srcId="{1A7D03B3-E5DC-4BF8-BC0E-673BE8094F20}" destId="{1CEB22B1-9A7E-4A91-AF0C-26B893E69FA6}" srcOrd="2" destOrd="0" presId="urn:microsoft.com/office/officeart/2005/8/layout/process4"/>
+  </dgm:cxnLst>
+  <dgm:bg/>
+  <dgm:whole>
+    <a:ln>
+      <a:noFill/>
+    </a:ln>
+  </dgm:whole>
   <dgm:extLst>
     <a:ext uri="http://schemas.microsoft.com/office/drawing/2008/diagram">
       <dsp:dataModelExt xmlns:dsp="http://schemas.microsoft.com/office/drawing/2008/diagram" relId="rId6" minVer="http://schemas.openxmlformats.org/drawingml/2006/diagram"/>
@@ -1319,7 +2804,9 @@
           <a:lin ang="5400000" scaled="0"/>
         </a:gradFill>
         <a:ln>
-          <a:noFill/>
+          <a:solidFill>
+            <a:schemeClr val="tx1"/>
+          </a:solidFill>
         </a:ln>
         <a:effectLst/>
         <a:scene3d>
@@ -1465,7 +2952,9 @@
           <a:lin ang="5400000" scaled="0"/>
         </a:gradFill>
         <a:ln>
-          <a:noFill/>
+          <a:solidFill>
+            <a:schemeClr val="tx1"/>
+          </a:solidFill>
         </a:ln>
         <a:effectLst/>
         <a:scene3d>
@@ -1608,7 +3097,9 @@
           <a:lin ang="5400000" scaled="0"/>
         </a:gradFill>
         <a:ln>
-          <a:noFill/>
+          <a:solidFill>
+            <a:schemeClr val="tx1"/>
+          </a:solidFill>
         </a:ln>
         <a:effectLst/>
         <a:scene3d>
@@ -1693,6 +3184,1064 @@
       <dsp:txXfrm>
         <a:off x="4300585" y="6746787"/>
         <a:ext cx="2469919" cy="1234664"/>
+      </dsp:txXfrm>
+    </dsp:sp>
+  </dsp:spTree>
+</dsp:drawing>
+</file>
+
+<file path=ppt/diagrams/drawing2.xml><?xml version="1.0" encoding="utf-8"?>
+<dsp:drawing xmlns:dgm="http://schemas.openxmlformats.org/drawingml/2006/diagram" xmlns:dsp="http://schemas.microsoft.com/office/drawing/2008/diagram" xmlns:a="http://schemas.openxmlformats.org/drawingml/2006/main">
+  <dsp:spTree>
+    <dsp:nvGrpSpPr>
+      <dsp:cNvPr id="0" name=""/>
+      <dsp:cNvGrpSpPr/>
+    </dsp:nvGrpSpPr>
+    <dsp:grpSpPr/>
+    <dsp:sp modelId="{32DFF38E-0B8C-4811-8E25-D1D460553EEF}">
+      <dsp:nvSpPr>
+        <dsp:cNvPr id="0" name=""/>
+        <dsp:cNvSpPr/>
+      </dsp:nvSpPr>
+      <dsp:spPr>
+        <a:xfrm>
+          <a:off x="0" y="8791101"/>
+          <a:ext cx="16775589" cy="2885435"/>
+        </a:xfrm>
+        <a:prstGeom prst="rect">
+          <a:avLst/>
+        </a:prstGeom>
+        <a:gradFill rotWithShape="0">
+          <a:gsLst>
+            <a:gs pos="0">
+              <a:schemeClr val="accent1">
+                <a:hueOff val="0"/>
+                <a:satOff val="0"/>
+                <a:lumOff val="0"/>
+                <a:alphaOff val="0"/>
+                <a:satMod val="103000"/>
+                <a:lumMod val="102000"/>
+                <a:tint val="94000"/>
+              </a:schemeClr>
+            </a:gs>
+            <a:gs pos="50000">
+              <a:schemeClr val="accent1">
+                <a:hueOff val="0"/>
+                <a:satOff val="0"/>
+                <a:lumOff val="0"/>
+                <a:alphaOff val="0"/>
+                <a:satMod val="110000"/>
+                <a:lumMod val="100000"/>
+                <a:shade val="100000"/>
+              </a:schemeClr>
+            </a:gs>
+            <a:gs pos="100000">
+              <a:schemeClr val="accent1">
+                <a:hueOff val="0"/>
+                <a:satOff val="0"/>
+                <a:lumOff val="0"/>
+                <a:alphaOff val="0"/>
+                <a:lumMod val="99000"/>
+                <a:satMod val="120000"/>
+                <a:shade val="78000"/>
+              </a:schemeClr>
+            </a:gs>
+          </a:gsLst>
+          <a:lin ang="5400000" scaled="0"/>
+        </a:gradFill>
+        <a:ln>
+          <a:solidFill>
+            <a:schemeClr val="tx1"/>
+          </a:solidFill>
+        </a:ln>
+        <a:effectLst/>
+        <a:scene3d>
+          <a:camera prst="orthographicFront"/>
+          <a:lightRig rig="flat" dir="t"/>
+        </a:scene3d>
+        <a:sp3d prstMaterial="plastic">
+          <a:bevelT w="120900" h="88900"/>
+          <a:bevelB w="88900" h="31750" prst="angle"/>
+        </a:sp3d>
+      </dsp:spPr>
+      <dsp:style>
+        <a:lnRef idx="0">
+          <a:scrgbClr r="0" g="0" b="0"/>
+        </a:lnRef>
+        <a:fillRef idx="3">
+          <a:scrgbClr r="0" g="0" b="0"/>
+        </a:fillRef>
+        <a:effectRef idx="2">
+          <a:scrgbClr r="0" g="0" b="0"/>
+        </a:effectRef>
+        <a:fontRef idx="minor">
+          <a:schemeClr val="lt1"/>
+        </a:fontRef>
+      </dsp:style>
+      <dsp:txBody>
+        <a:bodyPr spcFirstLastPara="0" vert="horz" wrap="square" lIns="341376" tIns="341376" rIns="341376" bIns="341376" numCol="1" spcCol="1270" anchor="ctr" anchorCtr="0">
+          <a:noAutofit/>
+        </a:bodyPr>
+        <a:lstStyle/>
+        <a:p>
+          <a:pPr marL="0" lvl="0" indent="0" algn="ctr" defTabSz="2133600">
+            <a:lnSpc>
+              <a:spcPct val="90000"/>
+            </a:lnSpc>
+            <a:spcBef>
+              <a:spcPct val="0"/>
+            </a:spcBef>
+            <a:spcAft>
+              <a:spcPct val="35000"/>
+            </a:spcAft>
+            <a:buNone/>
+          </a:pPr>
+          <a:r>
+            <a:rPr lang="en-IE" sz="4800" b="1" kern="1200" dirty="0"/>
+            <a:t>Deployment</a:t>
+          </a:r>
+          <a:endParaRPr lang="en-IE" sz="4000" b="1" kern="1200" dirty="0"/>
+        </a:p>
+      </dsp:txBody>
+      <dsp:txXfrm>
+        <a:off x="0" y="8791101"/>
+        <a:ext cx="16775589" cy="1558135"/>
+      </dsp:txXfrm>
+    </dsp:sp>
+    <dsp:sp modelId="{2147C4C3-E4ED-44EA-8A74-5AB07B9224C6}">
+      <dsp:nvSpPr>
+        <dsp:cNvPr id="0" name=""/>
+        <dsp:cNvSpPr/>
+      </dsp:nvSpPr>
+      <dsp:spPr>
+        <a:xfrm>
+          <a:off x="0" y="10351295"/>
+          <a:ext cx="5586402" cy="1327300"/>
+        </a:xfrm>
+        <a:prstGeom prst="rect">
+          <a:avLst/>
+        </a:prstGeom>
+        <a:solidFill>
+          <a:schemeClr val="accent1">
+            <a:alpha val="90000"/>
+            <a:tint val="40000"/>
+            <a:hueOff val="0"/>
+            <a:satOff val="0"/>
+            <a:lumOff val="0"/>
+            <a:alphaOff val="0"/>
+          </a:schemeClr>
+        </a:solidFill>
+        <a:ln w="12700" cap="flat" cmpd="sng" algn="ctr">
+          <a:solidFill>
+            <a:schemeClr val="tx1"/>
+          </a:solidFill>
+          <a:prstDash val="solid"/>
+          <a:miter lim="800000"/>
+        </a:ln>
+        <a:effectLst/>
+        <a:scene3d>
+          <a:camera prst="orthographicFront"/>
+          <a:lightRig rig="flat" dir="t"/>
+        </a:scene3d>
+        <a:sp3d z="190500" extrusionH="12700" prstMaterial="plastic">
+          <a:bevelT w="50800" h="50800"/>
+        </a:sp3d>
+      </dsp:spPr>
+      <dsp:style>
+        <a:lnRef idx="1">
+          <a:scrgbClr r="0" g="0" b="0"/>
+        </a:lnRef>
+        <a:fillRef idx="1">
+          <a:scrgbClr r="0" g="0" b="0"/>
+        </a:fillRef>
+        <a:effectRef idx="2">
+          <a:scrgbClr r="0" g="0" b="0"/>
+        </a:effectRef>
+        <a:fontRef idx="minor"/>
+      </dsp:style>
+      <dsp:txBody>
+        <a:bodyPr spcFirstLastPara="0" vert="horz" wrap="square" lIns="199136" tIns="35560" rIns="199136" bIns="35560" numCol="1" spcCol="1270" anchor="ctr" anchorCtr="0">
+          <a:noAutofit/>
+        </a:bodyPr>
+        <a:lstStyle/>
+        <a:p>
+          <a:pPr marL="0" lvl="0" indent="0" algn="ctr" defTabSz="1244600">
+            <a:lnSpc>
+              <a:spcPct val="90000"/>
+            </a:lnSpc>
+            <a:spcBef>
+              <a:spcPct val="0"/>
+            </a:spcBef>
+            <a:spcAft>
+              <a:spcPct val="35000"/>
+            </a:spcAft>
+            <a:buNone/>
+          </a:pPr>
+          <a:r>
+            <a:rPr lang="en-IE" sz="2800" kern="1200" dirty="0"/>
+            <a:t>AI play time optimizer</a:t>
+          </a:r>
+        </a:p>
+      </dsp:txBody>
+      <dsp:txXfrm>
+        <a:off x="0" y="10351295"/>
+        <a:ext cx="5586402" cy="1327300"/>
+      </dsp:txXfrm>
+    </dsp:sp>
+    <dsp:sp modelId="{EF0D8E2E-611F-48CE-B1FC-FF5FEBAA646D}">
+      <dsp:nvSpPr>
+        <dsp:cNvPr id="0" name=""/>
+        <dsp:cNvSpPr/>
+      </dsp:nvSpPr>
+      <dsp:spPr>
+        <a:xfrm>
+          <a:off x="5574258" y="10351295"/>
+          <a:ext cx="5586402" cy="1327300"/>
+        </a:xfrm>
+        <a:prstGeom prst="rect">
+          <a:avLst/>
+        </a:prstGeom>
+        <a:solidFill>
+          <a:schemeClr val="accent1">
+            <a:alpha val="90000"/>
+            <a:tint val="40000"/>
+            <a:hueOff val="0"/>
+            <a:satOff val="0"/>
+            <a:lumOff val="0"/>
+            <a:alphaOff val="0"/>
+          </a:schemeClr>
+        </a:solidFill>
+        <a:ln w="12700" cap="flat" cmpd="sng" algn="ctr">
+          <a:solidFill>
+            <a:schemeClr val="tx1"/>
+          </a:solidFill>
+          <a:prstDash val="solid"/>
+          <a:miter lim="800000"/>
+        </a:ln>
+        <a:effectLst/>
+        <a:scene3d>
+          <a:camera prst="orthographicFront"/>
+          <a:lightRig rig="flat" dir="t"/>
+        </a:scene3d>
+        <a:sp3d z="190500" extrusionH="12700" prstMaterial="plastic">
+          <a:bevelT w="50800" h="50800"/>
+        </a:sp3d>
+      </dsp:spPr>
+      <dsp:style>
+        <a:lnRef idx="1">
+          <a:scrgbClr r="0" g="0" b="0"/>
+        </a:lnRef>
+        <a:fillRef idx="1">
+          <a:scrgbClr r="0" g="0" b="0"/>
+        </a:fillRef>
+        <a:effectRef idx="2">
+          <a:scrgbClr r="0" g="0" b="0"/>
+        </a:effectRef>
+        <a:fontRef idx="minor"/>
+      </dsp:style>
+      <dsp:txBody>
+        <a:bodyPr spcFirstLastPara="0" vert="horz" wrap="square" lIns="199136" tIns="35560" rIns="199136" bIns="35560" numCol="1" spcCol="1270" anchor="ctr" anchorCtr="0">
+          <a:noAutofit/>
+        </a:bodyPr>
+        <a:lstStyle/>
+        <a:p>
+          <a:pPr marL="0" lvl="0" indent="0" algn="ctr" defTabSz="1244600">
+            <a:lnSpc>
+              <a:spcPct val="90000"/>
+            </a:lnSpc>
+            <a:spcBef>
+              <a:spcPct val="0"/>
+            </a:spcBef>
+            <a:spcAft>
+              <a:spcPct val="35000"/>
+            </a:spcAft>
+            <a:buNone/>
+          </a:pPr>
+          <a:r>
+            <a:rPr lang="en-IE" sz="2800" kern="1200" dirty="0"/>
+            <a:t>Validate containerized workloads</a:t>
+          </a:r>
+        </a:p>
+      </dsp:txBody>
+      <dsp:txXfrm>
+        <a:off x="5574258" y="10351295"/>
+        <a:ext cx="5586402" cy="1327300"/>
+      </dsp:txXfrm>
+    </dsp:sp>
+    <dsp:sp modelId="{A26E17A3-6ADC-4207-BAA9-6F37A7025026}">
+      <dsp:nvSpPr>
+        <dsp:cNvPr id="0" name=""/>
+        <dsp:cNvSpPr/>
+      </dsp:nvSpPr>
+      <dsp:spPr>
+        <a:xfrm>
+          <a:off x="11180995" y="10351295"/>
+          <a:ext cx="5586402" cy="1327300"/>
+        </a:xfrm>
+        <a:prstGeom prst="rect">
+          <a:avLst/>
+        </a:prstGeom>
+        <a:solidFill>
+          <a:schemeClr val="accent1">
+            <a:alpha val="90000"/>
+            <a:tint val="40000"/>
+            <a:hueOff val="0"/>
+            <a:satOff val="0"/>
+            <a:lumOff val="0"/>
+            <a:alphaOff val="0"/>
+          </a:schemeClr>
+        </a:solidFill>
+        <a:ln w="12700" cap="flat" cmpd="sng" algn="ctr">
+          <a:solidFill>
+            <a:schemeClr val="tx1"/>
+          </a:solidFill>
+          <a:prstDash val="solid"/>
+          <a:miter lim="800000"/>
+        </a:ln>
+        <a:effectLst/>
+        <a:scene3d>
+          <a:camera prst="orthographicFront"/>
+          <a:lightRig rig="flat" dir="t"/>
+        </a:scene3d>
+        <a:sp3d z="190500" extrusionH="12700" prstMaterial="plastic">
+          <a:bevelT w="50800" h="50800"/>
+        </a:sp3d>
+      </dsp:spPr>
+      <dsp:style>
+        <a:lnRef idx="1">
+          <a:scrgbClr r="0" g="0" b="0"/>
+        </a:lnRef>
+        <a:fillRef idx="1">
+          <a:scrgbClr r="0" g="0" b="0"/>
+        </a:fillRef>
+        <a:effectRef idx="2">
+          <a:scrgbClr r="0" g="0" b="0"/>
+        </a:effectRef>
+        <a:fontRef idx="minor"/>
+      </dsp:style>
+      <dsp:txBody>
+        <a:bodyPr spcFirstLastPara="0" vert="horz" wrap="square" lIns="199136" tIns="35560" rIns="199136" bIns="35560" numCol="1" spcCol="1270" anchor="ctr" anchorCtr="0">
+          <a:noAutofit/>
+        </a:bodyPr>
+        <a:lstStyle/>
+        <a:p>
+          <a:pPr marL="0" lvl="0" indent="0" algn="ctr" defTabSz="1244600">
+            <a:lnSpc>
+              <a:spcPct val="90000"/>
+            </a:lnSpc>
+            <a:spcBef>
+              <a:spcPct val="0"/>
+            </a:spcBef>
+            <a:spcAft>
+              <a:spcPct val="35000"/>
+            </a:spcAft>
+            <a:buNone/>
+          </a:pPr>
+          <a:r>
+            <a:rPr lang="en-IE" sz="2800" kern="1200" dirty="0"/>
+            <a:t>Node label constraints</a:t>
+          </a:r>
+        </a:p>
+      </dsp:txBody>
+      <dsp:txXfrm>
+        <a:off x="11180995" y="10351295"/>
+        <a:ext cx="5586402" cy="1327300"/>
+      </dsp:txXfrm>
+    </dsp:sp>
+    <dsp:sp modelId="{B5901160-2EED-4BC1-9CD9-CBC7C725C48E}">
+      <dsp:nvSpPr>
+        <dsp:cNvPr id="0" name=""/>
+        <dsp:cNvSpPr/>
+      </dsp:nvSpPr>
+      <dsp:spPr>
+        <a:xfrm rot="10800000">
+          <a:off x="0" y="4396582"/>
+          <a:ext cx="16775589" cy="4437799"/>
+        </a:xfrm>
+        <a:prstGeom prst="upArrowCallout">
+          <a:avLst/>
+        </a:prstGeom>
+        <a:gradFill rotWithShape="0">
+          <a:gsLst>
+            <a:gs pos="0">
+              <a:schemeClr val="accent1">
+                <a:hueOff val="0"/>
+                <a:satOff val="0"/>
+                <a:lumOff val="0"/>
+                <a:alphaOff val="0"/>
+                <a:satMod val="103000"/>
+                <a:lumMod val="102000"/>
+                <a:tint val="94000"/>
+              </a:schemeClr>
+            </a:gs>
+            <a:gs pos="50000">
+              <a:schemeClr val="accent1">
+                <a:hueOff val="0"/>
+                <a:satOff val="0"/>
+                <a:lumOff val="0"/>
+                <a:alphaOff val="0"/>
+                <a:satMod val="110000"/>
+                <a:lumMod val="100000"/>
+                <a:shade val="100000"/>
+              </a:schemeClr>
+            </a:gs>
+            <a:gs pos="100000">
+              <a:schemeClr val="accent1">
+                <a:hueOff val="0"/>
+                <a:satOff val="0"/>
+                <a:lumOff val="0"/>
+                <a:alphaOff val="0"/>
+                <a:lumMod val="99000"/>
+                <a:satMod val="120000"/>
+                <a:shade val="78000"/>
+              </a:schemeClr>
+            </a:gs>
+          </a:gsLst>
+          <a:lin ang="5400000" scaled="0"/>
+        </a:gradFill>
+        <a:ln>
+          <a:solidFill>
+            <a:schemeClr val="tx1"/>
+          </a:solidFill>
+        </a:ln>
+        <a:effectLst/>
+        <a:scene3d>
+          <a:camera prst="orthographicFront"/>
+          <a:lightRig rig="flat" dir="t"/>
+        </a:scene3d>
+        <a:sp3d prstMaterial="plastic">
+          <a:bevelT w="120900" h="88900"/>
+          <a:bevelB w="88900" h="31750" prst="angle"/>
+        </a:sp3d>
+      </dsp:spPr>
+      <dsp:style>
+        <a:lnRef idx="0">
+          <a:scrgbClr r="0" g="0" b="0"/>
+        </a:lnRef>
+        <a:fillRef idx="3">
+          <a:scrgbClr r="0" g="0" b="0"/>
+        </a:fillRef>
+        <a:effectRef idx="2">
+          <a:scrgbClr r="0" g="0" b="0"/>
+        </a:effectRef>
+        <a:fontRef idx="minor">
+          <a:schemeClr val="lt1"/>
+        </a:fontRef>
+      </dsp:style>
+      <dsp:txBody>
+        <a:bodyPr spcFirstLastPara="0" vert="horz" wrap="square" lIns="341376" tIns="341376" rIns="341376" bIns="341376" numCol="1" spcCol="1270" anchor="ctr" anchorCtr="0">
+          <a:noAutofit/>
+        </a:bodyPr>
+        <a:lstStyle/>
+        <a:p>
+          <a:pPr marL="0" lvl="0" indent="0" algn="ctr" defTabSz="2133600">
+            <a:lnSpc>
+              <a:spcPct val="90000"/>
+            </a:lnSpc>
+            <a:spcBef>
+              <a:spcPct val="0"/>
+            </a:spcBef>
+            <a:spcAft>
+              <a:spcPct val="35000"/>
+            </a:spcAft>
+            <a:buNone/>
+          </a:pPr>
+          <a:r>
+            <a:rPr lang="en-IE" sz="4800" b="1" kern="1200" dirty="0"/>
+            <a:t>Task Binding</a:t>
+          </a:r>
+        </a:p>
+      </dsp:txBody>
+      <dsp:txXfrm rot="-10800000">
+        <a:off x="0" y="4396582"/>
+        <a:ext cx="16775589" cy="1557667"/>
+      </dsp:txXfrm>
+    </dsp:sp>
+    <dsp:sp modelId="{9CE9A027-D096-4DBA-9F41-ACB337DEDCA0}">
+      <dsp:nvSpPr>
+        <dsp:cNvPr id="0" name=""/>
+        <dsp:cNvSpPr/>
+      </dsp:nvSpPr>
+      <dsp:spPr>
+        <a:xfrm>
+          <a:off x="8191" y="5954250"/>
+          <a:ext cx="5586402" cy="1326902"/>
+        </a:xfrm>
+        <a:prstGeom prst="rect">
+          <a:avLst/>
+        </a:prstGeom>
+        <a:solidFill>
+          <a:schemeClr val="accent1">
+            <a:alpha val="90000"/>
+            <a:tint val="40000"/>
+            <a:hueOff val="0"/>
+            <a:satOff val="0"/>
+            <a:lumOff val="0"/>
+            <a:alphaOff val="0"/>
+          </a:schemeClr>
+        </a:solidFill>
+        <a:ln w="12700" cap="flat" cmpd="sng" algn="ctr">
+          <a:solidFill>
+            <a:schemeClr val="tx1"/>
+          </a:solidFill>
+          <a:prstDash val="solid"/>
+          <a:miter lim="800000"/>
+        </a:ln>
+        <a:effectLst/>
+        <a:scene3d>
+          <a:camera prst="orthographicFront"/>
+          <a:lightRig rig="flat" dir="t"/>
+        </a:scene3d>
+        <a:sp3d z="190500" extrusionH="12700" prstMaterial="plastic">
+          <a:bevelT w="50800" h="50800"/>
+        </a:sp3d>
+      </dsp:spPr>
+      <dsp:style>
+        <a:lnRef idx="1">
+          <a:scrgbClr r="0" g="0" b="0"/>
+        </a:lnRef>
+        <a:fillRef idx="1">
+          <a:scrgbClr r="0" g="0" b="0"/>
+        </a:fillRef>
+        <a:effectRef idx="2">
+          <a:scrgbClr r="0" g="0" b="0"/>
+        </a:effectRef>
+        <a:fontRef idx="minor"/>
+      </dsp:style>
+      <dsp:txBody>
+        <a:bodyPr spcFirstLastPara="0" vert="horz" wrap="square" lIns="199136" tIns="35560" rIns="199136" bIns="35560" numCol="1" spcCol="1270" anchor="ctr" anchorCtr="0">
+          <a:noAutofit/>
+        </a:bodyPr>
+        <a:lstStyle/>
+        <a:p>
+          <a:pPr marL="0" lvl="0" indent="0" algn="ctr" defTabSz="1244600">
+            <a:lnSpc>
+              <a:spcPct val="90000"/>
+            </a:lnSpc>
+            <a:spcBef>
+              <a:spcPct val="0"/>
+            </a:spcBef>
+            <a:spcAft>
+              <a:spcPct val="35000"/>
+            </a:spcAft>
+            <a:buNone/>
+          </a:pPr>
+          <a:r>
+            <a:rPr lang="en-IE" sz="2800" kern="1200" dirty="0"/>
+            <a:t>Serialized function runner</a:t>
+          </a:r>
+        </a:p>
+      </dsp:txBody>
+      <dsp:txXfrm>
+        <a:off x="8191" y="5954250"/>
+        <a:ext cx="5586402" cy="1326902"/>
+      </dsp:txXfrm>
+    </dsp:sp>
+    <dsp:sp modelId="{87C3872B-7E02-4085-B647-9CD9B06A0313}">
+      <dsp:nvSpPr>
+        <dsp:cNvPr id="0" name=""/>
+        <dsp:cNvSpPr/>
+      </dsp:nvSpPr>
+      <dsp:spPr>
+        <a:xfrm>
+          <a:off x="5594593" y="5954250"/>
+          <a:ext cx="5586402" cy="1326902"/>
+        </a:xfrm>
+        <a:prstGeom prst="rect">
+          <a:avLst/>
+        </a:prstGeom>
+        <a:solidFill>
+          <a:schemeClr val="accent1">
+            <a:alpha val="90000"/>
+            <a:tint val="40000"/>
+            <a:hueOff val="0"/>
+            <a:satOff val="0"/>
+            <a:lumOff val="0"/>
+            <a:alphaOff val="0"/>
+          </a:schemeClr>
+        </a:solidFill>
+        <a:ln w="12700" cap="flat" cmpd="sng" algn="ctr">
+          <a:solidFill>
+            <a:schemeClr val="tx1"/>
+          </a:solidFill>
+          <a:prstDash val="solid"/>
+          <a:miter lim="800000"/>
+        </a:ln>
+        <a:effectLst/>
+        <a:scene3d>
+          <a:camera prst="orthographicFront"/>
+          <a:lightRig rig="flat" dir="t"/>
+        </a:scene3d>
+        <a:sp3d z="190500" extrusionH="12700" prstMaterial="plastic">
+          <a:bevelT w="50800" h="50800"/>
+        </a:sp3d>
+      </dsp:spPr>
+      <dsp:style>
+        <a:lnRef idx="1">
+          <a:scrgbClr r="0" g="0" b="0"/>
+        </a:lnRef>
+        <a:fillRef idx="1">
+          <a:scrgbClr r="0" g="0" b="0"/>
+        </a:fillRef>
+        <a:effectRef idx="2">
+          <a:scrgbClr r="0" g="0" b="0"/>
+        </a:effectRef>
+        <a:fontRef idx="minor"/>
+      </dsp:style>
+      <dsp:txBody>
+        <a:bodyPr spcFirstLastPara="0" vert="horz" wrap="square" lIns="199136" tIns="35560" rIns="199136" bIns="35560" numCol="1" spcCol="1270" anchor="ctr" anchorCtr="0">
+          <a:noAutofit/>
+        </a:bodyPr>
+        <a:lstStyle/>
+        <a:p>
+          <a:pPr marL="0" lvl="0" indent="0" algn="ctr" defTabSz="1244600">
+            <a:lnSpc>
+              <a:spcPct val="90000"/>
+            </a:lnSpc>
+            <a:spcBef>
+              <a:spcPct val="0"/>
+            </a:spcBef>
+            <a:spcAft>
+              <a:spcPct val="35000"/>
+            </a:spcAft>
+            <a:buNone/>
+          </a:pPr>
+          <a:r>
+            <a:rPr lang="en-IE" sz="2800" kern="1200" dirty="0"/>
+            <a:t>Validates explicit binding semantics (early vs late)</a:t>
+          </a:r>
+        </a:p>
+      </dsp:txBody>
+      <dsp:txXfrm>
+        <a:off x="5594593" y="5954250"/>
+        <a:ext cx="5586402" cy="1326902"/>
+      </dsp:txXfrm>
+    </dsp:sp>
+    <dsp:sp modelId="{6A9F14BE-80C0-4B02-B21C-6C233AACAF51}">
+      <dsp:nvSpPr>
+        <dsp:cNvPr id="0" name=""/>
+        <dsp:cNvSpPr/>
+      </dsp:nvSpPr>
+      <dsp:spPr>
+        <a:xfrm>
+          <a:off x="11180995" y="5954250"/>
+          <a:ext cx="5586402" cy="1326902"/>
+        </a:xfrm>
+        <a:prstGeom prst="rect">
+          <a:avLst/>
+        </a:prstGeom>
+        <a:solidFill>
+          <a:schemeClr val="accent1">
+            <a:alpha val="90000"/>
+            <a:tint val="40000"/>
+            <a:hueOff val="0"/>
+            <a:satOff val="0"/>
+            <a:lumOff val="0"/>
+            <a:alphaOff val="0"/>
+          </a:schemeClr>
+        </a:solidFill>
+        <a:ln w="12700" cap="flat" cmpd="sng" algn="ctr">
+          <a:solidFill>
+            <a:schemeClr val="tx1"/>
+          </a:solidFill>
+          <a:prstDash val="solid"/>
+          <a:miter lim="800000"/>
+        </a:ln>
+        <a:effectLst/>
+        <a:scene3d>
+          <a:camera prst="orthographicFront"/>
+          <a:lightRig rig="flat" dir="t"/>
+        </a:scene3d>
+        <a:sp3d z="190500" extrusionH="12700" prstMaterial="plastic">
+          <a:bevelT w="50800" h="50800"/>
+        </a:sp3d>
+      </dsp:spPr>
+      <dsp:style>
+        <a:lnRef idx="1">
+          <a:scrgbClr r="0" g="0" b="0"/>
+        </a:lnRef>
+        <a:fillRef idx="1">
+          <a:scrgbClr r="0" g="0" b="0"/>
+        </a:fillRef>
+        <a:effectRef idx="2">
+          <a:scrgbClr r="0" g="0" b="0"/>
+        </a:effectRef>
+        <a:fontRef idx="minor"/>
+      </dsp:style>
+      <dsp:txBody>
+        <a:bodyPr spcFirstLastPara="0" vert="horz" wrap="square" lIns="199136" tIns="35560" rIns="199136" bIns="35560" numCol="1" spcCol="1270" anchor="ctr" anchorCtr="0">
+          <a:noAutofit/>
+        </a:bodyPr>
+        <a:lstStyle/>
+        <a:p>
+          <a:pPr marL="0" lvl="0" indent="0" algn="ctr" defTabSz="1244600">
+            <a:lnSpc>
+              <a:spcPct val="90000"/>
+            </a:lnSpc>
+            <a:spcBef>
+              <a:spcPct val="0"/>
+            </a:spcBef>
+            <a:spcAft>
+              <a:spcPct val="35000"/>
+            </a:spcAft>
+            <a:buNone/>
+          </a:pPr>
+          <a:r>
+            <a:rPr lang="en-IE" sz="2800" kern="1200" dirty="0"/>
+            <a:t>Job environment attached             to tasks</a:t>
+          </a:r>
+        </a:p>
+      </dsp:txBody>
+      <dsp:txXfrm>
+        <a:off x="11180995" y="5954250"/>
+        <a:ext cx="5586402" cy="1326902"/>
+      </dsp:txXfrm>
+    </dsp:sp>
+    <dsp:sp modelId="{452ACE0D-CF1A-4DE8-8E3E-A45C514F1149}">
+      <dsp:nvSpPr>
+        <dsp:cNvPr id="0" name=""/>
+        <dsp:cNvSpPr/>
+      </dsp:nvSpPr>
+      <dsp:spPr>
+        <a:xfrm rot="10800000">
+          <a:off x="0" y="0"/>
+          <a:ext cx="16775589" cy="4437799"/>
+        </a:xfrm>
+        <a:prstGeom prst="upArrowCallout">
+          <a:avLst/>
+        </a:prstGeom>
+        <a:gradFill rotWithShape="0">
+          <a:gsLst>
+            <a:gs pos="0">
+              <a:schemeClr val="accent1">
+                <a:hueOff val="0"/>
+                <a:satOff val="0"/>
+                <a:lumOff val="0"/>
+                <a:alphaOff val="0"/>
+                <a:satMod val="103000"/>
+                <a:lumMod val="102000"/>
+                <a:tint val="94000"/>
+              </a:schemeClr>
+            </a:gs>
+            <a:gs pos="50000">
+              <a:schemeClr val="accent1">
+                <a:hueOff val="0"/>
+                <a:satOff val="0"/>
+                <a:lumOff val="0"/>
+                <a:alphaOff val="0"/>
+                <a:satMod val="110000"/>
+                <a:lumMod val="100000"/>
+                <a:shade val="100000"/>
+              </a:schemeClr>
+            </a:gs>
+            <a:gs pos="100000">
+              <a:schemeClr val="accent1">
+                <a:hueOff val="0"/>
+                <a:satOff val="0"/>
+                <a:lumOff val="0"/>
+                <a:alphaOff val="0"/>
+                <a:lumMod val="99000"/>
+                <a:satMod val="120000"/>
+                <a:shade val="78000"/>
+              </a:schemeClr>
+            </a:gs>
+          </a:gsLst>
+          <a:lin ang="5400000" scaled="0"/>
+        </a:gradFill>
+        <a:ln>
+          <a:noFill/>
+        </a:ln>
+        <a:effectLst/>
+        <a:scene3d>
+          <a:camera prst="orthographicFront"/>
+          <a:lightRig rig="flat" dir="t"/>
+        </a:scene3d>
+        <a:sp3d prstMaterial="plastic">
+          <a:bevelT w="120900" h="88900"/>
+          <a:bevelB w="88900" h="31750" prst="angle"/>
+        </a:sp3d>
+      </dsp:spPr>
+      <dsp:style>
+        <a:lnRef idx="0">
+          <a:scrgbClr r="0" g="0" b="0"/>
+        </a:lnRef>
+        <a:fillRef idx="3">
+          <a:scrgbClr r="0" g="0" b="0"/>
+        </a:fillRef>
+        <a:effectRef idx="2">
+          <a:scrgbClr r="0" g="0" b="0"/>
+        </a:effectRef>
+        <a:fontRef idx="minor">
+          <a:schemeClr val="lt1"/>
+        </a:fontRef>
+      </dsp:style>
+      <dsp:txBody>
+        <a:bodyPr spcFirstLastPara="0" vert="horz" wrap="square" lIns="341376" tIns="341376" rIns="341376" bIns="341376" numCol="1" spcCol="1270" anchor="ctr" anchorCtr="0">
+          <a:noAutofit/>
+        </a:bodyPr>
+        <a:lstStyle/>
+        <a:p>
+          <a:pPr marL="0" lvl="0" indent="0" algn="ctr" defTabSz="2133600">
+            <a:lnSpc>
+              <a:spcPct val="90000"/>
+            </a:lnSpc>
+            <a:spcBef>
+              <a:spcPct val="0"/>
+            </a:spcBef>
+            <a:spcAft>
+              <a:spcPct val="35000"/>
+            </a:spcAft>
+            <a:buNone/>
+          </a:pPr>
+          <a:r>
+            <a:rPr lang="en-IE" sz="4800" b="1" kern="1200" dirty="0"/>
+            <a:t>Workflow Orchestration</a:t>
+          </a:r>
+        </a:p>
+      </dsp:txBody>
+      <dsp:txXfrm rot="-10800000">
+        <a:off x="0" y="0"/>
+        <a:ext cx="16775589" cy="1557667"/>
+      </dsp:txXfrm>
+    </dsp:sp>
+    <dsp:sp modelId="{07763EBB-4274-4F86-A670-BA07EE7CCAD5}">
+      <dsp:nvSpPr>
+        <dsp:cNvPr id="0" name=""/>
+        <dsp:cNvSpPr/>
+      </dsp:nvSpPr>
+      <dsp:spPr>
+        <a:xfrm>
+          <a:off x="28525" y="1559732"/>
+          <a:ext cx="5586402" cy="1326902"/>
+        </a:xfrm>
+        <a:prstGeom prst="rect">
+          <a:avLst/>
+        </a:prstGeom>
+        <a:solidFill>
+          <a:schemeClr val="accent1">
+            <a:alpha val="90000"/>
+            <a:tint val="40000"/>
+            <a:hueOff val="0"/>
+            <a:satOff val="0"/>
+            <a:lumOff val="0"/>
+            <a:alphaOff val="0"/>
+          </a:schemeClr>
+        </a:solidFill>
+        <a:ln w="12700" cap="flat" cmpd="sng" algn="ctr">
+          <a:solidFill>
+            <a:schemeClr val="tx1"/>
+          </a:solidFill>
+          <a:prstDash val="solid"/>
+          <a:miter lim="800000"/>
+        </a:ln>
+        <a:effectLst/>
+        <a:scene3d>
+          <a:camera prst="orthographicFront"/>
+          <a:lightRig rig="flat" dir="t"/>
+        </a:scene3d>
+        <a:sp3d z="190500" extrusionH="12700" prstMaterial="plastic">
+          <a:bevelT w="50800" h="50800"/>
+        </a:sp3d>
+      </dsp:spPr>
+      <dsp:style>
+        <a:lnRef idx="1">
+          <a:scrgbClr r="0" g="0" b="0"/>
+        </a:lnRef>
+        <a:fillRef idx="1">
+          <a:scrgbClr r="0" g="0" b="0"/>
+        </a:fillRef>
+        <a:effectRef idx="2">
+          <a:scrgbClr r="0" g="0" b="0"/>
+        </a:effectRef>
+        <a:fontRef idx="minor"/>
+      </dsp:style>
+      <dsp:txBody>
+        <a:bodyPr spcFirstLastPara="0" vert="horz" wrap="square" lIns="199136" tIns="35560" rIns="199136" bIns="35560" numCol="1" spcCol="1270" anchor="ctr" anchorCtr="0">
+          <a:noAutofit/>
+        </a:bodyPr>
+        <a:lstStyle/>
+        <a:p>
+          <a:pPr marL="0" lvl="0" indent="0" algn="ctr" defTabSz="1244600">
+            <a:lnSpc>
+              <a:spcPct val="90000"/>
+            </a:lnSpc>
+            <a:spcBef>
+              <a:spcPct val="0"/>
+            </a:spcBef>
+            <a:spcAft>
+              <a:spcPct val="35000"/>
+            </a:spcAft>
+            <a:buNone/>
+          </a:pPr>
+          <a:r>
+            <a:rPr lang="en-IE" sz="2800" kern="1200" dirty="0"/>
+            <a:t>Bioinformatic workflow</a:t>
+          </a:r>
+        </a:p>
+      </dsp:txBody>
+      <dsp:txXfrm>
+        <a:off x="28525" y="1559732"/>
+        <a:ext cx="5586402" cy="1326902"/>
+      </dsp:txXfrm>
+    </dsp:sp>
+    <dsp:sp modelId="{A5384461-3C55-409F-A76C-DC6C5CADCFE8}">
+      <dsp:nvSpPr>
+        <dsp:cNvPr id="0" name=""/>
+        <dsp:cNvSpPr/>
+      </dsp:nvSpPr>
+      <dsp:spPr>
+        <a:xfrm>
+          <a:off x="5594593" y="1559732"/>
+          <a:ext cx="5586402" cy="1326902"/>
+        </a:xfrm>
+        <a:prstGeom prst="rect">
+          <a:avLst/>
+        </a:prstGeom>
+        <a:solidFill>
+          <a:schemeClr val="accent1">
+            <a:alpha val="90000"/>
+            <a:tint val="40000"/>
+            <a:hueOff val="0"/>
+            <a:satOff val="0"/>
+            <a:lumOff val="0"/>
+            <a:alphaOff val="0"/>
+          </a:schemeClr>
+        </a:solidFill>
+        <a:ln w="12700" cap="flat" cmpd="sng" algn="ctr">
+          <a:solidFill>
+            <a:schemeClr val="tx1"/>
+          </a:solidFill>
+          <a:prstDash val="solid"/>
+          <a:miter lim="800000"/>
+        </a:ln>
+        <a:effectLst/>
+        <a:scene3d>
+          <a:camera prst="orthographicFront"/>
+          <a:lightRig rig="flat" dir="t"/>
+        </a:scene3d>
+        <a:sp3d z="190500" extrusionH="12700" prstMaterial="plastic">
+          <a:bevelT w="50800" h="50800"/>
+        </a:sp3d>
+      </dsp:spPr>
+      <dsp:style>
+        <a:lnRef idx="1">
+          <a:scrgbClr r="0" g="0" b="0"/>
+        </a:lnRef>
+        <a:fillRef idx="1">
+          <a:scrgbClr r="0" g="0" b="0"/>
+        </a:fillRef>
+        <a:effectRef idx="2">
+          <a:scrgbClr r="0" g="0" b="0"/>
+        </a:effectRef>
+        <a:fontRef idx="minor"/>
+      </dsp:style>
+      <dsp:txBody>
+        <a:bodyPr spcFirstLastPara="0" vert="horz" wrap="square" lIns="199136" tIns="35560" rIns="199136" bIns="35560" numCol="1" spcCol="1270" anchor="ctr" anchorCtr="0">
+          <a:noAutofit/>
+        </a:bodyPr>
+        <a:lstStyle/>
+        <a:p>
+          <a:pPr marL="0" lvl="0" indent="0" algn="ctr" defTabSz="1244600">
+            <a:lnSpc>
+              <a:spcPct val="90000"/>
+            </a:lnSpc>
+            <a:spcBef>
+              <a:spcPct val="0"/>
+            </a:spcBef>
+            <a:spcAft>
+              <a:spcPct val="35000"/>
+            </a:spcAft>
+            <a:buNone/>
+          </a:pPr>
+          <a:r>
+            <a:rPr lang="en-IE" sz="2800" kern="1200" dirty="0"/>
+            <a:t>Validates workflow orchestration across generic pilots</a:t>
+          </a:r>
+        </a:p>
+      </dsp:txBody>
+      <dsp:txXfrm>
+        <a:off x="5594593" y="1559732"/>
+        <a:ext cx="5586402" cy="1326902"/>
+      </dsp:txXfrm>
+    </dsp:sp>
+    <dsp:sp modelId="{1CEB22B1-9A7E-4A91-AF0C-26B893E69FA6}">
+      <dsp:nvSpPr>
+        <dsp:cNvPr id="0" name=""/>
+        <dsp:cNvSpPr/>
+      </dsp:nvSpPr>
+      <dsp:spPr>
+        <a:xfrm>
+          <a:off x="11180995" y="1559732"/>
+          <a:ext cx="5586402" cy="1326902"/>
+        </a:xfrm>
+        <a:prstGeom prst="rect">
+          <a:avLst/>
+        </a:prstGeom>
+        <a:solidFill>
+          <a:schemeClr val="accent1">
+            <a:alpha val="90000"/>
+            <a:tint val="40000"/>
+            <a:hueOff val="0"/>
+            <a:satOff val="0"/>
+            <a:lumOff val="0"/>
+            <a:alphaOff val="0"/>
+          </a:schemeClr>
+        </a:solidFill>
+        <a:ln w="12700" cap="flat" cmpd="sng" algn="ctr">
+          <a:solidFill>
+            <a:schemeClr val="tx1"/>
+          </a:solidFill>
+          <a:prstDash val="solid"/>
+          <a:miter lim="800000"/>
+        </a:ln>
+        <a:effectLst/>
+        <a:scene3d>
+          <a:camera prst="orthographicFront"/>
+          <a:lightRig rig="flat" dir="t"/>
+        </a:scene3d>
+        <a:sp3d z="190500" extrusionH="12700" prstMaterial="plastic">
+          <a:bevelT w="50800" h="50800"/>
+        </a:sp3d>
+      </dsp:spPr>
+      <dsp:style>
+        <a:lnRef idx="1">
+          <a:scrgbClr r="0" g="0" b="0"/>
+        </a:lnRef>
+        <a:fillRef idx="1">
+          <a:scrgbClr r="0" g="0" b="0"/>
+        </a:fillRef>
+        <a:effectRef idx="2">
+          <a:scrgbClr r="0" g="0" b="0"/>
+        </a:effectRef>
+        <a:fontRef idx="minor"/>
+      </dsp:style>
+      <dsp:txBody>
+        <a:bodyPr spcFirstLastPara="0" vert="horz" wrap="square" lIns="199136" tIns="35560" rIns="199136" bIns="35560" numCol="1" spcCol="1270" anchor="ctr" anchorCtr="0">
+          <a:noAutofit/>
+        </a:bodyPr>
+        <a:lstStyle/>
+        <a:p>
+          <a:pPr marL="0" lvl="0" indent="0" algn="ctr" defTabSz="1244600">
+            <a:lnSpc>
+              <a:spcPct val="90000"/>
+            </a:lnSpc>
+            <a:spcBef>
+              <a:spcPct val="0"/>
+            </a:spcBef>
+            <a:spcAft>
+              <a:spcPct val="35000"/>
+            </a:spcAft>
+            <a:buNone/>
+          </a:pPr>
+          <a:r>
+            <a:rPr lang="en-IE" sz="2800" kern="1200" dirty="0"/>
+            <a:t>Operational across relational        &amp; non-relational databases</a:t>
+          </a:r>
+        </a:p>
+      </dsp:txBody>
+      <dsp:txXfrm>
+        <a:off x="11180995" y="1559732"/>
+        <a:ext cx="5586402" cy="1326902"/>
       </dsp:txXfrm>
     </dsp:sp>
   </dsp:spTree>
@@ -3775,7 +6324,1477 @@
 </dgm:layoutDef>
 </file>
 
+<file path=ppt/diagrams/layout2.xml><?xml version="1.0" encoding="utf-8"?>
+<dgm:layoutDef xmlns:dgm="http://schemas.openxmlformats.org/drawingml/2006/diagram" xmlns:a="http://schemas.openxmlformats.org/drawingml/2006/main" uniqueId="urn:microsoft.com/office/officeart/2005/8/layout/process4">
+  <dgm:title val=""/>
+  <dgm:desc val=""/>
+  <dgm:catLst>
+    <dgm:cat type="process" pri="16000"/>
+    <dgm:cat type="list" pri="20000"/>
+  </dgm:catLst>
+  <dgm:sampData>
+    <dgm:dataModel>
+      <dgm:ptLst>
+        <dgm:pt modelId="0" type="doc"/>
+        <dgm:pt modelId="1">
+          <dgm:prSet phldr="1"/>
+        </dgm:pt>
+        <dgm:pt modelId="11">
+          <dgm:prSet phldr="1"/>
+        </dgm:pt>
+        <dgm:pt modelId="12">
+          <dgm:prSet phldr="1"/>
+        </dgm:pt>
+        <dgm:pt modelId="2">
+          <dgm:prSet phldr="1"/>
+        </dgm:pt>
+        <dgm:pt modelId="21">
+          <dgm:prSet phldr="1"/>
+        </dgm:pt>
+        <dgm:pt modelId="22">
+          <dgm:prSet phldr="1"/>
+        </dgm:pt>
+        <dgm:pt modelId="3">
+          <dgm:prSet phldr="1"/>
+        </dgm:pt>
+        <dgm:pt modelId="31">
+          <dgm:prSet phldr="1"/>
+        </dgm:pt>
+        <dgm:pt modelId="32">
+          <dgm:prSet phldr="1"/>
+        </dgm:pt>
+      </dgm:ptLst>
+      <dgm:cxnLst>
+        <dgm:cxn modelId="4" srcId="0" destId="1" srcOrd="0" destOrd="0"/>
+        <dgm:cxn modelId="5" srcId="0" destId="2" srcOrd="1" destOrd="0"/>
+        <dgm:cxn modelId="6" srcId="0" destId="3" srcOrd="2" destOrd="0"/>
+        <dgm:cxn modelId="13" srcId="1" destId="11" srcOrd="0" destOrd="0"/>
+        <dgm:cxn modelId="14" srcId="1" destId="12" srcOrd="1" destOrd="0"/>
+        <dgm:cxn modelId="23" srcId="2" destId="21" srcOrd="0" destOrd="0"/>
+        <dgm:cxn modelId="24" srcId="2" destId="22" srcOrd="1" destOrd="0"/>
+        <dgm:cxn modelId="33" srcId="3" destId="31" srcOrd="0" destOrd="0"/>
+        <dgm:cxn modelId="34" srcId="3" destId="32" srcOrd="1" destOrd="0"/>
+      </dgm:cxnLst>
+      <dgm:bg/>
+      <dgm:whole/>
+    </dgm:dataModel>
+  </dgm:sampData>
+  <dgm:styleData>
+    <dgm:dataModel>
+      <dgm:ptLst>
+        <dgm:pt modelId="0" type="doc"/>
+        <dgm:pt modelId="1"/>
+        <dgm:pt modelId="11"/>
+        <dgm:pt modelId="2"/>
+        <dgm:pt modelId="21"/>
+      </dgm:ptLst>
+      <dgm:cxnLst>
+        <dgm:cxn modelId="4" srcId="0" destId="1" srcOrd="0" destOrd="0"/>
+        <dgm:cxn modelId="5" srcId="0" destId="2" srcOrd="1" destOrd="0"/>
+        <dgm:cxn modelId="13" srcId="1" destId="11" srcOrd="0" destOrd="0"/>
+        <dgm:cxn modelId="23" srcId="2" destId="21" srcOrd="0" destOrd="0"/>
+      </dgm:cxnLst>
+      <dgm:bg/>
+      <dgm:whole/>
+    </dgm:dataModel>
+  </dgm:styleData>
+  <dgm:clrData>
+    <dgm:dataModel>
+      <dgm:ptLst>
+        <dgm:pt modelId="0" type="doc"/>
+        <dgm:pt modelId="1"/>
+        <dgm:pt modelId="11"/>
+        <dgm:pt modelId="2"/>
+        <dgm:pt modelId="21"/>
+        <dgm:pt modelId="3"/>
+        <dgm:pt modelId="31"/>
+        <dgm:pt modelId="4"/>
+        <dgm:pt modelId="41"/>
+      </dgm:ptLst>
+      <dgm:cxnLst>
+        <dgm:cxn modelId="5" srcId="0" destId="1" srcOrd="0" destOrd="0"/>
+        <dgm:cxn modelId="6" srcId="0" destId="2" srcOrd="1" destOrd="0"/>
+        <dgm:cxn modelId="7" srcId="0" destId="3" srcOrd="2" destOrd="0"/>
+        <dgm:cxn modelId="8" srcId="0" destId="4" srcOrd="3" destOrd="0"/>
+        <dgm:cxn modelId="13" srcId="1" destId="11" srcOrd="0" destOrd="0"/>
+        <dgm:cxn modelId="23" srcId="2" destId="21" srcOrd="0" destOrd="0"/>
+        <dgm:cxn modelId="33" srcId="3" destId="31" srcOrd="0" destOrd="0"/>
+        <dgm:cxn modelId="43" srcId="4" destId="41" srcOrd="0" destOrd="0"/>
+      </dgm:cxnLst>
+      <dgm:bg/>
+      <dgm:whole/>
+    </dgm:dataModel>
+  </dgm:clrData>
+  <dgm:layoutNode name="Name0">
+    <dgm:varLst>
+      <dgm:dir/>
+      <dgm:animLvl val="lvl"/>
+      <dgm:resizeHandles val="exact"/>
+    </dgm:varLst>
+    <dgm:alg type="lin">
+      <dgm:param type="linDir" val="fromB"/>
+    </dgm:alg>
+    <dgm:shape xmlns:r="http://schemas.openxmlformats.org/officeDocument/2006/relationships" r:blip="">
+      <dgm:adjLst/>
+    </dgm:shape>
+    <dgm:presOf/>
+    <dgm:constrLst>
+      <dgm:constr type="h" for="ch" forName="boxAndChildren" refType="h"/>
+      <dgm:constr type="h" for="ch" forName="arrowAndChildren" refType="h" refFor="ch" refForName="boxAndChildren" op="equ" fact="1.538"/>
+      <dgm:constr type="w" for="ch" forName="arrowAndChildren" refType="w"/>
+      <dgm:constr type="w" for="ch" forName="boxAndChildren" refType="w"/>
+      <dgm:constr type="h" for="ch" forName="sp" refType="h" fact="-0.015"/>
+      <dgm:constr type="primFontSz" for="des" forName="parentTextBox" val="65"/>
+      <dgm:constr type="primFontSz" for="des" forName="parentTextArrow" refType="primFontSz" refFor="des" refForName="parentTextBox" op="equ"/>
+      <dgm:constr type="primFontSz" for="des" forName="childTextArrow" val="65"/>
+      <dgm:constr type="primFontSz" for="des" forName="childTextBox" refType="primFontSz" refFor="des" refForName="childTextArrow" op="equ"/>
+    </dgm:constrLst>
+    <dgm:ruleLst/>
+    <dgm:forEach name="Name1" axis="ch" ptType="node" st="-1" step="-1">
+      <dgm:choose name="Name2">
+        <dgm:if name="Name3" axis="self" ptType="node" func="revPos" op="equ" val="1">
+          <dgm:layoutNode name="boxAndChildren">
+            <dgm:alg type="composite"/>
+            <dgm:shape xmlns:r="http://schemas.openxmlformats.org/officeDocument/2006/relationships" r:blip="">
+              <dgm:adjLst/>
+            </dgm:shape>
+            <dgm:presOf/>
+            <dgm:choose name="Name4">
+              <dgm:if name="Name5" axis="ch" ptType="node" func="cnt" op="gte" val="1">
+                <dgm:constrLst>
+                  <dgm:constr type="w" for="ch" forName="parentTextBox" refType="w"/>
+                  <dgm:constr type="h" for="ch" forName="parentTextBox" refType="h" fact="0.54"/>
+                  <dgm:constr type="t" for="ch" forName="parentTextBox"/>
+                  <dgm:constr type="w" for="ch" forName="entireBox" refType="w"/>
+                  <dgm:constr type="h" for="ch" forName="entireBox" refType="h"/>
+                  <dgm:constr type="w" for="ch" forName="descendantBox" refType="w"/>
+                  <dgm:constr type="b" for="ch" forName="descendantBox" refType="h" fact="0.98"/>
+                  <dgm:constr type="h" for="ch" forName="descendantBox" refType="h" fact="0.46"/>
+                </dgm:constrLst>
+              </dgm:if>
+              <dgm:else name="Name6">
+                <dgm:constrLst>
+                  <dgm:constr type="w" for="ch" forName="parentTextBox" refType="w"/>
+                  <dgm:constr type="h" for="ch" forName="parentTextBox" refType="h"/>
+                </dgm:constrLst>
+              </dgm:else>
+            </dgm:choose>
+            <dgm:ruleLst/>
+            <dgm:layoutNode name="parentTextBox">
+              <dgm:alg type="tx"/>
+              <dgm:choose name="Name7">
+                <dgm:if name="Name8" axis="ch" ptType="node" func="cnt" op="gte" val="1">
+                  <dgm:shape xmlns:r="http://schemas.openxmlformats.org/officeDocument/2006/relationships" type="rect" r:blip="" zOrderOff="1" hideGeom="1">
+                    <dgm:adjLst/>
+                  </dgm:shape>
+                </dgm:if>
+                <dgm:else name="Name9">
+                  <dgm:shape xmlns:r="http://schemas.openxmlformats.org/officeDocument/2006/relationships" type="rect" r:blip="">
+                    <dgm:adjLst/>
+                  </dgm:shape>
+                </dgm:else>
+              </dgm:choose>
+              <dgm:presOf axis="self"/>
+              <dgm:constrLst/>
+              <dgm:ruleLst>
+                <dgm:rule type="primFontSz" val="5" fact="NaN" max="NaN"/>
+              </dgm:ruleLst>
+            </dgm:layoutNode>
+            <dgm:choose name="Name10">
+              <dgm:if name="Name11" axis="ch" ptType="node" func="cnt" op="gte" val="1">
+                <dgm:layoutNode name="entireBox">
+                  <dgm:alg type="sp"/>
+                  <dgm:shape xmlns:r="http://schemas.openxmlformats.org/officeDocument/2006/relationships" type="rect" r:blip="">
+                    <dgm:adjLst/>
+                  </dgm:shape>
+                  <dgm:presOf axis="self"/>
+                  <dgm:constrLst/>
+                  <dgm:ruleLst/>
+                </dgm:layoutNode>
+                <dgm:layoutNode name="descendantBox" styleLbl="fgAccFollowNode1">
+                  <dgm:choose name="Name12">
+                    <dgm:if name="Name13" func="var" arg="dir" op="equ" val="norm">
+                      <dgm:alg type="lin"/>
+                    </dgm:if>
+                    <dgm:else name="Name14">
+                      <dgm:alg type="lin">
+                        <dgm:param type="linDir" val="fromR"/>
+                      </dgm:alg>
+                    </dgm:else>
+                  </dgm:choose>
+                  <dgm:shape xmlns:r="http://schemas.openxmlformats.org/officeDocument/2006/relationships" r:blip="">
+                    <dgm:adjLst/>
+                  </dgm:shape>
+                  <dgm:presOf/>
+                  <dgm:constrLst>
+                    <dgm:constr type="w" for="ch" forName="childTextBox" refType="w"/>
+                    <dgm:constr type="h" for="ch" forName="childTextBox" refType="h"/>
+                  </dgm:constrLst>
+                  <dgm:ruleLst/>
+                  <dgm:forEach name="Name15" axis="ch" ptType="node">
+                    <dgm:layoutNode name="childTextBox" styleLbl="fgAccFollowNode1">
+                      <dgm:varLst>
+                        <dgm:bulletEnabled val="1"/>
+                      </dgm:varLst>
+                      <dgm:alg type="tx"/>
+                      <dgm:shape xmlns:r="http://schemas.openxmlformats.org/officeDocument/2006/relationships" type="rect" r:blip="">
+                        <dgm:adjLst/>
+                      </dgm:shape>
+                      <dgm:presOf axis="desOrSelf" ptType="node"/>
+                      <dgm:constrLst>
+                        <dgm:constr type="tMarg" refType="primFontSz" fact="0.1"/>
+                        <dgm:constr type="bMarg" refType="primFontSz" fact="0.1"/>
+                      </dgm:constrLst>
+                      <dgm:ruleLst>
+                        <dgm:rule type="primFontSz" val="5" fact="NaN" max="NaN"/>
+                      </dgm:ruleLst>
+                    </dgm:layoutNode>
+                  </dgm:forEach>
+                </dgm:layoutNode>
+              </dgm:if>
+              <dgm:else name="Name16"/>
+            </dgm:choose>
+          </dgm:layoutNode>
+        </dgm:if>
+        <dgm:else name="Name17">
+          <dgm:layoutNode name="arrowAndChildren">
+            <dgm:alg type="composite"/>
+            <dgm:shape xmlns:r="http://schemas.openxmlformats.org/officeDocument/2006/relationships" r:blip="">
+              <dgm:adjLst/>
+            </dgm:shape>
+            <dgm:presOf/>
+            <dgm:choose name="Name18">
+              <dgm:if name="Name19" axis="ch" ptType="node" func="cnt" op="gte" val="1">
+                <dgm:constrLst>
+                  <dgm:constr type="w" for="ch" forName="parentTextArrow" refType="w"/>
+                  <dgm:constr type="t" for="ch" forName="parentTextArrow"/>
+                  <dgm:constr type="h" for="ch" forName="parentTextArrow" refType="h" fact="0.351"/>
+                  <dgm:constr type="w" for="ch" forName="arrow" refType="w"/>
+                  <dgm:constr type="h" for="ch" forName="arrow" refType="h"/>
+                  <dgm:constr type="w" for="ch" forName="descendantArrow" refType="w"/>
+                  <dgm:constr type="b" for="ch" forName="descendantArrow" refType="h" fact="0.65"/>
+                  <dgm:constr type="h" for="ch" forName="descendantArrow" refType="h" fact="0.299"/>
+                </dgm:constrLst>
+              </dgm:if>
+              <dgm:else name="Name20">
+                <dgm:constrLst>
+                  <dgm:constr type="w" for="ch" forName="parentTextArrow" refType="w"/>
+                  <dgm:constr type="h" for="ch" forName="parentTextArrow" refType="h"/>
+                </dgm:constrLst>
+              </dgm:else>
+            </dgm:choose>
+            <dgm:ruleLst/>
+            <dgm:layoutNode name="parentTextArrow">
+              <dgm:alg type="tx"/>
+              <dgm:choose name="Name21">
+                <dgm:if name="Name22" axis="ch" ptType="node" func="cnt" op="gte" val="1">
+                  <dgm:shape xmlns:r="http://schemas.openxmlformats.org/officeDocument/2006/relationships" type="rect" r:blip="" zOrderOff="1" hideGeom="1">
+                    <dgm:adjLst/>
+                  </dgm:shape>
+                </dgm:if>
+                <dgm:else name="Name23">
+                  <dgm:shape xmlns:r="http://schemas.openxmlformats.org/officeDocument/2006/relationships" rot="180" type="upArrowCallout" r:blip="">
+                    <dgm:adjLst/>
+                  </dgm:shape>
+                </dgm:else>
+              </dgm:choose>
+              <dgm:presOf axis="self"/>
+              <dgm:constrLst/>
+              <dgm:ruleLst>
+                <dgm:rule type="primFontSz" val="5" fact="NaN" max="NaN"/>
+              </dgm:ruleLst>
+            </dgm:layoutNode>
+            <dgm:choose name="Name24">
+              <dgm:if name="Name25" axis="ch" ptType="node" func="cnt" op="gte" val="1">
+                <dgm:layoutNode name="arrow">
+                  <dgm:alg type="sp"/>
+                  <dgm:shape xmlns:r="http://schemas.openxmlformats.org/officeDocument/2006/relationships" rot="180" type="upArrowCallout" r:blip="">
+                    <dgm:adjLst/>
+                  </dgm:shape>
+                  <dgm:presOf axis="self"/>
+                  <dgm:constrLst/>
+                  <dgm:ruleLst/>
+                </dgm:layoutNode>
+                <dgm:layoutNode name="descendantArrow">
+                  <dgm:choose name="Name26">
+                    <dgm:if name="Name27" func="var" arg="dir" op="equ" val="norm">
+                      <dgm:alg type="lin"/>
+                    </dgm:if>
+                    <dgm:else name="Name28">
+                      <dgm:alg type="lin">
+                        <dgm:param type="linDir" val="fromR"/>
+                      </dgm:alg>
+                    </dgm:else>
+                  </dgm:choose>
+                  <dgm:shape xmlns:r="http://schemas.openxmlformats.org/officeDocument/2006/relationships" r:blip="">
+                    <dgm:adjLst/>
+                  </dgm:shape>
+                  <dgm:presOf/>
+                  <dgm:constrLst>
+                    <dgm:constr type="w" for="ch" forName="childTextArrow" refType="w"/>
+                    <dgm:constr type="h" for="ch" forName="childTextArrow" refType="h"/>
+                  </dgm:constrLst>
+                  <dgm:ruleLst/>
+                  <dgm:forEach name="Name29" axis="ch" ptType="node">
+                    <dgm:layoutNode name="childTextArrow" styleLbl="fgAccFollowNode1">
+                      <dgm:varLst>
+                        <dgm:bulletEnabled val="1"/>
+                      </dgm:varLst>
+                      <dgm:alg type="tx"/>
+                      <dgm:shape xmlns:r="http://schemas.openxmlformats.org/officeDocument/2006/relationships" type="rect" r:blip="">
+                        <dgm:adjLst/>
+                      </dgm:shape>
+                      <dgm:presOf axis="desOrSelf" ptType="node"/>
+                      <dgm:constrLst>
+                        <dgm:constr type="tMarg" refType="primFontSz" fact="0.1"/>
+                        <dgm:constr type="bMarg" refType="primFontSz" fact="0.1"/>
+                      </dgm:constrLst>
+                      <dgm:ruleLst>
+                        <dgm:rule type="primFontSz" val="5" fact="NaN" max="NaN"/>
+                      </dgm:ruleLst>
+                    </dgm:layoutNode>
+                  </dgm:forEach>
+                </dgm:layoutNode>
+              </dgm:if>
+              <dgm:else name="Name30"/>
+            </dgm:choose>
+          </dgm:layoutNode>
+        </dgm:else>
+      </dgm:choose>
+      <dgm:forEach name="Name31" axis="precedSib" ptType="sibTrans" st="-1" cnt="1">
+        <dgm:layoutNode name="sp">
+          <dgm:alg type="sp"/>
+          <dgm:shape xmlns:r="http://schemas.openxmlformats.org/officeDocument/2006/relationships" r:blip="">
+            <dgm:adjLst/>
+          </dgm:shape>
+          <dgm:presOf axis="self"/>
+          <dgm:constrLst/>
+          <dgm:ruleLst/>
+        </dgm:layoutNode>
+      </dgm:forEach>
+    </dgm:forEach>
+  </dgm:layoutNode>
+</dgm:layoutDef>
+</file>
+
 <file path=ppt/diagrams/quickStyle1.xml><?xml version="1.0" encoding="utf-8"?>
+<dgm:styleDef xmlns:dgm="http://schemas.openxmlformats.org/drawingml/2006/diagram" xmlns:a="http://schemas.openxmlformats.org/drawingml/2006/main" uniqueId="urn:microsoft.com/office/officeart/2005/8/quickstyle/3d1">
+  <dgm:title val=""/>
+  <dgm:desc val=""/>
+  <dgm:catLst>
+    <dgm:cat type="3D" pri="11100"/>
+  </dgm:catLst>
+  <dgm:scene3d>
+    <a:camera prst="orthographicFront"/>
+    <a:lightRig rig="threePt" dir="t"/>
+  </dgm:scene3d>
+  <dgm:styleLbl name="node0">
+    <dgm:scene3d>
+      <a:camera prst="orthographicFront"/>
+      <a:lightRig rig="flat" dir="t"/>
+    </dgm:scene3d>
+    <dgm:sp3d prstMaterial="plastic">
+      <a:bevelT w="120900" h="88900"/>
+      <a:bevelB w="88900" h="31750" prst="angle"/>
+    </dgm:sp3d>
+    <dgm:txPr/>
+    <dgm:style>
+      <a:lnRef idx="0">
+        <a:scrgbClr r="0" g="0" b="0"/>
+      </a:lnRef>
+      <a:fillRef idx="3">
+        <a:scrgbClr r="0" g="0" b="0"/>
+      </a:fillRef>
+      <a:effectRef idx="2">
+        <a:scrgbClr r="0" g="0" b="0"/>
+      </a:effectRef>
+      <a:fontRef idx="minor">
+        <a:schemeClr val="lt1"/>
+      </a:fontRef>
+    </dgm:style>
+  </dgm:styleLbl>
+  <dgm:styleLbl name="lnNode1">
+    <dgm:scene3d>
+      <a:camera prst="orthographicFront"/>
+      <a:lightRig rig="flat" dir="t"/>
+    </dgm:scene3d>
+    <dgm:sp3d prstMaterial="plastic">
+      <a:bevelT w="120900" h="88900"/>
+      <a:bevelB w="88900" h="31750" prst="angle"/>
+    </dgm:sp3d>
+    <dgm:txPr/>
+    <dgm:style>
+      <a:lnRef idx="0">
+        <a:scrgbClr r="0" g="0" b="0"/>
+      </a:lnRef>
+      <a:fillRef idx="3">
+        <a:scrgbClr r="0" g="0" b="0"/>
+      </a:fillRef>
+      <a:effectRef idx="1">
+        <a:scrgbClr r="0" g="0" b="0"/>
+      </a:effectRef>
+      <a:fontRef idx="minor">
+        <a:schemeClr val="lt1"/>
+      </a:fontRef>
+    </dgm:style>
+  </dgm:styleLbl>
+  <dgm:styleLbl name="vennNode1">
+    <dgm:scene3d>
+      <a:camera prst="orthographicFront"/>
+      <a:lightRig rig="flat" dir="t"/>
+    </dgm:scene3d>
+    <dgm:sp3d prstMaterial="plastic">
+      <a:bevelT w="120900" h="88900"/>
+      <a:bevelB w="88900" h="31750" prst="angle"/>
+    </dgm:sp3d>
+    <dgm:txPr/>
+    <dgm:style>
+      <a:lnRef idx="0">
+        <a:scrgbClr r="0" g="0" b="0"/>
+      </a:lnRef>
+      <a:fillRef idx="1">
+        <a:scrgbClr r="0" g="0" b="0"/>
+      </a:fillRef>
+      <a:effectRef idx="1">
+        <a:scrgbClr r="0" g="0" b="0"/>
+      </a:effectRef>
+      <a:fontRef idx="minor">
+        <a:schemeClr val="tx1"/>
+      </a:fontRef>
+    </dgm:style>
+  </dgm:styleLbl>
+  <dgm:styleLbl name="alignNode1">
+    <dgm:scene3d>
+      <a:camera prst="orthographicFront"/>
+      <a:lightRig rig="flat" dir="t"/>
+    </dgm:scene3d>
+    <dgm:sp3d prstMaterial="plastic">
+      <a:bevelT w="120900" h="88900"/>
+      <a:bevelB w="88900" h="31750" prst="angle"/>
+    </dgm:sp3d>
+    <dgm:txPr/>
+    <dgm:style>
+      <a:lnRef idx="1">
+        <a:scrgbClr r="0" g="0" b="0"/>
+      </a:lnRef>
+      <a:fillRef idx="3">
+        <a:scrgbClr r="0" g="0" b="0"/>
+      </a:fillRef>
+      <a:effectRef idx="2">
+        <a:scrgbClr r="0" g="0" b="0"/>
+      </a:effectRef>
+      <a:fontRef idx="minor">
+        <a:schemeClr val="lt1"/>
+      </a:fontRef>
+    </dgm:style>
+  </dgm:styleLbl>
+  <dgm:styleLbl name="node1">
+    <dgm:scene3d>
+      <a:camera prst="orthographicFront"/>
+      <a:lightRig rig="flat" dir="t"/>
+    </dgm:scene3d>
+    <dgm:sp3d prstMaterial="plastic">
+      <a:bevelT w="120900" h="88900"/>
+      <a:bevelB w="88900" h="31750" prst="angle"/>
+    </dgm:sp3d>
+    <dgm:txPr/>
+    <dgm:style>
+      <a:lnRef idx="0">
+        <a:scrgbClr r="0" g="0" b="0"/>
+      </a:lnRef>
+      <a:fillRef idx="3">
+        <a:scrgbClr r="0" g="0" b="0"/>
+      </a:fillRef>
+      <a:effectRef idx="2">
+        <a:scrgbClr r="0" g="0" b="0"/>
+      </a:effectRef>
+      <a:fontRef idx="minor">
+        <a:schemeClr val="lt1"/>
+      </a:fontRef>
+    </dgm:style>
+  </dgm:styleLbl>
+  <dgm:styleLbl name="node2">
+    <dgm:scene3d>
+      <a:camera prst="orthographicFront"/>
+      <a:lightRig rig="flat" dir="t"/>
+    </dgm:scene3d>
+    <dgm:sp3d prstMaterial="plastic">
+      <a:bevelT w="120900" h="88900"/>
+      <a:bevelB w="88900" h="31750" prst="angle"/>
+    </dgm:sp3d>
+    <dgm:txPr/>
+    <dgm:style>
+      <a:lnRef idx="0">
+        <a:scrgbClr r="0" g="0" b="0"/>
+      </a:lnRef>
+      <a:fillRef idx="3">
+        <a:scrgbClr r="0" g="0" b="0"/>
+      </a:fillRef>
+      <a:effectRef idx="1">
+        <a:scrgbClr r="0" g="0" b="0"/>
+      </a:effectRef>
+      <a:fontRef idx="minor">
+        <a:schemeClr val="lt1"/>
+      </a:fontRef>
+    </dgm:style>
+  </dgm:styleLbl>
+  <dgm:styleLbl name="node3">
+    <dgm:scene3d>
+      <a:camera prst="orthographicFront"/>
+      <a:lightRig rig="flat" dir="t"/>
+    </dgm:scene3d>
+    <dgm:sp3d prstMaterial="plastic">
+      <a:bevelT w="120900" h="88900"/>
+      <a:bevelB w="88900" h="31750" prst="angle"/>
+    </dgm:sp3d>
+    <dgm:txPr/>
+    <dgm:style>
+      <a:lnRef idx="0">
+        <a:scrgbClr r="0" g="0" b="0"/>
+      </a:lnRef>
+      <a:fillRef idx="3">
+        <a:scrgbClr r="0" g="0" b="0"/>
+      </a:fillRef>
+      <a:effectRef idx="1">
+        <a:scrgbClr r="0" g="0" b="0"/>
+      </a:effectRef>
+      <a:fontRef idx="minor">
+        <a:schemeClr val="lt1"/>
+      </a:fontRef>
+    </dgm:style>
+  </dgm:styleLbl>
+  <dgm:styleLbl name="node4">
+    <dgm:scene3d>
+      <a:camera prst="orthographicFront"/>
+      <a:lightRig rig="flat" dir="t"/>
+    </dgm:scene3d>
+    <dgm:sp3d prstMaterial="plastic">
+      <a:bevelT w="120900" h="88900"/>
+      <a:bevelB w="88900" h="31750" prst="angle"/>
+    </dgm:sp3d>
+    <dgm:txPr/>
+    <dgm:style>
+      <a:lnRef idx="0">
+        <a:scrgbClr r="0" g="0" b="0"/>
+      </a:lnRef>
+      <a:fillRef idx="3">
+        <a:scrgbClr r="0" g="0" b="0"/>
+      </a:fillRef>
+      <a:effectRef idx="1">
+        <a:scrgbClr r="0" g="0" b="0"/>
+      </a:effectRef>
+      <a:fontRef idx="minor">
+        <a:schemeClr val="lt1"/>
+      </a:fontRef>
+    </dgm:style>
+  </dgm:styleLbl>
+  <dgm:styleLbl name="fgImgPlace1">
+    <dgm:scene3d>
+      <a:camera prst="orthographicFront"/>
+      <a:lightRig rig="flat" dir="t"/>
+    </dgm:scene3d>
+    <dgm:sp3d z="127000" prstMaterial="plastic">
+      <a:bevelT w="88900" h="88900"/>
+      <a:bevelB w="88900" h="31750" prst="angle"/>
+    </dgm:sp3d>
+    <dgm:txPr/>
+    <dgm:style>
+      <a:lnRef idx="0">
+        <a:scrgbClr r="0" g="0" b="0"/>
+      </a:lnRef>
+      <a:fillRef idx="3">
+        <a:scrgbClr r="0" g="0" b="0"/>
+      </a:fillRef>
+      <a:effectRef idx="2">
+        <a:scrgbClr r="0" g="0" b="0"/>
+      </a:effectRef>
+      <a:fontRef idx="minor"/>
+    </dgm:style>
+  </dgm:styleLbl>
+  <dgm:styleLbl name="alignImgPlace1">
+    <dgm:scene3d>
+      <a:camera prst="orthographicFront"/>
+      <a:lightRig rig="flat" dir="t"/>
+    </dgm:scene3d>
+    <dgm:sp3d prstMaterial="plastic">
+      <a:bevelT w="88900" h="88900"/>
+      <a:bevelB w="88900" h="31750" prst="angle"/>
+    </dgm:sp3d>
+    <dgm:txPr/>
+    <dgm:style>
+      <a:lnRef idx="0">
+        <a:scrgbClr r="0" g="0" b="0"/>
+      </a:lnRef>
+      <a:fillRef idx="3">
+        <a:scrgbClr r="0" g="0" b="0"/>
+      </a:fillRef>
+      <a:effectRef idx="2">
+        <a:scrgbClr r="0" g="0" b="0"/>
+      </a:effectRef>
+      <a:fontRef idx="minor"/>
+    </dgm:style>
+  </dgm:styleLbl>
+  <dgm:styleLbl name="bgImgPlace1">
+    <dgm:scene3d>
+      <a:camera prst="orthographicFront"/>
+      <a:lightRig rig="flat" dir="t"/>
+    </dgm:scene3d>
+    <dgm:sp3d z="-190500" prstMaterial="plastic">
+      <a:bevelT w="88900" h="88900"/>
+      <a:bevelB w="88900" h="31750" prst="angle"/>
+    </dgm:sp3d>
+    <dgm:txPr/>
+    <dgm:style>
+      <a:lnRef idx="0">
+        <a:scrgbClr r="0" g="0" b="0"/>
+      </a:lnRef>
+      <a:fillRef idx="3">
+        <a:scrgbClr r="0" g="0" b="0"/>
+      </a:fillRef>
+      <a:effectRef idx="2">
+        <a:scrgbClr r="0" g="0" b="0"/>
+      </a:effectRef>
+      <a:fontRef idx="minor"/>
+    </dgm:style>
+  </dgm:styleLbl>
+  <dgm:styleLbl name="sibTrans2D1">
+    <dgm:scene3d>
+      <a:camera prst="orthographicFront"/>
+      <a:lightRig rig="flat" dir="t"/>
+    </dgm:scene3d>
+    <dgm:sp3d z="-80000" prstMaterial="plastic">
+      <a:bevelT w="50800" h="50800"/>
+      <a:bevelB w="25400" h="25400" prst="angle"/>
+    </dgm:sp3d>
+    <dgm:txPr/>
+    <dgm:style>
+      <a:lnRef idx="0">
+        <a:scrgbClr r="0" g="0" b="0"/>
+      </a:lnRef>
+      <a:fillRef idx="3">
+        <a:scrgbClr r="0" g="0" b="0"/>
+      </a:fillRef>
+      <a:effectRef idx="2">
+        <a:scrgbClr r="0" g="0" b="0"/>
+      </a:effectRef>
+      <a:fontRef idx="minor">
+        <a:schemeClr val="lt1"/>
+      </a:fontRef>
+    </dgm:style>
+  </dgm:styleLbl>
+  <dgm:styleLbl name="fgSibTrans2D1">
+    <dgm:scene3d>
+      <a:camera prst="orthographicFront"/>
+      <a:lightRig rig="flat" dir="t"/>
+    </dgm:scene3d>
+    <dgm:sp3d z="127000" prstMaterial="plastic">
+      <a:bevelT w="50800" h="50800"/>
+      <a:bevelB w="25400" h="25400" prst="angle"/>
+    </dgm:sp3d>
+    <dgm:txPr/>
+    <dgm:style>
+      <a:lnRef idx="0">
+        <a:scrgbClr r="0" g="0" b="0"/>
+      </a:lnRef>
+      <a:fillRef idx="3">
+        <a:scrgbClr r="0" g="0" b="0"/>
+      </a:fillRef>
+      <a:effectRef idx="2">
+        <a:scrgbClr r="0" g="0" b="0"/>
+      </a:effectRef>
+      <a:fontRef idx="minor">
+        <a:schemeClr val="lt1"/>
+      </a:fontRef>
+    </dgm:style>
+  </dgm:styleLbl>
+  <dgm:styleLbl name="bgSibTrans2D1">
+    <dgm:scene3d>
+      <a:camera prst="orthographicFront"/>
+      <a:lightRig rig="flat" dir="t"/>
+    </dgm:scene3d>
+    <dgm:sp3d z="-190500" prstMaterial="plastic">
+      <a:bevelT w="50800" h="50800"/>
+      <a:bevelB w="25400" h="25400" prst="angle"/>
+    </dgm:sp3d>
+    <dgm:txPr/>
+    <dgm:style>
+      <a:lnRef idx="0">
+        <a:scrgbClr r="0" g="0" b="0"/>
+      </a:lnRef>
+      <a:fillRef idx="3">
+        <a:scrgbClr r="0" g="0" b="0"/>
+      </a:fillRef>
+      <a:effectRef idx="2">
+        <a:scrgbClr r="0" g="0" b="0"/>
+      </a:effectRef>
+      <a:fontRef idx="minor">
+        <a:schemeClr val="lt1"/>
+      </a:fontRef>
+    </dgm:style>
+  </dgm:styleLbl>
+  <dgm:styleLbl name="sibTrans1D1">
+    <dgm:scene3d>
+      <a:camera prst="orthographicFront"/>
+      <a:lightRig rig="flat" dir="t"/>
+    </dgm:scene3d>
+    <dgm:sp3d z="-40000" prstMaterial="matte"/>
+    <dgm:txPr/>
+    <dgm:style>
+      <a:lnRef idx="1">
+        <a:scrgbClr r="0" g="0" b="0"/>
+      </a:lnRef>
+      <a:fillRef idx="0">
+        <a:scrgbClr r="0" g="0" b="0"/>
+      </a:fillRef>
+      <a:effectRef idx="0">
+        <a:scrgbClr r="0" g="0" b="0"/>
+      </a:effectRef>
+      <a:fontRef idx="minor"/>
+    </dgm:style>
+  </dgm:styleLbl>
+  <dgm:styleLbl name="callout">
+    <dgm:scene3d>
+      <a:camera prst="orthographicFront"/>
+      <a:lightRig rig="threePt" dir="t"/>
+    </dgm:scene3d>
+    <dgm:sp3d z="127000" prstMaterial="matte"/>
+    <dgm:txPr/>
+    <dgm:style>
+      <a:lnRef idx="2">
+        <a:scrgbClr r="0" g="0" b="0"/>
+      </a:lnRef>
+      <a:fillRef idx="1">
+        <a:scrgbClr r="0" g="0" b="0"/>
+      </a:fillRef>
+      <a:effectRef idx="0">
+        <a:scrgbClr r="0" g="0" b="0"/>
+      </a:effectRef>
+      <a:fontRef idx="minor"/>
+    </dgm:style>
+  </dgm:styleLbl>
+  <dgm:styleLbl name="asst0">
+    <dgm:scene3d>
+      <a:camera prst="orthographicFront"/>
+      <a:lightRig rig="flat" dir="t"/>
+    </dgm:scene3d>
+    <dgm:sp3d prstMaterial="plastic">
+      <a:bevelT w="120900" h="88900"/>
+      <a:bevelB w="88900" h="31750" prst="angle"/>
+    </dgm:sp3d>
+    <dgm:txPr/>
+    <dgm:style>
+      <a:lnRef idx="0">
+        <a:scrgbClr r="0" g="0" b="0"/>
+      </a:lnRef>
+      <a:fillRef idx="3">
+        <a:scrgbClr r="0" g="0" b="0"/>
+      </a:fillRef>
+      <a:effectRef idx="1">
+        <a:scrgbClr r="0" g="0" b="0"/>
+      </a:effectRef>
+      <a:fontRef idx="minor">
+        <a:schemeClr val="lt1"/>
+      </a:fontRef>
+    </dgm:style>
+  </dgm:styleLbl>
+  <dgm:styleLbl name="asst1">
+    <dgm:scene3d>
+      <a:camera prst="orthographicFront"/>
+      <a:lightRig rig="flat" dir="t"/>
+    </dgm:scene3d>
+    <dgm:sp3d prstMaterial="plastic">
+      <a:bevelT w="120900" h="88900"/>
+      <a:bevelB w="88900" h="31750" prst="angle"/>
+    </dgm:sp3d>
+    <dgm:txPr/>
+    <dgm:style>
+      <a:lnRef idx="0">
+        <a:scrgbClr r="0" g="0" b="0"/>
+      </a:lnRef>
+      <a:fillRef idx="3">
+        <a:scrgbClr r="0" g="0" b="0"/>
+      </a:fillRef>
+      <a:effectRef idx="1">
+        <a:scrgbClr r="0" g="0" b="0"/>
+      </a:effectRef>
+      <a:fontRef idx="minor">
+        <a:schemeClr val="lt1"/>
+      </a:fontRef>
+    </dgm:style>
+  </dgm:styleLbl>
+  <dgm:styleLbl name="asst2">
+    <dgm:scene3d>
+      <a:camera prst="orthographicFront"/>
+      <a:lightRig rig="flat" dir="t"/>
+    </dgm:scene3d>
+    <dgm:sp3d prstMaterial="plastic">
+      <a:bevelT w="120900" h="88900"/>
+      <a:bevelB w="88900" h="31750" prst="angle"/>
+    </dgm:sp3d>
+    <dgm:txPr/>
+    <dgm:style>
+      <a:lnRef idx="0">
+        <a:scrgbClr r="0" g="0" b="0"/>
+      </a:lnRef>
+      <a:fillRef idx="3">
+        <a:scrgbClr r="0" g="0" b="0"/>
+      </a:fillRef>
+      <a:effectRef idx="1">
+        <a:scrgbClr r="0" g="0" b="0"/>
+      </a:effectRef>
+      <a:fontRef idx="minor">
+        <a:schemeClr val="lt1"/>
+      </a:fontRef>
+    </dgm:style>
+  </dgm:styleLbl>
+  <dgm:styleLbl name="asst3">
+    <dgm:scene3d>
+      <a:camera prst="orthographicFront"/>
+      <a:lightRig rig="flat" dir="t"/>
+    </dgm:scene3d>
+    <dgm:sp3d prstMaterial="plastic">
+      <a:bevelT w="120900" h="88900"/>
+      <a:bevelB w="88900" h="31750" prst="angle"/>
+    </dgm:sp3d>
+    <dgm:txPr/>
+    <dgm:style>
+      <a:lnRef idx="0">
+        <a:scrgbClr r="0" g="0" b="0"/>
+      </a:lnRef>
+      <a:fillRef idx="3">
+        <a:scrgbClr r="0" g="0" b="0"/>
+      </a:fillRef>
+      <a:effectRef idx="1">
+        <a:scrgbClr r="0" g="0" b="0"/>
+      </a:effectRef>
+      <a:fontRef idx="minor">
+        <a:schemeClr val="lt1"/>
+      </a:fontRef>
+    </dgm:style>
+  </dgm:styleLbl>
+  <dgm:styleLbl name="parChTrans2D1">
+    <dgm:scene3d>
+      <a:camera prst="orthographicFront"/>
+      <a:lightRig rig="flat" dir="t"/>
+    </dgm:scene3d>
+    <dgm:sp3d z="-100000" prstMaterial="plastic">
+      <a:bevelT w="120900" h="88900"/>
+      <a:bevelB w="88900" h="31750" prst="angle"/>
+    </dgm:sp3d>
+    <dgm:txPr/>
+    <dgm:style>
+      <a:lnRef idx="0">
+        <a:scrgbClr r="0" g="0" b="0"/>
+      </a:lnRef>
+      <a:fillRef idx="3">
+        <a:scrgbClr r="0" g="0" b="0"/>
+      </a:fillRef>
+      <a:effectRef idx="1">
+        <a:scrgbClr r="0" g="0" b="0"/>
+      </a:effectRef>
+      <a:fontRef idx="minor">
+        <a:schemeClr val="lt1"/>
+      </a:fontRef>
+    </dgm:style>
+  </dgm:styleLbl>
+  <dgm:styleLbl name="parChTrans2D2">
+    <dgm:scene3d>
+      <a:camera prst="orthographicFront"/>
+      <a:lightRig rig="flat" dir="t"/>
+    </dgm:scene3d>
+    <dgm:sp3d z="-60000" prstMaterial="plastic">
+      <a:bevelT w="120900" h="88900"/>
+      <a:bevelB w="88900" h="31750" prst="angle"/>
+    </dgm:sp3d>
+    <dgm:txPr/>
+    <dgm:style>
+      <a:lnRef idx="0">
+        <a:scrgbClr r="0" g="0" b="0"/>
+      </a:lnRef>
+      <a:fillRef idx="3">
+        <a:scrgbClr r="0" g="0" b="0"/>
+      </a:fillRef>
+      <a:effectRef idx="1">
+        <a:scrgbClr r="0" g="0" b="0"/>
+      </a:effectRef>
+      <a:fontRef idx="minor">
+        <a:schemeClr val="lt1"/>
+      </a:fontRef>
+    </dgm:style>
+  </dgm:styleLbl>
+  <dgm:styleLbl name="parChTrans2D3">
+    <dgm:scene3d>
+      <a:camera prst="orthographicFront"/>
+      <a:lightRig rig="flat" dir="t"/>
+    </dgm:scene3d>
+    <dgm:sp3d z="-60000" prstMaterial="plastic">
+      <a:bevelT w="120900" h="88900"/>
+      <a:bevelB w="88900" h="31750" prst="angle"/>
+    </dgm:sp3d>
+    <dgm:txPr/>
+    <dgm:style>
+      <a:lnRef idx="0">
+        <a:scrgbClr r="0" g="0" b="0"/>
+      </a:lnRef>
+      <a:fillRef idx="3">
+        <a:scrgbClr r="0" g="0" b="0"/>
+      </a:fillRef>
+      <a:effectRef idx="1">
+        <a:scrgbClr r="0" g="0" b="0"/>
+      </a:effectRef>
+      <a:fontRef idx="minor">
+        <a:schemeClr val="lt1"/>
+      </a:fontRef>
+    </dgm:style>
+  </dgm:styleLbl>
+  <dgm:styleLbl name="parChTrans2D4">
+    <dgm:scene3d>
+      <a:camera prst="orthographicFront"/>
+      <a:lightRig rig="flat" dir="t"/>
+    </dgm:scene3d>
+    <dgm:sp3d z="-60000" prstMaterial="plastic">
+      <a:bevelT w="120900" h="88900"/>
+      <a:bevelB w="88900" h="31750" prst="angle"/>
+    </dgm:sp3d>
+    <dgm:txPr/>
+    <dgm:style>
+      <a:lnRef idx="0">
+        <a:scrgbClr r="0" g="0" b="0"/>
+      </a:lnRef>
+      <a:fillRef idx="3">
+        <a:scrgbClr r="0" g="0" b="0"/>
+      </a:fillRef>
+      <a:effectRef idx="1">
+        <a:scrgbClr r="0" g="0" b="0"/>
+      </a:effectRef>
+      <a:fontRef idx="minor">
+        <a:schemeClr val="lt1"/>
+      </a:fontRef>
+    </dgm:style>
+  </dgm:styleLbl>
+  <dgm:styleLbl name="parChTrans1D1">
+    <dgm:scene3d>
+      <a:camera prst="orthographicFront"/>
+      <a:lightRig rig="flat" dir="t"/>
+    </dgm:scene3d>
+    <dgm:sp3d prstMaterial="matte"/>
+    <dgm:txPr/>
+    <dgm:style>
+      <a:lnRef idx="2">
+        <a:scrgbClr r="0" g="0" b="0"/>
+      </a:lnRef>
+      <a:fillRef idx="0">
+        <a:scrgbClr r="0" g="0" b="0"/>
+      </a:fillRef>
+      <a:effectRef idx="0">
+        <a:scrgbClr r="0" g="0" b="0"/>
+      </a:effectRef>
+      <a:fontRef idx="minor"/>
+    </dgm:style>
+  </dgm:styleLbl>
+  <dgm:styleLbl name="parChTrans1D2">
+    <dgm:scene3d>
+      <a:camera prst="orthographicFront"/>
+      <a:lightRig rig="flat" dir="t"/>
+    </dgm:scene3d>
+    <dgm:sp3d prstMaterial="matte"/>
+    <dgm:txPr/>
+    <dgm:style>
+      <a:lnRef idx="2">
+        <a:scrgbClr r="0" g="0" b="0"/>
+      </a:lnRef>
+      <a:fillRef idx="0">
+        <a:scrgbClr r="0" g="0" b="0"/>
+      </a:fillRef>
+      <a:effectRef idx="0">
+        <a:scrgbClr r="0" g="0" b="0"/>
+      </a:effectRef>
+      <a:fontRef idx="minor"/>
+    </dgm:style>
+  </dgm:styleLbl>
+  <dgm:styleLbl name="parChTrans1D3">
+    <dgm:scene3d>
+      <a:camera prst="orthographicFront"/>
+      <a:lightRig rig="flat" dir="t"/>
+    </dgm:scene3d>
+    <dgm:sp3d prstMaterial="matte"/>
+    <dgm:txPr/>
+    <dgm:style>
+      <a:lnRef idx="2">
+        <a:scrgbClr r="0" g="0" b="0"/>
+      </a:lnRef>
+      <a:fillRef idx="0">
+        <a:scrgbClr r="0" g="0" b="0"/>
+      </a:fillRef>
+      <a:effectRef idx="0">
+        <a:scrgbClr r="0" g="0" b="0"/>
+      </a:effectRef>
+      <a:fontRef idx="minor"/>
+    </dgm:style>
+  </dgm:styleLbl>
+  <dgm:styleLbl name="parChTrans1D4">
+    <dgm:scene3d>
+      <a:camera prst="orthographicFront"/>
+      <a:lightRig rig="flat" dir="t"/>
+    </dgm:scene3d>
+    <dgm:sp3d prstMaterial="matte"/>
+    <dgm:txPr/>
+    <dgm:style>
+      <a:lnRef idx="2">
+        <a:scrgbClr r="0" g="0" b="0"/>
+      </a:lnRef>
+      <a:fillRef idx="0">
+        <a:scrgbClr r="0" g="0" b="0"/>
+      </a:fillRef>
+      <a:effectRef idx="0">
+        <a:scrgbClr r="0" g="0" b="0"/>
+      </a:effectRef>
+      <a:fontRef idx="minor"/>
+    </dgm:style>
+  </dgm:styleLbl>
+  <dgm:styleLbl name="fgAcc1">
+    <dgm:scene3d>
+      <a:camera prst="orthographicFront"/>
+      <a:lightRig rig="flat" dir="t"/>
+    </dgm:scene3d>
+    <dgm:sp3d z="190500" extrusionH="12700" prstMaterial="plastic">
+      <a:bevelT w="50800" h="50800"/>
+    </dgm:sp3d>
+    <dgm:txPr/>
+    <dgm:style>
+      <a:lnRef idx="1">
+        <a:scrgbClr r="0" g="0" b="0"/>
+      </a:lnRef>
+      <a:fillRef idx="1">
+        <a:scrgbClr r="0" g="0" b="0"/>
+      </a:fillRef>
+      <a:effectRef idx="2">
+        <a:scrgbClr r="0" g="0" b="0"/>
+      </a:effectRef>
+      <a:fontRef idx="minor"/>
+    </dgm:style>
+  </dgm:styleLbl>
+  <dgm:styleLbl name="conFgAcc1">
+    <dgm:scene3d>
+      <a:camera prst="orthographicFront"/>
+      <a:lightRig rig="flat" dir="t"/>
+    </dgm:scene3d>
+    <dgm:sp3d z="190500" extrusionH="12700" prstMaterial="plastic">
+      <a:bevelT w="50800" h="50800"/>
+    </dgm:sp3d>
+    <dgm:txPr/>
+    <dgm:style>
+      <a:lnRef idx="1">
+        <a:scrgbClr r="0" g="0" b="0"/>
+      </a:lnRef>
+      <a:fillRef idx="1">
+        <a:scrgbClr r="0" g="0" b="0"/>
+      </a:fillRef>
+      <a:effectRef idx="2">
+        <a:scrgbClr r="0" g="0" b="0"/>
+      </a:effectRef>
+      <a:fontRef idx="minor"/>
+    </dgm:style>
+  </dgm:styleLbl>
+  <dgm:styleLbl name="alignAcc1">
+    <dgm:scene3d>
+      <a:camera prst="orthographicFront"/>
+      <a:lightRig rig="flat" dir="t"/>
+    </dgm:scene3d>
+    <dgm:sp3d extrusionH="12700" prstMaterial="plastic">
+      <a:bevelT w="50800" h="50800"/>
+    </dgm:sp3d>
+    <dgm:txPr/>
+    <dgm:style>
+      <a:lnRef idx="1">
+        <a:scrgbClr r="0" g="0" b="0"/>
+      </a:lnRef>
+      <a:fillRef idx="1">
+        <a:scrgbClr r="0" g="0" b="0"/>
+      </a:fillRef>
+      <a:effectRef idx="2">
+        <a:scrgbClr r="0" g="0" b="0"/>
+      </a:effectRef>
+      <a:fontRef idx="minor"/>
+    </dgm:style>
+  </dgm:styleLbl>
+  <dgm:styleLbl name="trAlignAcc1">
+    <dgm:scene3d>
+      <a:camera prst="orthographicFront"/>
+      <a:lightRig rig="flat" dir="t"/>
+    </dgm:scene3d>
+    <dgm:sp3d extrusionH="12700" prstMaterial="plastic">
+      <a:bevelT w="50800" h="50800"/>
+    </dgm:sp3d>
+    <dgm:txPr/>
+    <dgm:style>
+      <a:lnRef idx="1">
+        <a:scrgbClr r="0" g="0" b="0"/>
+      </a:lnRef>
+      <a:fillRef idx="1">
+        <a:scrgbClr r="0" g="0" b="0"/>
+      </a:fillRef>
+      <a:effectRef idx="2">
+        <a:scrgbClr r="0" g="0" b="0"/>
+      </a:effectRef>
+      <a:fontRef idx="minor"/>
+    </dgm:style>
+  </dgm:styleLbl>
+  <dgm:styleLbl name="bgAcc1">
+    <dgm:scene3d>
+      <a:camera prst="orthographicFront"/>
+      <a:lightRig rig="flat" dir="t"/>
+    </dgm:scene3d>
+    <dgm:sp3d z="-190500" extrusionH="12700" prstMaterial="plastic">
+      <a:bevelT w="50800" h="50800"/>
+    </dgm:sp3d>
+    <dgm:txPr/>
+    <dgm:style>
+      <a:lnRef idx="1">
+        <a:scrgbClr r="0" g="0" b="0"/>
+      </a:lnRef>
+      <a:fillRef idx="1">
+        <a:scrgbClr r="0" g="0" b="0"/>
+      </a:fillRef>
+      <a:effectRef idx="2">
+        <a:scrgbClr r="0" g="0" b="0"/>
+      </a:effectRef>
+      <a:fontRef idx="minor"/>
+    </dgm:style>
+  </dgm:styleLbl>
+  <dgm:styleLbl name="solidFgAcc1">
+    <dgm:scene3d>
+      <a:camera prst="orthographicFront"/>
+      <a:lightRig rig="flat" dir="t"/>
+    </dgm:scene3d>
+    <dgm:sp3d z="190500" extrusionH="12700" prstMaterial="plastic">
+      <a:bevelT w="50800" h="50800"/>
+    </dgm:sp3d>
+    <dgm:txPr/>
+    <dgm:style>
+      <a:lnRef idx="1">
+        <a:scrgbClr r="0" g="0" b="0"/>
+      </a:lnRef>
+      <a:fillRef idx="1">
+        <a:scrgbClr r="0" g="0" b="0"/>
+      </a:fillRef>
+      <a:effectRef idx="2">
+        <a:scrgbClr r="0" g="0" b="0"/>
+      </a:effectRef>
+      <a:fontRef idx="minor"/>
+    </dgm:style>
+  </dgm:styleLbl>
+  <dgm:styleLbl name="solidAlignAcc1">
+    <dgm:scene3d>
+      <a:camera prst="orthographicFront"/>
+      <a:lightRig rig="flat" dir="t"/>
+    </dgm:scene3d>
+    <dgm:sp3d extrusionH="12700" prstMaterial="plastic">
+      <a:bevelT w="50800" h="50800"/>
+    </dgm:sp3d>
+    <dgm:txPr/>
+    <dgm:style>
+      <a:lnRef idx="1">
+        <a:scrgbClr r="0" g="0" b="0"/>
+      </a:lnRef>
+      <a:fillRef idx="1">
+        <a:scrgbClr r="0" g="0" b="0"/>
+      </a:fillRef>
+      <a:effectRef idx="2">
+        <a:scrgbClr r="0" g="0" b="0"/>
+      </a:effectRef>
+      <a:fontRef idx="minor"/>
+    </dgm:style>
+  </dgm:styleLbl>
+  <dgm:styleLbl name="solidBgAcc1">
+    <dgm:scene3d>
+      <a:camera prst="orthographicFront"/>
+      <a:lightRig rig="flat" dir="t"/>
+    </dgm:scene3d>
+    <dgm:sp3d z="-190500" extrusionH="12700" prstMaterial="plastic">
+      <a:bevelT w="50800" h="50800"/>
+    </dgm:sp3d>
+    <dgm:txPr/>
+    <dgm:style>
+      <a:lnRef idx="1">
+        <a:scrgbClr r="0" g="0" b="0"/>
+      </a:lnRef>
+      <a:fillRef idx="1">
+        <a:scrgbClr r="0" g="0" b="0"/>
+      </a:fillRef>
+      <a:effectRef idx="2">
+        <a:scrgbClr r="0" g="0" b="0"/>
+      </a:effectRef>
+      <a:fontRef idx="minor"/>
+    </dgm:style>
+  </dgm:styleLbl>
+  <dgm:styleLbl name="fgAccFollowNode1">
+    <dgm:scene3d>
+      <a:camera prst="orthographicFront"/>
+      <a:lightRig rig="flat" dir="t"/>
+    </dgm:scene3d>
+    <dgm:sp3d z="190500" extrusionH="12700" prstMaterial="plastic">
+      <a:bevelT w="50800" h="50800"/>
+    </dgm:sp3d>
+    <dgm:txPr/>
+    <dgm:style>
+      <a:lnRef idx="1">
+        <a:scrgbClr r="0" g="0" b="0"/>
+      </a:lnRef>
+      <a:fillRef idx="1">
+        <a:scrgbClr r="0" g="0" b="0"/>
+      </a:fillRef>
+      <a:effectRef idx="2">
+        <a:scrgbClr r="0" g="0" b="0"/>
+      </a:effectRef>
+      <a:fontRef idx="minor"/>
+    </dgm:style>
+  </dgm:styleLbl>
+  <dgm:styleLbl name="alignAccFollowNode1">
+    <dgm:scene3d>
+      <a:camera prst="orthographicFront"/>
+      <a:lightRig rig="flat" dir="t"/>
+    </dgm:scene3d>
+    <dgm:sp3d extrusionH="12700" prstMaterial="plastic">
+      <a:bevelT w="50800" h="50800"/>
+    </dgm:sp3d>
+    <dgm:txPr/>
+    <dgm:style>
+      <a:lnRef idx="1">
+        <a:scrgbClr r="0" g="0" b="0"/>
+      </a:lnRef>
+      <a:fillRef idx="1">
+        <a:scrgbClr r="0" g="0" b="0"/>
+      </a:fillRef>
+      <a:effectRef idx="2">
+        <a:scrgbClr r="0" g="0" b="0"/>
+      </a:effectRef>
+      <a:fontRef idx="minor"/>
+    </dgm:style>
+  </dgm:styleLbl>
+  <dgm:styleLbl name="bgAccFollowNode1">
+    <dgm:scene3d>
+      <a:camera prst="orthographicFront"/>
+      <a:lightRig rig="flat" dir="t"/>
+    </dgm:scene3d>
+    <dgm:sp3d z="-190500" extrusionH="12700" prstMaterial="plastic">
+      <a:bevelT w="50800" h="50800"/>
+    </dgm:sp3d>
+    <dgm:txPr/>
+    <dgm:style>
+      <a:lnRef idx="1">
+        <a:scrgbClr r="0" g="0" b="0"/>
+      </a:lnRef>
+      <a:fillRef idx="1">
+        <a:scrgbClr r="0" g="0" b="0"/>
+      </a:fillRef>
+      <a:effectRef idx="2">
+        <a:scrgbClr r="0" g="0" b="0"/>
+      </a:effectRef>
+      <a:fontRef idx="minor"/>
+    </dgm:style>
+  </dgm:styleLbl>
+  <dgm:styleLbl name="fgAcc0">
+    <dgm:scene3d>
+      <a:camera prst="orthographicFront"/>
+      <a:lightRig rig="flat" dir="t"/>
+    </dgm:scene3d>
+    <dgm:sp3d z="190500" extrusionH="12700" prstMaterial="plastic">
+      <a:bevelT w="50800" h="50800"/>
+    </dgm:sp3d>
+    <dgm:txPr/>
+    <dgm:style>
+      <a:lnRef idx="1">
+        <a:scrgbClr r="0" g="0" b="0"/>
+      </a:lnRef>
+      <a:fillRef idx="1">
+        <a:scrgbClr r="0" g="0" b="0"/>
+      </a:fillRef>
+      <a:effectRef idx="2">
+        <a:scrgbClr r="0" g="0" b="0"/>
+      </a:effectRef>
+      <a:fontRef idx="minor"/>
+    </dgm:style>
+  </dgm:styleLbl>
+  <dgm:styleLbl name="fgAcc2">
+    <dgm:scene3d>
+      <a:camera prst="orthographicFront"/>
+      <a:lightRig rig="flat" dir="t"/>
+    </dgm:scene3d>
+    <dgm:sp3d z="190500" extrusionH="12700" prstMaterial="plastic">
+      <a:bevelT w="50800" h="50800"/>
+    </dgm:sp3d>
+    <dgm:txPr/>
+    <dgm:style>
+      <a:lnRef idx="1">
+        <a:scrgbClr r="0" g="0" b="0"/>
+      </a:lnRef>
+      <a:fillRef idx="1">
+        <a:scrgbClr r="0" g="0" b="0"/>
+      </a:fillRef>
+      <a:effectRef idx="2">
+        <a:scrgbClr r="0" g="0" b="0"/>
+      </a:effectRef>
+      <a:fontRef idx="minor"/>
+    </dgm:style>
+  </dgm:styleLbl>
+  <dgm:styleLbl name="fgAcc3">
+    <dgm:scene3d>
+      <a:camera prst="orthographicFront"/>
+      <a:lightRig rig="flat" dir="t"/>
+    </dgm:scene3d>
+    <dgm:sp3d z="190500" extrusionH="12700" prstMaterial="plastic">
+      <a:bevelT w="50800" h="50800"/>
+    </dgm:sp3d>
+    <dgm:txPr/>
+    <dgm:style>
+      <a:lnRef idx="1">
+        <a:scrgbClr r="0" g="0" b="0"/>
+      </a:lnRef>
+      <a:fillRef idx="1">
+        <a:scrgbClr r="0" g="0" b="0"/>
+      </a:fillRef>
+      <a:effectRef idx="2">
+        <a:scrgbClr r="0" g="0" b="0"/>
+      </a:effectRef>
+      <a:fontRef idx="minor"/>
+    </dgm:style>
+  </dgm:styleLbl>
+  <dgm:styleLbl name="fgAcc4">
+    <dgm:scene3d>
+      <a:camera prst="orthographicFront"/>
+      <a:lightRig rig="flat" dir="t"/>
+    </dgm:scene3d>
+    <dgm:sp3d z="190500" extrusionH="12700" prstMaterial="plastic">
+      <a:bevelT w="50800" h="50800"/>
+    </dgm:sp3d>
+    <dgm:txPr/>
+    <dgm:style>
+      <a:lnRef idx="1">
+        <a:scrgbClr r="0" g="0" b="0"/>
+      </a:lnRef>
+      <a:fillRef idx="1">
+        <a:scrgbClr r="0" g="0" b="0"/>
+      </a:fillRef>
+      <a:effectRef idx="2">
+        <a:scrgbClr r="0" g="0" b="0"/>
+      </a:effectRef>
+      <a:fontRef idx="minor"/>
+    </dgm:style>
+  </dgm:styleLbl>
+  <dgm:styleLbl name="bgShp">
+    <dgm:scene3d>
+      <a:camera prst="orthographicFront"/>
+      <a:lightRig rig="flat" dir="t"/>
+    </dgm:scene3d>
+    <dgm:sp3d z="-190500" extrusionH="12700" prstMaterial="plastic">
+      <a:bevelT w="50800" h="50800"/>
+    </dgm:sp3d>
+    <dgm:txPr/>
+    <dgm:style>
+      <a:lnRef idx="0">
+        <a:scrgbClr r="0" g="0" b="0"/>
+      </a:lnRef>
+      <a:fillRef idx="3">
+        <a:scrgbClr r="0" g="0" b="0"/>
+      </a:fillRef>
+      <a:effectRef idx="0">
+        <a:scrgbClr r="0" g="0" b="0"/>
+      </a:effectRef>
+      <a:fontRef idx="minor"/>
+    </dgm:style>
+  </dgm:styleLbl>
+  <dgm:styleLbl name="dkBgShp">
+    <dgm:scene3d>
+      <a:camera prst="orthographicFront"/>
+      <a:lightRig rig="flat" dir="t"/>
+    </dgm:scene3d>
+    <dgm:sp3d z="-190500" extrusionH="12700" prstMaterial="plastic">
+      <a:bevelT w="50800" h="50800"/>
+    </dgm:sp3d>
+    <dgm:txPr/>
+    <dgm:style>
+      <a:lnRef idx="0">
+        <a:scrgbClr r="0" g="0" b="0"/>
+      </a:lnRef>
+      <a:fillRef idx="2">
+        <a:scrgbClr r="0" g="0" b="0"/>
+      </a:fillRef>
+      <a:effectRef idx="0">
+        <a:scrgbClr r="0" g="0" b="0"/>
+      </a:effectRef>
+      <a:fontRef idx="minor"/>
+    </dgm:style>
+  </dgm:styleLbl>
+  <dgm:styleLbl name="trBgShp">
+    <dgm:scene3d>
+      <a:camera prst="orthographicFront"/>
+      <a:lightRig rig="flat" dir="t"/>
+    </dgm:scene3d>
+    <dgm:sp3d z="-190500" extrusionH="12700" prstMaterial="matte"/>
+    <dgm:txPr/>
+    <dgm:style>
+      <a:lnRef idx="0">
+        <a:scrgbClr r="0" g="0" b="0"/>
+      </a:lnRef>
+      <a:fillRef idx="1">
+        <a:scrgbClr r="0" g="0" b="0"/>
+      </a:fillRef>
+      <a:effectRef idx="0">
+        <a:scrgbClr r="0" g="0" b="0"/>
+      </a:effectRef>
+      <a:fontRef idx="minor"/>
+    </dgm:style>
+  </dgm:styleLbl>
+  <dgm:styleLbl name="fgShp">
+    <dgm:scene3d>
+      <a:camera prst="orthographicFront"/>
+      <a:lightRig rig="flat" dir="t"/>
+    </dgm:scene3d>
+    <dgm:sp3d z="190500" prstMaterial="plastic">
+      <a:bevelT w="120900" h="88900"/>
+      <a:bevelB w="88900" h="31750" prst="angle"/>
+    </dgm:sp3d>
+    <dgm:txPr/>
+    <dgm:style>
+      <a:lnRef idx="0">
+        <a:scrgbClr r="0" g="0" b="0"/>
+      </a:lnRef>
+      <a:fillRef idx="1">
+        <a:scrgbClr r="0" g="0" b="0"/>
+      </a:fillRef>
+      <a:effectRef idx="3">
+        <a:scrgbClr r="0" g="0" b="0"/>
+      </a:effectRef>
+      <a:fontRef idx="minor">
+        <a:schemeClr val="lt1"/>
+      </a:fontRef>
+    </dgm:style>
+  </dgm:styleLbl>
+  <dgm:styleLbl name="revTx">
+    <dgm:scene3d>
+      <a:camera prst="orthographicFront"/>
+      <a:lightRig rig="threePt" dir="t"/>
+    </dgm:scene3d>
+    <dgm:sp3d/>
+    <dgm:txPr/>
+    <dgm:style>
+      <a:lnRef idx="0">
+        <a:scrgbClr r="0" g="0" b="0"/>
+      </a:lnRef>
+      <a:fillRef idx="0">
+        <a:scrgbClr r="0" g="0" b="0"/>
+      </a:fillRef>
+      <a:effectRef idx="0">
+        <a:scrgbClr r="0" g="0" b="0"/>
+      </a:effectRef>
+      <a:fontRef idx="minor"/>
+    </dgm:style>
+  </dgm:styleLbl>
+</dgm:styleDef>
+</file>
+
+<file path=ppt/diagrams/quickStyle2.xml><?xml version="1.0" encoding="utf-8"?>
 <dgm:styleDef xmlns:dgm="http://schemas.openxmlformats.org/drawingml/2006/diagram" xmlns:a="http://schemas.openxmlformats.org/drawingml/2006/main" uniqueId="urn:microsoft.com/office/officeart/2005/8/quickstyle/3d1">
   <dgm:title val=""/>
   <dgm:desc val=""/>
@@ -5023,7 +9042,7 @@
           <a:p>
             <a:fld id="{79C0705B-4870-4470-A32F-307AEE1697AB}" type="datetimeFigureOut">
               <a:rPr lang="en-IE" smtClean="0"/>
-              <a:t>05/09/2025</a:t>
+              <a:t>18/09/2025</a:t>
             </a:fld>
             <a:endParaRPr lang="en-IE"/>
           </a:p>
@@ -5193,7 +9212,7 @@
           <a:p>
             <a:fld id="{79C0705B-4870-4470-A32F-307AEE1697AB}" type="datetimeFigureOut">
               <a:rPr lang="en-IE" smtClean="0"/>
-              <a:t>05/09/2025</a:t>
+              <a:t>18/09/2025</a:t>
             </a:fld>
             <a:endParaRPr lang="en-IE"/>
           </a:p>
@@ -5373,7 +9392,7 @@
           <a:p>
             <a:fld id="{79C0705B-4870-4470-A32F-307AEE1697AB}" type="datetimeFigureOut">
               <a:rPr lang="en-IE" smtClean="0"/>
-              <a:t>05/09/2025</a:t>
+              <a:t>18/09/2025</a:t>
             </a:fld>
             <a:endParaRPr lang="en-IE"/>
           </a:p>
@@ -5543,7 +9562,7 @@
           <a:p>
             <a:fld id="{79C0705B-4870-4470-A32F-307AEE1697AB}" type="datetimeFigureOut">
               <a:rPr lang="en-IE" smtClean="0"/>
-              <a:t>05/09/2025</a:t>
+              <a:t>18/09/2025</a:t>
             </a:fld>
             <a:endParaRPr lang="en-IE"/>
           </a:p>
@@ -5789,7 +9808,7 @@
           <a:p>
             <a:fld id="{79C0705B-4870-4470-A32F-307AEE1697AB}" type="datetimeFigureOut">
               <a:rPr lang="en-IE" smtClean="0"/>
-              <a:t>05/09/2025</a:t>
+              <a:t>18/09/2025</a:t>
             </a:fld>
             <a:endParaRPr lang="en-IE"/>
           </a:p>
@@ -6021,7 +10040,7 @@
           <a:p>
             <a:fld id="{79C0705B-4870-4470-A32F-307AEE1697AB}" type="datetimeFigureOut">
               <a:rPr lang="en-IE" smtClean="0"/>
-              <a:t>05/09/2025</a:t>
+              <a:t>18/09/2025</a:t>
             </a:fld>
             <a:endParaRPr lang="en-IE"/>
           </a:p>
@@ -6388,7 +10407,7 @@
           <a:p>
             <a:fld id="{79C0705B-4870-4470-A32F-307AEE1697AB}" type="datetimeFigureOut">
               <a:rPr lang="en-IE" smtClean="0"/>
-              <a:t>05/09/2025</a:t>
+              <a:t>18/09/2025</a:t>
             </a:fld>
             <a:endParaRPr lang="en-IE"/>
           </a:p>
@@ -6506,7 +10525,7 @@
           <a:p>
             <a:fld id="{79C0705B-4870-4470-A32F-307AEE1697AB}" type="datetimeFigureOut">
               <a:rPr lang="en-IE" smtClean="0"/>
-              <a:t>05/09/2025</a:t>
+              <a:t>18/09/2025</a:t>
             </a:fld>
             <a:endParaRPr lang="en-IE"/>
           </a:p>
@@ -6601,7 +10620,7 @@
           <a:p>
             <a:fld id="{79C0705B-4870-4470-A32F-307AEE1697AB}" type="datetimeFigureOut">
               <a:rPr lang="en-IE" smtClean="0"/>
-              <a:t>05/09/2025</a:t>
+              <a:t>18/09/2025</a:t>
             </a:fld>
             <a:endParaRPr lang="en-IE"/>
           </a:p>
@@ -6878,7 +10897,7 @@
           <a:p>
             <a:fld id="{79C0705B-4870-4470-A32F-307AEE1697AB}" type="datetimeFigureOut">
               <a:rPr lang="en-IE" smtClean="0"/>
-              <a:t>05/09/2025</a:t>
+              <a:t>18/09/2025</a:t>
             </a:fld>
             <a:endParaRPr lang="en-IE"/>
           </a:p>
@@ -7135,7 +11154,7 @@
           <a:p>
             <a:fld id="{79C0705B-4870-4470-A32F-307AEE1697AB}" type="datetimeFigureOut">
               <a:rPr lang="en-IE" smtClean="0"/>
-              <a:t>05/09/2025</a:t>
+              <a:t>18/09/2025</a:t>
             </a:fld>
             <a:endParaRPr lang="en-IE"/>
           </a:p>
@@ -7348,7 +11367,7 @@
           <a:p>
             <a:fld id="{79C0705B-4870-4470-A32F-307AEE1697AB}" type="datetimeFigureOut">
               <a:rPr lang="en-IE" smtClean="0"/>
-              <a:t>05/09/2025</a:t>
+              <a:t>18/09/2025</a:t>
             </a:fld>
             <a:endParaRPr lang="en-IE"/>
           </a:p>
@@ -7813,7 +11832,9 @@
             <a:srgbClr val="800020"/>
           </a:solidFill>
           <a:ln w="38100">
-            <a:noFill/>
+            <a:solidFill>
+              <a:schemeClr val="tx1"/>
+            </a:solidFill>
           </a:ln>
           <a:effectLst>
             <a:outerShdw blurRad="190500" dist="228600" dir="2700000" algn="ctr">
@@ -7917,7 +11938,9 @@
             <a:srgbClr val="3B3B98"/>
           </a:solidFill>
           <a:ln w="38100">
-            <a:noFill/>
+            <a:solidFill>
+              <a:schemeClr val="tx1"/>
+            </a:solidFill>
           </a:ln>
           <a:effectLst>
             <a:outerShdw blurRad="190500" dist="228600" dir="2700000" algn="ctr">
@@ -8037,7 +12060,9 @@
             <a:srgbClr val="2A2A72"/>
           </a:solidFill>
           <a:ln w="38100">
-            <a:noFill/>
+            <a:solidFill>
+              <a:schemeClr val="tx1"/>
+            </a:solidFill>
           </a:ln>
           <a:effectLst>
             <a:outerShdw blurRad="190500" dist="228600" dir="2700000" algn="ctr">
@@ -8965,7 +12990,9 @@
             <a:srgbClr val="B56576"/>
           </a:solidFill>
           <a:ln w="38100">
-            <a:noFill/>
+            <a:solidFill>
+              <a:schemeClr val="tx1"/>
+            </a:solidFill>
           </a:ln>
           <a:effectLst>
             <a:outerShdw blurRad="44450" dist="27940" dir="5400000" algn="ctr">
@@ -9045,7 +13072,9 @@
             <a:srgbClr val="B56576"/>
           </a:solidFill>
           <a:ln w="38100">
-            <a:noFill/>
+            <a:solidFill>
+              <a:schemeClr val="tx1"/>
+            </a:solidFill>
           </a:ln>
           <a:effectLst>
             <a:outerShdw blurRad="44450" dist="27940" dir="5400000" algn="ctr">
@@ -9125,7 +13154,9 @@
             <a:srgbClr val="4A4E69"/>
           </a:solidFill>
           <a:ln w="38100">
-            <a:noFill/>
+            <a:solidFill>
+              <a:schemeClr val="tx1"/>
+            </a:solidFill>
           </a:ln>
           <a:effectLst>
             <a:outerShdw blurRad="44450" dist="27940" dir="5400000" algn="ctr">
@@ -9205,7 +13236,9 @@
             <a:srgbClr val="4A4E69"/>
           </a:solidFill>
           <a:ln w="38100">
-            <a:noFill/>
+            <a:solidFill>
+              <a:schemeClr val="tx1"/>
+            </a:solidFill>
           </a:ln>
           <a:effectLst>
             <a:outerShdw blurRad="44450" dist="27940" dir="5400000" algn="ctr">
@@ -9293,7 +13326,9 @@
             <a:srgbClr val="6B5B95"/>
           </a:solidFill>
           <a:ln w="38100">
-            <a:noFill/>
+            <a:solidFill>
+              <a:schemeClr val="tx1"/>
+            </a:solidFill>
           </a:ln>
           <a:effectLst>
             <a:outerShdw blurRad="44450" dist="27940" dir="5400000" algn="ctr">
@@ -9373,7 +13408,9 @@
             <a:srgbClr val="6B5B95"/>
           </a:solidFill>
           <a:ln w="38100">
-            <a:noFill/>
+            <a:solidFill>
+              <a:schemeClr val="tx1"/>
+            </a:solidFill>
           </a:ln>
           <a:effectLst>
             <a:outerShdw blurRad="44450" dist="27940" dir="5400000" algn="ctr">
@@ -9663,7 +13700,7 @@
           <p:nvPr>
             <p:extLst>
               <p:ext uri="{D42A27DB-BD31-4B8C-83A1-F6EECF244321}">
-                <p14:modId xmlns:p14="http://schemas.microsoft.com/office/powerpoint/2010/main" val="3174936920"/>
+                <p14:modId xmlns:p14="http://schemas.microsoft.com/office/powerpoint/2010/main" val="3440689850"/>
               </p:ext>
             </p:extLst>
           </p:nvPr>
@@ -10221,7 +14258,9 @@
             <a:avLst/>
           </a:prstGeom>
           <a:ln w="38100">
-            <a:noFill/>
+            <a:solidFill>
+              <a:schemeClr val="tx1"/>
+            </a:solidFill>
           </a:ln>
           <a:effectLst>
             <a:outerShdw blurRad="190500" dist="228600" dir="2700000" algn="ctr">
@@ -10291,7 +14330,9 @@
             <a:avLst/>
           </a:prstGeom>
           <a:ln w="38100">
-            <a:noFill/>
+            <a:solidFill>
+              <a:schemeClr val="tx1"/>
+            </a:solidFill>
           </a:ln>
           <a:effectLst>
             <a:outerShdw blurRad="190500" dist="228600" dir="2700000" algn="ctr">
@@ -10361,7 +14402,9 @@
             <a:avLst/>
           </a:prstGeom>
           <a:ln w="38100">
-            <a:noFill/>
+            <a:solidFill>
+              <a:schemeClr val="tx1"/>
+            </a:solidFill>
           </a:ln>
           <a:effectLst>
             <a:outerShdw blurRad="190500" dist="228600" dir="2700000" algn="ctr">
@@ -10431,7 +14474,9 @@
             <a:avLst/>
           </a:prstGeom>
           <a:ln w="38100">
-            <a:noFill/>
+            <a:solidFill>
+              <a:schemeClr val="tx1"/>
+            </a:solidFill>
           </a:ln>
           <a:effectLst>
             <a:outerShdw blurRad="190500" dist="228600" dir="2700000" algn="ctr">
@@ -10501,7 +14546,9 @@
             <a:avLst/>
           </a:prstGeom>
           <a:ln w="38100">
-            <a:noFill/>
+            <a:solidFill>
+              <a:schemeClr val="tx1"/>
+            </a:solidFill>
           </a:ln>
           <a:effectLst>
             <a:outerShdw blurRad="190500" dist="228600" dir="2700000" algn="ctr">
@@ -10575,7 +14622,9 @@
             <a:avLst/>
           </a:prstGeom>
           <a:ln w="38100">
-            <a:noFill/>
+            <a:solidFill>
+              <a:schemeClr val="tx1"/>
+            </a:solidFill>
           </a:ln>
           <a:effectLst>
             <a:outerShdw blurRad="190500" dist="228600" dir="2700000" algn="ctr">
@@ -10649,7 +14698,9 @@
             <a:avLst/>
           </a:prstGeom>
           <a:ln w="38100">
-            <a:noFill/>
+            <a:solidFill>
+              <a:schemeClr val="tx1"/>
+            </a:solidFill>
           </a:ln>
           <a:effectLst>
             <a:outerShdw blurRad="190500" dist="228600" dir="2700000" algn="ctr">
@@ -10857,6 +14908,100 @@
 </file>
 
 <file path=ppt/slides/slide5.xml><?xml version="1.0" encoding="utf-8"?>
+<p:sld xmlns:a="http://schemas.openxmlformats.org/drawingml/2006/main" xmlns:r="http://schemas.openxmlformats.org/officeDocument/2006/relationships" xmlns:p="http://schemas.openxmlformats.org/presentationml/2006/main">
+  <p:cSld>
+    <p:spTree>
+      <p:nvGrpSpPr>
+        <p:cNvPr id="1" name=""/>
+        <p:cNvGrpSpPr/>
+        <p:nvPr/>
+      </p:nvGrpSpPr>
+      <p:grpSpPr>
+        <a:xfrm>
+          <a:off x="0" y="0"/>
+          <a:ext cx="0" cy="0"/>
+          <a:chOff x="0" y="0"/>
+          <a:chExt cx="0" cy="0"/>
+        </a:xfrm>
+      </p:grpSpPr>
+      <p:sp>
+        <p:nvSpPr>
+          <p:cNvPr id="4" name="Title 1">
+            <a:extLst>
+              <a:ext uri="{FF2B5EF4-FFF2-40B4-BE49-F238E27FC236}">
+                <a16:creationId xmlns:a16="http://schemas.microsoft.com/office/drawing/2014/main" id="{B7025FF1-2EE4-12D9-7F37-8AD7AD049012}"/>
+              </a:ext>
+            </a:extLst>
+          </p:cNvPr>
+          <p:cNvSpPr>
+            <a:spLocks noGrp="1"/>
+          </p:cNvSpPr>
+          <p:nvPr>
+            <p:ph type="title"/>
+          </p:nvPr>
+        </p:nvSpPr>
+        <p:spPr>
+          <a:xfrm>
+            <a:off x="1237545" y="628847"/>
+            <a:ext cx="15525572" cy="1489831"/>
+          </a:xfrm>
+        </p:spPr>
+        <p:txBody>
+          <a:bodyPr>
+            <a:normAutofit fontScale="90000"/>
+          </a:bodyPr>
+          <a:lstStyle/>
+          <a:p>
+            <a:pPr algn="ctr"/>
+            <a:r>
+              <a:rPr lang="en-IE" b="1" dirty="0"/>
+              <a:t>High Level Development Approach</a:t>
+            </a:r>
+          </a:p>
+        </p:txBody>
+      </p:sp>
+      <p:graphicFrame>
+        <p:nvGraphicFramePr>
+          <p:cNvPr id="5" name="Diagram 4">
+            <a:extLst>
+              <a:ext uri="{FF2B5EF4-FFF2-40B4-BE49-F238E27FC236}">
+                <a16:creationId xmlns:a16="http://schemas.microsoft.com/office/drawing/2014/main" id="{4D9ACF76-073C-44F3-C456-69DA6124BA89}"/>
+              </a:ext>
+            </a:extLst>
+          </p:cNvPr>
+          <p:cNvGraphicFramePr/>
+          <p:nvPr>
+            <p:extLst>
+              <p:ext uri="{D42A27DB-BD31-4B8C-83A1-F6EECF244321}">
+                <p14:modId xmlns:p14="http://schemas.microsoft.com/office/powerpoint/2010/main" val="1334874910"/>
+              </p:ext>
+            </p:extLst>
+          </p:nvPr>
+        </p:nvGraphicFramePr>
+        <p:xfrm>
+          <a:off x="612536" y="2748599"/>
+          <a:ext cx="16775589" cy="11678601"/>
+        </p:xfrm>
+        <a:graphic>
+          <a:graphicData uri="http://schemas.openxmlformats.org/drawingml/2006/diagram">
+            <dgm:relIds xmlns:dgm="http://schemas.openxmlformats.org/drawingml/2006/diagram" xmlns:r="http://schemas.openxmlformats.org/officeDocument/2006/relationships" r:dm="rId2" r:lo="rId3" r:qs="rId4" r:cs="rId5"/>
+          </a:graphicData>
+        </a:graphic>
+      </p:graphicFrame>
+    </p:spTree>
+    <p:extLst>
+      <p:ext uri="{BB962C8B-B14F-4D97-AF65-F5344CB8AC3E}">
+        <p14:creationId xmlns:p14="http://schemas.microsoft.com/office/powerpoint/2010/main" val="813586131"/>
+      </p:ext>
+    </p:extLst>
+  </p:cSld>
+  <p:clrMapOvr>
+    <a:masterClrMapping/>
+  </p:clrMapOvr>
+</p:sld>
+</file>
+
+<file path=ppt/slides/slide6.xml><?xml version="1.0" encoding="utf-8"?>
 <p:sld xmlns:a="http://schemas.openxmlformats.org/drawingml/2006/main" xmlns:r="http://schemas.openxmlformats.org/officeDocument/2006/relationships" xmlns:p="http://schemas.openxmlformats.org/presentationml/2006/main">
   <p:cSld>
     <p:spTree>
@@ -12798,7 +16943,7 @@
 </p:sld>
 </file>
 
-<file path=ppt/slides/slide6.xml><?xml version="1.0" encoding="utf-8"?>
+<file path=ppt/slides/slide7.xml><?xml version="1.0" encoding="utf-8"?>
 <p:sld xmlns:a="http://schemas.openxmlformats.org/drawingml/2006/main" xmlns:r="http://schemas.openxmlformats.org/officeDocument/2006/relationships" xmlns:p="http://schemas.openxmlformats.org/presentationml/2006/main">
   <p:cSld>
     <p:spTree>

</xml_diff>

<commit_message>
Diagrams + Bug Fixes
1). Crisper diagrams
2). StateObserver through the TaskTide Engine Utility using the Manager Utility applies JobEnvironment Id.
3). ItemTaskExectuor attaches results to annotation if expected file path is provided.
4). Parallel chunks provided instead of whole list by threads.
5). ItemStore open/close connections methods are now synchronized. Should fix the RocksDB bug
6). TaskTideProcessor shuffles the workload, and then chunks.
</commit_message>
<xml_diff>
--- a/tasktide/docs/Diagrams/Diagrams.pptx
+++ b/tasktide/docs/Diagrams/Diagrams.pptx
@@ -2567,7 +2567,7 @@
       <dgm:spPr/>
     </dgm:pt>
     <dgm:pt modelId="{2147C4C3-E4ED-44EA-8A74-5AB07B9224C6}" type="pres">
-      <dgm:prSet presAssocID="{1550EBB1-3E8A-4444-A1CB-728671E739D9}" presName="childTextBox" presStyleLbl="fgAccFollowNode1" presStyleIdx="0" presStyleCnt="9" custLinFactNeighborX="-147" custLinFactNeighborY="6417">
+      <dgm:prSet presAssocID="{1550EBB1-3E8A-4444-A1CB-728671E739D9}" presName="childTextBox" presStyleLbl="fgAccFollowNode1" presStyleIdx="0" presStyleCnt="9" custLinFactNeighborX="-536" custLinFactNeighborY="4503">
         <dgm:presLayoutVars>
           <dgm:bulletEnabled val="1"/>
         </dgm:presLayoutVars>
@@ -2575,7 +2575,7 @@
       <dgm:spPr/>
     </dgm:pt>
     <dgm:pt modelId="{EF0D8E2E-611F-48CE-B1FC-FF5FEBAA646D}" type="pres">
-      <dgm:prSet presAssocID="{F87B134D-0DC2-4772-90D6-BABD7BD5BC76}" presName="childTextBox" presStyleLbl="fgAccFollowNode1" presStyleIdx="1" presStyleCnt="9" custLinFactNeighborX="-364" custLinFactNeighborY="6417">
+      <dgm:prSet presAssocID="{F87B134D-0DC2-4772-90D6-BABD7BD5BC76}" presName="childTextBox" presStyleLbl="fgAccFollowNode1" presStyleIdx="1" presStyleCnt="9" custLinFactNeighborX="-364" custLinFactNeighborY="6026">
         <dgm:presLayoutVars>
           <dgm:bulletEnabled val="1"/>
         </dgm:presLayoutVars>
@@ -2583,7 +2583,7 @@
       <dgm:spPr/>
     </dgm:pt>
     <dgm:pt modelId="{A26E17A3-6ADC-4207-BAA9-6F37A7025026}" type="pres">
-      <dgm:prSet presAssocID="{A68E66D0-FC3E-4696-AEE9-FA917CE8B43F}" presName="childTextBox" presStyleLbl="fgAccFollowNode1" presStyleIdx="2" presStyleCnt="9" custLinFactNeighborY="6026">
+      <dgm:prSet presAssocID="{A68E66D0-FC3E-4696-AEE9-FA917CE8B43F}" presName="childTextBox" presStyleLbl="fgAccFollowNode1" presStyleIdx="2" presStyleCnt="9" custLinFactNeighborX="0" custLinFactNeighborY="4503">
         <dgm:presLayoutVars>
           <dgm:bulletEnabled val="1"/>
         </dgm:presLayoutVars>
@@ -2627,7 +2627,7 @@
       <dgm:spPr/>
     </dgm:pt>
     <dgm:pt modelId="{6A9F14BE-80C0-4B02-B21C-6C233AACAF51}" type="pres">
-      <dgm:prSet presAssocID="{28E7254B-914D-454C-9420-190BF7BC8B3F}" presName="childTextArrow" presStyleLbl="fgAccFollowNode1" presStyleIdx="5" presStyleCnt="9" custLinFactNeighborX="455" custLinFactNeighborY="1914">
+      <dgm:prSet presAssocID="{28E7254B-914D-454C-9420-190BF7BC8B3F}" presName="childTextArrow" presStyleLbl="fgAccFollowNode1" presStyleIdx="5" presStyleCnt="9" custLinFactNeighborX="147" custLinFactNeighborY="1914">
         <dgm:presLayoutVars>
           <dgm:bulletEnabled val="1"/>
         </dgm:presLayoutVars>
@@ -2655,7 +2655,7 @@
       <dgm:spPr/>
     </dgm:pt>
     <dgm:pt modelId="{07763EBB-4274-4F86-A670-BA07EE7CCAD5}" type="pres">
-      <dgm:prSet presAssocID="{C9D27329-5219-4575-8C28-F198FA7C7E21}" presName="childTextArrow" presStyleLbl="fgAccFollowNode1" presStyleIdx="6" presStyleCnt="9" custLinFactNeighborX="-82">
+      <dgm:prSet presAssocID="{C9D27329-5219-4575-8C28-F198FA7C7E21}" presName="childTextArrow" presStyleLbl="fgAccFollowNode1" presStyleIdx="6" presStyleCnt="9" custLinFactNeighborX="-82" custLinFactNeighborY="1523">
         <dgm:presLayoutVars>
           <dgm:bulletEnabled val="1"/>
         </dgm:presLayoutVars>
@@ -2663,7 +2663,7 @@
       <dgm:spPr/>
     </dgm:pt>
     <dgm:pt modelId="{A5384461-3C55-409F-A76C-DC6C5CADCFE8}" type="pres">
-      <dgm:prSet presAssocID="{0E7A854B-37EA-407C-A97F-3A739191418A}" presName="childTextArrow" presStyleLbl="fgAccFollowNode1" presStyleIdx="7" presStyleCnt="9">
+      <dgm:prSet presAssocID="{0E7A854B-37EA-407C-A97F-3A739191418A}" presName="childTextArrow" presStyleLbl="fgAccFollowNode1" presStyleIdx="7" presStyleCnt="9" custLinFactNeighborY="1523">
         <dgm:presLayoutVars>
           <dgm:bulletEnabled val="1"/>
         </dgm:presLayoutVars>
@@ -2671,7 +2671,7 @@
       <dgm:spPr/>
     </dgm:pt>
     <dgm:pt modelId="{1CEB22B1-9A7E-4A91-AF0C-26B893E69FA6}" type="pres">
-      <dgm:prSet presAssocID="{51E22944-1523-458B-8828-B060A21B0734}" presName="childTextArrow" presStyleLbl="fgAccFollowNode1" presStyleIdx="8" presStyleCnt="9" custLinFactNeighborX="390">
+      <dgm:prSet presAssocID="{51E22944-1523-458B-8828-B060A21B0734}" presName="childTextArrow" presStyleLbl="fgAccFollowNode1" presStyleIdx="8" presStyleCnt="9" custLinFactNeighborX="147" custLinFactNeighborY="1523">
         <dgm:presLayoutVars>
           <dgm:bulletEnabled val="1"/>
         </dgm:presLayoutVars>
@@ -3324,7 +3324,7 @@
       </dsp:nvSpPr>
       <dsp:spPr>
         <a:xfrm>
-          <a:off x="0" y="11148912"/>
+          <a:off x="0" y="11148907"/>
           <a:ext cx="5586402" cy="1429574"/>
         </a:xfrm>
         <a:prstGeom prst="rect">
@@ -3393,7 +3393,7 @@
         </a:p>
       </dsp:txBody>
       <dsp:txXfrm>
-        <a:off x="0" y="11148912"/>
+        <a:off x="0" y="11148907"/>
         <a:ext cx="5586402" cy="1429574"/>
       </dsp:txXfrm>
     </dsp:sp>
@@ -3484,7 +3484,7 @@
       </dsp:nvSpPr>
       <dsp:spPr>
         <a:xfrm>
-          <a:off x="11180995" y="11148912"/>
+          <a:off x="11180995" y="11148907"/>
           <a:ext cx="5586402" cy="1429574"/>
         </a:xfrm>
         <a:prstGeom prst="rect">
@@ -3553,7 +3553,7 @@
         </a:p>
       </dsp:txBody>
       <dsp:txXfrm>
-        <a:off x="11180995" y="11148912"/>
+        <a:off x="11180995" y="11148907"/>
         <a:ext cx="5586402" cy="1429574"/>
       </dsp:txXfrm>
     </dsp:sp>
@@ -4022,7 +4022,7 @@
       </dsp:nvSpPr>
       <dsp:spPr>
         <a:xfrm>
-          <a:off x="3610" y="1679916"/>
+          <a:off x="3610" y="1701681"/>
           <a:ext cx="5586402" cy="1429145"/>
         </a:xfrm>
         <a:prstGeom prst="rect">
@@ -4091,7 +4091,7 @@
         </a:p>
       </dsp:txBody>
       <dsp:txXfrm>
-        <a:off x="3610" y="1679916"/>
+        <a:off x="3610" y="1701681"/>
         <a:ext cx="5586402" cy="1429145"/>
       </dsp:txXfrm>
     </dsp:sp>
@@ -4102,7 +4102,7 @@
       </dsp:nvSpPr>
       <dsp:spPr>
         <a:xfrm>
-          <a:off x="5594593" y="1679916"/>
+          <a:off x="5594593" y="1701681"/>
           <a:ext cx="5586402" cy="1429145"/>
         </a:xfrm>
         <a:prstGeom prst="rect">
@@ -4171,7 +4171,7 @@
         </a:p>
       </dsp:txBody>
       <dsp:txXfrm>
-        <a:off x="5594593" y="1679916"/>
+        <a:off x="5594593" y="1701681"/>
         <a:ext cx="5586402" cy="1429145"/>
       </dsp:txXfrm>
     </dsp:sp>
@@ -4182,7 +4182,7 @@
       </dsp:nvSpPr>
       <dsp:spPr>
         <a:xfrm>
-          <a:off x="11189186" y="1679916"/>
+          <a:off x="11189186" y="1701681"/>
           <a:ext cx="5586402" cy="1429145"/>
         </a:xfrm>
         <a:prstGeom prst="rect">
@@ -4251,7 +4251,7 @@
         </a:p>
       </dsp:txBody>
       <dsp:txXfrm>
-        <a:off x="11189186" y="1679916"/>
+        <a:off x="11189186" y="1701681"/>
         <a:ext cx="5586402" cy="1429145"/>
       </dsp:txXfrm>
     </dsp:sp>
@@ -9053,7 +9053,7 @@
           <a:p>
             <a:fld id="{79C0705B-4870-4470-A32F-307AEE1697AB}" type="datetimeFigureOut">
               <a:rPr lang="en-IE" smtClean="0"/>
-              <a:t>13/11/2025</a:t>
+              <a:t>14/11/2025</a:t>
             </a:fld>
             <a:endParaRPr lang="en-IE"/>
           </a:p>
@@ -9223,7 +9223,7 @@
           <a:p>
             <a:fld id="{79C0705B-4870-4470-A32F-307AEE1697AB}" type="datetimeFigureOut">
               <a:rPr lang="en-IE" smtClean="0"/>
-              <a:t>13/11/2025</a:t>
+              <a:t>14/11/2025</a:t>
             </a:fld>
             <a:endParaRPr lang="en-IE"/>
           </a:p>
@@ -9403,7 +9403,7 @@
           <a:p>
             <a:fld id="{79C0705B-4870-4470-A32F-307AEE1697AB}" type="datetimeFigureOut">
               <a:rPr lang="en-IE" smtClean="0"/>
-              <a:t>13/11/2025</a:t>
+              <a:t>14/11/2025</a:t>
             </a:fld>
             <a:endParaRPr lang="en-IE"/>
           </a:p>
@@ -9573,7 +9573,7 @@
           <a:p>
             <a:fld id="{79C0705B-4870-4470-A32F-307AEE1697AB}" type="datetimeFigureOut">
               <a:rPr lang="en-IE" smtClean="0"/>
-              <a:t>13/11/2025</a:t>
+              <a:t>14/11/2025</a:t>
             </a:fld>
             <a:endParaRPr lang="en-IE"/>
           </a:p>
@@ -9819,7 +9819,7 @@
           <a:p>
             <a:fld id="{79C0705B-4870-4470-A32F-307AEE1697AB}" type="datetimeFigureOut">
               <a:rPr lang="en-IE" smtClean="0"/>
-              <a:t>13/11/2025</a:t>
+              <a:t>14/11/2025</a:t>
             </a:fld>
             <a:endParaRPr lang="en-IE"/>
           </a:p>
@@ -10051,7 +10051,7 @@
           <a:p>
             <a:fld id="{79C0705B-4870-4470-A32F-307AEE1697AB}" type="datetimeFigureOut">
               <a:rPr lang="en-IE" smtClean="0"/>
-              <a:t>13/11/2025</a:t>
+              <a:t>14/11/2025</a:t>
             </a:fld>
             <a:endParaRPr lang="en-IE"/>
           </a:p>
@@ -10418,7 +10418,7 @@
           <a:p>
             <a:fld id="{79C0705B-4870-4470-A32F-307AEE1697AB}" type="datetimeFigureOut">
               <a:rPr lang="en-IE" smtClean="0"/>
-              <a:t>13/11/2025</a:t>
+              <a:t>14/11/2025</a:t>
             </a:fld>
             <a:endParaRPr lang="en-IE"/>
           </a:p>
@@ -10536,7 +10536,7 @@
           <a:p>
             <a:fld id="{79C0705B-4870-4470-A32F-307AEE1697AB}" type="datetimeFigureOut">
               <a:rPr lang="en-IE" smtClean="0"/>
-              <a:t>13/11/2025</a:t>
+              <a:t>14/11/2025</a:t>
             </a:fld>
             <a:endParaRPr lang="en-IE"/>
           </a:p>
@@ -10631,7 +10631,7 @@
           <a:p>
             <a:fld id="{79C0705B-4870-4470-A32F-307AEE1697AB}" type="datetimeFigureOut">
               <a:rPr lang="en-IE" smtClean="0"/>
-              <a:t>13/11/2025</a:t>
+              <a:t>14/11/2025</a:t>
             </a:fld>
             <a:endParaRPr lang="en-IE"/>
           </a:p>
@@ -10908,7 +10908,7 @@
           <a:p>
             <a:fld id="{79C0705B-4870-4470-A32F-307AEE1697AB}" type="datetimeFigureOut">
               <a:rPr lang="en-IE" smtClean="0"/>
-              <a:t>13/11/2025</a:t>
+              <a:t>14/11/2025</a:t>
             </a:fld>
             <a:endParaRPr lang="en-IE"/>
           </a:p>
@@ -11165,7 +11165,7 @@
           <a:p>
             <a:fld id="{79C0705B-4870-4470-A32F-307AEE1697AB}" type="datetimeFigureOut">
               <a:rPr lang="en-IE" smtClean="0"/>
-              <a:t>13/11/2025</a:t>
+              <a:t>14/11/2025</a:t>
             </a:fld>
             <a:endParaRPr lang="en-IE"/>
           </a:p>
@@ -11378,7 +11378,7 @@
           <a:p>
             <a:fld id="{79C0705B-4870-4470-A32F-307AEE1697AB}" type="datetimeFigureOut">
               <a:rPr lang="en-IE" smtClean="0"/>
-              <a:t>13/11/2025</a:t>
+              <a:t>14/11/2025</a:t>
             </a:fld>
             <a:endParaRPr lang="en-IE"/>
           </a:p>
@@ -11996,74 +11996,6 @@
           </p:txBody>
         </p:sp>
       </p:grpSp>
-      <p:sp>
-        <p:nvSpPr>
-          <p:cNvPr id="14" name="Cylinder 13">
-            <a:extLst>
-              <a:ext uri="{FF2B5EF4-FFF2-40B4-BE49-F238E27FC236}">
-                <a16:creationId xmlns:a16="http://schemas.microsoft.com/office/drawing/2014/main" id="{D0BBDB7D-B1CF-0BD7-3CC6-E05CC1245F0F}"/>
-              </a:ext>
-            </a:extLst>
-          </p:cNvPr>
-          <p:cNvSpPr/>
-          <p:nvPr/>
-        </p:nvSpPr>
-        <p:spPr>
-          <a:xfrm>
-            <a:off x="7482943" y="3894380"/>
-            <a:ext cx="2726479" cy="2646489"/>
-          </a:xfrm>
-          <a:prstGeom prst="can">
-            <a:avLst/>
-          </a:prstGeom>
-          <a:solidFill>
-            <a:srgbClr val="400020"/>
-          </a:solidFill>
-          <a:ln w="38100">
-            <a:solidFill>
-              <a:schemeClr val="tx1">
-                <a:lumMod val="65000"/>
-                <a:lumOff val="35000"/>
-              </a:schemeClr>
-            </a:solidFill>
-          </a:ln>
-          <a:effectLst>
-            <a:outerShdw blurRad="50800" dist="38100" algn="l" rotWithShape="0">
-              <a:prstClr val="black">
-                <a:alpha val="40000"/>
-              </a:prstClr>
-            </a:outerShdw>
-          </a:effectLst>
-        </p:spPr>
-        <p:style>
-          <a:lnRef idx="2">
-            <a:schemeClr val="accent1">
-              <a:shade val="15000"/>
-            </a:schemeClr>
-          </a:lnRef>
-          <a:fillRef idx="1">
-            <a:schemeClr val="accent1"/>
-          </a:fillRef>
-          <a:effectRef idx="0">
-            <a:schemeClr val="accent1"/>
-          </a:effectRef>
-          <a:fontRef idx="minor">
-            <a:schemeClr val="lt1"/>
-          </a:fontRef>
-        </p:style>
-        <p:txBody>
-          <a:bodyPr rtlCol="0" anchor="ctr"/>
-          <a:lstStyle/>
-          <a:p>
-            <a:pPr algn="ctr"/>
-            <a:r>
-              <a:rPr lang="en-IE" sz="3600" b="1" dirty="0"/>
-              <a:t>Database</a:t>
-            </a:r>
-            <a:endParaRPr lang="en-IE" sz="2800" b="1" dirty="0"/>
-          </a:p>
-        </p:txBody>
-      </p:sp>
       <p:sp>
         <p:nvSpPr>
           <p:cNvPr id="15" name="TextBox 14">
@@ -12813,6 +12745,82 @@
           </a:p>
         </p:txBody>
       </p:sp>
+      <p:pic>
+        <p:nvPicPr>
+          <p:cNvPr id="8" name="Graphic 7" descr="Database with solid fill">
+            <a:extLst>
+              <a:ext uri="{FF2B5EF4-FFF2-40B4-BE49-F238E27FC236}">
+                <a16:creationId xmlns:a16="http://schemas.microsoft.com/office/drawing/2014/main" id="{ED8D8A1C-43A2-F999-B330-E1B3A6D4568B}"/>
+              </a:ext>
+            </a:extLst>
+          </p:cNvPr>
+          <p:cNvPicPr>
+            <a:picLocks noChangeAspect="1"/>
+          </p:cNvPicPr>
+          <p:nvPr/>
+        </p:nvPicPr>
+        <p:blipFill>
+          <a:blip r:embed="rId6">
+            <a:extLst>
+              <a:ext uri="{96DAC541-7B7A-43D3-8B79-37D633B846F1}">
+                <asvg:svgBlip xmlns:asvg="http://schemas.microsoft.com/office/drawing/2016/SVG/main" r:embed="rId7"/>
+              </a:ext>
+            </a:extLst>
+          </a:blip>
+          <a:stretch>
+            <a:fillRect/>
+          </a:stretch>
+        </p:blipFill>
+        <p:spPr>
+          <a:xfrm>
+            <a:off x="6858873" y="3406574"/>
+            <a:ext cx="3893439" cy="3477750"/>
+          </a:xfrm>
+          <a:prstGeom prst="rect">
+            <a:avLst/>
+          </a:prstGeom>
+        </p:spPr>
+      </p:pic>
+      <p:sp>
+        <p:nvSpPr>
+          <p:cNvPr id="9" name="TextBox 8">
+            <a:extLst>
+              <a:ext uri="{FF2B5EF4-FFF2-40B4-BE49-F238E27FC236}">
+                <a16:creationId xmlns:a16="http://schemas.microsoft.com/office/drawing/2014/main" id="{357A4EB6-B6C0-EE2C-43D3-54A695091B52}"/>
+              </a:ext>
+            </a:extLst>
+          </p:cNvPr>
+          <p:cNvSpPr txBox="1"/>
+          <p:nvPr/>
+        </p:nvSpPr>
+        <p:spPr>
+          <a:xfrm>
+            <a:off x="7466555" y="6626837"/>
+            <a:ext cx="2766018" cy="646331"/>
+          </a:xfrm>
+          <a:prstGeom prst="rect">
+            <a:avLst/>
+          </a:prstGeom>
+          <a:noFill/>
+        </p:spPr>
+        <p:txBody>
+          <a:bodyPr wrap="square" rtlCol="0">
+            <a:spAutoFit/>
+          </a:bodyPr>
+          <a:lstStyle/>
+          <a:p>
+            <a:pPr algn="ctr"/>
+            <a:r>
+              <a:rPr lang="en-IE" sz="3600" b="1" dirty="0">
+                <a:solidFill>
+                  <a:srgbClr val="400020"/>
+                </a:solidFill>
+              </a:rPr>
+              <a:t>Database</a:t>
+            </a:r>
+          </a:p>
+        </p:txBody>
+      </p:sp>
     </p:spTree>
     <p:extLst>
       <p:ext uri="{BB962C8B-B14F-4D97-AF65-F5344CB8AC3E}">
@@ -13103,7 +13111,7 @@
                   <a:schemeClr val="bg1"/>
                 </a:solidFill>
               </a:rPr>
-              <a:t>, Kubernetes, Cloud)</a:t>
+              <a:t>, Kubernetes)</a:t>
             </a:r>
             <a:endParaRPr lang="en-IE" sz="4000" b="1" i="1" dirty="0">
               <a:solidFill>
@@ -14777,13 +14785,13 @@
           <p:nvPr>
             <p:extLst>
               <p:ext uri="{D42A27DB-BD31-4B8C-83A1-F6EECF244321}">
-                <p14:modId xmlns:p14="http://schemas.microsoft.com/office/powerpoint/2010/main" val="4160423314"/>
+                <p14:modId xmlns:p14="http://schemas.microsoft.com/office/powerpoint/2010/main" val="1281753465"/>
               </p:ext>
             </p:extLst>
           </p:nvPr>
         </p:nvGraphicFramePr>
         <p:xfrm>
-          <a:off x="-2316478" y="3993735"/>
+          <a:off x="-2229392" y="3993735"/>
           <a:ext cx="9834878" cy="9234585"/>
         </p:xfrm>
         <a:graphic>
@@ -14806,7 +14814,7 @@
         </p:nvCxnSpPr>
         <p:spPr>
           <a:xfrm>
-            <a:off x="5374640" y="2743200"/>
+            <a:off x="5418182" y="2743200"/>
             <a:ext cx="0" cy="11988800"/>
           </a:xfrm>
           <a:prstGeom prst="line">
@@ -15154,6 +15162,29 @@
           <a:prstGeom prst="roundRect">
             <a:avLst/>
           </a:prstGeom>
+          <a:gradFill>
+            <a:gsLst>
+              <a:gs pos="0">
+                <a:schemeClr val="accent1">
+                  <a:shade val="30000"/>
+                  <a:satMod val="115000"/>
+                </a:schemeClr>
+              </a:gs>
+              <a:gs pos="50000">
+                <a:schemeClr val="accent1">
+                  <a:shade val="67500"/>
+                  <a:satMod val="115000"/>
+                </a:schemeClr>
+              </a:gs>
+              <a:gs pos="100000">
+                <a:schemeClr val="accent1">
+                  <a:shade val="100000"/>
+                  <a:satMod val="115000"/>
+                </a:schemeClr>
+              </a:gs>
+            </a:gsLst>
+            <a:lin ang="5400000" scaled="1"/>
+          </a:gradFill>
           <a:ln w="38100">
             <a:solidFill>
               <a:schemeClr val="tx1"/>
@@ -15226,6 +15257,29 @@
           <a:prstGeom prst="roundRect">
             <a:avLst/>
           </a:prstGeom>
+          <a:gradFill>
+            <a:gsLst>
+              <a:gs pos="0">
+                <a:schemeClr val="accent1">
+                  <a:shade val="30000"/>
+                  <a:satMod val="115000"/>
+                </a:schemeClr>
+              </a:gs>
+              <a:gs pos="50000">
+                <a:schemeClr val="accent1">
+                  <a:shade val="67500"/>
+                  <a:satMod val="115000"/>
+                </a:schemeClr>
+              </a:gs>
+              <a:gs pos="100000">
+                <a:schemeClr val="accent1">
+                  <a:shade val="100000"/>
+                  <a:satMod val="115000"/>
+                </a:schemeClr>
+              </a:gs>
+            </a:gsLst>
+            <a:lin ang="5400000" scaled="1"/>
+          </a:gradFill>
           <a:ln w="38100">
             <a:solidFill>
               <a:schemeClr val="tx1"/>
@@ -15298,6 +15352,29 @@
           <a:prstGeom prst="roundRect">
             <a:avLst/>
           </a:prstGeom>
+          <a:gradFill>
+            <a:gsLst>
+              <a:gs pos="0">
+                <a:schemeClr val="accent1">
+                  <a:shade val="30000"/>
+                  <a:satMod val="115000"/>
+                </a:schemeClr>
+              </a:gs>
+              <a:gs pos="50000">
+                <a:schemeClr val="accent1">
+                  <a:shade val="67500"/>
+                  <a:satMod val="115000"/>
+                </a:schemeClr>
+              </a:gs>
+              <a:gs pos="100000">
+                <a:schemeClr val="accent1">
+                  <a:shade val="100000"/>
+                  <a:satMod val="115000"/>
+                </a:schemeClr>
+              </a:gs>
+            </a:gsLst>
+            <a:lin ang="5400000" scaled="1"/>
+          </a:gradFill>
           <a:ln w="38100">
             <a:solidFill>
               <a:schemeClr val="tx1"/>
@@ -15481,6 +15558,29 @@
           <a:prstGeom prst="roundRect">
             <a:avLst/>
           </a:prstGeom>
+          <a:gradFill>
+            <a:gsLst>
+              <a:gs pos="0">
+                <a:schemeClr val="accent1">
+                  <a:shade val="30000"/>
+                  <a:satMod val="115000"/>
+                </a:schemeClr>
+              </a:gs>
+              <a:gs pos="50000">
+                <a:schemeClr val="accent1">
+                  <a:shade val="67500"/>
+                  <a:satMod val="115000"/>
+                </a:schemeClr>
+              </a:gs>
+              <a:gs pos="100000">
+                <a:schemeClr val="accent1">
+                  <a:shade val="100000"/>
+                  <a:satMod val="115000"/>
+                </a:schemeClr>
+              </a:gs>
+            </a:gsLst>
+            <a:lin ang="5400000" scaled="1"/>
+          </a:gradFill>
           <a:ln w="38100">
             <a:solidFill>
               <a:schemeClr val="tx1"/>
@@ -15553,6 +15653,29 @@
           <a:prstGeom prst="roundRect">
             <a:avLst/>
           </a:prstGeom>
+          <a:gradFill>
+            <a:gsLst>
+              <a:gs pos="0">
+                <a:schemeClr val="accent1">
+                  <a:shade val="30000"/>
+                  <a:satMod val="115000"/>
+                </a:schemeClr>
+              </a:gs>
+              <a:gs pos="50000">
+                <a:schemeClr val="accent1">
+                  <a:shade val="67500"/>
+                  <a:satMod val="115000"/>
+                </a:schemeClr>
+              </a:gs>
+              <a:gs pos="100000">
+                <a:schemeClr val="accent1">
+                  <a:shade val="100000"/>
+                  <a:satMod val="115000"/>
+                </a:schemeClr>
+              </a:gs>
+            </a:gsLst>
+            <a:lin ang="5400000" scaled="1"/>
+          </a:gradFill>
           <a:ln w="38100">
             <a:solidFill>
               <a:schemeClr val="tx1"/>
@@ -15625,6 +15748,29 @@
           <a:prstGeom prst="roundRect">
             <a:avLst/>
           </a:prstGeom>
+          <a:gradFill>
+            <a:gsLst>
+              <a:gs pos="0">
+                <a:schemeClr val="accent1">
+                  <a:shade val="30000"/>
+                  <a:satMod val="115000"/>
+                </a:schemeClr>
+              </a:gs>
+              <a:gs pos="50000">
+                <a:schemeClr val="accent1">
+                  <a:shade val="67500"/>
+                  <a:satMod val="115000"/>
+                </a:schemeClr>
+              </a:gs>
+              <a:gs pos="100000">
+                <a:schemeClr val="accent1">
+                  <a:shade val="100000"/>
+                  <a:satMod val="115000"/>
+                </a:schemeClr>
+              </a:gs>
+            </a:gsLst>
+            <a:lin ang="5400000" scaled="1"/>
+          </a:gradFill>
           <a:ln w="38100">
             <a:solidFill>
               <a:schemeClr val="tx1"/>
@@ -16013,7 +16159,7 @@
           <p:nvPr>
             <p:extLst>
               <p:ext uri="{D42A27DB-BD31-4B8C-83A1-F6EECF244321}">
-                <p14:modId xmlns:p14="http://schemas.microsoft.com/office/powerpoint/2010/main" val="1414130534"/>
+                <p14:modId xmlns:p14="http://schemas.microsoft.com/office/powerpoint/2010/main" val="1521909535"/>
               </p:ext>
             </p:extLst>
           </p:nvPr>

</xml_diff>

<commit_message>
Unit test coverage over MutexStrategy
</commit_message>
<xml_diff>
--- a/tasktide/docs/Diagrams/Diagrams.pptx
+++ b/tasktide/docs/Diagrams/Diagrams.pptx
@@ -24037,7 +24037,7 @@
         </p:nvSpPr>
         <p:spPr>
           <a:xfrm>
-            <a:off x="190500" y="3825969"/>
+            <a:off x="190500" y="3853678"/>
             <a:ext cx="29851350" cy="6923211"/>
           </a:xfrm>
           <a:prstGeom prst="roundRect">
@@ -24091,7 +24091,7 @@
         </p:nvSpPr>
         <p:spPr>
           <a:xfrm>
-            <a:off x="423801" y="4198046"/>
+            <a:off x="423801" y="4225755"/>
             <a:ext cx="9277350" cy="830997"/>
           </a:xfrm>
           <a:prstGeom prst="rect">
@@ -24127,7 +24127,7 @@
         </p:nvGrpSpPr>
         <p:grpSpPr>
           <a:xfrm>
-            <a:off x="495300" y="5132799"/>
+            <a:off x="495300" y="5160508"/>
             <a:ext cx="9277350" cy="5044882"/>
             <a:chOff x="609600" y="4232468"/>
             <a:chExt cx="9277350" cy="5044882"/>
@@ -24372,7 +24372,7 @@
         </p:nvSpPr>
         <p:spPr>
           <a:xfrm>
-            <a:off x="11316463" y="4198046"/>
+            <a:off x="11316463" y="4225755"/>
             <a:ext cx="9277350" cy="830997"/>
           </a:xfrm>
           <a:prstGeom prst="rect">
@@ -24408,7 +24408,7 @@
         </p:nvSpPr>
         <p:spPr>
           <a:xfrm>
-            <a:off x="11887200" y="5501099"/>
+            <a:off x="11887200" y="5528808"/>
             <a:ext cx="7905750" cy="4037241"/>
           </a:xfrm>
           <a:prstGeom prst="roundRect">
@@ -24483,7 +24483,7 @@
         </p:nvGrpSpPr>
         <p:grpSpPr>
           <a:xfrm>
-            <a:off x="12017069" y="5623699"/>
+            <a:off x="12017069" y="5651408"/>
             <a:ext cx="7710947" cy="499728"/>
             <a:chOff x="914400" y="4442816"/>
             <a:chExt cx="9048750" cy="624453"/>
@@ -24591,7 +24591,7 @@
         </p:nvSpPr>
         <p:spPr>
           <a:xfrm>
-            <a:off x="10063163" y="6792275"/>
+            <a:off x="10063163" y="6819984"/>
             <a:ext cx="1619250" cy="1413703"/>
           </a:xfrm>
           <a:prstGeom prst="rightArrow">
@@ -24666,7 +24666,7 @@
         </p:nvSpPr>
         <p:spPr>
           <a:xfrm>
-            <a:off x="20059650" y="6765384"/>
+            <a:off x="20059650" y="6793093"/>
             <a:ext cx="1619250" cy="1440594"/>
           </a:xfrm>
           <a:prstGeom prst="rightArrow">
@@ -24741,7 +24741,7 @@
         </p:nvSpPr>
         <p:spPr>
           <a:xfrm>
-            <a:off x="22412325" y="4217096"/>
+            <a:off x="22412325" y="4244805"/>
             <a:ext cx="6657975" cy="830997"/>
           </a:xfrm>
           <a:prstGeom prst="rect">
@@ -24777,7 +24777,7 @@
         </p:nvGrpSpPr>
         <p:grpSpPr>
           <a:xfrm>
-            <a:off x="21839238" y="5539998"/>
+            <a:off x="21839238" y="5567707"/>
             <a:ext cx="7905750" cy="3770158"/>
             <a:chOff x="12363450" y="4232467"/>
             <a:chExt cx="9277350" cy="5044882"/>
@@ -24995,7 +24995,7 @@
         </p:blipFill>
         <p:spPr>
           <a:xfrm>
-            <a:off x="27117170" y="6637894"/>
+            <a:off x="27117170" y="6665603"/>
             <a:ext cx="2105025" cy="2105025"/>
           </a:xfrm>
           <a:prstGeom prst="rect">
@@ -25031,7 +25031,7 @@
         </p:blipFill>
         <p:spPr>
           <a:xfrm>
-            <a:off x="22468970" y="6390244"/>
+            <a:off x="22468970" y="6417953"/>
             <a:ext cx="2105025" cy="2105025"/>
           </a:xfrm>
           <a:prstGeom prst="rect">
@@ -25053,7 +25053,7 @@
         </p:nvSpPr>
         <p:spPr>
           <a:xfrm>
-            <a:off x="24806275" y="7142286"/>
+            <a:off x="24806275" y="7169995"/>
             <a:ext cx="1828800" cy="981939"/>
           </a:xfrm>
           <a:prstGeom prst="rightArrow">
@@ -25107,7 +25107,7 @@
         </p:nvGrpSpPr>
         <p:grpSpPr>
           <a:xfrm>
-            <a:off x="5122141" y="2606098"/>
+            <a:off x="5122141" y="2633807"/>
             <a:ext cx="20817737" cy="1143120"/>
             <a:chOff x="4899243" y="2108980"/>
             <a:chExt cx="18821400" cy="1107996"/>
@@ -25218,7 +25218,7 @@
         </p:nvGrpSpPr>
         <p:grpSpPr>
           <a:xfrm>
-            <a:off x="5280891" y="14747296"/>
+            <a:off x="5280891" y="14525624"/>
             <a:ext cx="18859500" cy="1107996"/>
             <a:chOff x="4953000" y="2082800"/>
             <a:chExt cx="18859500" cy="1107996"/>
@@ -25329,7 +25329,7 @@
         </p:nvSpPr>
         <p:spPr>
           <a:xfrm>
-            <a:off x="188191" y="15944275"/>
+            <a:off x="188191" y="15722603"/>
             <a:ext cx="29851350" cy="5918192"/>
           </a:xfrm>
           <a:prstGeom prst="roundRect">
@@ -25383,7 +25383,7 @@
         </p:nvSpPr>
         <p:spPr>
           <a:xfrm>
-            <a:off x="-289708" y="16186844"/>
+            <a:off x="-289708" y="15965172"/>
             <a:ext cx="9277350" cy="830997"/>
           </a:xfrm>
           <a:prstGeom prst="rect">
@@ -25419,7 +25419,7 @@
         </p:nvSpPr>
         <p:spPr>
           <a:xfrm>
-            <a:off x="10337075" y="16186844"/>
+            <a:off x="10337075" y="15965172"/>
             <a:ext cx="9277350" cy="830997"/>
           </a:xfrm>
           <a:prstGeom prst="rect">
@@ -25455,7 +25455,7 @@
         </p:nvSpPr>
         <p:spPr>
           <a:xfrm>
-            <a:off x="8768936" y="18429630"/>
+            <a:off x="8768936" y="18207958"/>
             <a:ext cx="1979305" cy="1413703"/>
           </a:xfrm>
           <a:prstGeom prst="rightArrow">
@@ -25530,7 +25530,7 @@
         </p:nvSpPr>
         <p:spPr>
           <a:xfrm>
-            <a:off x="18640529" y="18322382"/>
+            <a:off x="18640529" y="18100710"/>
             <a:ext cx="2242312" cy="1440594"/>
           </a:xfrm>
           <a:prstGeom prst="rightArrow">
@@ -25605,7 +25605,7 @@
         </p:nvSpPr>
         <p:spPr>
           <a:xfrm>
-            <a:off x="22365661" y="16186844"/>
+            <a:off x="22365661" y="15965172"/>
             <a:ext cx="6657975" cy="830997"/>
           </a:xfrm>
           <a:prstGeom prst="rect">
@@ -25641,7 +25641,7 @@
         </p:nvGrpSpPr>
         <p:grpSpPr>
           <a:xfrm>
-            <a:off x="21325242" y="17001638"/>
+            <a:off x="21325242" y="16779966"/>
             <a:ext cx="8392038" cy="4236049"/>
             <a:chOff x="12363450" y="4232467"/>
             <a:chExt cx="9277350" cy="5044882"/>
@@ -25845,7 +25845,7 @@
         </p:nvSpPr>
         <p:spPr>
           <a:xfrm rot="5400000">
-            <a:off x="13797988" y="11983555"/>
+            <a:off x="13797988" y="12011264"/>
             <a:ext cx="2656859" cy="1619250"/>
           </a:xfrm>
           <a:prstGeom prst="rightArrow">
@@ -25920,7 +25920,7 @@
         </p:nvGrpSpPr>
         <p:grpSpPr>
           <a:xfrm>
-            <a:off x="734291" y="17127947"/>
+            <a:off x="734291" y="16906275"/>
             <a:ext cx="7521575" cy="3842943"/>
             <a:chOff x="609600" y="4232468"/>
             <a:chExt cx="9277350" cy="5044882"/>
@@ -26123,7 +26123,7 @@
         </p:nvGrpSpPr>
         <p:grpSpPr>
           <a:xfrm>
-            <a:off x="2801215" y="17976379"/>
+            <a:off x="2801215" y="17754707"/>
             <a:ext cx="3140911" cy="2301407"/>
             <a:chOff x="1939924" y="18109350"/>
             <a:chExt cx="3573819" cy="2536825"/>
@@ -26216,7 +26216,7 @@
         </p:nvGrpSpPr>
         <p:grpSpPr>
           <a:xfrm>
-            <a:off x="11122891" y="17127947"/>
+            <a:off x="11122891" y="16906275"/>
             <a:ext cx="7023100" cy="3919143"/>
             <a:chOff x="12363450" y="4232467"/>
             <a:chExt cx="9277350" cy="5044882"/>
@@ -26420,7 +26420,7 @@
         </p:nvGrpSpPr>
         <p:grpSpPr>
           <a:xfrm>
-            <a:off x="12985467" y="17813790"/>
+            <a:off x="12985467" y="17592118"/>
             <a:ext cx="4074674" cy="2638970"/>
             <a:chOff x="15089626" y="18117665"/>
             <a:chExt cx="2911547" cy="2214581"/>
@@ -26513,7 +26513,7 @@
         </p:nvSpPr>
         <p:spPr>
           <a:xfrm rot="2461338">
-            <a:off x="25800995" y="18867001"/>
+            <a:off x="25800995" y="18645329"/>
             <a:ext cx="4601827" cy="763631"/>
           </a:xfrm>
           <a:prstGeom prst="mathMinus">
@@ -26573,7 +26573,7 @@
         </p:nvGrpSpPr>
         <p:grpSpPr>
           <a:xfrm>
-            <a:off x="20892445" y="18258842"/>
+            <a:off x="20892445" y="18037170"/>
             <a:ext cx="8251657" cy="2105025"/>
             <a:chOff x="20920154" y="17681571"/>
             <a:chExt cx="8251657" cy="2105025"/>
@@ -26837,7 +26837,7 @@
         </p:nvSpPr>
         <p:spPr>
           <a:xfrm>
-            <a:off x="13082300" y="20477304"/>
+            <a:off x="13082300" y="20255632"/>
             <a:ext cx="3099279" cy="400110"/>
           </a:xfrm>
           <a:prstGeom prst="rect">
@@ -26882,7 +26882,7 @@
         </p:nvSpPr>
         <p:spPr>
           <a:xfrm>
-            <a:off x="24093343" y="8718149"/>
+            <a:off x="24093343" y="8745858"/>
             <a:ext cx="3099279" cy="400110"/>
           </a:xfrm>
           <a:prstGeom prst="rect">
@@ -26927,7 +26927,7 @@
         </p:nvSpPr>
         <p:spPr>
           <a:xfrm>
-            <a:off x="22975262" y="20665264"/>
+            <a:off x="22975262" y="20443592"/>
             <a:ext cx="5526310" cy="400110"/>
           </a:xfrm>
           <a:prstGeom prst="rect">
@@ -26972,7 +26972,7 @@
         </p:nvSpPr>
         <p:spPr>
           <a:xfrm>
-            <a:off x="2527706" y="20340796"/>
+            <a:off x="2527706" y="20119124"/>
             <a:ext cx="3099279" cy="400110"/>
           </a:xfrm>
           <a:prstGeom prst="rect">
@@ -27017,7 +27017,7 @@
         </p:nvSpPr>
         <p:spPr>
           <a:xfrm>
-            <a:off x="12017069" y="6390244"/>
+            <a:off x="12017069" y="6417953"/>
             <a:ext cx="7519788" cy="2708434"/>
           </a:xfrm>
           <a:prstGeom prst="rect">

</xml_diff>

<commit_message>
Adds mutex workflow image
</commit_message>
<xml_diff>
--- a/tasktide/docs/Diagrams/Diagrams.pptx
+++ b/tasktide/docs/Diagrams/Diagrams.pptx
@@ -9010,7 +9010,7 @@
           <a:p>
             <a:fld id="{CB18BCE7-0017-4B0C-A2FB-E6F7885367AC}" type="datetimeFigureOut">
               <a:rPr lang="en-IE" smtClean="0"/>
-              <a:t>15/08/2026</a:t>
+              <a:t>20/08/2026</a:t>
             </a:fld>
             <a:endParaRPr lang="en-IE"/>
           </a:p>
@@ -9514,7 +9514,7 @@
           <a:p>
             <a:fld id="{79C0705B-4870-4470-A32F-307AEE1697AB}" type="datetimeFigureOut">
               <a:rPr lang="en-IE" smtClean="0"/>
-              <a:t>15/08/2026</a:t>
+              <a:t>20/08/2026</a:t>
             </a:fld>
             <a:endParaRPr lang="en-IE"/>
           </a:p>
@@ -9684,7 +9684,7 @@
           <a:p>
             <a:fld id="{79C0705B-4870-4470-A32F-307AEE1697AB}" type="datetimeFigureOut">
               <a:rPr lang="en-IE" smtClean="0"/>
-              <a:t>15/08/2026</a:t>
+              <a:t>20/08/2026</a:t>
             </a:fld>
             <a:endParaRPr lang="en-IE"/>
           </a:p>
@@ -9864,7 +9864,7 @@
           <a:p>
             <a:fld id="{79C0705B-4870-4470-A32F-307AEE1697AB}" type="datetimeFigureOut">
               <a:rPr lang="en-IE" smtClean="0"/>
-              <a:t>15/08/2026</a:t>
+              <a:t>20/08/2026</a:t>
             </a:fld>
             <a:endParaRPr lang="en-IE"/>
           </a:p>
@@ -10034,7 +10034,7 @@
           <a:p>
             <a:fld id="{79C0705B-4870-4470-A32F-307AEE1697AB}" type="datetimeFigureOut">
               <a:rPr lang="en-IE" smtClean="0"/>
-              <a:t>15/08/2026</a:t>
+              <a:t>20/08/2026</a:t>
             </a:fld>
             <a:endParaRPr lang="en-IE"/>
           </a:p>
@@ -10280,7 +10280,7 @@
           <a:p>
             <a:fld id="{79C0705B-4870-4470-A32F-307AEE1697AB}" type="datetimeFigureOut">
               <a:rPr lang="en-IE" smtClean="0"/>
-              <a:t>15/08/2026</a:t>
+              <a:t>20/08/2026</a:t>
             </a:fld>
             <a:endParaRPr lang="en-IE"/>
           </a:p>
@@ -10512,7 +10512,7 @@
           <a:p>
             <a:fld id="{79C0705B-4870-4470-A32F-307AEE1697AB}" type="datetimeFigureOut">
               <a:rPr lang="en-IE" smtClean="0"/>
-              <a:t>15/08/2026</a:t>
+              <a:t>20/08/2026</a:t>
             </a:fld>
             <a:endParaRPr lang="en-IE"/>
           </a:p>
@@ -10879,7 +10879,7 @@
           <a:p>
             <a:fld id="{79C0705B-4870-4470-A32F-307AEE1697AB}" type="datetimeFigureOut">
               <a:rPr lang="en-IE" smtClean="0"/>
-              <a:t>15/08/2026</a:t>
+              <a:t>20/08/2026</a:t>
             </a:fld>
             <a:endParaRPr lang="en-IE"/>
           </a:p>
@@ -10997,7 +10997,7 @@
           <a:p>
             <a:fld id="{79C0705B-4870-4470-A32F-307AEE1697AB}" type="datetimeFigureOut">
               <a:rPr lang="en-IE" smtClean="0"/>
-              <a:t>15/08/2026</a:t>
+              <a:t>20/08/2026</a:t>
             </a:fld>
             <a:endParaRPr lang="en-IE"/>
           </a:p>
@@ -11092,7 +11092,7 @@
           <a:p>
             <a:fld id="{79C0705B-4870-4470-A32F-307AEE1697AB}" type="datetimeFigureOut">
               <a:rPr lang="en-IE" smtClean="0"/>
-              <a:t>15/08/2026</a:t>
+              <a:t>20/08/2026</a:t>
             </a:fld>
             <a:endParaRPr lang="en-IE"/>
           </a:p>
@@ -11369,7 +11369,7 @@
           <a:p>
             <a:fld id="{79C0705B-4870-4470-A32F-307AEE1697AB}" type="datetimeFigureOut">
               <a:rPr lang="en-IE" smtClean="0"/>
-              <a:t>15/08/2026</a:t>
+              <a:t>20/08/2026</a:t>
             </a:fld>
             <a:endParaRPr lang="en-IE"/>
           </a:p>
@@ -11626,7 +11626,7 @@
           <a:p>
             <a:fld id="{79C0705B-4870-4470-A32F-307AEE1697AB}" type="datetimeFigureOut">
               <a:rPr lang="en-IE" smtClean="0"/>
-              <a:t>15/08/2026</a:t>
+              <a:t>20/08/2026</a:t>
             </a:fld>
             <a:endParaRPr lang="en-IE"/>
           </a:p>
@@ -11839,7 +11839,7 @@
           <a:p>
             <a:fld id="{79C0705B-4870-4470-A32F-307AEE1697AB}" type="datetimeFigureOut">
               <a:rPr lang="en-IE" smtClean="0"/>
-              <a:t>15/08/2026</a:t>
+              <a:t>20/08/2026</a:t>
             </a:fld>
             <a:endParaRPr lang="en-IE"/>
           </a:p>
@@ -26935,7 +26935,7 @@
             <a:pPr algn="ctr"/>
             <a:r>
               <a:rPr lang="en-IE" b="1" i="1" dirty="0"/>
-              <a:t>Distributed Mutex Workflow</a:t>
+              <a:t>De-centralized Mutex Workflow</a:t>
             </a:r>
           </a:p>
         </p:txBody>

</xml_diff>